<commit_message>
Enhance slide generator documentation by adding a new section for mathematical formulas, including usage of the `formula` field. Update JSON examples to reflect changes. Modify existing slides to improve clarity and accuracy of content, including renaming and restructuring for better flow. Update presentation file to align with new slide content.
</commit_message>
<xml_diff>
--- a/lessons/derevo_resheniy/presentation.pptx
+++ b/lessons/derevo_resheniy/presentation.pptx
@@ -24,6 +24,11 @@
     <p:sldId id="272" r:id="rId24"/>
     <p:sldId id="273" r:id="rId25"/>
     <p:sldId id="274" r:id="rId26"/>
+    <p:sldId id="275" r:id="rId27"/>
+    <p:sldId id="276" r:id="rId28"/>
+    <p:sldId id="277" r:id="rId29"/>
+    <p:sldId id="278" r:id="rId30"/>
+    <p:sldId id="279" r:id="rId31"/>
   </p:sldIdLst>
   <p:sldSz cx="12191695" cy="6858000" type="screen4x3"/>
   <p:notesSz cx="6858000" cy="9144000"/>
@@ -590,7 +595,7 @@
           <a:lstStyle/>
           <a:p>
             <a:r>
-              <a:t>Показать график зависимости train/test accuracy от глубины дерева: train растёт монотонно, test — сначала растёт, потом падает (типичный колокол переобучения).</a:t>
+              <a:t>Упомянуть: точность (precision), полноту (recall), F1-меру для каждого класса. Показать, как class_weight влияет на выбор разбиения.</a:t>
             </a:r>
           </a:p>
         </p:txBody>
@@ -660,7 +665,7 @@
           <a:lstStyle/>
           <a:p>
             <a:r>
-              <a:t>Показать вызов в jupyter notebook, сделать predict на новых данных.</a:t>
+              <a:t>Показать график зависимости train/test accuracy от глубины дерева: train растёт монотонно, test — сначала растёт, потом падает (типичный колокол переобучения).</a:t>
             </a:r>
           </a:p>
         </p:txBody>
@@ -730,7 +735,7 @@
           <a:lstStyle/>
           <a:p>
             <a:r>
-              <a:t>Показать пример: feature_importances_ в sklearn. Обсудить этическую сторону — если в данных есть дискриминационный признак, модель его выучит.</a:t>
+              <a:t>Показать вызов в jupyter notebook, сделать predict на новых данных.</a:t>
             </a:r>
           </a:p>
         </p:txBody>
@@ -800,7 +805,7 @@
           <a:lstStyle/>
           <a:p>
             <a:r>
-              <a:t>Показать кусочно-постоянную аппроксимацию на одномерном примере: ступеньки разной высоты.</a:t>
+              <a:t>Показать пример: feature_importances_ в sklearn. Обсудить этическую сторону — если в данных есть дискриминационный признак, модель его выучит.</a:t>
             </a:r>
           </a:p>
         </p:txBody>
@@ -870,7 +875,7 @@
           <a:lstStyle/>
           <a:p>
             <a:r>
-              <a:t>Не углубляться — это анонс следующей темы. Сказать, что подробно разберём на следующем занятии.</a:t>
+              <a:t>Показать кусочно-постоянную аппроксимацию на одномерном примере: ступеньки разной высоты.</a:t>
             </a:r>
           </a:p>
         </p:txBody>
@@ -940,7 +945,7 @@
           <a:lstStyle/>
           <a:p>
             <a:r>
-              <a:t>Показать все три варианта в Jupyter. Объяснить, как читать дерево: в каждом узле — условие, impurity, число объектов, класс.</a:t>
+              <a:t>Не углубляться — это анонс следующей темы. Сказать, что подробно разберём на следующем занятии.</a:t>
             </a:r>
           </a:p>
         </p:txBody>
@@ -1010,7 +1015,7 @@
           <a:lstStyle/>
           <a:p>
             <a:r>
-              <a:t>Показать картинку с делением 2D-пространства деревом глубины 3. Обсудить, почему это ограничение важно и как ансамбли его смягчают.</a:t>
+              <a:t>Показать все три варианта в Jupyter. Объяснить, как читать дерево: в каждом узле — условие, impurity, число объектов, класс.</a:t>
             </a:r>
           </a:p>
         </p:txBody>
@@ -1080,7 +1085,7 @@
           <a:lstStyle/>
           <a:p>
             <a:r>
-              <a:t>Можно раздать как памятку или вывести на экран во время обсуждения.</a:t>
+              <a:t>Показать картинку с делением 2D-пространства деревом глубины 3. Обсудить, почему это ограничение важно и как ансамбли его смягчают.</a:t>
             </a:r>
           </a:p>
         </p:txBody>
@@ -1150,6 +1155,76 @@
           <a:lstStyle/>
           <a:p>
             <a:r>
+              <a:t>Можно раздать как памятку или вывести на экран во время обсуждения.</a:t>
+            </a:r>
+          </a:p>
+        </p:txBody>
+      </p:sp>
+      <p:sp>
+        <p:nvSpPr>
+          <p:cNvPr id="4" name="Slide Number Placeholder 3"/>
+          <p:cNvSpPr>
+            <a:spLocks noGrp="1"/>
+          </p:cNvSpPr>
+          <p:nvPr>
+            <p:ph type="sldNum" idx="5" sz="quarter"/>
+          </p:nvPr>
+        </p:nvSpPr>
+        <p:spPr/>
+      </p:sp>
+    </p:spTree>
+  </p:cSld>
+  <p:clrMapOvr>
+    <a:masterClrMapping/>
+  </p:clrMapOvr>
+</p:notes>
+</file>
+
+<file path=ppt/notesSlides/notesSlide19.xml><?xml version="1.0" encoding="utf-8"?>
+<p:notes xmlns:a="http://schemas.openxmlformats.org/drawingml/2006/main" xmlns:p="http://schemas.openxmlformats.org/presentationml/2006/main" xmlns:r="http://schemas.openxmlformats.org/officeDocument/2006/relationships">
+  <p:cSld>
+    <p:spTree>
+      <p:nvGrpSpPr>
+        <p:cNvPr id="1" name=""/>
+        <p:cNvGrpSpPr/>
+        <p:nvPr/>
+      </p:nvGrpSpPr>
+      <p:grpSpPr>
+        <a:xfrm>
+          <a:off x="0" y="0"/>
+          <a:ext cx="0" cy="0"/>
+          <a:chOff x="0" y="0"/>
+          <a:chExt cx="0" cy="0"/>
+        </a:xfrm>
+      </p:grpSpPr>
+      <p:sp>
+        <p:nvSpPr>
+          <p:cNvPr id="2" name="Slide Image Placeholder 1"/>
+          <p:cNvSpPr>
+            <a:spLocks noGrp="1"/>
+          </p:cNvSpPr>
+          <p:nvPr>
+            <p:ph type="sldImg" idx="2"/>
+          </p:nvPr>
+        </p:nvSpPr>
+        <p:spPr/>
+      </p:sp>
+      <p:sp>
+        <p:nvSpPr>
+          <p:cNvPr id="3" name="Notes Placeholder 2"/>
+          <p:cNvSpPr>
+            <a:spLocks noGrp="1"/>
+          </p:cNvSpPr>
+          <p:nvPr>
+            <p:ph type="body" idx="3" sz="quarter"/>
+          </p:nvPr>
+        </p:nvSpPr>
+        <p:spPr/>
+        <p:txBody>
+          <a:bodyPr/>
+          <a:lstStyle/>
+          <a:p>
+            <a:r>
               <a:t>Обсудить компромисс: точность vs интерпретируемость. Где важна объяснимость (медицина, кредитный скоринг) — дерево может быть предпочтительнее нейросети.</a:t>
             </a:r>
           </a:p>
@@ -1245,6 +1320,286 @@
 </p:notes>
 </file>
 
+<file path=ppt/notesSlides/notesSlide20.xml><?xml version="1.0" encoding="utf-8"?>
+<p:notes xmlns:a="http://schemas.openxmlformats.org/drawingml/2006/main" xmlns:p="http://schemas.openxmlformats.org/presentationml/2006/main" xmlns:r="http://schemas.openxmlformats.org/officeDocument/2006/relationships">
+  <p:cSld>
+    <p:spTree>
+      <p:nvGrpSpPr>
+        <p:cNvPr id="1" name=""/>
+        <p:cNvGrpSpPr/>
+        <p:nvPr/>
+      </p:nvGrpSpPr>
+      <p:grpSpPr>
+        <a:xfrm>
+          <a:off x="0" y="0"/>
+          <a:ext cx="0" cy="0"/>
+          <a:chOff x="0" y="0"/>
+          <a:chExt cx="0" cy="0"/>
+        </a:xfrm>
+      </p:grpSpPr>
+      <p:sp>
+        <p:nvSpPr>
+          <p:cNvPr id="2" name="Slide Image Placeholder 1"/>
+          <p:cNvSpPr>
+            <a:spLocks noGrp="1"/>
+          </p:cNvSpPr>
+          <p:nvPr>
+            <p:ph type="sldImg" idx="2"/>
+          </p:nvPr>
+        </p:nvSpPr>
+        <p:spPr/>
+      </p:sp>
+      <p:sp>
+        <p:nvSpPr>
+          <p:cNvPr id="3" name="Notes Placeholder 2"/>
+          <p:cNvSpPr>
+            <a:spLocks noGrp="1"/>
+          </p:cNvSpPr>
+          <p:nvPr>
+            <p:ph type="body" idx="3" sz="quarter"/>
+          </p:nvPr>
+        </p:nvSpPr>
+        <p:spPr/>
+        <p:txBody>
+          <a:bodyPr/>
+          <a:lstStyle/>
+          <a:p>
+            <a:r>
+              <a:t>Подчеркнуть, что ограничение на один признак и бинарные вопросы — это не баг, а фича: оно даёт интерпретируемость и контролируемую сложность.</a:t>
+            </a:r>
+          </a:p>
+        </p:txBody>
+      </p:sp>
+      <p:sp>
+        <p:nvSpPr>
+          <p:cNvPr id="4" name="Slide Number Placeholder 3"/>
+          <p:cNvSpPr>
+            <a:spLocks noGrp="1"/>
+          </p:cNvSpPr>
+          <p:nvPr>
+            <p:ph type="sldNum" idx="5" sz="quarter"/>
+          </p:nvPr>
+        </p:nvSpPr>
+        <p:spPr/>
+      </p:sp>
+    </p:spTree>
+  </p:cSld>
+  <p:clrMapOvr>
+    <a:masterClrMapping/>
+  </p:clrMapOvr>
+</p:notes>
+</file>
+
+<file path=ppt/notesSlides/notesSlide21.xml><?xml version="1.0" encoding="utf-8"?>
+<p:notes xmlns:a="http://schemas.openxmlformats.org/drawingml/2006/main" xmlns:p="http://schemas.openxmlformats.org/presentationml/2006/main" xmlns:r="http://schemas.openxmlformats.org/officeDocument/2006/relationships">
+  <p:cSld>
+    <p:spTree>
+      <p:nvGrpSpPr>
+        <p:cNvPr id="1" name=""/>
+        <p:cNvGrpSpPr/>
+        <p:nvPr/>
+      </p:nvGrpSpPr>
+      <p:grpSpPr>
+        <a:xfrm>
+          <a:off x="0" y="0"/>
+          <a:ext cx="0" cy="0"/>
+          <a:chOff x="0" y="0"/>
+          <a:chExt cx="0" cy="0"/>
+        </a:xfrm>
+      </p:grpSpPr>
+      <p:sp>
+        <p:nvSpPr>
+          <p:cNvPr id="2" name="Slide Image Placeholder 1"/>
+          <p:cNvSpPr>
+            <a:spLocks noGrp="1"/>
+          </p:cNvSpPr>
+          <p:nvPr>
+            <p:ph type="sldImg" idx="2"/>
+          </p:nvPr>
+        </p:nvSpPr>
+        <p:spPr/>
+      </p:sp>
+      <p:sp>
+        <p:nvSpPr>
+          <p:cNvPr id="3" name="Notes Placeholder 2"/>
+          <p:cNvSpPr>
+            <a:spLocks noGrp="1"/>
+          </p:cNvSpPr>
+          <p:nvPr>
+            <p:ph type="body" idx="3" sz="quarter"/>
+          </p:nvPr>
+        </p:nvSpPr>
+        <p:spPr/>
+        <p:txBody>
+          <a:bodyPr/>
+          <a:lstStyle/>
+          <a:p>
+            <a:r>
+              <a:t>Объяснить, почему жадность — вынужденная необходимость, а не лень разработчиков. Привести аналогию: жадный алгоритм как выбор лучшего хода в шахматах без просчёта всей партии.</a:t>
+            </a:r>
+          </a:p>
+        </p:txBody>
+      </p:sp>
+      <p:sp>
+        <p:nvSpPr>
+          <p:cNvPr id="4" name="Slide Number Placeholder 3"/>
+          <p:cNvSpPr>
+            <a:spLocks noGrp="1"/>
+          </p:cNvSpPr>
+          <p:nvPr>
+            <p:ph type="sldNum" idx="5" sz="quarter"/>
+          </p:nvPr>
+        </p:nvSpPr>
+        <p:spPr/>
+      </p:sp>
+    </p:spTree>
+  </p:cSld>
+  <p:clrMapOvr>
+    <a:masterClrMapping/>
+  </p:clrMapOvr>
+</p:notes>
+</file>
+
+<file path=ppt/notesSlides/notesSlide22.xml><?xml version="1.0" encoding="utf-8"?>
+<p:notes xmlns:a="http://schemas.openxmlformats.org/drawingml/2006/main" xmlns:p="http://schemas.openxmlformats.org/presentationml/2006/main" xmlns:r="http://schemas.openxmlformats.org/officeDocument/2006/relationships">
+  <p:cSld>
+    <p:spTree>
+      <p:nvGrpSpPr>
+        <p:cNvPr id="1" name=""/>
+        <p:cNvGrpSpPr/>
+        <p:nvPr/>
+      </p:nvGrpSpPr>
+      <p:grpSpPr>
+        <a:xfrm>
+          <a:off x="0" y="0"/>
+          <a:ext cx="0" cy="0"/>
+          <a:chOff x="0" y="0"/>
+          <a:chExt cx="0" cy="0"/>
+        </a:xfrm>
+      </p:grpSpPr>
+      <p:sp>
+        <p:nvSpPr>
+          <p:cNvPr id="2" name="Slide Image Placeholder 1"/>
+          <p:cNvSpPr>
+            <a:spLocks noGrp="1"/>
+          </p:cNvSpPr>
+          <p:nvPr>
+            <p:ph type="sldImg" idx="2"/>
+          </p:nvPr>
+        </p:nvSpPr>
+        <p:spPr/>
+      </p:sp>
+      <p:sp>
+        <p:nvSpPr>
+          <p:cNvPr id="3" name="Notes Placeholder 2"/>
+          <p:cNvSpPr>
+            <a:spLocks noGrp="1"/>
+          </p:cNvSpPr>
+          <p:nvPr>
+            <p:ph type="body" idx="3" sz="quarter"/>
+          </p:nvPr>
+        </p:nvSpPr>
+        <p:spPr/>
+        <p:txBody>
+          <a:bodyPr/>
+          <a:lstStyle/>
+          <a:p>
+            <a:r>
+              <a:t>Доказать на примере: два разбиения с одинаковой Misclassification, но разной энтропией/Джини — объяснить, почему второе предпочтительнее.</a:t>
+            </a:r>
+          </a:p>
+        </p:txBody>
+      </p:sp>
+      <p:sp>
+        <p:nvSpPr>
+          <p:cNvPr id="4" name="Slide Number Placeholder 3"/>
+          <p:cNvSpPr>
+            <a:spLocks noGrp="1"/>
+          </p:cNvSpPr>
+          <p:nvPr>
+            <p:ph type="sldNum" idx="5" sz="quarter"/>
+          </p:nvPr>
+        </p:nvSpPr>
+        <p:spPr/>
+      </p:sp>
+    </p:spTree>
+  </p:cSld>
+  <p:clrMapOvr>
+    <a:masterClrMapping/>
+  </p:clrMapOvr>
+</p:notes>
+</file>
+
+<file path=ppt/notesSlides/notesSlide23.xml><?xml version="1.0" encoding="utf-8"?>
+<p:notes xmlns:a="http://schemas.openxmlformats.org/drawingml/2006/main" xmlns:p="http://schemas.openxmlformats.org/presentationml/2006/main" xmlns:r="http://schemas.openxmlformats.org/officeDocument/2006/relationships">
+  <p:cSld>
+    <p:spTree>
+      <p:nvGrpSpPr>
+        <p:cNvPr id="1" name=""/>
+        <p:cNvGrpSpPr/>
+        <p:nvPr/>
+      </p:nvGrpSpPr>
+      <p:grpSpPr>
+        <a:xfrm>
+          <a:off x="0" y="0"/>
+          <a:ext cx="0" cy="0"/>
+          <a:chOff x="0" y="0"/>
+          <a:chExt cx="0" cy="0"/>
+        </a:xfrm>
+      </p:grpSpPr>
+      <p:sp>
+        <p:nvSpPr>
+          <p:cNvPr id="2" name="Slide Image Placeholder 1"/>
+          <p:cNvSpPr>
+            <a:spLocks noGrp="1"/>
+          </p:cNvSpPr>
+          <p:nvPr>
+            <p:ph type="sldImg" idx="2"/>
+          </p:nvPr>
+        </p:nvSpPr>
+        <p:spPr/>
+      </p:sp>
+      <p:sp>
+        <p:nvSpPr>
+          <p:cNvPr id="3" name="Notes Placeholder 2"/>
+          <p:cNvSpPr>
+            <a:spLocks noGrp="1"/>
+          </p:cNvSpPr>
+          <p:nvPr>
+            <p:ph type="body" idx="3" sz="quarter"/>
+          </p:nvPr>
+        </p:nvSpPr>
+        <p:spPr/>
+        <p:txBody>
+          <a:bodyPr/>
+          <a:lstStyle/>
+          <a:p>
+            <a:r>
+              <a:t>Рекомендация: начинать с Gini (быстрее, sklearn по умолчанию), при желании попробовать entropy. Не тратить время на тонкую настройку этого параметра.</a:t>
+            </a:r>
+          </a:p>
+        </p:txBody>
+      </p:sp>
+      <p:sp>
+        <p:nvSpPr>
+          <p:cNvPr id="4" name="Slide Number Placeholder 3"/>
+          <p:cNvSpPr>
+            <a:spLocks noGrp="1"/>
+          </p:cNvSpPr>
+          <p:nvPr>
+            <p:ph type="sldNum" idx="5" sz="quarter"/>
+          </p:nvPr>
+        </p:nvSpPr>
+        <p:spPr/>
+      </p:sp>
+    </p:spTree>
+  </p:cSld>
+  <p:clrMapOvr>
+    <a:masterClrMapping/>
+  </p:clrMapOvr>
+</p:notes>
+</file>
+
 <file path=ppt/notesSlides/notesSlide3.xml><?xml version="1.0" encoding="utf-8"?>
 <p:notes xmlns:a="http://schemas.openxmlformats.org/drawingml/2006/main" xmlns:p="http://schemas.openxmlformats.org/presentationml/2006/main" xmlns:r="http://schemas.openxmlformats.org/officeDocument/2006/relationships">
   <p:cSld>
@@ -1500,7 +1855,7 @@
           <a:lstStyle/>
           <a:p>
             <a:r>
-              <a:t>Показать графики обеих функций для бинарного случая (p от 0 до 1). Обратить внимание, что обе достигают максимума при p=0.5 и минимума при p=0 или 1.</a:t>
+              <a:t>Показать графики обеих функций для бинарного случая (p от 0 до 1). Обе достигают максимума при p=0.5 и минимума при p=0 или 1.</a:t>
             </a:r>
           </a:p>
         </p:txBody>
@@ -1570,7 +1925,7 @@
           <a:lstStyle/>
           <a:p>
             <a:r>
-              <a:t>Подчеркнуть контраст с логистической регрессией, где для K классов нужно обучать K классификаторов или использовать softmax.</a:t>
+              <a:t>Показать графики обеих функций для бинарного случая (p от 0 до 1). Обратить внимание, что обе достигают максимума при p=0.5 и минимума при p=0 или 1.</a:t>
             </a:r>
           </a:p>
         </p:txBody>
@@ -1640,7 +1995,7 @@
           <a:lstStyle/>
           <a:p>
             <a:r>
-              <a:t>Показать пример: если добавить столбец Номер строки от 1 до N, дерево выберет его как лучший признак — он разделит все объекты идеально, но с нулевой обобщающей способностью.</a:t>
+              <a:t>Подчеркнуть контраст с логистической регрессией, где для K классов нужно обучать K классификаторов или использовать softmax.</a:t>
             </a:r>
           </a:p>
         </p:txBody>
@@ -1710,7 +2065,7 @@
           <a:lstStyle/>
           <a:p>
             <a:r>
-              <a:t>Упомянуть: точность (precision), полноту (recall), F1-меру для каждого класса. Показать, как class_weight влияет на выбор разбиения.</a:t>
+              <a:t>Показать пример: если добавить столбец Номер строки от 1 до N, дерево выберет его как лучший признак — он разделит все объекты идеально, но с нулевой обобщающей способностью.</a:t>
             </a:r>
           </a:p>
         </p:txBody>
@@ -4904,7 +5259,7 @@
               </a:defRPr>
             </a:pPr>
             <a:r>
-              <a:t>Оценка качества дерева</a:t>
+              <a:t>Предвзятость дерева: Bias towards high-cardinality features</a:t>
             </a:r>
           </a:p>
         </p:txBody>
@@ -4938,40 +5293,40 @@
               <a:defRPr sz="2000"/>
             </a:pPr>
             <a:r>
-              <a:t>Accuracy недостаточна для несбалансированных данных</a:t>
-            </a:r>
-          </a:p>
-          <a:p>
-            <a:pPr>
-              <a:spcAft>
-                <a:spcPts val="800"/>
-              </a:spcAft>
-              <a:defRPr sz="2000"/>
-            </a:pPr>
-            <a:r>
-              <a:t>Для многоклассовой классификации — микро/макро-усреднение метрик</a:t>
-            </a:r>
-          </a:p>
-          <a:p>
-            <a:pPr>
-              <a:spcAft>
-                <a:spcPts val="800"/>
-              </a:spcAft>
-              <a:defRPr sz="2000"/>
-            </a:pPr>
-            <a:r>
-              <a:t>DecisionTreeClassifier: class_weight=balanced — автоматически увеличивает вес минорных классов при подсчёте impurity</a:t>
-            </a:r>
-          </a:p>
-          <a:p>
-            <a:pPr>
-              <a:spcAft>
-                <a:spcPts val="800"/>
-              </a:spcAft>
-              <a:defRPr sz="2000"/>
-            </a:pPr>
-            <a:r>
-              <a:t>Это частично решает проблему дисбаланса</a:t>
+              <a:t>Дерево склонно выбирать признаки с большим числом уникальных значений (ID, дата рождения, имя)</a:t>
+            </a:r>
+          </a:p>
+          <a:p>
+            <a:pPr>
+              <a:spcAft>
+                <a:spcPts val="800"/>
+              </a:spcAft>
+              <a:defRPr sz="2000"/>
+            </a:pPr>
+            <a:r>
+              <a:t>Такой признак может идеально разделить выборку — каждому объекту свой лист → переобучение</a:t>
+            </a:r>
+          </a:p>
+          <a:p>
+            <a:pPr>
+              <a:spcAft>
+                <a:spcPts val="800"/>
+              </a:spcAft>
+              <a:defRPr sz="2000"/>
+            </a:pPr>
+            <a:r>
+              <a:t>Решение: Gain Ratio (C4.5), ограничение глубины, min_samples_leaf</a:t>
+            </a:r>
+          </a:p>
+          <a:p>
+            <a:pPr>
+              <a:spcAft>
+                <a:spcPts val="800"/>
+              </a:spcAft>
+              <a:defRPr sz="2000"/>
+            </a:pPr>
+            <a:r>
+              <a:t>Если есть ID или строка-идентификатор — УДАЛИТЕ перед обучением!</a:t>
             </a:r>
           </a:p>
         </p:txBody>
@@ -4985,6 +5340,126 @@
 </file>
 
 <file path=ppt/slides/slide11.xml><?xml version="1.0" encoding="utf-8"?>
+<p:sld xmlns:a="http://schemas.openxmlformats.org/drawingml/2006/main" xmlns:p="http://schemas.openxmlformats.org/presentationml/2006/main" xmlns:r="http://schemas.openxmlformats.org/officeDocument/2006/relationships">
+  <p:cSld>
+    <p:spTree>
+      <p:nvGrpSpPr>
+        <p:cNvPr id="1" name=""/>
+        <p:cNvGrpSpPr/>
+        <p:nvPr/>
+      </p:nvGrpSpPr>
+      <p:grpSpPr/>
+      <p:sp>
+        <p:nvSpPr>
+          <p:cNvPr id="2" name="TextBox 1"/>
+          <p:cNvSpPr txBox="1"/>
+          <p:nvPr/>
+        </p:nvSpPr>
+        <p:spPr>
+          <a:xfrm>
+            <a:off x="457200" y="274320"/>
+            <a:ext cx="11247120" cy="914400"/>
+          </a:xfrm>
+          <a:prstGeom prst="rect">
+            <a:avLst/>
+          </a:prstGeom>
+          <a:noFill/>
+        </p:spPr>
+        <p:txBody>
+          <a:bodyPr wrap="square">
+            <a:spAutoFit/>
+          </a:bodyPr>
+          <a:lstStyle/>
+          <a:p>
+            <a:pPr>
+              <a:defRPr sz="3200" b="1">
+                <a:solidFill>
+                  <a:srgbClr val="1A1A2E"/>
+                </a:solidFill>
+              </a:defRPr>
+            </a:pPr>
+            <a:r>
+              <a:t>Оценка качества дерева</a:t>
+            </a:r>
+          </a:p>
+        </p:txBody>
+      </p:sp>
+      <p:sp>
+        <p:nvSpPr>
+          <p:cNvPr id="3" name="TextBox 2"/>
+          <p:cNvSpPr txBox="1"/>
+          <p:nvPr/>
+        </p:nvSpPr>
+        <p:spPr>
+          <a:xfrm>
+            <a:off x="640080" y="1371600"/>
+            <a:ext cx="6858000" cy="5029200"/>
+          </a:xfrm>
+          <a:prstGeom prst="rect">
+            <a:avLst/>
+          </a:prstGeom>
+          <a:noFill/>
+        </p:spPr>
+        <p:txBody>
+          <a:bodyPr wrap="square">
+            <a:spAutoFit/>
+          </a:bodyPr>
+          <a:lstStyle/>
+          <a:p>
+            <a:pPr>
+              <a:spcAft>
+                <a:spcPts val="800"/>
+              </a:spcAft>
+              <a:defRPr sz="2000"/>
+            </a:pPr>
+            <a:r>
+              <a:t>Accuracy недостаточна для несбалансированных данных</a:t>
+            </a:r>
+          </a:p>
+          <a:p>
+            <a:pPr>
+              <a:spcAft>
+                <a:spcPts val="800"/>
+              </a:spcAft>
+              <a:defRPr sz="2000"/>
+            </a:pPr>
+            <a:r>
+              <a:t>Для многоклассовой классификации — микро/макро-усреднение метрик</a:t>
+            </a:r>
+          </a:p>
+          <a:p>
+            <a:pPr>
+              <a:spcAft>
+                <a:spcPts val="800"/>
+              </a:spcAft>
+              <a:defRPr sz="2000"/>
+            </a:pPr>
+            <a:r>
+              <a:t>DecisionTreeClassifier: class_weight=balanced — автоматически увеличивает вес минорных классов при подсчёте impurity</a:t>
+            </a:r>
+          </a:p>
+          <a:p>
+            <a:pPr>
+              <a:spcAft>
+                <a:spcPts val="800"/>
+              </a:spcAft>
+              <a:defRPr sz="2000"/>
+            </a:pPr>
+            <a:r>
+              <a:t>Это частично решает проблему дисбаланса</a:t>
+            </a:r>
+          </a:p>
+        </p:txBody>
+      </p:sp>
+    </p:spTree>
+  </p:cSld>
+  <p:clrMapOvr>
+    <a:masterClrMapping/>
+  </p:clrMapOvr>
+</p:sld>
+</file>
+
+<file path=ppt/slides/slide12.xml><?xml version="1.0" encoding="utf-8"?>
 <p:sld xmlns:a="http://schemas.openxmlformats.org/drawingml/2006/main" xmlns:p="http://schemas.openxmlformats.org/presentationml/2006/main" xmlns:r="http://schemas.openxmlformats.org/officeDocument/2006/relationships">
   <p:cSld>
     <p:spTree>
@@ -5139,7 +5614,7 @@
 </p:sld>
 </file>
 
-<file path=ppt/slides/slide12.xml><?xml version="1.0" encoding="utf-8"?>
+<file path=ppt/slides/slide13.xml><?xml version="1.0" encoding="utf-8"?>
 <p:sld xmlns:a="http://schemas.openxmlformats.org/drawingml/2006/main" xmlns:p="http://schemas.openxmlformats.org/presentationml/2006/main" xmlns:r="http://schemas.openxmlformats.org/officeDocument/2006/relationships">
   <p:cSld>
     <p:spTree>
@@ -5259,7 +5734,7 @@
 </p:sld>
 </file>
 
-<file path=ppt/slides/slide13.xml><?xml version="1.0" encoding="utf-8"?>
+<file path=ppt/slides/slide14.xml><?xml version="1.0" encoding="utf-8"?>
 <p:sld xmlns:a="http://schemas.openxmlformats.org/drawingml/2006/main" xmlns:p="http://schemas.openxmlformats.org/presentationml/2006/main" xmlns:r="http://schemas.openxmlformats.org/officeDocument/2006/relationships">
   <p:cSld>
     <p:spTree>
@@ -5392,7 +5867,7 @@
 </p:sld>
 </file>
 
-<file path=ppt/slides/slide14.xml><?xml version="1.0" encoding="utf-8"?>
+<file path=ppt/slides/slide15.xml><?xml version="1.0" encoding="utf-8"?>
 <p:sld xmlns:a="http://schemas.openxmlformats.org/drawingml/2006/main" xmlns:p="http://schemas.openxmlformats.org/presentationml/2006/main" xmlns:r="http://schemas.openxmlformats.org/officeDocument/2006/relationships">
   <p:cSld>
     <p:spTree>
@@ -5500,137 +5975,6 @@
             </a:pPr>
             <a:r>
               <a:t>Выбросы: дерево не чувствительно к выбросам в X, но чувствительно к выбросам в y — лучше чистить данные или использовать MAE</a:t>
-            </a:r>
-          </a:p>
-        </p:txBody>
-      </p:sp>
-    </p:spTree>
-  </p:cSld>
-  <p:clrMapOvr>
-    <a:masterClrMapping/>
-  </p:clrMapOvr>
-</p:sld>
-</file>
-
-<file path=ppt/slides/slide15.xml><?xml version="1.0" encoding="utf-8"?>
-<p:sld xmlns:a="http://schemas.openxmlformats.org/drawingml/2006/main" xmlns:p="http://schemas.openxmlformats.org/presentationml/2006/main" xmlns:r="http://schemas.openxmlformats.org/officeDocument/2006/relationships">
-  <p:cSld>
-    <p:spTree>
-      <p:nvGrpSpPr>
-        <p:cNvPr id="1" name=""/>
-        <p:cNvGrpSpPr/>
-        <p:nvPr/>
-      </p:nvGrpSpPr>
-      <p:grpSpPr/>
-      <p:sp>
-        <p:nvSpPr>
-          <p:cNvPr id="2" name="TextBox 1"/>
-          <p:cNvSpPr txBox="1"/>
-          <p:nvPr/>
-        </p:nvSpPr>
-        <p:spPr>
-          <a:xfrm>
-            <a:off x="457200" y="274320"/>
-            <a:ext cx="11247120" cy="914400"/>
-          </a:xfrm>
-          <a:prstGeom prst="rect">
-            <a:avLst/>
-          </a:prstGeom>
-          <a:noFill/>
-        </p:spPr>
-        <p:txBody>
-          <a:bodyPr wrap="square">
-            <a:spAutoFit/>
-          </a:bodyPr>
-          <a:lstStyle/>
-          <a:p>
-            <a:pPr>
-              <a:defRPr sz="3200" b="1">
-                <a:solidFill>
-                  <a:srgbClr val="1A1A2E"/>
-                </a:solidFill>
-              </a:defRPr>
-            </a:pPr>
-            <a:r>
-              <a:t>Ансамбли деревьев — мостик к следующему занятию</a:t>
-            </a:r>
-          </a:p>
-        </p:txBody>
-      </p:sp>
-      <p:sp>
-        <p:nvSpPr>
-          <p:cNvPr id="3" name="TextBox 2"/>
-          <p:cNvSpPr txBox="1"/>
-          <p:nvPr/>
-        </p:nvSpPr>
-        <p:spPr>
-          <a:xfrm>
-            <a:off x="640080" y="1371600"/>
-            <a:ext cx="6858000" cy="5029200"/>
-          </a:xfrm>
-          <a:prstGeom prst="rect">
-            <a:avLst/>
-          </a:prstGeom>
-          <a:noFill/>
-        </p:spPr>
-        <p:txBody>
-          <a:bodyPr wrap="square">
-            <a:spAutoFit/>
-          </a:bodyPr>
-          <a:lstStyle/>
-          <a:p>
-            <a:pPr>
-              <a:spcAft>
-                <a:spcPts val="800"/>
-              </a:spcAft>
-              <a:defRPr sz="2000"/>
-            </a:pPr>
-            <a:r>
-              <a:t>Одно дерево — нестабильно и склонно к переобучению</a:t>
-            </a:r>
-          </a:p>
-          <a:p>
-            <a:pPr>
-              <a:spcAft>
-                <a:spcPts val="800"/>
-              </a:spcAft>
-              <a:defRPr sz="2000"/>
-            </a:pPr>
-            <a:r>
-              <a:t>Решение: строить много деревьев и усреднять их ответы</a:t>
-            </a:r>
-          </a:p>
-          <a:p>
-            <a:pPr>
-              <a:spcAft>
-                <a:spcPts val="800"/>
-              </a:spcAft>
-              <a:defRPr sz="2000"/>
-            </a:pPr>
-            <a:r>
-              <a:t>Random Forest: случайные подвыборки данных и признаков → независимые деревья → среднее</a:t>
-            </a:r>
-          </a:p>
-          <a:p>
-            <a:pPr>
-              <a:spcAft>
-                <a:spcPts val="800"/>
-              </a:spcAft>
-              <a:defRPr sz="2000"/>
-            </a:pPr>
-            <a:r>
-              <a:t>Gradient Boosting: деревья строятся последовательно, каждое исправляет ошибки предыдущего</a:t>
-            </a:r>
-          </a:p>
-          <a:p>
-            <a:pPr>
-              <a:spcAft>
-                <a:spcPts val="800"/>
-              </a:spcAft>
-              <a:defRPr sz="2000"/>
-            </a:pPr>
-            <a:r>
-              <a:t>Оба подхода используют жадные деревья как слабых учеников</a:t>
             </a:r>
           </a:p>
         </p:txBody>
@@ -5683,7 +6027,7 @@
               </a:defRPr>
             </a:pPr>
             <a:r>
-              <a:t>Визуализация деревьев в sklearn</a:t>
+              <a:t>Ансамбли деревьев — мостик к следующему занятию</a:t>
             </a:r>
           </a:p>
         </p:txBody>
@@ -5717,29 +6061,51 @@
               <a:defRPr sz="2000"/>
             </a:pPr>
             <a:r>
-              <a:t>sklearn.tree.plot_tree(clf, filled=True) — графическое дерево с цветом классов</a:t>
-            </a:r>
-          </a:p>
-          <a:p>
-            <a:pPr>
-              <a:spcAft>
-                <a:spcPts val="800"/>
-              </a:spcAft>
-              <a:defRPr sz="2000"/>
-            </a:pPr>
-            <a:r>
-              <a:t>export_graphviz — экспорт для Graphviz (dot-формат)</a:t>
-            </a:r>
-          </a:p>
-          <a:p>
-            <a:pPr>
-              <a:spcAft>
-                <a:spcPts val="800"/>
-              </a:spcAft>
-              <a:defRPr sz="2000"/>
-            </a:pPr>
-            <a:r>
-              <a:t>export_text — текстовое представление: правила вида X[0] &lt;= 2.5 → class=1</a:t>
+              <a:t>Одно дерево — нестабильно и склонно к переобучению</a:t>
+            </a:r>
+          </a:p>
+          <a:p>
+            <a:pPr>
+              <a:spcAft>
+                <a:spcPts val="800"/>
+              </a:spcAft>
+              <a:defRPr sz="2000"/>
+            </a:pPr>
+            <a:r>
+              <a:t>Решение: строить много деревьев и усреднять их ответы</a:t>
+            </a:r>
+          </a:p>
+          <a:p>
+            <a:pPr>
+              <a:spcAft>
+                <a:spcPts val="800"/>
+              </a:spcAft>
+              <a:defRPr sz="2000"/>
+            </a:pPr>
+            <a:r>
+              <a:t>Random Forest: случайные подвыборки данных и признаков → независимые деревья → среднее</a:t>
+            </a:r>
+          </a:p>
+          <a:p>
+            <a:pPr>
+              <a:spcAft>
+                <a:spcPts val="800"/>
+              </a:spcAft>
+              <a:defRPr sz="2000"/>
+            </a:pPr>
+            <a:r>
+              <a:t>Gradient Boosting: деревья строятся последовательно, каждое исправляет ошибки предыдущего</a:t>
+            </a:r>
+          </a:p>
+          <a:p>
+            <a:pPr>
+              <a:spcAft>
+                <a:spcPts val="800"/>
+              </a:spcAft>
+              <a:defRPr sz="2000"/>
+            </a:pPr>
+            <a:r>
+              <a:t>Оба подхода используют жадные деревья как слабых учеников</a:t>
             </a:r>
           </a:p>
         </p:txBody>
@@ -5753,6 +6119,115 @@
 </file>
 
 <file path=ppt/slides/slide17.xml><?xml version="1.0" encoding="utf-8"?>
+<p:sld xmlns:a="http://schemas.openxmlformats.org/drawingml/2006/main" xmlns:p="http://schemas.openxmlformats.org/presentationml/2006/main" xmlns:r="http://schemas.openxmlformats.org/officeDocument/2006/relationships">
+  <p:cSld>
+    <p:spTree>
+      <p:nvGrpSpPr>
+        <p:cNvPr id="1" name=""/>
+        <p:cNvGrpSpPr/>
+        <p:nvPr/>
+      </p:nvGrpSpPr>
+      <p:grpSpPr/>
+      <p:sp>
+        <p:nvSpPr>
+          <p:cNvPr id="2" name="TextBox 1"/>
+          <p:cNvSpPr txBox="1"/>
+          <p:nvPr/>
+        </p:nvSpPr>
+        <p:spPr>
+          <a:xfrm>
+            <a:off x="457200" y="274320"/>
+            <a:ext cx="11247120" cy="914400"/>
+          </a:xfrm>
+          <a:prstGeom prst="rect">
+            <a:avLst/>
+          </a:prstGeom>
+          <a:noFill/>
+        </p:spPr>
+        <p:txBody>
+          <a:bodyPr wrap="square">
+            <a:spAutoFit/>
+          </a:bodyPr>
+          <a:lstStyle/>
+          <a:p>
+            <a:pPr>
+              <a:defRPr sz="3200" b="1">
+                <a:solidFill>
+                  <a:srgbClr val="1A1A2E"/>
+                </a:solidFill>
+              </a:defRPr>
+            </a:pPr>
+            <a:r>
+              <a:t>Визуализация деревьев в sklearn</a:t>
+            </a:r>
+          </a:p>
+        </p:txBody>
+      </p:sp>
+      <p:sp>
+        <p:nvSpPr>
+          <p:cNvPr id="3" name="TextBox 2"/>
+          <p:cNvSpPr txBox="1"/>
+          <p:nvPr/>
+        </p:nvSpPr>
+        <p:spPr>
+          <a:xfrm>
+            <a:off x="640080" y="1371600"/>
+            <a:ext cx="6858000" cy="5029200"/>
+          </a:xfrm>
+          <a:prstGeom prst="rect">
+            <a:avLst/>
+          </a:prstGeom>
+          <a:noFill/>
+        </p:spPr>
+        <p:txBody>
+          <a:bodyPr wrap="square">
+            <a:spAutoFit/>
+          </a:bodyPr>
+          <a:lstStyle/>
+          <a:p>
+            <a:pPr>
+              <a:spcAft>
+                <a:spcPts val="800"/>
+              </a:spcAft>
+              <a:defRPr sz="2000"/>
+            </a:pPr>
+            <a:r>
+              <a:t>sklearn.tree.plot_tree(clf, filled=True) — графическое дерево с цветом классов</a:t>
+            </a:r>
+          </a:p>
+          <a:p>
+            <a:pPr>
+              <a:spcAft>
+                <a:spcPts val="800"/>
+              </a:spcAft>
+              <a:defRPr sz="2000"/>
+            </a:pPr>
+            <a:r>
+              <a:t>export_graphviz — экспорт для Graphviz (dot-формат)</a:t>
+            </a:r>
+          </a:p>
+          <a:p>
+            <a:pPr>
+              <a:spcAft>
+                <a:spcPts val="800"/>
+              </a:spcAft>
+              <a:defRPr sz="2000"/>
+            </a:pPr>
+            <a:r>
+              <a:t>export_text — текстовое представление: правила вида X[0] &lt;= 2.5 → class=1</a:t>
+            </a:r>
+          </a:p>
+        </p:txBody>
+      </p:sp>
+    </p:spTree>
+  </p:cSld>
+  <p:clrMapOvr>
+    <a:masterClrMapping/>
+  </p:clrMapOvr>
+</p:sld>
+</file>
+
+<file path=ppt/slides/slide18.xml><?xml version="1.0" encoding="utf-8"?>
 <p:sld xmlns:a="http://schemas.openxmlformats.org/drawingml/2006/main" xmlns:p="http://schemas.openxmlformats.org/presentationml/2006/main" xmlns:r="http://schemas.openxmlformats.org/officeDocument/2006/relationships">
   <p:cSld>
     <p:spTree>
@@ -5885,7 +6360,7 @@
 </p:sld>
 </file>
 
-<file path=ppt/slides/slide18.xml><?xml version="1.0" encoding="utf-8"?>
+<file path=ppt/slides/slide19.xml><?xml version="1.0" encoding="utf-8"?>
 <p:sld xmlns:a="http://schemas.openxmlformats.org/drawingml/2006/main" xmlns:p="http://schemas.openxmlformats.org/presentationml/2006/main" xmlns:r="http://schemas.openxmlformats.org/officeDocument/2006/relationships">
   <p:cSld>
     <p:spTree>
@@ -5993,126 +6468,6 @@
             </a:pPr>
             <a:r>
               <a:t>Q: Почему дерево может быть хуже случайного леса? A: Высокая дисперсия — ответ сильно меняется от малых изменений данных</a:t>
-            </a:r>
-          </a:p>
-        </p:txBody>
-      </p:sp>
-    </p:spTree>
-  </p:cSld>
-  <p:clrMapOvr>
-    <a:masterClrMapping/>
-  </p:clrMapOvr>
-</p:sld>
-</file>
-
-<file path=ppt/slides/slide19.xml><?xml version="1.0" encoding="utf-8"?>
-<p:sld xmlns:a="http://schemas.openxmlformats.org/drawingml/2006/main" xmlns:p="http://schemas.openxmlformats.org/presentationml/2006/main" xmlns:r="http://schemas.openxmlformats.org/officeDocument/2006/relationships">
-  <p:cSld>
-    <p:spTree>
-      <p:nvGrpSpPr>
-        <p:cNvPr id="1" name=""/>
-        <p:cNvGrpSpPr/>
-        <p:nvPr/>
-      </p:nvGrpSpPr>
-      <p:grpSpPr/>
-      <p:sp>
-        <p:nvSpPr>
-          <p:cNvPr id="2" name="TextBox 1"/>
-          <p:cNvSpPr txBox="1"/>
-          <p:nvPr/>
-        </p:nvSpPr>
-        <p:spPr>
-          <a:xfrm>
-            <a:off x="457200" y="274320"/>
-            <a:ext cx="11247120" cy="914400"/>
-          </a:xfrm>
-          <a:prstGeom prst="rect">
-            <a:avLst/>
-          </a:prstGeom>
-          <a:noFill/>
-        </p:spPr>
-        <p:txBody>
-          <a:bodyPr wrap="square">
-            <a:spAutoFit/>
-          </a:bodyPr>
-          <a:lstStyle/>
-          <a:p>
-            <a:pPr>
-              <a:defRPr sz="3200" b="1">
-                <a:solidFill>
-                  <a:srgbClr val="1A1A2E"/>
-                </a:solidFill>
-              </a:defRPr>
-            </a:pPr>
-            <a:r>
-              <a:t>Зачем нужно дерево в эпоху нейросетей?</a:t>
-            </a:r>
-          </a:p>
-        </p:txBody>
-      </p:sp>
-      <p:sp>
-        <p:nvSpPr>
-          <p:cNvPr id="3" name="TextBox 2"/>
-          <p:cNvSpPr txBox="1"/>
-          <p:nvPr/>
-        </p:nvSpPr>
-        <p:spPr>
-          <a:xfrm>
-            <a:off x="640080" y="1371600"/>
-            <a:ext cx="6858000" cy="5029200"/>
-          </a:xfrm>
-          <a:prstGeom prst="rect">
-            <a:avLst/>
-          </a:prstGeom>
-          <a:noFill/>
-        </p:spPr>
-        <p:txBody>
-          <a:bodyPr wrap="square">
-            <a:spAutoFit/>
-          </a:bodyPr>
-          <a:lstStyle/>
-          <a:p>
-            <a:pPr>
-              <a:spcAft>
-                <a:spcPts val="800"/>
-              </a:spcAft>
-              <a:defRPr sz="2000"/>
-            </a:pPr>
-            <a:r>
-              <a:t>Скорость и память: работает на слабых устройствах (микроконтроллеры, старые ноутбуки)</a:t>
-            </a:r>
-          </a:p>
-          <a:p>
-            <a:pPr>
-              <a:spcAft>
-                <a:spcPts val="800"/>
-              </a:spcAft>
-              <a:defRPr sz="2000"/>
-            </a:pPr>
-            <a:r>
-              <a:t>Интерпретируемость: решение можно объяснить пошагово (в отличие от нейросети)</a:t>
-            </a:r>
-          </a:p>
-          <a:p>
-            <a:pPr>
-              <a:spcAft>
-                <a:spcPts val="800"/>
-              </a:spcAft>
-              <a:defRPr sz="2000"/>
-            </a:pPr>
-            <a:r>
-              <a:t>Чем лучше логистической регрессии? — ловит нелинейности без ручного создания признаков</a:t>
-            </a:r>
-          </a:p>
-          <a:p>
-            <a:pPr>
-              <a:spcAft>
-                <a:spcPts val="800"/>
-              </a:spcAft>
-              <a:defRPr sz="2000"/>
-            </a:pPr>
-            <a:r>
-              <a:t>Чем лучше KNN? — не нужно хранить все данные; быстрое предсказание (O(log n))</a:t>
             </a:r>
           </a:p>
         </p:txBody>
@@ -6261,6 +6616,650 @@
           </a:prstGeom>
         </p:spPr>
       </p:pic>
+    </p:spTree>
+  </p:cSld>
+  <p:clrMapOvr>
+    <a:masterClrMapping/>
+  </p:clrMapOvr>
+</p:sld>
+</file>
+
+<file path=ppt/slides/slide20.xml><?xml version="1.0" encoding="utf-8"?>
+<p:sld xmlns:a="http://schemas.openxmlformats.org/drawingml/2006/main" xmlns:p="http://schemas.openxmlformats.org/presentationml/2006/main" xmlns:r="http://schemas.openxmlformats.org/officeDocument/2006/relationships">
+  <p:cSld>
+    <p:spTree>
+      <p:nvGrpSpPr>
+        <p:cNvPr id="1" name=""/>
+        <p:cNvGrpSpPr/>
+        <p:nvPr/>
+      </p:nvGrpSpPr>
+      <p:grpSpPr/>
+      <p:sp>
+        <p:nvSpPr>
+          <p:cNvPr id="2" name="TextBox 1"/>
+          <p:cNvSpPr txBox="1"/>
+          <p:nvPr/>
+        </p:nvSpPr>
+        <p:spPr>
+          <a:xfrm>
+            <a:off x="457200" y="274320"/>
+            <a:ext cx="11247120" cy="914400"/>
+          </a:xfrm>
+          <a:prstGeom prst="rect">
+            <a:avLst/>
+          </a:prstGeom>
+          <a:noFill/>
+        </p:spPr>
+        <p:txBody>
+          <a:bodyPr wrap="square">
+            <a:spAutoFit/>
+          </a:bodyPr>
+          <a:lstStyle/>
+          <a:p>
+            <a:pPr>
+              <a:defRPr sz="3200" b="1">
+                <a:solidFill>
+                  <a:srgbClr val="1A1A2E"/>
+                </a:solidFill>
+              </a:defRPr>
+            </a:pPr>
+            <a:r>
+              <a:t>Зачем нужно дерево в эпоху нейросетей?</a:t>
+            </a:r>
+          </a:p>
+        </p:txBody>
+      </p:sp>
+      <p:sp>
+        <p:nvSpPr>
+          <p:cNvPr id="3" name="TextBox 2"/>
+          <p:cNvSpPr txBox="1"/>
+          <p:nvPr/>
+        </p:nvSpPr>
+        <p:spPr>
+          <a:xfrm>
+            <a:off x="640080" y="1371600"/>
+            <a:ext cx="6858000" cy="5029200"/>
+          </a:xfrm>
+          <a:prstGeom prst="rect">
+            <a:avLst/>
+          </a:prstGeom>
+          <a:noFill/>
+        </p:spPr>
+        <p:txBody>
+          <a:bodyPr wrap="square">
+            <a:spAutoFit/>
+          </a:bodyPr>
+          <a:lstStyle/>
+          <a:p>
+            <a:pPr>
+              <a:spcAft>
+                <a:spcPts val="800"/>
+              </a:spcAft>
+              <a:defRPr sz="2000"/>
+            </a:pPr>
+            <a:r>
+              <a:t>Скорость и память: работает на слабых устройствах (микроконтроллеры, старые ноутбуки)</a:t>
+            </a:r>
+          </a:p>
+          <a:p>
+            <a:pPr>
+              <a:spcAft>
+                <a:spcPts val="800"/>
+              </a:spcAft>
+              <a:defRPr sz="2000"/>
+            </a:pPr>
+            <a:r>
+              <a:t>Интерпретируемость: решение можно объяснить пошагово (в отличие от нейросети)</a:t>
+            </a:r>
+          </a:p>
+          <a:p>
+            <a:pPr>
+              <a:spcAft>
+                <a:spcPts val="800"/>
+              </a:spcAft>
+              <a:defRPr sz="2000"/>
+            </a:pPr>
+            <a:r>
+              <a:t>Чем лучше логистической регрессии? — ловит нелинейности без ручного создания признаков</a:t>
+            </a:r>
+          </a:p>
+          <a:p>
+            <a:pPr>
+              <a:spcAft>
+                <a:spcPts val="800"/>
+              </a:spcAft>
+              <a:defRPr sz="2000"/>
+            </a:pPr>
+            <a:r>
+              <a:t>Чем лучше KNN? — не нужно хранить все данные; быстрое предсказание (O(log n))</a:t>
+            </a:r>
+          </a:p>
+        </p:txBody>
+      </p:sp>
+    </p:spTree>
+  </p:cSld>
+  <p:clrMapOvr>
+    <a:masterClrMapping/>
+  </p:clrMapOvr>
+</p:sld>
+</file>
+
+<file path=ppt/slides/slide21.xml><?xml version="1.0" encoding="utf-8"?>
+<p:sld xmlns:a="http://schemas.openxmlformats.org/drawingml/2006/main" xmlns:p="http://schemas.openxmlformats.org/presentationml/2006/main" xmlns:r="http://schemas.openxmlformats.org/officeDocument/2006/relationships">
+  <p:cSld>
+    <p:spTree>
+      <p:nvGrpSpPr>
+        <p:cNvPr id="1" name=""/>
+        <p:cNvGrpSpPr/>
+        <p:nvPr/>
+      </p:nvGrpSpPr>
+      <p:grpSpPr/>
+      <p:sp>
+        <p:nvSpPr>
+          <p:cNvPr id="2" name="TextBox 1"/>
+          <p:cNvSpPr txBox="1"/>
+          <p:nvPr/>
+        </p:nvSpPr>
+        <p:spPr>
+          <a:xfrm>
+            <a:off x="457200" y="274320"/>
+            <a:ext cx="11247120" cy="914400"/>
+          </a:xfrm>
+          <a:prstGeom prst="rect">
+            <a:avLst/>
+          </a:prstGeom>
+          <a:noFill/>
+        </p:spPr>
+        <p:txBody>
+          <a:bodyPr wrap="square">
+            <a:spAutoFit/>
+          </a:bodyPr>
+          <a:lstStyle/>
+          <a:p>
+            <a:pPr>
+              <a:defRPr sz="3200" b="1">
+                <a:solidFill>
+                  <a:srgbClr val="1A1A2E"/>
+                </a:solidFill>
+              </a:defRPr>
+            </a:pPr>
+            <a:r>
+              <a:t>Почему в узле мы выбираем только один признак и только вопросы вида «x &lt; a»?</a:t>
+            </a:r>
+          </a:p>
+        </p:txBody>
+      </p:sp>
+      <p:sp>
+        <p:nvSpPr>
+          <p:cNvPr id="3" name="TextBox 2"/>
+          <p:cNvSpPr txBox="1"/>
+          <p:nvPr/>
+        </p:nvSpPr>
+        <p:spPr>
+          <a:xfrm>
+            <a:off x="640080" y="1371600"/>
+            <a:ext cx="6858000" cy="5029200"/>
+          </a:xfrm>
+          <a:prstGeom prst="rect">
+            <a:avLst/>
+          </a:prstGeom>
+          <a:noFill/>
+        </p:spPr>
+        <p:txBody>
+          <a:bodyPr wrap="square">
+            <a:spAutoFit/>
+          </a:bodyPr>
+          <a:lstStyle/>
+          <a:p>
+            <a:pPr>
+              <a:spcAft>
+                <a:spcPts val="800"/>
+              </a:spcAft>
+              <a:defRPr sz="2000"/>
+            </a:pPr>
+            <a:r>
+              <a:t>Перебор комбинаций признаков в каждом узле вырос бы экспоненциально</a:t>
+            </a:r>
+          </a:p>
+          <a:p>
+            <a:pPr>
+              <a:spcAft>
+                <a:spcPts val="800"/>
+              </a:spcAft>
+              <a:defRPr sz="2000"/>
+            </a:pPr>
+            <a:r>
+              <a:t>Интерпретируемость: простые, понятные правила (если x &lt; a, то …)</a:t>
+            </a:r>
+          </a:p>
+          <a:p>
+            <a:pPr>
+              <a:spcAft>
+                <a:spcPts val="800"/>
+              </a:spcAft>
+              <a:defRPr sz="2000"/>
+            </a:pPr>
+            <a:r>
+              <a:t>Один признак → прямоугольные области, которыми можно приблизить любую функцию (теорема о приближении)</a:t>
+            </a:r>
+          </a:p>
+          <a:p>
+            <a:pPr>
+              <a:spcAft>
+                <a:spcPts val="800"/>
+              </a:spcAft>
+              <a:defRPr sz="2000"/>
+            </a:pPr>
+            <a:r>
+              <a:t>Сложные комбинации в одном узле резко повышают риск переобучения</a:t>
+            </a:r>
+          </a:p>
+          <a:p>
+            <a:pPr>
+              <a:spcAft>
+                <a:spcPts val="800"/>
+              </a:spcAft>
+              <a:defRPr sz="2000"/>
+            </a:pPr>
+            <a:r>
+              <a:t>Исключение: ID3/C4.5 для категориальных признаков допускают небинарные узлы, но каждый узел всё равно соответствует одному признаку</a:t>
+            </a:r>
+          </a:p>
+        </p:txBody>
+      </p:sp>
+    </p:spTree>
+  </p:cSld>
+  <p:clrMapOvr>
+    <a:masterClrMapping/>
+  </p:clrMapOvr>
+</p:sld>
+</file>
+
+<file path=ppt/slides/slide22.xml><?xml version="1.0" encoding="utf-8"?>
+<p:sld xmlns:a="http://schemas.openxmlformats.org/drawingml/2006/main" xmlns:p="http://schemas.openxmlformats.org/presentationml/2006/main" xmlns:r="http://schemas.openxmlformats.org/officeDocument/2006/relationships">
+  <p:cSld>
+    <p:spTree>
+      <p:nvGrpSpPr>
+        <p:cNvPr id="1" name=""/>
+        <p:cNvGrpSpPr/>
+        <p:nvPr/>
+      </p:nvGrpSpPr>
+      <p:grpSpPr/>
+      <p:sp>
+        <p:nvSpPr>
+          <p:cNvPr id="2" name="TextBox 1"/>
+          <p:cNvSpPr txBox="1"/>
+          <p:nvPr/>
+        </p:nvSpPr>
+        <p:spPr>
+          <a:xfrm>
+            <a:off x="457200" y="274320"/>
+            <a:ext cx="11247120" cy="914400"/>
+          </a:xfrm>
+          <a:prstGeom prst="rect">
+            <a:avLst/>
+          </a:prstGeom>
+          <a:noFill/>
+        </p:spPr>
+        <p:txBody>
+          <a:bodyPr wrap="square">
+            <a:spAutoFit/>
+          </a:bodyPr>
+          <a:lstStyle/>
+          <a:p>
+            <a:pPr>
+              <a:defRPr sz="3200" b="1">
+                <a:solidFill>
+                  <a:srgbClr val="1A1A2E"/>
+                </a:solidFill>
+              </a:defRPr>
+            </a:pPr>
+            <a:r>
+              <a:t>Почему мы строим дерево жадно?</a:t>
+            </a:r>
+          </a:p>
+        </p:txBody>
+      </p:sp>
+      <p:sp>
+        <p:nvSpPr>
+          <p:cNvPr id="3" name="TextBox 2"/>
+          <p:cNvSpPr txBox="1"/>
+          <p:nvPr/>
+        </p:nvSpPr>
+        <p:spPr>
+          <a:xfrm>
+            <a:off x="640080" y="1371600"/>
+            <a:ext cx="6858000" cy="5029200"/>
+          </a:xfrm>
+          <a:prstGeom prst="rect">
+            <a:avLst/>
+          </a:prstGeom>
+          <a:noFill/>
+        </p:spPr>
+        <p:txBody>
+          <a:bodyPr wrap="square">
+            <a:spAutoFit/>
+          </a:bodyPr>
+          <a:lstStyle/>
+          <a:p>
+            <a:pPr>
+              <a:spcAft>
+                <a:spcPts val="800"/>
+              </a:spcAft>
+              <a:defRPr sz="2000"/>
+            </a:pPr>
+            <a:r>
+              <a:t>Краткий ответ: это компромисс между качеством, временем и переобучением</a:t>
+            </a:r>
+          </a:p>
+          <a:p>
+            <a:pPr>
+              <a:spcAft>
+                <a:spcPts val="800"/>
+              </a:spcAft>
+              <a:defRPr sz="2000"/>
+            </a:pPr>
+            <a:r>
+              <a:t>Полный перебор оптимального дерева — NP-трудная задача (доказано)</a:t>
+            </a:r>
+          </a:p>
+          <a:p>
+            <a:pPr>
+              <a:spcAft>
+                <a:spcPts val="800"/>
+              </a:spcAft>
+              <a:defRPr sz="2000"/>
+            </a:pPr>
+            <a:r>
+              <a:t>Жадный алгоритм работает за разумное время: O(n_features · n_samples · log n_samples) на узел</a:t>
+            </a:r>
+          </a:p>
+          <a:p>
+            <a:pPr>
+              <a:spcAft>
+                <a:spcPts val="800"/>
+              </a:spcAft>
+              <a:defRPr sz="2000"/>
+            </a:pPr>
+            <a:r>
+              <a:t>Жадность даёт возможность контролировать сложность (остановка, прунинг)</a:t>
+            </a:r>
+          </a:p>
+          <a:p>
+            <a:pPr>
+              <a:spcAft>
+                <a:spcPts val="800"/>
+              </a:spcAft>
+              <a:defRPr sz="2000"/>
+            </a:pPr>
+            <a:r>
+              <a:t>Недостатки жадности становятся достоинствами в ансамблях (Random Forest, Gradient Boosting)</a:t>
+            </a:r>
+          </a:p>
+        </p:txBody>
+      </p:sp>
+    </p:spTree>
+  </p:cSld>
+  <p:clrMapOvr>
+    <a:masterClrMapping/>
+  </p:clrMapOvr>
+</p:sld>
+</file>
+
+<file path=ppt/slides/slide23.xml><?xml version="1.0" encoding="utf-8"?>
+<p:sld xmlns:a="http://schemas.openxmlformats.org/drawingml/2006/main" xmlns:p="http://schemas.openxmlformats.org/presentationml/2006/main" xmlns:r="http://schemas.openxmlformats.org/officeDocument/2006/relationships">
+  <p:cSld>
+    <p:spTree>
+      <p:nvGrpSpPr>
+        <p:cNvPr id="1" name=""/>
+        <p:cNvGrpSpPr/>
+        <p:nvPr/>
+      </p:nvGrpSpPr>
+      <p:grpSpPr/>
+      <p:sp>
+        <p:nvSpPr>
+          <p:cNvPr id="2" name="TextBox 1"/>
+          <p:cNvSpPr txBox="1"/>
+          <p:nvPr/>
+        </p:nvSpPr>
+        <p:spPr>
+          <a:xfrm>
+            <a:off x="457200" y="274320"/>
+            <a:ext cx="11247120" cy="914400"/>
+          </a:xfrm>
+          <a:prstGeom prst="rect">
+            <a:avLst/>
+          </a:prstGeom>
+          <a:noFill/>
+        </p:spPr>
+        <p:txBody>
+          <a:bodyPr wrap="square">
+            <a:spAutoFit/>
+          </a:bodyPr>
+          <a:lstStyle/>
+          <a:p>
+            <a:pPr>
+              <a:defRPr sz="3200" b="1">
+                <a:solidFill>
+                  <a:srgbClr val="1A1A2E"/>
+                </a:solidFill>
+              </a:defRPr>
+            </a:pPr>
+            <a:r>
+              <a:t>Почему нам важна строгая вогнутость, если мы не используем градиенты?</a:t>
+            </a:r>
+          </a:p>
+        </p:txBody>
+      </p:sp>
+      <p:sp>
+        <p:nvSpPr>
+          <p:cNvPr id="3" name="TextBox 2"/>
+          <p:cNvSpPr txBox="1"/>
+          <p:nvPr/>
+        </p:nvSpPr>
+        <p:spPr>
+          <a:xfrm>
+            <a:off x="640080" y="1371600"/>
+            <a:ext cx="6858000" cy="5029200"/>
+          </a:xfrm>
+          <a:prstGeom prst="rect">
+            <a:avLst/>
+          </a:prstGeom>
+          <a:noFill/>
+        </p:spPr>
+        <p:txBody>
+          <a:bodyPr wrap="square">
+            <a:spAutoFit/>
+          </a:bodyPr>
+          <a:lstStyle/>
+          <a:p>
+            <a:pPr>
+              <a:spcAft>
+                <a:spcPts val="800"/>
+              </a:spcAft>
+              <a:defRPr sz="2000"/>
+            </a:pPr>
+            <a:r>
+              <a:t>Гладкость не является причиной (она не обязательна для выбора разбиения)</a:t>
+            </a:r>
+          </a:p>
+          <a:p>
+            <a:pPr>
+              <a:spcAft>
+                <a:spcPts val="800"/>
+              </a:spcAft>
+              <a:defRPr sz="2000"/>
+            </a:pPr>
+            <a:r>
+              <a:t>Проблема Misclassification impurity: она кусочно-линейна, а не строго вогнута</a:t>
+            </a:r>
+          </a:p>
+          <a:p>
+            <a:pPr>
+              <a:spcAft>
+                <a:spcPts val="800"/>
+              </a:spcAft>
+              <a:defRPr sz="2000"/>
+            </a:pPr>
+            <a:r>
+              <a:t>При K ≥ 3 может давать одинаковые значения для разных распределений (например, (0.6, 0.2, 0.2) и (0.6, 0.1, 0.3) → I = 0.4)</a:t>
+            </a:r>
+          </a:p>
+          <a:p>
+            <a:pPr>
+              <a:spcAft>
+                <a:spcPts val="800"/>
+              </a:spcAft>
+              <a:defRPr sz="2000"/>
+            </a:pPr>
+            <a:r>
+              <a:t>Она смотрит только на самый большой класс, игнорируя распределение остальных</a:t>
+            </a:r>
+          </a:p>
+          <a:p>
+            <a:pPr>
+              <a:spcAft>
+                <a:spcPts val="800"/>
+              </a:spcAft>
+              <a:defRPr sz="2000"/>
+            </a:pPr>
+            <a:r>
+              <a:t>Энтропия и Джини строго вогнуты — каждое изменение распределения даёт различный прирост, алгоритм выбирает лучший порог однозначно</a:t>
+            </a:r>
+          </a:p>
+        </p:txBody>
+      </p:sp>
+    </p:spTree>
+  </p:cSld>
+  <p:clrMapOvr>
+    <a:masterClrMapping/>
+  </p:clrMapOvr>
+</p:sld>
+</file>
+
+<file path=ppt/slides/slide24.xml><?xml version="1.0" encoding="utf-8"?>
+<p:sld xmlns:a="http://schemas.openxmlformats.org/drawingml/2006/main" xmlns:p="http://schemas.openxmlformats.org/presentationml/2006/main" xmlns:r="http://schemas.openxmlformats.org/officeDocument/2006/relationships">
+  <p:cSld>
+    <p:spTree>
+      <p:nvGrpSpPr>
+        <p:cNvPr id="1" name=""/>
+        <p:cNvGrpSpPr/>
+        <p:nvPr/>
+      </p:nvGrpSpPr>
+      <p:grpSpPr/>
+      <p:sp>
+        <p:nvSpPr>
+          <p:cNvPr id="2" name="TextBox 1"/>
+          <p:cNvSpPr txBox="1"/>
+          <p:nvPr/>
+        </p:nvSpPr>
+        <p:spPr>
+          <a:xfrm>
+            <a:off x="457200" y="274320"/>
+            <a:ext cx="11247120" cy="914400"/>
+          </a:xfrm>
+          <a:prstGeom prst="rect">
+            <a:avLst/>
+          </a:prstGeom>
+          <a:noFill/>
+        </p:spPr>
+        <p:txBody>
+          <a:bodyPr wrap="square">
+            <a:spAutoFit/>
+          </a:bodyPr>
+          <a:lstStyle/>
+          <a:p>
+            <a:pPr>
+              <a:defRPr sz="3200" b="1">
+                <a:solidFill>
+                  <a:srgbClr val="1A1A2E"/>
+                </a:solidFill>
+              </a:defRPr>
+            </a:pPr>
+            <a:r>
+              <a:t>Джини или энтропия?</a:t>
+            </a:r>
+          </a:p>
+        </p:txBody>
+      </p:sp>
+      <p:sp>
+        <p:nvSpPr>
+          <p:cNvPr id="3" name="TextBox 2"/>
+          <p:cNvSpPr txBox="1"/>
+          <p:nvPr/>
+        </p:nvSpPr>
+        <p:spPr>
+          <a:xfrm>
+            <a:off x="640080" y="1371600"/>
+            <a:ext cx="6858000" cy="5029200"/>
+          </a:xfrm>
+          <a:prstGeom prst="rect">
+            <a:avLst/>
+          </a:prstGeom>
+          <a:noFill/>
+        </p:spPr>
+        <p:txBody>
+          <a:bodyPr wrap="square">
+            <a:spAutoFit/>
+          </a:bodyPr>
+          <a:lstStyle/>
+          <a:p>
+            <a:pPr>
+              <a:spcAft>
+                <a:spcPts val="800"/>
+              </a:spcAft>
+              <a:defRPr sz="2000"/>
+            </a:pPr>
+            <a:r>
+              <a:t>Джини считается быстрее (только квадраты), энтропия требует логарифмов, но разница несущественна</a:t>
+            </a:r>
+          </a:p>
+          <a:p>
+            <a:pPr>
+              <a:spcAft>
+                <a:spcPts val="800"/>
+              </a:spcAft>
+              <a:defRPr sz="2000"/>
+            </a:pPr>
+            <a:r>
+              <a:t>Энтропия имеет удобную информационную интерпретацию (среднее количество бит)</a:t>
+            </a:r>
+          </a:p>
+          <a:p>
+            <a:pPr>
+              <a:spcAft>
+                <a:spcPts val="800"/>
+              </a:spcAft>
+              <a:defRPr sz="2000"/>
+            </a:pPr>
+            <a:r>
+              <a:t>Джини — квадратичное приближение энтропии вблизи равномерного распределения, результаты обычно очень похожи</a:t>
+            </a:r>
+          </a:p>
+          <a:p>
+            <a:pPr>
+              <a:spcAft>
+                <a:spcPts val="800"/>
+              </a:spcAft>
+              <a:defRPr sz="2000"/>
+            </a:pPr>
+            <a:r>
+              <a:t>Вблизи чистых узлов (p_k ≈ 1) энтропия сильнее «штрафует» за появление редкого класса</a:t>
+            </a:r>
+          </a:p>
+          <a:p>
+            <a:pPr>
+              <a:spcAft>
+                <a:spcPts val="800"/>
+              </a:spcAft>
+              <a:defRPr sz="2000"/>
+            </a:pPr>
+            <a:r>
+              <a:t>На практике выбор между ними редко критичен — деревья получаются почти одинаковыми</a:t>
+            </a:r>
+          </a:p>
+        </p:txBody>
+      </p:sp>
     </p:spTree>
   </p:cSld>
   <p:clrMapOvr>
@@ -6895,6 +7894,137 @@
               </a:defRPr>
             </a:pPr>
             <a:r>
+              <a:t>Альтернатива: энтропия и индекс Джини</a:t>
+            </a:r>
+          </a:p>
+        </p:txBody>
+      </p:sp>
+      <p:sp>
+        <p:nvSpPr>
+          <p:cNvPr id="3" name="TextBox 2"/>
+          <p:cNvSpPr txBox="1"/>
+          <p:nvPr/>
+        </p:nvSpPr>
+        <p:spPr>
+          <a:xfrm>
+            <a:off x="640080" y="1371600"/>
+            <a:ext cx="6858000" cy="5029200"/>
+          </a:xfrm>
+          <a:prstGeom prst="rect">
+            <a:avLst/>
+          </a:prstGeom>
+          <a:noFill/>
+        </p:spPr>
+        <p:txBody>
+          <a:bodyPr wrap="square">
+            <a:spAutoFit/>
+          </a:bodyPr>
+          <a:lstStyle/>
+          <a:p>
+            <a:pPr>
+              <a:spcAft>
+                <a:spcPts val="800"/>
+              </a:spcAft>
+              <a:defRPr sz="2000"/>
+            </a:pPr>
+            <a:r>
+              <a:t>Энтропия: H = -∑ p_k · log₂(p_k)</a:t>
+            </a:r>
+          </a:p>
+          <a:p>
+            <a:pPr>
+              <a:spcAft>
+                <a:spcPts val="800"/>
+              </a:spcAft>
+              <a:defRPr sz="2000"/>
+            </a:pPr>
+            <a:r>
+              <a:t>Индекс Джини: G = ∑ p_k · (1-p_k) = 1 - ∑ p_k²</a:t>
+            </a:r>
+          </a:p>
+          <a:p>
+            <a:pPr>
+              <a:spcAft>
+                <a:spcPts val="800"/>
+              </a:spcAft>
+              <a:defRPr sz="2000"/>
+            </a:pPr>
+            <a:r>
+              <a:t>Обе функции строго вогнуты — учитывают распределение всех классов</a:t>
+            </a:r>
+          </a:p>
+          <a:p>
+            <a:pPr>
+              <a:spcAft>
+                <a:spcPts val="800"/>
+              </a:spcAft>
+              <a:defRPr sz="2000"/>
+            </a:pPr>
+            <a:r>
+              <a:t>Именно их используют на практике (sklearn: criterion='gini' или 'entropy')</a:t>
+            </a:r>
+          </a:p>
+          <a:p>
+            <a:pPr>
+              <a:spcAft>
+                <a:spcPts val="800"/>
+              </a:spcAft>
+              <a:defRPr sz="2000"/>
+            </a:pPr>
+            <a:r>
+              <a:t>Почему они лучше Misclassification — объясним позже</a:t>
+            </a:r>
+          </a:p>
+        </p:txBody>
+      </p:sp>
+    </p:spTree>
+  </p:cSld>
+  <p:clrMapOvr>
+    <a:masterClrMapping/>
+  </p:clrMapOvr>
+</p:sld>
+</file>
+
+<file path=ppt/slides/slide8.xml><?xml version="1.0" encoding="utf-8"?>
+<p:sld xmlns:a="http://schemas.openxmlformats.org/drawingml/2006/main" xmlns:p="http://schemas.openxmlformats.org/presentationml/2006/main" xmlns:r="http://schemas.openxmlformats.org/officeDocument/2006/relationships">
+  <p:cSld>
+    <p:spTree>
+      <p:nvGrpSpPr>
+        <p:cNvPr id="1" name=""/>
+        <p:cNvGrpSpPr/>
+        <p:nvPr/>
+      </p:nvGrpSpPr>
+      <p:grpSpPr/>
+      <p:sp>
+        <p:nvSpPr>
+          <p:cNvPr id="2" name="TextBox 1"/>
+          <p:cNvSpPr txBox="1"/>
+          <p:nvPr/>
+        </p:nvSpPr>
+        <p:spPr>
+          <a:xfrm>
+            <a:off x="457200" y="274320"/>
+            <a:ext cx="11247120" cy="914400"/>
+          </a:xfrm>
+          <a:prstGeom prst="rect">
+            <a:avLst/>
+          </a:prstGeom>
+          <a:noFill/>
+        </p:spPr>
+        <p:txBody>
+          <a:bodyPr wrap="square">
+            <a:spAutoFit/>
+          </a:bodyPr>
+          <a:lstStyle/>
+          <a:p>
+            <a:pPr>
+              <a:defRPr sz="3200" b="1">
+                <a:solidFill>
+                  <a:srgbClr val="1A1A2E"/>
+                </a:solidFill>
+              </a:defRPr>
+            </a:pPr>
+            <a:r>
               <a:t>Энтропия и индекс Джини</a:t>
             </a:r>
           </a:p>
@@ -7010,7 +8140,7 @@
 </p:sld>
 </file>
 
-<file path=ppt/slides/slide8.xml><?xml version="1.0" encoding="utf-8"?>
+<file path=ppt/slides/slide9.xml><?xml version="1.0" encoding="utf-8"?>
 <p:sld xmlns:a="http://schemas.openxmlformats.org/drawingml/2006/main" xmlns:p="http://schemas.openxmlformats.org/presentationml/2006/main" xmlns:r="http://schemas.openxmlformats.org/officeDocument/2006/relationships">
   <p:cSld>
     <p:spTree>
@@ -7118,126 +8248,6 @@
             </a:pPr>
             <a:r>
               <a:t>Никаких one-vs-rest, никаких дополнительных моделей</a:t>
-            </a:r>
-          </a:p>
-        </p:txBody>
-      </p:sp>
-    </p:spTree>
-  </p:cSld>
-  <p:clrMapOvr>
-    <a:masterClrMapping/>
-  </p:clrMapOvr>
-</p:sld>
-</file>
-
-<file path=ppt/slides/slide9.xml><?xml version="1.0" encoding="utf-8"?>
-<p:sld xmlns:a="http://schemas.openxmlformats.org/drawingml/2006/main" xmlns:p="http://schemas.openxmlformats.org/presentationml/2006/main" xmlns:r="http://schemas.openxmlformats.org/officeDocument/2006/relationships">
-  <p:cSld>
-    <p:spTree>
-      <p:nvGrpSpPr>
-        <p:cNvPr id="1" name=""/>
-        <p:cNvGrpSpPr/>
-        <p:nvPr/>
-      </p:nvGrpSpPr>
-      <p:grpSpPr/>
-      <p:sp>
-        <p:nvSpPr>
-          <p:cNvPr id="2" name="TextBox 1"/>
-          <p:cNvSpPr txBox="1"/>
-          <p:nvPr/>
-        </p:nvSpPr>
-        <p:spPr>
-          <a:xfrm>
-            <a:off x="457200" y="274320"/>
-            <a:ext cx="11247120" cy="914400"/>
-          </a:xfrm>
-          <a:prstGeom prst="rect">
-            <a:avLst/>
-          </a:prstGeom>
-          <a:noFill/>
-        </p:spPr>
-        <p:txBody>
-          <a:bodyPr wrap="square">
-            <a:spAutoFit/>
-          </a:bodyPr>
-          <a:lstStyle/>
-          <a:p>
-            <a:pPr>
-              <a:defRPr sz="3200" b="1">
-                <a:solidFill>
-                  <a:srgbClr val="1A1A2E"/>
-                </a:solidFill>
-              </a:defRPr>
-            </a:pPr>
-            <a:r>
-              <a:t>Предвзятость дерева: Bias towards high-cardinality features</a:t>
-            </a:r>
-          </a:p>
-        </p:txBody>
-      </p:sp>
-      <p:sp>
-        <p:nvSpPr>
-          <p:cNvPr id="3" name="TextBox 2"/>
-          <p:cNvSpPr txBox="1"/>
-          <p:nvPr/>
-        </p:nvSpPr>
-        <p:spPr>
-          <a:xfrm>
-            <a:off x="640080" y="1371600"/>
-            <a:ext cx="6858000" cy="5029200"/>
-          </a:xfrm>
-          <a:prstGeom prst="rect">
-            <a:avLst/>
-          </a:prstGeom>
-          <a:noFill/>
-        </p:spPr>
-        <p:txBody>
-          <a:bodyPr wrap="square">
-            <a:spAutoFit/>
-          </a:bodyPr>
-          <a:lstStyle/>
-          <a:p>
-            <a:pPr>
-              <a:spcAft>
-                <a:spcPts val="800"/>
-              </a:spcAft>
-              <a:defRPr sz="2000"/>
-            </a:pPr>
-            <a:r>
-              <a:t>Дерево склонно выбирать признаки с большим числом уникальных значений (ID, дата рождения, имя)</a:t>
-            </a:r>
-          </a:p>
-          <a:p>
-            <a:pPr>
-              <a:spcAft>
-                <a:spcPts val="800"/>
-              </a:spcAft>
-              <a:defRPr sz="2000"/>
-            </a:pPr>
-            <a:r>
-              <a:t>Такой признак может идеально разделить выборку — каждому объекту свой лист → переобучение</a:t>
-            </a:r>
-          </a:p>
-          <a:p>
-            <a:pPr>
-              <a:spcAft>
-                <a:spcPts val="800"/>
-              </a:spcAft>
-              <a:defRPr sz="2000"/>
-            </a:pPr>
-            <a:r>
-              <a:t>Решение: Gain Ratio (C4.5), ограничение глубины, min_samples_leaf</a:t>
-            </a:r>
-          </a:p>
-          <a:p>
-            <a:pPr>
-              <a:spcAft>
-                <a:spcPts val="800"/>
-              </a:spcAft>
-              <a:defRPr sz="2000"/>
-            </a:pPr>
-            <a:r>
-              <a:t>Если есть ID или строка-идентификатор — УДАЛИТЕ перед обучением!</a:t>
             </a:r>
           </a:p>
         </p:txBody>

</xml_diff>

<commit_message>
Remove formula_renderer.py and update presentation.pptx
</commit_message>
<xml_diff>
--- a/lessons/derevo_resheniy/presentation.pptx
+++ b/lessons/derevo_resheniy/presentation.pptx
@@ -7819,17 +7819,6 @@
               <a:defRPr sz="2000"/>
             </a:pPr>
             <a:r>
-              <a:t>I_mis(t) = 1 - max_k p_k, где p_k — доля класса k в узле t</a:t>
-            </a:r>
-          </a:p>
-          <a:p>
-            <a:pPr>
-              <a:spcAft>
-                <a:spcPts val="800"/>
-              </a:spcAft>
-              <a:defRPr sz="2000"/>
-            </a:pPr>
-            <a:r>
               <a:t>Интуиция: если бы мы ответили самым частым классом, какова вероятность ошибки?</a:t>
             </a:r>
           </a:p>
@@ -7843,6 +7832,67 @@
             <a:r>
               <a:t>Простой и интуитивный, но есть недостатки (обсудим на слайде 21)</a:t>
             </a:r>
+          </a:p>
+        </p:txBody>
+      </p:sp>
+      <p:sp>
+        <p:nvSpPr>
+          <p:cNvPr id="4" name="TextBox 3"/>
+          <p:cNvSpPr txBox="1"/>
+          <p:nvPr/>
+        </p:nvSpPr>
+        <p:spPr>
+          <a:xfrm>
+            <a:off x="7772400" y="1371600"/>
+            <a:ext cx="4114800" cy="2286000"/>
+          </a:xfrm>
+          <a:prstGeom prst="rect">
+            <a:avLst/>
+          </a:prstGeom>
+          <a:noFill/>
+        </p:spPr>
+        <p:txBody>
+          <a:bodyPr wrap="square">
+            <a:spAutoFit/>
+          </a:bodyPr>
+          <a:lstStyle/>
+          <a:p>
+            <a:pPr>
+              <a:spcAft>
+                <a:spcPts val="600"/>
+              </a:spcAft>
+              <a:defRPr sz="1600">
+                <a:solidFill>
+                  <a:srgbClr val="555555"/>
+                </a:solidFill>
+              </a:defRPr>
+            </a:pPr>
+            <a:r>
+              <a:t>Misclassification impurity</a:t>
+            </a:r>
+          </a:p>
+          <a:p>
+            <a:pPr>
+              <a:spcAft>
+                <a:spcPts val="1000"/>
+              </a:spcAft>
+            </a:pPr>
+            <ns0:m xmlns:ns0="http://schemas.microsoft.com/office/drawing/2010/main">
+              <ns1:oMath xmlns:ns1="http://schemas.openxmlformats.org/officeDocument/2006/math">
+                <ns1:sSub>
+                  <ns1:e>
+                    <ns1:r>
+                      <ns1:t>I</ns1:t>
+                    </ns1:r>
+                  </ns1:e>
+                  <ns1:sub>
+                    <ns1:r>
+                      <ns1:t>mis</ns1:t>
+                    </ns1:r>
+                  </ns1:sub>
+                </ns1:sSub>
+              </ns1:oMath>
+            </ns0:m>
           </a:p>
         </p:txBody>
       </p:sp>
@@ -7928,28 +7978,6 @@
               <a:defRPr sz="2000"/>
             </a:pPr>
             <a:r>
-              <a:t>Энтропия: H = -∑ p_k · log₂(p_k)</a:t>
-            </a:r>
-          </a:p>
-          <a:p>
-            <a:pPr>
-              <a:spcAft>
-                <a:spcPts val="800"/>
-              </a:spcAft>
-              <a:defRPr sz="2000"/>
-            </a:pPr>
-            <a:r>
-              <a:t>Индекс Джини: G = ∑ p_k · (1-p_k) = 1 - ∑ p_k²</a:t>
-            </a:r>
-          </a:p>
-          <a:p>
-            <a:pPr>
-              <a:spcAft>
-                <a:spcPts val="800"/>
-              </a:spcAft>
-              <a:defRPr sz="2000"/>
-            </a:pPr>
-            <a:r>
               <a:t>Обе функции строго вогнуты — учитывают распределение всех классов</a:t>
             </a:r>
           </a:p>
@@ -7974,6 +8002,72 @@
             <a:r>
               <a:t>Почему они лучше Misclassification — объясним позже</a:t>
             </a:r>
+          </a:p>
+        </p:txBody>
+      </p:sp>
+      <p:sp>
+        <p:nvSpPr>
+          <p:cNvPr id="4" name="TextBox 3"/>
+          <p:cNvSpPr txBox="1"/>
+          <p:nvPr/>
+        </p:nvSpPr>
+        <p:spPr>
+          <a:xfrm>
+            <a:off x="7772400" y="1371600"/>
+            <a:ext cx="4114800" cy="2286000"/>
+          </a:xfrm>
+          <a:prstGeom prst="rect">
+            <a:avLst/>
+          </a:prstGeom>
+          <a:noFill/>
+        </p:spPr>
+        <p:txBody>
+          <a:bodyPr wrap="square">
+            <a:spAutoFit/>
+          </a:bodyPr>
+          <a:lstStyle/>
+          <a:p>
+            <a:pPr>
+              <a:spcAft>
+                <a:spcPts val="600"/>
+              </a:spcAft>
+              <a:defRPr sz="1600">
+                <a:solidFill>
+                  <a:srgbClr val="555555"/>
+                </a:solidFill>
+              </a:defRPr>
+            </a:pPr>
+            <a:r>
+              <a:t>Энтропия и индекс Джини</a:t>
+            </a:r>
+          </a:p>
+          <a:p>
+            <a:pPr>
+              <a:spcAft>
+                <a:spcPts val="1000"/>
+              </a:spcAft>
+            </a:pPr>
+            <ns0:m xmlns:ns0="http://schemas.microsoft.com/office/drawing/2010/main">
+              <ns1:oMath xmlns:ns1="http://schemas.openxmlformats.org/officeDocument/2006/math">
+                <ns1:r>
+                  <ns1:t>H=−</ns1:t>
+                </ns1:r>
+              </ns1:oMath>
+            </ns0:m>
+          </a:p>
+          <a:p>
+            <a:pPr>
+              <a:spcAft>
+                <a:spcPts val="1000"/>
+              </a:spcAft>
+            </a:pPr>
+            <ns0:m xmlns:ns0="http://schemas.microsoft.com/office/drawing/2010/main">
+              <ns1:oMath xmlns:ns1="http://schemas.openxmlformats.org/officeDocument/2006/math">
+                <ns1:r>
+                  <ns1:t>G=</ns1:t>
+                </ns1:r>
+              </ns1:oMath>
+            </ns0:m>
           </a:p>
         </p:txBody>
       </p:sp>

</xml_diff>

<commit_message>
Add reviewer and notebook agents; finalize decision tree lesson.
Introduce lesson_reviewer and notebook_generator with docs and pipeline updates. Refresh derevo_resheniy slides after review, add code.ipynb, and scaffold three new lesson folders.

Co-authored-by: Cursor <cursoragent@cursor.com>
</commit_message>
<xml_diff>
--- a/lessons/derevo_resheniy/presentation.pptx
+++ b/lessons/derevo_resheniy/presentation.pptx
@@ -1155,7 +1155,7 @@
           <a:lstStyle/>
           <a:p>
             <a:r>
-              <a:t>Можно раздать как памятку или вывести на экран во время обсуждения.</a:t>
+              <a:t>Обсудить компромисс: точность vs интерпретируемость. Где важна объяснимость (медицина, кредитный скоринг) — дерево может быть предпочтительнее нейросети.</a:t>
             </a:r>
           </a:p>
         </p:txBody>
@@ -1225,7 +1225,7 @@
           <a:lstStyle/>
           <a:p>
             <a:r>
-              <a:t>Обсудить компромисс: точность vs интерпретируемость. Где важна объяснимость (медицина, кредитный скоринг) — дерево может быть предпочтительнее нейросети.</a:t>
+              <a:t>Показать пример: номинативный признак «цвет» с Label Encoding ломает интерпретацию дерева.</a:t>
             </a:r>
           </a:p>
         </p:txBody>
@@ -1435,7 +1435,7 @@
           <a:lstStyle/>
           <a:p>
             <a:r>
-              <a:t>Объяснить, почему жадность — вынужденная необходимость, а не лень разработчиков. Привести аналогию: жадный алгоритм как выбор лучшего хода в шахматах без просчёта всей партии.</a:t>
+              <a:t>Аналогия: жадный ход в шахматах без просчёта всей партии. Жадность — вынужденная необходимость, не «лень разработчиков».</a:t>
             </a:r>
           </a:p>
         </p:txBody>
@@ -1505,7 +1505,7 @@
           <a:lstStyle/>
           <a:p>
             <a:r>
-              <a:t>Доказать на примере: два разбиения с одинаковой Misclassification, но разной энтропией/Джини — объяснить, почему второе предпочтительнее.</a:t>
+              <a:t>На доске: два разбиения с одинаковой misclassification, но разной энтропией — почему второе предпочтительнее. Подчеркнуть: важна именно строгая вогнутость, а не «выпуклость».</a:t>
             </a:r>
           </a:p>
         </p:txBody>
@@ -1575,7 +1575,7 @@
           <a:lstStyle/>
           <a:p>
             <a:r>
-              <a:t>Рекомендация: начинать с Gini (быстрее, sklearn по умолчанию), при желании попробовать entropy. Не тратить время на тонкую настройку этого параметра.</a:t>
+              <a:t>Краткое резюме. Можно пропустить при нехватке времени — суть уже на предыдущем слайде.</a:t>
             </a:r>
           </a:p>
         </p:txBody>
@@ -1925,7 +1925,7 @@
           <a:lstStyle/>
           <a:p>
             <a:r>
-              <a:t>Показать графики обеих функций для бинарного случая (p от 0 до 1). Обратить внимание, что обе достигают максимума при p=0.5 и минимума при p=0 или 1.</a:t>
+              <a:t>Краткая историческая справка: от ID3 к промышленным библиотекам.</a:t>
             </a:r>
           </a:p>
         </p:txBody>
@@ -1995,7 +1995,7 @@
           <a:lstStyle/>
           <a:p>
             <a:r>
-              <a:t>Подчеркнуть контраст с логистической регрессией, где для K классов нужно обучать K классификаторов или использовать softmax.</a:t>
+              <a:t>Контраст: softmax — одна линейная модель, но другая архитектура; дерево — другой принцип разбиений.</a:t>
             </a:r>
           </a:p>
         </p:txBody>
@@ -5251,14 +5251,12 @@
           </a:bodyPr>
           <a:lstStyle/>
           <a:p>
-            <a:pPr>
-              <a:defRPr sz="3200" b="1">
+            <a:r>
+              <a:rPr lang="ru-RU" dirty="0" sz="3200" b="1">
                 <a:solidFill>
                   <a:srgbClr val="1A1A2E"/>
                 </a:solidFill>
-              </a:defRPr>
-            </a:pPr>
-            <a:r>
+              </a:rPr>
               <a:t>Предвзятость дерева: Bias towards high-cardinality features</a:t>
             </a:r>
           </a:p>
@@ -5273,7 +5271,7 @@
         <p:spPr>
           <a:xfrm>
             <a:off x="640080" y="1371600"/>
-            <a:ext cx="6858000" cy="5029200"/>
+            <a:ext cx="11247120" cy="5029200"/>
           </a:xfrm>
           <a:prstGeom prst="rect">
             <a:avLst/>
@@ -5290,9 +5288,13 @@
               <a:spcAft>
                 <a:spcPts val="800"/>
               </a:spcAft>
-              <a:defRPr sz="2000"/>
-            </a:pPr>
-            <a:r>
+            </a:pPr>
+            <a:r>
+              <a:rPr lang="ru-RU" dirty="0" sz="2000">
+                <a:solidFill>
+                  <a:srgbClr val="000000"/>
+                </a:solidFill>
+              </a:rPr>
               <a:t>Дерево склонно выбирать признаки с большим числом уникальных значений (ID, дата рождения, имя)</a:t>
             </a:r>
           </a:p>
@@ -5301,9 +5303,13 @@
               <a:spcAft>
                 <a:spcPts val="800"/>
               </a:spcAft>
-              <a:defRPr sz="2000"/>
-            </a:pPr>
-            <a:r>
+            </a:pPr>
+            <a:r>
+              <a:rPr lang="ru-RU" dirty="0" sz="2000">
+                <a:solidFill>
+                  <a:srgbClr val="000000"/>
+                </a:solidFill>
+              </a:rPr>
               <a:t>Такой признак может идеально разделить выборку — каждому объекту свой лист → переобучение</a:t>
             </a:r>
           </a:p>
@@ -5312,10 +5318,14 @@
               <a:spcAft>
                 <a:spcPts val="800"/>
               </a:spcAft>
-              <a:defRPr sz="2000"/>
-            </a:pPr>
-            <a:r>
-              <a:t>Решение: Gain Ratio (C4.5), ограничение глубины, min_samples_leaf</a:t>
+            </a:pPr>
+            <a:r>
+              <a:rPr lang="ru-RU" dirty="0" sz="2000">
+                <a:solidFill>
+                  <a:srgbClr val="000000"/>
+                </a:solidFill>
+              </a:rPr>
+              <a:t>Решение: Gain Ratio в C4.5 (нормирует gain на split information), ограничение глубины, min_samples_leaf</a:t>
             </a:r>
           </a:p>
           <a:p>
@@ -5323,9 +5333,13 @@
               <a:spcAft>
                 <a:spcPts val="800"/>
               </a:spcAft>
-              <a:defRPr sz="2000"/>
-            </a:pPr>
-            <a:r>
+            </a:pPr>
+            <a:r>
+              <a:rPr lang="ru-RU" dirty="0" sz="2000">
+                <a:solidFill>
+                  <a:srgbClr val="000000"/>
+                </a:solidFill>
+              </a:rPr>
               <a:t>Если есть ID или строка-идентификатор — УДАЛИТЕ перед обучением!</a:t>
             </a:r>
           </a:p>
@@ -5371,14 +5385,12 @@
           </a:bodyPr>
           <a:lstStyle/>
           <a:p>
-            <a:pPr>
-              <a:defRPr sz="3200" b="1">
+            <a:r>
+              <a:rPr lang="ru-RU" dirty="0" sz="3200" b="1">
                 <a:solidFill>
                   <a:srgbClr val="1A1A2E"/>
                 </a:solidFill>
-              </a:defRPr>
-            </a:pPr>
-            <a:r>
+              </a:rPr>
               <a:t>Оценка качества дерева</a:t>
             </a:r>
           </a:p>
@@ -5393,7 +5405,7 @@
         <p:spPr>
           <a:xfrm>
             <a:off x="640080" y="1371600"/>
-            <a:ext cx="6858000" cy="5029200"/>
+            <a:ext cx="11247120" cy="5029200"/>
           </a:xfrm>
           <a:prstGeom prst="rect">
             <a:avLst/>
@@ -5410,10 +5422,14 @@
               <a:spcAft>
                 <a:spcPts val="800"/>
               </a:spcAft>
-              <a:defRPr sz="2000"/>
-            </a:pPr>
-            <a:r>
-              <a:t>Accuracy недостаточна для несбалансированных данных</a:t>
+            </a:pPr>
+            <a:r>
+              <a:rPr lang="ru-RU" dirty="0" sz="2000">
+                <a:solidFill>
+                  <a:srgbClr val="000000"/>
+                </a:solidFill>
+              </a:rPr>
+              <a:t>Accuracy недостаточна для несбалансированных данных — смотрите precision, recall, F1 по классам</a:t>
             </a:r>
           </a:p>
           <a:p>
@@ -5421,9 +5437,13 @@
               <a:spcAft>
                 <a:spcPts val="800"/>
               </a:spcAft>
-              <a:defRPr sz="2000"/>
-            </a:pPr>
-            <a:r>
+            </a:pPr>
+            <a:r>
+              <a:rPr lang="ru-RU" dirty="0" sz="2000">
+                <a:solidFill>
+                  <a:srgbClr val="000000"/>
+                </a:solidFill>
+              </a:rPr>
               <a:t>Для многоклассовой классификации — микро/макро-усреднение метрик</a:t>
             </a:r>
           </a:p>
@@ -5432,10 +5452,14 @@
               <a:spcAft>
                 <a:spcPts val="800"/>
               </a:spcAft>
-              <a:defRPr sz="2000"/>
-            </a:pPr>
-            <a:r>
-              <a:t>DecisionTreeClassifier: class_weight=balanced — автоматически увеличивает вес минорных классов при подсчёте impurity</a:t>
+            </a:pPr>
+            <a:r>
+              <a:rPr lang="ru-RU" dirty="0" sz="2000">
+                <a:solidFill>
+                  <a:srgbClr val="000000"/>
+                </a:solidFill>
+              </a:rPr>
+              <a:t>DecisionTreeClassifier: class_weight='balanced' — увеличивает вес минорных классов при подсчёте impurity при построении дерева (не при predict)</a:t>
             </a:r>
           </a:p>
           <a:p>
@@ -5443,9 +5467,13 @@
               <a:spcAft>
                 <a:spcPts val="800"/>
               </a:spcAft>
-              <a:defRPr sz="2000"/>
-            </a:pPr>
-            <a:r>
+            </a:pPr>
+            <a:r>
+              <a:rPr lang="ru-RU" dirty="0" sz="2000">
+                <a:solidFill>
+                  <a:srgbClr val="000000"/>
+                </a:solidFill>
+              </a:rPr>
               <a:t>Это частично решает проблему дисбаланса</a:t>
             </a:r>
           </a:p>
@@ -5491,14 +5519,12 @@
           </a:bodyPr>
           <a:lstStyle/>
           <a:p>
-            <a:pPr>
-              <a:defRPr sz="3200" b="1">
+            <a:r>
+              <a:rPr lang="ru-RU" dirty="0" sz="3200" b="1">
                 <a:solidFill>
                   <a:srgbClr val="1A1A2E"/>
                 </a:solidFill>
-              </a:defRPr>
-            </a:pPr>
-            <a:r>
+              </a:rPr>
               <a:t>Переобучение и его решение</a:t>
             </a:r>
           </a:p>
@@ -5530,9 +5556,13 @@
               <a:spcAft>
                 <a:spcPts val="800"/>
               </a:spcAft>
-              <a:defRPr sz="2000"/>
-            </a:pPr>
-            <a:r>
+            </a:pPr>
+            <a:r>
+              <a:rPr lang="ru-RU" dirty="0" sz="2000">
+                <a:solidFill>
+                  <a:srgbClr val="000000"/>
+                </a:solidFill>
+              </a:rPr>
               <a:t>Переобучение: дерево идеально запоминает шум — accuracy 100% на train, низкая на test</a:t>
             </a:r>
           </a:p>
@@ -5541,9 +5571,13 @@
               <a:spcAft>
                 <a:spcPts val="800"/>
               </a:spcAft>
-              <a:defRPr sz="2000"/>
-            </a:pPr>
-            <a:r>
+            </a:pPr>
+            <a:r>
+              <a:rPr lang="ru-RU" dirty="0" sz="2000">
+                <a:solidFill>
+                  <a:srgbClr val="000000"/>
+                </a:solidFill>
+              </a:rPr>
               <a:t>Нестабильность (высокая дисперсия): малое изменение данных → полностью другое дерево</a:t>
             </a:r>
           </a:p>
@@ -5552,9 +5586,13 @@
               <a:spcAft>
                 <a:spcPts val="800"/>
               </a:spcAft>
-              <a:defRPr sz="2000"/>
-            </a:pPr>
-            <a:r>
+            </a:pPr>
+            <a:r>
+              <a:rPr lang="ru-RU" dirty="0" sz="2000">
+                <a:solidFill>
+                  <a:srgbClr val="000000"/>
+                </a:solidFill>
+              </a:rPr>
               <a:t>Одно дерево — плохая идея в продакшене из-за этой нестабильности</a:t>
             </a:r>
           </a:p>
@@ -5563,9 +5601,13 @@
               <a:spcAft>
                 <a:spcPts val="800"/>
               </a:spcAft>
-              <a:defRPr sz="2000"/>
-            </a:pPr>
-            <a:r>
+            </a:pPr>
+            <a:r>
+              <a:rPr lang="ru-RU" dirty="0" sz="2000">
+                <a:solidFill>
+                  <a:srgbClr val="000000"/>
+                </a:solidFill>
+              </a:rPr>
               <a:t>Оценка: обязательно train/test split! Ошибка на тех же данных — грубейшая ошибка!</a:t>
             </a:r>
           </a:p>
@@ -5574,9 +5616,13 @@
               <a:spcAft>
                 <a:spcPts val="800"/>
               </a:spcAft>
-              <a:defRPr sz="2000"/>
-            </a:pPr>
-            <a:r>
+            </a:pPr>
+            <a:r>
+              <a:rPr lang="ru-RU" dirty="0" sz="2000">
+                <a:solidFill>
+                  <a:srgbClr val="000000"/>
+                </a:solidFill>
+              </a:rPr>
               <a:t>Прунинг (ccp_alpha): вырастить глубокое дерево, затем обрезать ветки с малым приростом качества — эффективнее жёсткого max_depth</a:t>
             </a:r>
           </a:p>
@@ -5646,14 +5692,12 @@
           </a:bodyPr>
           <a:lstStyle/>
           <a:p>
-            <a:pPr>
-              <a:defRPr sz="3200" b="1">
+            <a:r>
+              <a:rPr lang="ru-RU" dirty="0" sz="3200" b="1">
                 <a:solidFill>
                   <a:srgbClr val="1A1A2E"/>
                 </a:solidFill>
-              </a:defRPr>
-            </a:pPr>
-            <a:r>
+              </a:rPr>
               <a:t>Дерево решений в sklearn</a:t>
             </a:r>
           </a:p>
@@ -5668,7 +5712,7 @@
         <p:spPr>
           <a:xfrm>
             <a:off x="640080" y="1371600"/>
-            <a:ext cx="6858000" cy="5029200"/>
+            <a:ext cx="11247120" cy="5029200"/>
           </a:xfrm>
           <a:prstGeom prst="rect">
             <a:avLst/>
@@ -5685,9 +5729,13 @@
               <a:spcAft>
                 <a:spcPts val="800"/>
               </a:spcAft>
-              <a:defRPr sz="2000"/>
-            </a:pPr>
-            <a:r>
+            </a:pPr>
+            <a:r>
+              <a:rPr lang="ru-RU" dirty="0" sz="2000">
+                <a:solidFill>
+                  <a:srgbClr val="000000"/>
+                </a:solidFill>
+              </a:rPr>
               <a:t>clf = DecisionTreeClassifier(max_depth=3, ccp_alpha=0.01, random_state=42)</a:t>
             </a:r>
           </a:p>
@@ -5696,9 +5744,13 @@
               <a:spcAft>
                 <a:spcPts val="800"/>
               </a:spcAft>
-              <a:defRPr sz="2000"/>
-            </a:pPr>
-            <a:r>
+            </a:pPr>
+            <a:r>
+              <a:rPr lang="ru-RU" dirty="0" sz="2000">
+                <a:solidFill>
+                  <a:srgbClr val="000000"/>
+                </a:solidFill>
+              </a:rPr>
               <a:t>clf.fit(X, y)</a:t>
             </a:r>
           </a:p>
@@ -5707,9 +5759,13 @@
               <a:spcAft>
                 <a:spcPts val="800"/>
               </a:spcAft>
-              <a:defRPr sz="2000"/>
-            </a:pPr>
-            <a:r>
+            </a:pPr>
+            <a:r>
+              <a:rPr lang="ru-RU" dirty="0" sz="2000">
+                <a:solidFill>
+                  <a:srgbClr val="000000"/>
+                </a:solidFill>
+              </a:rPr>
               <a:t>Важные параметры: max_depth, min_samples_leaf, ccp_alpha, criterion (gini/entropy)</a:t>
             </a:r>
           </a:p>
@@ -5718,9 +5774,13 @@
               <a:spcAft>
                 <a:spcPts val="800"/>
               </a:spcAft>
-              <a:defRPr sz="2000"/>
-            </a:pPr>
-            <a:r>
+            </a:pPr>
+            <a:r>
+              <a:rPr lang="ru-RU" dirty="0" sz="2000">
+                <a:solidFill>
+                  <a:srgbClr val="000000"/>
+                </a:solidFill>
+              </a:rPr>
               <a:t>Для воспроизводимости: random_state фиксирует случайность при равной информативности разбиений</a:t>
             </a:r>
           </a:p>
@@ -5766,14 +5826,12 @@
           </a:bodyPr>
           <a:lstStyle/>
           <a:p>
-            <a:pPr>
-              <a:defRPr sz="3200" b="1">
+            <a:r>
+              <a:rPr lang="ru-RU" dirty="0" sz="3200" b="1">
                 <a:solidFill>
                   <a:srgbClr val="1A1A2E"/>
                 </a:solidFill>
-              </a:defRPr>
-            </a:pPr>
-            <a:r>
+              </a:rPr>
               <a:t>Интерпретируемость и важность признаков</a:t>
             </a:r>
           </a:p>
@@ -5805,9 +5863,13 @@
               <a:spcAft>
                 <a:spcPts val="800"/>
               </a:spcAft>
-              <a:defRPr sz="2000"/>
-            </a:pPr>
-            <a:r>
+            </a:pPr>
+            <a:r>
+              <a:rPr lang="ru-RU" dirty="0" sz="2000">
+                <a:solidFill>
+                  <a:srgbClr val="000000"/>
+                </a:solidFill>
+              </a:rPr>
               <a:t>Важность признака: суммарное уменьшение impurity во всех узлах, где он используется, взвешенное на число объектов</a:t>
             </a:r>
           </a:p>
@@ -5816,9 +5878,13 @@
               <a:spcAft>
                 <a:spcPts val="800"/>
               </a:spcAft>
-              <a:defRPr sz="2000"/>
-            </a:pPr>
-            <a:r>
+            </a:pPr>
+            <a:r>
+              <a:rPr lang="ru-RU" dirty="0" sz="2000">
+                <a:solidFill>
+                  <a:srgbClr val="000000"/>
+                </a:solidFill>
+              </a:rPr>
               <a:t>Можно отсортировать признаки по важности — понять, что реально влияет</a:t>
             </a:r>
           </a:p>
@@ -5827,9 +5893,13 @@
               <a:spcAft>
                 <a:spcPts val="800"/>
               </a:spcAft>
-              <a:defRPr sz="2000"/>
-            </a:pPr>
-            <a:r>
+            </a:pPr>
+            <a:r>
+              <a:rPr lang="ru-RU" dirty="0" sz="2000">
+                <a:solidFill>
+                  <a:srgbClr val="000000"/>
+                </a:solidFill>
+              </a:rPr>
               <a:t>Важно помнить о bias: модель может выучить несправедливые закономерности (пол, национальность) — дерево их воспроизведёт</a:t>
             </a:r>
           </a:p>
@@ -5899,14 +5969,12 @@
           </a:bodyPr>
           <a:lstStyle/>
           <a:p>
-            <a:pPr>
-              <a:defRPr sz="3200" b="1">
+            <a:r>
+              <a:rPr lang="ru-RU" dirty="0" sz="3200" b="1">
                 <a:solidFill>
                   <a:srgbClr val="1A1A2E"/>
                 </a:solidFill>
-              </a:defRPr>
-            </a:pPr>
-            <a:r>
+              </a:rPr>
               <a:t>Дерево решений для регрессии</a:t>
             </a:r>
           </a:p>
@@ -5921,7 +5989,7 @@
         <p:spPr>
           <a:xfrm>
             <a:off x="640080" y="1371600"/>
-            <a:ext cx="6858000" cy="5029200"/>
+            <a:ext cx="11247120" cy="5029200"/>
           </a:xfrm>
           <a:prstGeom prst="rect">
             <a:avLst/>
@@ -5938,9 +6006,13 @@
               <a:spcAft>
                 <a:spcPts val="800"/>
               </a:spcAft>
-              <a:defRPr sz="2000"/>
-            </a:pPr>
-            <a:r>
+            </a:pPr>
+            <a:r>
+              <a:rPr lang="ru-RU" dirty="0" sz="2000">
+                <a:solidFill>
+                  <a:srgbClr val="000000"/>
+                </a:solidFill>
+              </a:rPr>
               <a:t>Критерий разбиения — MSE (средний квадрат ошибки)</a:t>
             </a:r>
           </a:p>
@@ -5949,9 +6021,13 @@
               <a:spcAft>
                 <a:spcPts val="800"/>
               </a:spcAft>
-              <a:defRPr sz="2000"/>
-            </a:pPr>
-            <a:r>
+            </a:pPr>
+            <a:r>
+              <a:rPr lang="ru-RU" dirty="0" sz="2000">
+                <a:solidFill>
+                  <a:srgbClr val="000000"/>
+                </a:solidFill>
+              </a:rPr>
               <a:t>Значение в листе — среднее арифметическое целевой переменной</a:t>
             </a:r>
           </a:p>
@@ -5960,9 +6036,13 @@
               <a:spcAft>
                 <a:spcPts val="800"/>
               </a:spcAft>
-              <a:defRPr sz="2000"/>
-            </a:pPr>
-            <a:r>
+            </a:pPr>
+            <a:r>
+              <a:rPr lang="ru-RU" dirty="0" sz="2000">
+                <a:solidFill>
+                  <a:srgbClr val="000000"/>
+                </a:solidFill>
+              </a:rPr>
               <a:t>Отличие от классификации: не голосование, а среднее</a:t>
             </a:r>
           </a:p>
@@ -5971,10 +6051,14 @@
               <a:spcAft>
                 <a:spcPts val="800"/>
               </a:spcAft>
-              <a:defRPr sz="2000"/>
-            </a:pPr>
-            <a:r>
-              <a:t>Выбросы: дерево не чувствительно к выбросам в X, но чувствительно к выбросам в y — лучше чистить данные или использовать MAE</a:t>
+            </a:pPr>
+            <a:r>
+              <a:rPr lang="ru-RU" dirty="0" sz="2000">
+                <a:solidFill>
+                  <a:srgbClr val="000000"/>
+                </a:solidFill>
+              </a:rPr>
+              <a:t>Выбросы в y: чувствительны при MSE; в sklearn — DecisionTreeRegressor(criterion='absolute_error') или чистка данных</a:t>
             </a:r>
           </a:p>
         </p:txBody>
@@ -6019,14 +6103,12 @@
           </a:bodyPr>
           <a:lstStyle/>
           <a:p>
-            <a:pPr>
-              <a:defRPr sz="3200" b="1">
+            <a:r>
+              <a:rPr lang="ru-RU" dirty="0" sz="3200" b="1">
                 <a:solidFill>
                   <a:srgbClr val="1A1A2E"/>
                 </a:solidFill>
-              </a:defRPr>
-            </a:pPr>
-            <a:r>
+              </a:rPr>
               <a:t>Ансамбли деревьев — мостик к следующему занятию</a:t>
             </a:r>
           </a:p>
@@ -6041,7 +6123,7 @@
         <p:spPr>
           <a:xfrm>
             <a:off x="640080" y="1371600"/>
-            <a:ext cx="6858000" cy="5029200"/>
+            <a:ext cx="11247120" cy="5029200"/>
           </a:xfrm>
           <a:prstGeom prst="rect">
             <a:avLst/>
@@ -6058,9 +6140,13 @@
               <a:spcAft>
                 <a:spcPts val="800"/>
               </a:spcAft>
-              <a:defRPr sz="2000"/>
-            </a:pPr>
-            <a:r>
+            </a:pPr>
+            <a:r>
+              <a:rPr lang="ru-RU" dirty="0" sz="2000">
+                <a:solidFill>
+                  <a:srgbClr val="000000"/>
+                </a:solidFill>
+              </a:rPr>
               <a:t>Одно дерево — нестабильно и склонно к переобучению</a:t>
             </a:r>
           </a:p>
@@ -6069,9 +6155,13 @@
               <a:spcAft>
                 <a:spcPts val="800"/>
               </a:spcAft>
-              <a:defRPr sz="2000"/>
-            </a:pPr>
-            <a:r>
+            </a:pPr>
+            <a:r>
+              <a:rPr lang="ru-RU" dirty="0" sz="2000">
+                <a:solidFill>
+                  <a:srgbClr val="000000"/>
+                </a:solidFill>
+              </a:rPr>
               <a:t>Решение: строить много деревьев и усреднять их ответы</a:t>
             </a:r>
           </a:p>
@@ -6080,9 +6170,13 @@
               <a:spcAft>
                 <a:spcPts val="800"/>
               </a:spcAft>
-              <a:defRPr sz="2000"/>
-            </a:pPr>
-            <a:r>
+            </a:pPr>
+            <a:r>
+              <a:rPr lang="ru-RU" dirty="0" sz="2000">
+                <a:solidFill>
+                  <a:srgbClr val="000000"/>
+                </a:solidFill>
+              </a:rPr>
               <a:t>Random Forest: случайные подвыборки данных и признаков → независимые деревья → среднее</a:t>
             </a:r>
           </a:p>
@@ -6091,9 +6185,13 @@
               <a:spcAft>
                 <a:spcPts val="800"/>
               </a:spcAft>
-              <a:defRPr sz="2000"/>
-            </a:pPr>
-            <a:r>
+            </a:pPr>
+            <a:r>
+              <a:rPr lang="ru-RU" dirty="0" sz="2000">
+                <a:solidFill>
+                  <a:srgbClr val="000000"/>
+                </a:solidFill>
+              </a:rPr>
               <a:t>Gradient Boosting: деревья строятся последовательно, каждое исправляет ошибки предыдущего</a:t>
             </a:r>
           </a:p>
@@ -6102,9 +6200,13 @@
               <a:spcAft>
                 <a:spcPts val="800"/>
               </a:spcAft>
-              <a:defRPr sz="2000"/>
-            </a:pPr>
-            <a:r>
+            </a:pPr>
+            <a:r>
+              <a:rPr lang="ru-RU" dirty="0" sz="2000">
+                <a:solidFill>
+                  <a:srgbClr val="000000"/>
+                </a:solidFill>
+              </a:rPr>
               <a:t>Оба подхода используют жадные деревья как слабых учеников</a:t>
             </a:r>
           </a:p>
@@ -6150,14 +6252,12 @@
           </a:bodyPr>
           <a:lstStyle/>
           <a:p>
-            <a:pPr>
-              <a:defRPr sz="3200" b="1">
+            <a:r>
+              <a:rPr lang="ru-RU" dirty="0" sz="3200" b="1">
                 <a:solidFill>
                   <a:srgbClr val="1A1A2E"/>
                 </a:solidFill>
-              </a:defRPr>
-            </a:pPr>
-            <a:r>
+              </a:rPr>
               <a:t>Визуализация деревьев в sklearn</a:t>
             </a:r>
           </a:p>
@@ -6172,7 +6272,7 @@
         <p:spPr>
           <a:xfrm>
             <a:off x="640080" y="1371600"/>
-            <a:ext cx="6858000" cy="5029200"/>
+            <a:ext cx="11247120" cy="5029200"/>
           </a:xfrm>
           <a:prstGeom prst="rect">
             <a:avLst/>
@@ -6189,9 +6289,13 @@
               <a:spcAft>
                 <a:spcPts val="800"/>
               </a:spcAft>
-              <a:defRPr sz="2000"/>
-            </a:pPr>
-            <a:r>
+            </a:pPr>
+            <a:r>
+              <a:rPr lang="ru-RU" dirty="0" sz="2000">
+                <a:solidFill>
+                  <a:srgbClr val="000000"/>
+                </a:solidFill>
+              </a:rPr>
               <a:t>sklearn.tree.plot_tree(clf, filled=True) — графическое дерево с цветом классов</a:t>
             </a:r>
           </a:p>
@@ -6200,9 +6304,13 @@
               <a:spcAft>
                 <a:spcPts val="800"/>
               </a:spcAft>
-              <a:defRPr sz="2000"/>
-            </a:pPr>
-            <a:r>
+            </a:pPr>
+            <a:r>
+              <a:rPr lang="ru-RU" dirty="0" sz="2000">
+                <a:solidFill>
+                  <a:srgbClr val="000000"/>
+                </a:solidFill>
+              </a:rPr>
               <a:t>export_graphviz — экспорт для Graphviz (dot-формат)</a:t>
             </a:r>
           </a:p>
@@ -6211,9 +6319,13 @@
               <a:spcAft>
                 <a:spcPts val="800"/>
               </a:spcAft>
-              <a:defRPr sz="2000"/>
-            </a:pPr>
-            <a:r>
+            </a:pPr>
+            <a:r>
+              <a:rPr lang="ru-RU" dirty="0" sz="2000">
+                <a:solidFill>
+                  <a:srgbClr val="000000"/>
+                </a:solidFill>
+              </a:rPr>
               <a:t>export_text — текстовое представление: правила вида X[0] &lt;= 2.5 → class=1</a:t>
             </a:r>
           </a:p>
@@ -6259,14 +6371,12 @@
           </a:bodyPr>
           <a:lstStyle/>
           <a:p>
-            <a:pPr>
-              <a:defRPr sz="3200" b="1">
+            <a:r>
+              <a:rPr lang="ru-RU" dirty="0" sz="3200" b="1">
                 <a:solidFill>
                   <a:srgbClr val="1A1A2E"/>
                 </a:solidFill>
-              </a:defRPr>
-            </a:pPr>
-            <a:r>
+              </a:rPr>
               <a:t>Границы решения: оси-параллельные прямоугольники</a:t>
             </a:r>
           </a:p>
@@ -6298,9 +6408,13 @@
               <a:spcAft>
                 <a:spcPts val="800"/>
               </a:spcAft>
-              <a:defRPr sz="2000"/>
-            </a:pPr>
-            <a:r>
+            </a:pPr>
+            <a:r>
+              <a:rPr lang="ru-RU" dirty="0" sz="2000">
+                <a:solidFill>
+                  <a:srgbClr val="000000"/>
+                </a:solidFill>
+              </a:rPr>
               <a:t>Дерево делит пространство признаков на прямоугольники (оси-параллельные)</a:t>
             </a:r>
           </a:p>
@@ -6309,9 +6423,13 @@
               <a:spcAft>
                 <a:spcPts val="800"/>
               </a:spcAft>
-              <a:defRPr sz="2000"/>
-            </a:pPr>
-            <a:r>
+            </a:pPr>
+            <a:r>
+              <a:rPr lang="ru-RU" dirty="0" sz="2000">
+                <a:solidFill>
+                  <a:srgbClr val="000000"/>
+                </a:solidFill>
+              </a:rPr>
               <a:t>Проблема лестницы: дерево не может провести диагональные или круговые границы</a:t>
             </a:r>
           </a:p>
@@ -6320,9 +6438,13 @@
               <a:spcAft>
                 <a:spcPts val="800"/>
               </a:spcAft>
-              <a:defRPr sz="2000"/>
-            </a:pPr>
-            <a:r>
+            </a:pPr>
+            <a:r>
+              <a:rPr lang="ru-RU" dirty="0" sz="2000">
+                <a:solidFill>
+                  <a:srgbClr val="000000"/>
+                </a:solidFill>
+              </a:rPr>
               <a:t>Для регрессии — кусочно-постоянная аппроксимация (в каждом прямоугольнике — своя константа)</a:t>
             </a:r>
           </a:p>
@@ -6392,15 +6514,13 @@
           </a:bodyPr>
           <a:lstStyle/>
           <a:p>
-            <a:pPr>
-              <a:defRPr sz="3200" b="1">
+            <a:r>
+              <a:rPr lang="ru-RU" dirty="0" sz="3200" b="1">
                 <a:solidFill>
                   <a:srgbClr val="1A1A2E"/>
                 </a:solidFill>
-              </a:defRPr>
-            </a:pPr>
-            <a:r>
-              <a:t>Частые вопросы школьников</a:t>
+              </a:rPr>
+              <a:t>Зачем дерево решений сегодня?</a:t>
             </a:r>
           </a:p>
         </p:txBody>
@@ -6414,7 +6534,7 @@
         <p:spPr>
           <a:xfrm>
             <a:off x="640080" y="1371600"/>
-            <a:ext cx="6858000" cy="5029200"/>
+            <a:ext cx="11247120" cy="5029200"/>
           </a:xfrm>
           <a:prstGeom prst="rect">
             <a:avLst/>
@@ -6431,10 +6551,14 @@
               <a:spcAft>
                 <a:spcPts val="800"/>
               </a:spcAft>
-              <a:defRPr sz="2000"/>
-            </a:pPr>
-            <a:r>
-              <a:t>Q: Дерево всегда находит лучшее разбиение? A: Жадно — локально лучшее, не глобально (NP-трудная задача)</a:t>
+            </a:pPr>
+            <a:r>
+              <a:rPr lang="ru-RU" dirty="0" sz="2000">
+                <a:solidFill>
+                  <a:srgbClr val="000000"/>
+                </a:solidFill>
+              </a:rPr>
+              <a:t>Скорость и память: работает на слабых устройствах (микроконтроллеры, старые ноутбуки)</a:t>
             </a:r>
           </a:p>
           <a:p>
@@ -6442,10 +6566,14 @@
               <a:spcAft>
                 <a:spcPts val="800"/>
               </a:spcAft>
-              <a:defRPr sz="2000"/>
-            </a:pPr>
-            <a:r>
-              <a:t>Q: Почему вопросы только x &lt; a? A: Иначе перебор комбинаций растёт экспоненциально</a:t>
+            </a:pPr>
+            <a:r>
+              <a:rPr lang="ru-RU" dirty="0" sz="2000">
+                <a:solidFill>
+                  <a:srgbClr val="000000"/>
+                </a:solidFill>
+              </a:rPr>
+              <a:t>Интерпретируемость: решение можно объяснить пошагово (в отличие от нейросети)</a:t>
             </a:r>
           </a:p>
           <a:p>
@@ -6453,10 +6581,14 @@
               <a:spcAft>
                 <a:spcPts val="800"/>
               </a:spcAft>
-              <a:defRPr sz="2000"/>
-            </a:pPr>
-            <a:r>
-              <a:t>Q: Что делать с пропусками? A: Заполнять средним/медианой (sklearn не умеет сам)</a:t>
+            </a:pPr>
+            <a:r>
+              <a:rPr lang="ru-RU" dirty="0" sz="2000">
+                <a:solidFill>
+                  <a:srgbClr val="000000"/>
+                </a:solidFill>
+              </a:rPr>
+              <a:t>Чем лучше логистической регрессии? — ловит нелинейности без ручного создания признаков</a:t>
             </a:r>
           </a:p>
           <a:p>
@@ -6464,10 +6596,14 @@
               <a:spcAft>
                 <a:spcPts val="800"/>
               </a:spcAft>
-              <a:defRPr sz="2000"/>
-            </a:pPr>
-            <a:r>
-              <a:t>Q: Почему дерево может быть хуже случайного леса? A: Высокая дисперсия — ответ сильно меняется от малых изменений данных</a:t>
+            </a:pPr>
+            <a:r>
+              <a:rPr lang="ru-RU" dirty="0" sz="2000">
+                <a:solidFill>
+                  <a:srgbClr val="000000"/>
+                </a:solidFill>
+              </a:rPr>
+              <a:t>Чем лучше KNN? — не хранит обучающую выборку; предсказание за O(глубина дерева)</a:t>
             </a:r>
           </a:p>
         </p:txBody>
@@ -6512,14 +6648,12 @@
           </a:bodyPr>
           <a:lstStyle/>
           <a:p>
-            <a:pPr>
-              <a:defRPr sz="3200" b="1">
+            <a:r>
+              <a:rPr lang="ru-RU" dirty="0" sz="3200" b="1">
                 <a:solidFill>
                   <a:srgbClr val="1A1A2E"/>
                 </a:solidFill>
-              </a:defRPr>
-            </a:pPr>
-            <a:r>
+              </a:rPr>
               <a:t>Дерево решений: от игры к математике</a:t>
             </a:r>
           </a:p>
@@ -6551,9 +6685,13 @@
               <a:spcAft>
                 <a:spcPts val="800"/>
               </a:spcAft>
-              <a:defRPr sz="2000"/>
-            </a:pPr>
-            <a:r>
+            </a:pPr>
+            <a:r>
+              <a:rPr lang="ru-RU" dirty="0" sz="2000">
+                <a:solidFill>
+                  <a:srgbClr val="000000"/>
+                </a:solidFill>
+              </a:rPr>
               <a:t>Игра 'Угадай число': последовательность вопросов → структура дерева</a:t>
             </a:r>
           </a:p>
@@ -6562,9 +6700,13 @@
               <a:spcAft>
                 <a:spcPts val="800"/>
               </a:spcAft>
-              <a:defRPr sz="2000"/>
-            </a:pPr>
-            <a:r>
+            </a:pPr>
+            <a:r>
+              <a:rPr lang="ru-RU" dirty="0" sz="2000">
+                <a:solidFill>
+                  <a:srgbClr val="000000"/>
+                </a:solidFill>
+              </a:rPr>
               <a:t>Каждый вопрос разделяет множество вариантов на подмножества</a:t>
             </a:r>
           </a:p>
@@ -6573,9 +6715,13 @@
               <a:spcAft>
                 <a:spcPts val="800"/>
               </a:spcAft>
-              <a:defRPr sz="2000"/>
-            </a:pPr>
-            <a:r>
+            </a:pPr>
+            <a:r>
+              <a:rPr lang="ru-RU" dirty="0" sz="2000">
+                <a:solidFill>
+                  <a:srgbClr val="000000"/>
+                </a:solidFill>
+              </a:rPr>
               <a:t>Дерево: связный ациклический граф с корнем, внутренними узлами (вопросы) и листьями (ответы)</a:t>
             </a:r>
           </a:p>
@@ -6584,9 +6730,13 @@
               <a:spcAft>
                 <a:spcPts val="800"/>
               </a:spcAft>
-              <a:defRPr sz="2000"/>
-            </a:pPr>
-            <a:r>
+            </a:pPr>
+            <a:r>
+              <a:rPr lang="ru-RU" dirty="0" sz="2000">
+                <a:solidFill>
+                  <a:srgbClr val="000000"/>
+                </a:solidFill>
+              </a:rPr>
               <a:t>Глубина дерева — максимальное число вопросов до ответа</a:t>
             </a:r>
           </a:p>
@@ -6656,15 +6806,13 @@
           </a:bodyPr>
           <a:lstStyle/>
           <a:p>
-            <a:pPr>
-              <a:defRPr sz="3200" b="1">
+            <a:r>
+              <a:rPr lang="ru-RU" dirty="0" sz="3200" b="1">
                 <a:solidFill>
                   <a:srgbClr val="1A1A2E"/>
                 </a:solidFill>
-              </a:defRPr>
-            </a:pPr>
-            <a:r>
-              <a:t>Зачем нужно дерево в эпоху нейросетей?</a:t>
+              </a:rPr>
+              <a:t>Какая предобработка нужна деревьям?</a:t>
             </a:r>
           </a:p>
         </p:txBody>
@@ -6678,7 +6826,7 @@
         <p:spPr>
           <a:xfrm>
             <a:off x="640080" y="1371600"/>
-            <a:ext cx="6858000" cy="5029200"/>
+            <a:ext cx="11247120" cy="5029200"/>
           </a:xfrm>
           <a:prstGeom prst="rect">
             <a:avLst/>
@@ -6695,10 +6843,14 @@
               <a:spcAft>
                 <a:spcPts val="800"/>
               </a:spcAft>
-              <a:defRPr sz="2000"/>
-            </a:pPr>
-            <a:r>
-              <a:t>Скорость и память: работает на слабых устройствах (микроконтроллеры, старые ноутбуки)</a:t>
+            </a:pPr>
+            <a:r>
+              <a:rPr lang="ru-RU" dirty="0" sz="2000">
+                <a:solidFill>
+                  <a:srgbClr val="000000"/>
+                </a:solidFill>
+              </a:rPr>
+              <a:t>Нормализация не нужна — масштабирование не меняет порядок значений, структура дерева не изменится</a:t>
             </a:r>
           </a:p>
           <a:p>
@@ -6706,10 +6858,14 @@
               <a:spcAft>
                 <a:spcPts val="800"/>
               </a:spcAft>
-              <a:defRPr sz="2000"/>
-            </a:pPr>
-            <a:r>
-              <a:t>Интерпретируемость: решение можно объяснить пошагово (в отличие от нейросети)</a:t>
+            </a:pPr>
+            <a:r>
+              <a:rPr lang="ru-RU" dirty="0" sz="2000">
+                <a:solidFill>
+                  <a:srgbClr val="000000"/>
+                </a:solidFill>
+              </a:rPr>
+              <a:t>Пропуски нужно заполнять (impute); sklearn DecisionTree не работает с NaN (в отличие от XGBoost)</a:t>
             </a:r>
           </a:p>
           <a:p>
@@ -6717,10 +6873,14 @@
               <a:spcAft>
                 <a:spcPts val="800"/>
               </a:spcAft>
-              <a:defRPr sz="2000"/>
-            </a:pPr>
-            <a:r>
-              <a:t>Чем лучше логистической регрессии? — ловит нелинейности без ручного создания признаков</a:t>
+            </a:pPr>
+            <a:r>
+              <a:rPr lang="ru-RU" dirty="0" sz="2000">
+                <a:solidFill>
+                  <a:srgbClr val="000000"/>
+                </a:solidFill>
+              </a:rPr>
+              <a:t>Категориальные признаки: sklearn не принимает строки — нужно кодирование</a:t>
             </a:r>
           </a:p>
           <a:p>
@@ -6728,10 +6888,44 @@
               <a:spcAft>
                 <a:spcPts val="800"/>
               </a:spcAft>
-              <a:defRPr sz="2000"/>
-            </a:pPr>
-            <a:r>
-              <a:t>Чем лучше KNN? — не нужно хранить все данные; быстрое предсказание (O(log n))</a:t>
+            </a:pPr>
+            <a:r>
+              <a:rPr lang="ru-RU" dirty="0" sz="2000">
+                <a:solidFill>
+                  <a:srgbClr val="000000"/>
+                </a:solidFill>
+              </a:rPr>
+              <a:t>Порядковые категории (младший, средний, старший): Label Encoding (0, 1, 2)</a:t>
+            </a:r>
+          </a:p>
+          <a:p>
+            <a:pPr>
+              <a:spcAft>
+                <a:spcPts val="800"/>
+              </a:spcAft>
+            </a:pPr>
+            <a:r>
+              <a:rPr lang="ru-RU" dirty="0" sz="2000">
+                <a:solidFill>
+                  <a:srgbClr val="000000"/>
+                </a:solidFill>
+              </a:rPr>
+              <a:t>Номинативные (цвет, город, пол): только One-Hot Encoding — иначе вопросы вида «цвет &lt; 2.5» бессмысленны</a:t>
+            </a:r>
+          </a:p>
+          <a:p>
+            <a:pPr>
+              <a:spcAft>
+                <a:spcPts val="800"/>
+              </a:spcAft>
+            </a:pPr>
+            <a:r>
+              <a:rPr lang="ru-RU" dirty="0" sz="2000">
+                <a:solidFill>
+                  <a:srgbClr val="000000"/>
+                </a:solidFill>
+              </a:rPr>
+              <a:t>One-Hot при 100+ категориях — разреженность и замедление; альтернатива — целевое кодирование</a:t>
             </a:r>
           </a:p>
         </p:txBody>
@@ -6776,14 +6970,12 @@
           </a:bodyPr>
           <a:lstStyle/>
           <a:p>
-            <a:pPr>
-              <a:defRPr sz="3200" b="1">
+            <a:r>
+              <a:rPr lang="ru-RU" dirty="0" sz="3200" b="1">
                 <a:solidFill>
                   <a:srgbClr val="1A1A2E"/>
                 </a:solidFill>
-              </a:defRPr>
-            </a:pPr>
-            <a:r>
+              </a:rPr>
               <a:t>Почему в узле мы выбираем только один признак и только вопросы вида «x &lt; a»?</a:t>
             </a:r>
           </a:p>
@@ -6798,7 +6990,7 @@
         <p:spPr>
           <a:xfrm>
             <a:off x="640080" y="1371600"/>
-            <a:ext cx="6858000" cy="5029200"/>
+            <a:ext cx="11247120" cy="5029200"/>
           </a:xfrm>
           <a:prstGeom prst="rect">
             <a:avLst/>
@@ -6815,9 +7007,13 @@
               <a:spcAft>
                 <a:spcPts val="800"/>
               </a:spcAft>
-              <a:defRPr sz="2000"/>
-            </a:pPr>
-            <a:r>
+            </a:pPr>
+            <a:r>
+              <a:rPr lang="ru-RU" dirty="0" sz="2000">
+                <a:solidFill>
+                  <a:srgbClr val="000000"/>
+                </a:solidFill>
+              </a:rPr>
               <a:t>Перебор комбинаций признаков в каждом узле вырос бы экспоненциально</a:t>
             </a:r>
           </a:p>
@@ -6826,9 +7022,13 @@
               <a:spcAft>
                 <a:spcPts val="800"/>
               </a:spcAft>
-              <a:defRPr sz="2000"/>
-            </a:pPr>
-            <a:r>
+            </a:pPr>
+            <a:r>
+              <a:rPr lang="ru-RU" dirty="0" sz="2000">
+                <a:solidFill>
+                  <a:srgbClr val="000000"/>
+                </a:solidFill>
+              </a:rPr>
               <a:t>Интерпретируемость: простые, понятные правила (если x &lt; a, то …)</a:t>
             </a:r>
           </a:p>
@@ -6837,10 +7037,14 @@
               <a:spcAft>
                 <a:spcPts val="800"/>
               </a:spcAft>
-              <a:defRPr sz="2000"/>
-            </a:pPr>
-            <a:r>
-              <a:t>Один признак → прямоугольные области, которыми можно приблизить любую функцию (теорема о приближении)</a:t>
+            </a:pPr>
+            <a:r>
+              <a:rPr lang="ru-RU" dirty="0" sz="2000">
+                <a:solidFill>
+                  <a:srgbClr val="000000"/>
+                </a:solidFill>
+              </a:rPr>
+              <a:t>Один признак → оси-параллельные прямоугольные области; при достаточной глубине ими можно аппроксимировать сложные границы</a:t>
             </a:r>
           </a:p>
           <a:p>
@@ -6848,9 +7052,13 @@
               <a:spcAft>
                 <a:spcPts val="800"/>
               </a:spcAft>
-              <a:defRPr sz="2000"/>
-            </a:pPr>
-            <a:r>
+            </a:pPr>
+            <a:r>
+              <a:rPr lang="ru-RU" dirty="0" sz="2000">
+                <a:solidFill>
+                  <a:srgbClr val="000000"/>
+                </a:solidFill>
+              </a:rPr>
               <a:t>Сложные комбинации в одном узле резко повышают риск переобучения</a:t>
             </a:r>
           </a:p>
@@ -6859,9 +7067,13 @@
               <a:spcAft>
                 <a:spcPts val="800"/>
               </a:spcAft>
-              <a:defRPr sz="2000"/>
-            </a:pPr>
-            <a:r>
+            </a:pPr>
+            <a:r>
+              <a:rPr lang="ru-RU" dirty="0" sz="2000">
+                <a:solidFill>
+                  <a:srgbClr val="000000"/>
+                </a:solidFill>
+              </a:rPr>
               <a:t>Исключение: ID3/C4.5 для категориальных признаков допускают небинарные узлы, но каждый узел всё равно соответствует одному признаку</a:t>
             </a:r>
           </a:p>
@@ -6907,14 +7119,12 @@
           </a:bodyPr>
           <a:lstStyle/>
           <a:p>
-            <a:pPr>
-              <a:defRPr sz="3200" b="1">
+            <a:r>
+              <a:rPr lang="ru-RU" dirty="0" sz="3200" b="1">
                 <a:solidFill>
                   <a:srgbClr val="1A1A2E"/>
                 </a:solidFill>
-              </a:defRPr>
-            </a:pPr>
-            <a:r>
+              </a:rPr>
               <a:t>Почему мы строим дерево жадно?</a:t>
             </a:r>
           </a:p>
@@ -6929,7 +7139,7 @@
         <p:spPr>
           <a:xfrm>
             <a:off x="640080" y="1371600"/>
-            <a:ext cx="6858000" cy="5029200"/>
+            <a:ext cx="11247120" cy="5029200"/>
           </a:xfrm>
           <a:prstGeom prst="rect">
             <a:avLst/>
@@ -6946,10 +7156,14 @@
               <a:spcAft>
                 <a:spcPts val="800"/>
               </a:spcAft>
-              <a:defRPr sz="2000"/>
-            </a:pPr>
-            <a:r>
-              <a:t>Краткий ответ: это компромисс между качеством, временем и переобучением</a:t>
+            </a:pPr>
+            <a:r>
+              <a:rPr lang="ru-RU" dirty="0" sz="2000">
+                <a:solidFill>
+                  <a:srgbClr val="000000"/>
+                </a:solidFill>
+              </a:rPr>
+              <a:t>Краткий ответ: компромисс между качеством, временем и переобучением</a:t>
             </a:r>
           </a:p>
           <a:p>
@@ -6957,9 +7171,13 @@
               <a:spcAft>
                 <a:spcPts val="800"/>
               </a:spcAft>
-              <a:defRPr sz="2000"/>
-            </a:pPr>
-            <a:r>
+            </a:pPr>
+            <a:r>
+              <a:rPr lang="ru-RU" dirty="0" sz="2000">
+                <a:solidFill>
+                  <a:srgbClr val="000000"/>
+                </a:solidFill>
+              </a:rPr>
               <a:t>Полный перебор оптимального дерева — NP-трудная задача (доказано)</a:t>
             </a:r>
           </a:p>
@@ -6968,10 +7186,80 @@
               <a:spcAft>
                 <a:spcPts val="800"/>
               </a:spcAft>
-              <a:defRPr sz="2000"/>
-            </a:pPr>
-            <a:r>
-              <a:t>Жадный алгоритм работает за разумное время: O(n_features · n_samples · log n_samples) на узел</a:t>
+            </a:pPr>
+            <a:r>
+              <a:rPr lang="ru-RU" dirty="0" sz="2000">
+                <a:solidFill>
+                  <a:srgbClr val="000000"/>
+                </a:solidFill>
+              </a:rPr>
+              <a:t xml:space="preserve">Жадный алгоритм: </a:t>
+            </a:r>
+            <ns0:m xmlns:ns0="http://schemas.microsoft.com/office/drawing/2010/main">
+              <m:oMath xmlns:m="http://schemas.openxmlformats.org/officeDocument/2006/math">
+                <m:r>
+                  <m:t>O(</m:t>
+                </m:r>
+                <m:sSub>
+                  <m:e>
+                    <m:r>
+                      <m:t>n</m:t>
+                    </m:r>
+                  </m:e>
+                  <m:sub>
+                    <m:r>
+                      <m:t>features</m:t>
+                    </m:r>
+                  </m:sub>
+                </m:sSub>
+                <m:r>
+                  <m:t>·</m:t>
+                </m:r>
+                <m:sSub>
+                  <m:e>
+                    <m:r>
+                      <m:t>n</m:t>
+                    </m:r>
+                  </m:e>
+                  <m:sub>
+                    <m:r>
+                      <m:t>samples</m:t>
+                    </m:r>
+                  </m:sub>
+                </m:sSub>
+                <m:r>
+                  <m:t>·</m:t>
+                </m:r>
+                <m:r>
+                  <m:rPr>
+                    <m:sty m:val="p"/>
+                  </m:rPr>
+                  <m:t>log</m:t>
+                </m:r>
+                <m:sSub>
+                  <m:e>
+                    <m:r>
+                      <m:t>n</m:t>
+                    </m:r>
+                  </m:e>
+                  <m:sub>
+                    <m:r>
+                      <m:t>samples</m:t>
+                    </m:r>
+                  </m:sub>
+                </m:sSub>
+                <m:r>
+                  <m:t>)</m:t>
+                </m:r>
+              </m:oMath>
+            </ns0:m>
+            <a:r>
+              <a:rPr lang="ru-RU" dirty="0" sz="2000">
+                <a:solidFill>
+                  <a:srgbClr val="000000"/>
+                </a:solidFill>
+              </a:rPr>
+              <a:t xml:space="preserve"> на узел (в sklearn — сортировка по признаку)</a:t>
             </a:r>
           </a:p>
           <a:p>
@@ -6979,10 +7267,14 @@
               <a:spcAft>
                 <a:spcPts val="800"/>
               </a:spcAft>
-              <a:defRPr sz="2000"/>
-            </a:pPr>
-            <a:r>
-              <a:t>Жадность даёт возможность контролировать сложность (остановка, прунинг)</a:t>
+            </a:pPr>
+            <a:r>
+              <a:rPr lang="ru-RU" dirty="0" sz="2000">
+                <a:solidFill>
+                  <a:srgbClr val="000000"/>
+                </a:solidFill>
+              </a:rPr>
+              <a:t>Жадность даёт интерпретируемые результаты и контроль сложности (остановка, прунинг)</a:t>
             </a:r>
           </a:p>
           <a:p>
@@ -6990,10 +7282,14 @@
               <a:spcAft>
                 <a:spcPts val="800"/>
               </a:spcAft>
-              <a:defRPr sz="2000"/>
-            </a:pPr>
-            <a:r>
-              <a:t>Недостатки жадности становятся достоинствами в ансамблях (Random Forest, Gradient Boosting)</a:t>
+            </a:pPr>
+            <a:r>
+              <a:rPr lang="ru-RU" dirty="0" sz="2000">
+                <a:solidFill>
+                  <a:srgbClr val="000000"/>
+                </a:solidFill>
+              </a:rPr>
+              <a:t>Недостатки жадности — плюс в ансамблях: много слабых деревьев лучше одного сильного</a:t>
             </a:r>
           </a:p>
         </p:txBody>
@@ -7038,14 +7334,12 @@
           </a:bodyPr>
           <a:lstStyle/>
           <a:p>
-            <a:pPr>
-              <a:defRPr sz="3200" b="1">
+            <a:r>
+              <a:rPr lang="ru-RU" dirty="0" sz="3200" b="1">
                 <a:solidFill>
                   <a:srgbClr val="1A1A2E"/>
                 </a:solidFill>
-              </a:defRPr>
-            </a:pPr>
-            <a:r>
+              </a:rPr>
               <a:t>Почему нам важна строгая вогнутость, если мы не используем градиенты?</a:t>
             </a:r>
           </a:p>
@@ -7060,7 +7354,7 @@
         <p:spPr>
           <a:xfrm>
             <a:off x="640080" y="1371600"/>
-            <a:ext cx="6858000" cy="5029200"/>
+            <a:ext cx="11247120" cy="5029200"/>
           </a:xfrm>
           <a:prstGeom prst="rect">
             <a:avLst/>
@@ -7077,9 +7371,13 @@
               <a:spcAft>
                 <a:spcPts val="800"/>
               </a:spcAft>
-              <a:defRPr sz="2000"/>
-            </a:pPr>
-            <a:r>
+            </a:pPr>
+            <a:r>
+              <a:rPr lang="ru-RU" dirty="0" sz="2000">
+                <a:solidFill>
+                  <a:srgbClr val="000000"/>
+                </a:solidFill>
+              </a:rPr>
               <a:t>Гладкость не является причиной (она не обязательна для выбора разбиения)</a:t>
             </a:r>
           </a:p>
@@ -7088,10 +7386,14 @@
               <a:spcAft>
                 <a:spcPts val="800"/>
               </a:spcAft>
-              <a:defRPr sz="2000"/>
-            </a:pPr>
-            <a:r>
-              <a:t>Проблема Misclassification impurity: она кусочно-линейна, а не строго вогнута</a:t>
+            </a:pPr>
+            <a:r>
+              <a:rPr lang="ru-RU" dirty="0" sz="2000">
+                <a:solidFill>
+                  <a:srgbClr val="000000"/>
+                </a:solidFill>
+              </a:rPr>
+              <a:t>Misclassification impurity кусочно-линейна и не является строго вогнутой — в этом суть проблемы</a:t>
             </a:r>
           </a:p>
           <a:p>
@@ -7099,10 +7401,29 @@
               <a:spcAft>
                 <a:spcPts val="800"/>
               </a:spcAft>
-              <a:defRPr sz="2000"/>
-            </a:pPr>
-            <a:r>
-              <a:t>При K ≥ 3 может давать одинаковые значения для разных распределений (например, (0.6, 0.2, 0.2) и (0.6, 0.1, 0.3) → I = 0.4)</a:t>
+            </a:pPr>
+            <a:r>
+              <a:rPr lang="ru-RU" dirty="0" sz="2000">
+                <a:solidFill>
+                  <a:srgbClr val="000000"/>
+                </a:solidFill>
+              </a:rPr>
+              <a:t xml:space="preserve">При </a:t>
+            </a:r>
+            <ns0:m xmlns:ns0="http://schemas.microsoft.com/office/drawing/2010/main">
+              <m:oMath xmlns:m="http://schemas.openxmlformats.org/officeDocument/2006/math">
+                <m:r>
+                  <m:t>K≥3</m:t>
+                </m:r>
+              </m:oMath>
+            </ns0:m>
+            <a:r>
+              <a:rPr lang="ru-RU" dirty="0" sz="2000">
+                <a:solidFill>
+                  <a:srgbClr val="000000"/>
+                </a:solidFill>
+              </a:rPr>
+              <a:t xml:space="preserve"> misclassification может совпадать на разных распределениях классов</a:t>
             </a:r>
           </a:p>
           <a:p>
@@ -7110,10 +7431,105 @@
               <a:spcAft>
                 <a:spcPts val="800"/>
               </a:spcAft>
-              <a:defRPr sz="2000"/>
-            </a:pPr>
-            <a:r>
-              <a:t>Она смотрит только на самый большой класс, игнорируя распределение остальных</a:t>
+            </a:pPr>
+            <a:r>
+              <a:rPr lang="ru-RU" dirty="0" sz="2000">
+                <a:solidFill>
+                  <a:srgbClr val="000000"/>
+                </a:solidFill>
+              </a:rPr>
+              <a:t xml:space="preserve">Пример: </a:t>
+            </a:r>
+            <ns0:m xmlns:ns0="http://schemas.microsoft.com/office/drawing/2010/main">
+              <m:oMath xmlns:m="http://schemas.openxmlformats.org/officeDocument/2006/math">
+                <m:d>
+                  <m:dPr>
+                    <m:sepChr m:val=","/>
+                  </m:dPr>
+                  <m:e>
+                    <m:r>
+                      <m:t>0.6</m:t>
+                    </m:r>
+                  </m:e>
+                  <m:e>
+                    <m:r>
+                      <m:t>0.2</m:t>
+                    </m:r>
+                  </m:e>
+                  <m:e>
+                    <m:r>
+                      <m:t>0.2</m:t>
+                    </m:r>
+                  </m:e>
+                </m:d>
+              </m:oMath>
+            </ns0:m>
+            <a:r>
+              <a:rPr lang="ru-RU" dirty="0" sz="2000">
+                <a:solidFill>
+                  <a:srgbClr val="000000"/>
+                </a:solidFill>
+              </a:rPr>
+              <a:t xml:space="preserve"> и </a:t>
+            </a:r>
+            <ns0:m xmlns:ns0="http://schemas.microsoft.com/office/drawing/2010/main">
+              <m:oMath xmlns:m="http://schemas.openxmlformats.org/officeDocument/2006/math">
+                <m:d>
+                  <m:dPr>
+                    <m:sepChr m:val=","/>
+                  </m:dPr>
+                  <m:e>
+                    <m:r>
+                      <m:t>0.6</m:t>
+                    </m:r>
+                  </m:e>
+                  <m:e>
+                    <m:r>
+                      <m:t>0.1</m:t>
+                    </m:r>
+                  </m:e>
+                  <m:e>
+                    <m:r>
+                      <m:t>0.3</m:t>
+                    </m:r>
+                  </m:e>
+                </m:d>
+              </m:oMath>
+            </ns0:m>
+            <a:r>
+              <a:rPr lang="ru-RU" dirty="0" sz="2000">
+                <a:solidFill>
+                  <a:srgbClr val="000000"/>
+                </a:solidFill>
+              </a:rPr>
+              <a:t xml:space="preserve"> дают </a:t>
+            </a:r>
+            <ns0:m xmlns:ns0="http://schemas.microsoft.com/office/drawing/2010/main">
+              <m:oMath xmlns:m="http://schemas.openxmlformats.org/officeDocument/2006/math">
+                <m:sSub>
+                  <m:e>
+                    <m:r>
+                      <m:t>I</m:t>
+                    </m:r>
+                  </m:e>
+                  <m:sub>
+                    <m:r>
+                      <m:t>mis</m:t>
+                    </m:r>
+                  </m:sub>
+                </m:sSub>
+                <m:r>
+                  <m:t>=0.4</m:t>
+                </m:r>
+              </m:oMath>
+            </ns0:m>
+            <a:r>
+              <a:rPr lang="ru-RU" dirty="0" sz="2000">
+                <a:solidFill>
+                  <a:srgbClr val="000000"/>
+                </a:solidFill>
+              </a:rPr>
+              <a:t>, но разную энтропию и Джини</a:t>
             </a:r>
           </a:p>
           <a:p>
@@ -7121,10 +7537,44 @@
               <a:spcAft>
                 <a:spcPts val="800"/>
               </a:spcAft>
-              <a:defRPr sz="2000"/>
-            </a:pPr>
-            <a:r>
-              <a:t>Энтропия и Джини строго вогнуты — каждое изменение распределения даёт различный прирост, алгоритм выбирает лучший порог однозначно</a:t>
+            </a:pPr>
+            <a:r>
+              <a:rPr lang="ru-RU" dirty="0" sz="2000">
+                <a:solidFill>
+                  <a:srgbClr val="000000"/>
+                </a:solidFill>
+              </a:rPr>
+              <a:t>Misclassification смотрит только на самый большой класс, игнорируя остальные</a:t>
+            </a:r>
+          </a:p>
+          <a:p>
+            <a:pPr>
+              <a:spcAft>
+                <a:spcPts val="800"/>
+              </a:spcAft>
+            </a:pPr>
+            <a:r>
+              <a:rPr lang="ru-RU" dirty="0" sz="2000">
+                <a:solidFill>
+                  <a:srgbClr val="000000"/>
+                </a:solidFill>
+              </a:rPr>
+              <a:t>Энтропия и Джини строго вогнуты — прирост разбиения однозначен, меньше случайности в выборе порога</a:t>
+            </a:r>
+          </a:p>
+          <a:p>
+            <a:pPr>
+              <a:spcAft>
+                <a:spcPts val="800"/>
+              </a:spcAft>
+            </a:pPr>
+            <a:r>
+              <a:rPr lang="ru-RU" dirty="0" sz="2000">
+                <a:solidFill>
+                  <a:srgbClr val="000000"/>
+                </a:solidFill>
+              </a:rPr>
+              <a:t>Вывод: misclassification на практике почти не используют; деревья с Gini и entropy обычно близки по качеству</a:t>
             </a:r>
           </a:p>
         </p:txBody>
@@ -7169,14 +7619,12 @@
           </a:bodyPr>
           <a:lstStyle/>
           <a:p>
-            <a:pPr>
-              <a:defRPr sz="3200" b="1">
+            <a:r>
+              <a:rPr lang="ru-RU" dirty="0" sz="3200" b="1">
                 <a:solidFill>
                   <a:srgbClr val="1A1A2E"/>
                 </a:solidFill>
-              </a:defRPr>
-            </a:pPr>
-            <a:r>
+              </a:rPr>
               <a:t>Джини или энтропия?</a:t>
             </a:r>
           </a:p>
@@ -7191,7 +7639,7 @@
         <p:spPr>
           <a:xfrm>
             <a:off x="640080" y="1371600"/>
-            <a:ext cx="6858000" cy="5029200"/>
+            <a:ext cx="11247120" cy="5029200"/>
           </a:xfrm>
           <a:prstGeom prst="rect">
             <a:avLst/>
@@ -7208,10 +7656,41 @@
               <a:spcAft>
                 <a:spcPts val="800"/>
               </a:spcAft>
-              <a:defRPr sz="2000"/>
-            </a:pPr>
-            <a:r>
-              <a:t>Джини считается быстрее (только квадраты), энтропия требует логарифмов, но разница несущественна</a:t>
+            </a:pPr>
+            <a:r>
+              <a:rPr lang="ru-RU" dirty="0" sz="2000">
+                <a:solidFill>
+                  <a:srgbClr val="000000"/>
+                </a:solidFill>
+              </a:rPr>
+              <a:t xml:space="preserve">Джини быстрее (только квадраты), энтропия требует </a:t>
+            </a:r>
+            <ns0:m xmlns:ns0="http://schemas.microsoft.com/office/drawing/2010/main">
+              <m:oMath xmlns:m="http://schemas.openxmlformats.org/officeDocument/2006/math">
+                <m:sSub>
+                  <m:e>
+                    <m:r>
+                      <m:rPr>
+                        <m:sty m:val="p"/>
+                      </m:rPr>
+                      <m:t>log</m:t>
+                    </m:r>
+                  </m:e>
+                  <m:sub>
+                    <m:r>
+                      <m:t>2</m:t>
+                    </m:r>
+                  </m:sub>
+                </m:sSub>
+              </m:oMath>
+            </ns0:m>
+            <a:r>
+              <a:rPr lang="ru-RU" dirty="0" sz="2000">
+                <a:solidFill>
+                  <a:srgbClr val="000000"/>
+                </a:solidFill>
+              </a:rPr>
+              <a:t xml:space="preserve"> — на современных данных разница несущественна</a:t>
             </a:r>
           </a:p>
           <a:p>
@@ -7219,10 +7698,14 @@
               <a:spcAft>
                 <a:spcPts val="800"/>
               </a:spcAft>
-              <a:defRPr sz="2000"/>
-            </a:pPr>
-            <a:r>
-              <a:t>Энтропия имеет удобную информационную интерпретацию (среднее количество бит)</a:t>
+            </a:pPr>
+            <a:r>
+              <a:rPr lang="ru-RU" dirty="0" sz="2000">
+                <a:solidFill>
+                  <a:srgbClr val="000000"/>
+                </a:solidFill>
+              </a:rPr>
+              <a:t>Энтропия: интерпретация в битах; Джини — квадратичное приближение энтропии вблизи равномерного распределения</a:t>
             </a:r>
           </a:p>
           <a:p>
@@ -7230,10 +7713,41 @@
               <a:spcAft>
                 <a:spcPts val="800"/>
               </a:spcAft>
-              <a:defRPr sz="2000"/>
-            </a:pPr>
-            <a:r>
-              <a:t>Джини — квадратичное приближение энтропии вблизи равномерного распределения, результаты обычно очень похожи</a:t>
+            </a:pPr>
+            <a:r>
+              <a:rPr lang="ru-RU" dirty="0" sz="2000">
+                <a:solidFill>
+                  <a:srgbClr val="000000"/>
+                </a:solidFill>
+              </a:rPr>
+              <a:t>Вблизи чистых узлов (</a:t>
+            </a:r>
+            <ns0:m xmlns:ns0="http://schemas.microsoft.com/office/drawing/2010/main">
+              <m:oMath xmlns:m="http://schemas.openxmlformats.org/officeDocument/2006/math">
+                <m:sSub>
+                  <m:e>
+                    <m:r>
+                      <m:t>p</m:t>
+                    </m:r>
+                  </m:e>
+                  <m:sub>
+                    <m:r>
+                      <m:t>k</m:t>
+                    </m:r>
+                  </m:sub>
+                </m:sSub>
+                <m:r>
+                  <m:t>≈1</m:t>
+                </m:r>
+              </m:oMath>
+            </ns0:m>
+            <a:r>
+              <a:rPr lang="ru-RU" dirty="0" sz="2000">
+                <a:solidFill>
+                  <a:srgbClr val="000000"/>
+                </a:solidFill>
+              </a:rPr>
+              <a:t>) энтропия сильнее штрафует редкий класс</a:t>
             </a:r>
           </a:p>
           <a:p>
@@ -7241,21 +7755,14 @@
               <a:spcAft>
                 <a:spcPts val="800"/>
               </a:spcAft>
-              <a:defRPr sz="2000"/>
-            </a:pPr>
-            <a:r>
-              <a:t>Вблизи чистых узлов (p_k ≈ 1) энтропия сильнее «штрафует» за появление редкого класса</a:t>
-            </a:r>
-          </a:p>
-          <a:p>
-            <a:pPr>
-              <a:spcAft>
-                <a:spcPts val="800"/>
-              </a:spcAft>
-              <a:defRPr sz="2000"/>
-            </a:pPr>
-            <a:r>
-              <a:t>На практике выбор между ними редко критичен — деревья получаются почти одинаковыми</a:t>
+            </a:pPr>
+            <a:r>
+              <a:rPr lang="ru-RU" dirty="0" sz="2000">
+                <a:solidFill>
+                  <a:srgbClr val="000000"/>
+                </a:solidFill>
+              </a:rPr>
+              <a:t>На практике деревья почти одинаковы — начинайте с Gini (default в sklearn), не тратьте время на тонкую настройку</a:t>
             </a:r>
           </a:p>
         </p:txBody>
@@ -7300,14 +7807,12 @@
           </a:bodyPr>
           <a:lstStyle/>
           <a:p>
-            <a:pPr>
-              <a:defRPr sz="3200" b="1">
+            <a:r>
+              <a:rPr lang="ru-RU" dirty="0" sz="3200" b="1">
                 <a:solidFill>
                   <a:srgbClr val="1A1A2E"/>
                 </a:solidFill>
-              </a:defRPr>
-            </a:pPr>
-            <a:r>
+              </a:rPr>
               <a:t>Акинатор: дерево в действии</a:t>
             </a:r>
           </a:p>
@@ -7339,9 +7844,13 @@
               <a:spcAft>
                 <a:spcPts val="800"/>
               </a:spcAft>
-              <a:defRPr sz="2000"/>
-            </a:pPr>
-            <a:r>
+            </a:pPr>
+            <a:r>
+              <a:rPr lang="ru-RU" dirty="0" sz="2000">
+                <a:solidFill>
+                  <a:srgbClr val="000000"/>
+                </a:solidFill>
+              </a:rPr>
               <a:t>Акинатор угадывает персонажа/объект по серии вопросов ('да/нет')</a:t>
             </a:r>
           </a:p>
@@ -7350,9 +7859,13 @@
               <a:spcAft>
                 <a:spcPts val="800"/>
               </a:spcAft>
-              <a:defRPr sz="2000"/>
-            </a:pPr>
-            <a:r>
+            </a:pPr>
+            <a:r>
+              <a:rPr lang="ru-RU" dirty="0" sz="2000">
+                <a:solidFill>
+                  <a:srgbClr val="000000"/>
+                </a:solidFill>
+              </a:rPr>
               <a:t>Каждый ответ ведёт к следующему вопросу — структура дерева</a:t>
             </a:r>
           </a:p>
@@ -7361,9 +7874,13 @@
               <a:spcAft>
                 <a:spcPts val="800"/>
               </a:spcAft>
-              <a:defRPr sz="2000"/>
-            </a:pPr>
-            <a:r>
+            </a:pPr>
+            <a:r>
+              <a:rPr lang="ru-RU" dirty="0" sz="2000">
+                <a:solidFill>
+                  <a:srgbClr val="000000"/>
+                </a:solidFill>
+              </a:rPr>
               <a:t>Листья — конкретные персонажи/объекты</a:t>
             </a:r>
           </a:p>
@@ -7372,9 +7889,13 @@
               <a:spcAft>
                 <a:spcPts val="800"/>
               </a:spcAft>
-              <a:defRPr sz="2000"/>
-            </a:pPr>
-            <a:r>
+            </a:pPr>
+            <a:r>
+              <a:rPr lang="ru-RU" dirty="0" sz="2000">
+                <a:solidFill>
+                  <a:srgbClr val="000000"/>
+                </a:solidFill>
+              </a:rPr>
               <a:t>Демонстрация: дерево решений уже используется в повседневных приложениях</a:t>
             </a:r>
           </a:p>
@@ -7427,13 +7948,21 @@
           <a:lstStyle/>
           <a:p>
             <a:r>
+              <a:rPr lang="ru-RU" dirty="0" sz="1400">
+                <a:solidFill>
+                  <a:srgbClr val="3366CC"/>
+                </a:solidFill>
+              </a:rPr>
+              <a:t xml:space="preserve">Поиграть в Акинатора: </a:t>
+            </a:r>
+            <a:r>
               <a:rPr sz="1400">
                 <a:solidFill>
                   <a:srgbClr val="3366CC"/>
                 </a:solidFill>
                 <a:hlinkClick r:id="rId3"/>
               </a:rPr>
-              <a:t>Поиграть в Акинатора: https://en.akinator.com/</a:t>
+              <a:t>https://en.akinator.com/</a:t>
             </a:r>
           </a:p>
         </p:txBody>
@@ -7502,14 +8031,12 @@
           </a:bodyPr>
           <a:lstStyle/>
           <a:p>
-            <a:pPr>
-              <a:defRPr sz="3200" b="1">
+            <a:r>
+              <a:rPr lang="ru-RU" dirty="0" sz="3200" b="1">
                 <a:solidFill>
                   <a:srgbClr val="1A1A2E"/>
                 </a:solidFill>
-              </a:defRPr>
-            </a:pPr>
-            <a:r>
+              </a:rPr>
               <a:t>Бинарная классификация деревом</a:t>
             </a:r>
           </a:p>
@@ -7541,9 +8068,13 @@
               <a:spcAft>
                 <a:spcPts val="800"/>
               </a:spcAft>
-              <a:defRPr sz="2000"/>
-            </a:pPr>
-            <a:r>
+            </a:pPr>
+            <a:r>
+              <a:rPr lang="ru-RU" dirty="0" sz="2000">
+                <a:solidFill>
+                  <a:srgbClr val="000000"/>
+                </a:solidFill>
+              </a:rPr>
               <a:t>Дано: объекты с признаками (x₁, x₂, ..., xₙ) и меткой класса (0 или 1)</a:t>
             </a:r>
           </a:p>
@@ -7552,9 +8083,13 @@
               <a:spcAft>
                 <a:spcPts val="800"/>
               </a:spcAft>
-              <a:defRPr sz="2000"/>
-            </a:pPr>
-            <a:r>
+            </a:pPr>
+            <a:r>
+              <a:rPr lang="ru-RU" dirty="0" sz="2000">
+                <a:solidFill>
+                  <a:srgbClr val="000000"/>
+                </a:solidFill>
+              </a:rPr>
               <a:t>Дерево задаёт вопросы вида xᵢ &lt; a — ровно один признак в узле</a:t>
             </a:r>
           </a:p>
@@ -7563,9 +8098,13 @@
               <a:spcAft>
                 <a:spcPts val="800"/>
               </a:spcAft>
-              <a:defRPr sz="2000"/>
-            </a:pPr>
-            <a:r>
+            </a:pPr>
+            <a:r>
+              <a:rPr lang="ru-RU" dirty="0" sz="2000">
+                <a:solidFill>
+                  <a:srgbClr val="000000"/>
+                </a:solidFill>
+              </a:rPr>
               <a:t>Да → левый потомок, Нет → правый потомок</a:t>
             </a:r>
           </a:p>
@@ -7574,9 +8113,13 @@
               <a:spcAft>
                 <a:spcPts val="800"/>
               </a:spcAft>
-              <a:defRPr sz="2000"/>
-            </a:pPr>
-            <a:r>
+            </a:pPr>
+            <a:r>
+              <a:rPr lang="ru-RU" dirty="0" sz="2000">
+                <a:solidFill>
+                  <a:srgbClr val="000000"/>
+                </a:solidFill>
+              </a:rPr>
               <a:t>В листе: ответ — мажоритарный класс среди попавших туда объектов</a:t>
             </a:r>
           </a:p>
@@ -7585,9 +8128,13 @@
               <a:spcAft>
                 <a:spcPts val="800"/>
               </a:spcAft>
-              <a:defRPr sz="2000"/>
-            </a:pPr>
-            <a:r>
+            </a:pPr>
+            <a:r>
+              <a:rPr lang="ru-RU" dirty="0" sz="2000">
+                <a:solidFill>
+                  <a:srgbClr val="000000"/>
+                </a:solidFill>
+              </a:rPr>
               <a:t>Граница решения: оси-параллельные прямоугольники</a:t>
             </a:r>
           </a:p>
@@ -7657,14 +8204,12 @@
           </a:bodyPr>
           <a:lstStyle/>
           <a:p>
-            <a:pPr>
-              <a:defRPr sz="3200" b="1">
+            <a:r>
+              <a:rPr lang="ru-RU" dirty="0" sz="3200" b="1">
                 <a:solidFill>
                   <a:srgbClr val="1A1A2E"/>
                 </a:solidFill>
-              </a:defRPr>
-            </a:pPr>
-            <a:r>
+              </a:rPr>
               <a:t>Как построить дерево?</a:t>
             </a:r>
           </a:p>
@@ -7679,7 +8224,7 @@
         <p:spPr>
           <a:xfrm>
             <a:off x="640080" y="1371600"/>
-            <a:ext cx="6858000" cy="5029200"/>
+            <a:ext cx="11247120" cy="5029200"/>
           </a:xfrm>
           <a:prstGeom prst="rect">
             <a:avLst/>
@@ -7696,9 +8241,13 @@
               <a:spcAft>
                 <a:spcPts val="800"/>
               </a:spcAft>
-              <a:defRPr sz="2000"/>
-            </a:pPr>
-            <a:r>
+            </a:pPr>
+            <a:r>
+              <a:rPr lang="ru-RU" dirty="0" sz="2000">
+                <a:solidFill>
+                  <a:srgbClr val="000000"/>
+                </a:solidFill>
+              </a:rPr>
               <a:t>Перебираем все признаки, для каждого — все возможные пороги (их конечное число, т.к. между соседними объектами impurity не меняется)</a:t>
             </a:r>
           </a:p>
@@ -7707,10 +8256,14 @@
               <a:spcAft>
                 <a:spcPts val="800"/>
               </a:spcAft>
-              <a:defRPr sz="2000"/>
-            </a:pPr>
-            <a:r>
-              <a:t>Выбираем разбиение с максимальным уменьшением impurity (Gini/энтропия)</a:t>
+            </a:pPr>
+            <a:r>
+              <a:rPr lang="ru-RU" dirty="0" sz="2000">
+                <a:solidFill>
+                  <a:srgbClr val="000000"/>
+                </a:solidFill>
+              </a:rPr>
+              <a:t>Выбираем разбиение с максимальным уменьшением неоднородности узла — критерии misclassification, энтропия и Джини на следующих слайдах</a:t>
             </a:r>
           </a:p>
           <a:p>
@@ -7718,9 +8271,13 @@
               <a:spcAft>
                 <a:spcPts val="800"/>
               </a:spcAft>
-              <a:defRPr sz="2000"/>
-            </a:pPr>
-            <a:r>
+            </a:pPr>
+            <a:r>
+              <a:rPr lang="ru-RU" dirty="0" sz="2000">
+                <a:solidFill>
+                  <a:srgbClr val="000000"/>
+                </a:solidFill>
+              </a:rPr>
               <a:t>Критерии остановки: max_depth, min_samples_leaf — чтобы не переобучаться</a:t>
             </a:r>
           </a:p>
@@ -7729,9 +8286,13 @@
               <a:spcAft>
                 <a:spcPts val="800"/>
               </a:spcAft>
-              <a:defRPr sz="2000"/>
-            </a:pPr>
-            <a:r>
+            </a:pPr>
+            <a:r>
+              <a:rPr lang="ru-RU" dirty="0" sz="2000">
+                <a:solidFill>
+                  <a:srgbClr val="000000"/>
+                </a:solidFill>
+              </a:rPr>
               <a:t>В листе: ответ — мажоритарный класс попавших туда объектов</a:t>
             </a:r>
           </a:p>
@@ -7777,14 +8338,12 @@
           </a:bodyPr>
           <a:lstStyle/>
           <a:p>
-            <a:pPr>
-              <a:defRPr sz="3200" b="1">
+            <a:r>
+              <a:rPr lang="ru-RU" dirty="0" sz="3200" b="1">
                 <a:solidFill>
                   <a:srgbClr val="1A1A2E"/>
                 </a:solidFill>
-              </a:defRPr>
-            </a:pPr>
-            <a:r>
+              </a:rPr>
               <a:t>Критерий качества разбиения: Misclassification Impurity</a:t>
             </a:r>
           </a:p>
@@ -7799,7 +8358,7 @@
         <p:spPr>
           <a:xfrm>
             <a:off x="640080" y="1371600"/>
-            <a:ext cx="6858000" cy="5029200"/>
+            <a:ext cx="11247120" cy="5029200"/>
           </a:xfrm>
           <a:prstGeom prst="rect">
             <a:avLst/>
@@ -7816,10 +8375,57 @@
               <a:spcAft>
                 <a:spcPts val="800"/>
               </a:spcAft>
-              <a:defRPr sz="2000"/>
-            </a:pPr>
-            <a:r>
-              <a:t>Интуиция: если бы мы ответили самым частым классом, какова вероятность ошибки?</a:t>
+            </a:pPr>
+            <ns0:m xmlns:ns0="http://schemas.microsoft.com/office/drawing/2010/main">
+              <m:oMath xmlns:m="http://schemas.openxmlformats.org/officeDocument/2006/math">
+                <m:sSub>
+                  <m:e>
+                    <m:r>
+                      <m:t>I</m:t>
+                    </m:r>
+                  </m:e>
+                  <m:sub>
+                    <m:r>
+                      <m:t>mis</m:t>
+                    </m:r>
+                  </m:sub>
+                </m:sSub>
+                <m:r>
+                  <m:t>(t)=1−</m:t>
+                </m:r>
+                <m:sSub>
+                  <m:e>
+                    <m:r>
+                      <m:t>max</m:t>
+                    </m:r>
+                  </m:e>
+                  <m:sub>
+                    <m:r>
+                      <m:t>k</m:t>
+                    </m:r>
+                  </m:sub>
+                </m:sSub>
+                <m:sSub>
+                  <m:e>
+                    <m:r>
+                      <m:t>p</m:t>
+                    </m:r>
+                  </m:e>
+                  <m:sub>
+                    <m:r>
+                      <m:t>k</m:t>
+                    </m:r>
+                  </m:sub>
+                </m:sSub>
+              </m:oMath>
+            </ns0:m>
+            <a:r>
+              <a:rPr lang="ru-RU" dirty="0" sz="2000">
+                <a:solidFill>
+                  <a:srgbClr val="000000"/>
+                </a:solidFill>
+              </a:rPr>
+              <a:t xml:space="preserve"> — если ответить самым частым классом, какова вероятность ошибки?</a:t>
             </a:r>
           </a:p>
           <a:p>
@@ -7827,72 +8433,30 @@
               <a:spcAft>
                 <a:spcPts val="800"/>
               </a:spcAft>
-              <a:defRPr sz="2000"/>
-            </a:pPr>
-            <a:r>
-              <a:t>Простой и интуитивный, но есть недостатки (обсудим на слайде 21)</a:t>
-            </a:r>
-          </a:p>
-        </p:txBody>
-      </p:sp>
-      <p:sp>
-        <p:nvSpPr>
-          <p:cNvPr id="4" name="TextBox 3"/>
-          <p:cNvSpPr txBox="1"/>
-          <p:nvPr/>
-        </p:nvSpPr>
-        <p:spPr>
-          <a:xfrm>
-            <a:off x="7772400" y="1371600"/>
-            <a:ext cx="4114800" cy="2286000"/>
-          </a:xfrm>
-          <a:prstGeom prst="rect">
-            <a:avLst/>
-          </a:prstGeom>
-          <a:noFill/>
-        </p:spPr>
-        <p:txBody>
-          <a:bodyPr wrap="square">
-            <a:spAutoFit/>
-          </a:bodyPr>
-          <a:lstStyle/>
-          <a:p>
-            <a:pPr>
-              <a:spcAft>
-                <a:spcPts val="600"/>
-              </a:spcAft>
-              <a:defRPr sz="1600">
-                <a:solidFill>
-                  <a:srgbClr val="555555"/>
-                </a:solidFill>
-              </a:defRPr>
-            </a:pPr>
-            <a:r>
-              <a:t>Misclassification impurity</a:t>
-            </a:r>
-          </a:p>
-          <a:p>
-            <a:pPr>
-              <a:spcAft>
-                <a:spcPts val="1000"/>
-              </a:spcAft>
-            </a:pPr>
+            </a:pPr>
+            <a:r>
+              <a:rPr lang="ru-RU" dirty="0" sz="2000">
+                <a:solidFill>
+                  <a:srgbClr val="000000"/>
+                </a:solidFill>
+              </a:rPr>
+              <a:t xml:space="preserve">Простой и интуитивный, но есть недостатки при </a:t>
+            </a:r>
             <ns0:m xmlns:ns0="http://schemas.microsoft.com/office/drawing/2010/main">
-              <ns1:oMath xmlns:ns1="http://schemas.openxmlformats.org/officeDocument/2006/math">
-                <ns1:sSub>
-                  <ns1:e>
-                    <ns1:r>
-                      <ns1:t>I</ns1:t>
-                    </ns1:r>
-                  </ns1:e>
-                  <ns1:sub>
-                    <ns1:r>
-                      <ns1:t>mis</ns1:t>
-                    </ns1:r>
-                  </ns1:sub>
-                </ns1:sSub>
-              </ns1:oMath>
+              <m:oMath xmlns:m="http://schemas.openxmlformats.org/officeDocument/2006/math">
+                <m:r>
+                  <m:t>K≥3</m:t>
+                </m:r>
+              </m:oMath>
             </ns0:m>
+            <a:r>
+              <a:rPr lang="ru-RU" dirty="0" sz="2000">
+                <a:solidFill>
+                  <a:srgbClr val="000000"/>
+                </a:solidFill>
+              </a:rPr>
+              <a:t xml:space="preserve"> — разберём в теоретическом блоке</a:t>
+            </a:r>
           </a:p>
         </p:txBody>
       </p:sp>
@@ -7936,15 +8500,13 @@
           </a:bodyPr>
           <a:lstStyle/>
           <a:p>
-            <a:pPr>
-              <a:defRPr sz="3200" b="1">
+            <a:r>
+              <a:rPr lang="ru-RU" dirty="0" sz="3200" b="1">
                 <a:solidFill>
                   <a:srgbClr val="1A1A2E"/>
                 </a:solidFill>
-              </a:defRPr>
-            </a:pPr>
-            <a:r>
-              <a:t>Альтернатива: энтропия и индекс Джини</a:t>
+              </a:rPr>
+              <a:t>Энтропия и индекс Джини</a:t>
             </a:r>
           </a:p>
         </p:txBody>
@@ -7975,185 +8537,210 @@
               <a:spcAft>
                 <a:spcPts val="800"/>
               </a:spcAft>
-              <a:defRPr sz="2000"/>
-            </a:pPr>
-            <a:r>
-              <a:t>Обе функции строго вогнуты — учитывают распределение всех классов</a:t>
-            </a:r>
+            </a:pPr>
+            <a:r>
+              <a:rPr lang="ru-RU" dirty="0" sz="2000">
+                <a:solidFill>
+                  <a:srgbClr val="000000"/>
+                </a:solidFill>
+              </a:rPr>
+              <a:t xml:space="preserve">Энтропия: </a:t>
+            </a:r>
+            <ns0:m xmlns:ns0="http://schemas.microsoft.com/office/drawing/2010/main">
+              <m:oMath xmlns:m="http://schemas.openxmlformats.org/officeDocument/2006/math">
+                <m:r>
+                  <m:t>H=−</m:t>
+                </m:r>
+                <m:nary>
+                  <m:naryPr>
+                    <m:chr m:val="∑"/>
+                    <m:limLoc m:val="subSup"/>
+                    <m:grow m:val="1"/>
+                    <m:subHide m:val="off"/>
+                    <m:supHide m:val="on"/>
+                  </m:naryPr>
+                  <m:sub>
+                    <m:r>
+                      <m:t>k</m:t>
+                    </m:r>
+                  </m:sub>
+                  <m:sup/>
+                  <m:e>
+                    <m:sSub>
+                      <m:e>
+                        <m:r>
+                          <m:t>p</m:t>
+                        </m:r>
+                      </m:e>
+                      <m:sub>
+                        <m:r>
+                          <m:t>k</m:t>
+                        </m:r>
+                      </m:sub>
+                    </m:sSub>
+                  </m:e>
+                </m:nary>
+                <m:sSub>
+                  <m:e>
+                    <m:r>
+                      <m:rPr>
+                        <m:sty m:val="p"/>
+                      </m:rPr>
+                      <m:t>log</m:t>
+                    </m:r>
+                  </m:e>
+                  <m:sub>
+                    <m:r>
+                      <m:t>2</m:t>
+                    </m:r>
+                  </m:sub>
+                </m:sSub>
+                <m:sSub>
+                  <m:e>
+                    <m:r>
+                      <m:t>p</m:t>
+                    </m:r>
+                  </m:e>
+                  <m:sub>
+                    <m:r>
+                      <m:t>k</m:t>
+                    </m:r>
+                  </m:sub>
+                </m:sSub>
+              </m:oMath>
+            </ns0:m>
           </a:p>
           <a:p>
             <a:pPr>
               <a:spcAft>
                 <a:spcPts val="800"/>
               </a:spcAft>
-              <a:defRPr sz="2000"/>
-            </a:pPr>
-            <a:r>
-              <a:t>Именно их используют на практике (sklearn: criterion='gini' или 'entropy')</a:t>
-            </a:r>
+            </a:pPr>
+            <a:r>
+              <a:rPr lang="ru-RU" dirty="0" sz="2000">
+                <a:solidFill>
+                  <a:srgbClr val="000000"/>
+                </a:solidFill>
+              </a:rPr>
+              <a:t xml:space="preserve">Индекс Джини: </a:t>
+            </a:r>
+            <ns0:m xmlns:ns0="http://schemas.microsoft.com/office/drawing/2010/main">
+              <m:oMath xmlns:m="http://schemas.openxmlformats.org/officeDocument/2006/math">
+                <m:r>
+                  <m:t>G=</m:t>
+                </m:r>
+                <m:nary>
+                  <m:naryPr>
+                    <m:chr m:val="∑"/>
+                    <m:limLoc m:val="subSup"/>
+                    <m:grow m:val="1"/>
+                    <m:subHide m:val="off"/>
+                    <m:supHide m:val="on"/>
+                  </m:naryPr>
+                  <m:sub>
+                    <m:r>
+                      <m:t>k</m:t>
+                    </m:r>
+                  </m:sub>
+                  <m:sup/>
+                  <m:e>
+                    <m:sSub>
+                      <m:e>
+                        <m:r>
+                          <m:t>p</m:t>
+                        </m:r>
+                      </m:e>
+                      <m:sub>
+                        <m:r>
+                          <m:t>k</m:t>
+                        </m:r>
+                      </m:sub>
+                    </m:sSub>
+                  </m:e>
+                </m:nary>
+                <m:r>
+                  <m:t>(1−</m:t>
+                </m:r>
+                <m:sSub>
+                  <m:e>
+                    <m:r>
+                      <m:t>p</m:t>
+                    </m:r>
+                  </m:e>
+                  <m:sub>
+                    <m:r>
+                      <m:t>k</m:t>
+                    </m:r>
+                  </m:sub>
+                </m:sSub>
+                <m:r>
+                  <m:t>)=1−</m:t>
+                </m:r>
+                <m:nary>
+                  <m:naryPr>
+                    <m:chr m:val="∑"/>
+                    <m:limLoc m:val="subSup"/>
+                    <m:grow m:val="1"/>
+                    <m:subHide m:val="off"/>
+                    <m:supHide m:val="on"/>
+                  </m:naryPr>
+                  <m:sub>
+                    <m:r>
+                      <m:t>k</m:t>
+                    </m:r>
+                  </m:sub>
+                  <m:sup/>
+                  <m:e>
+                    <m:sSubSup>
+                      <m:e>
+                        <m:r>
+                          <m:t>p</m:t>
+                        </m:r>
+                      </m:e>
+                      <m:sub>
+                        <m:r>
+                          <m:t>k</m:t>
+                        </m:r>
+                      </m:sub>
+                      <m:sup>
+                        <m:r>
+                          <m:t>2</m:t>
+                        </m:r>
+                      </m:sup>
+                    </m:sSubSup>
+                  </m:e>
+                </m:nary>
+              </m:oMath>
+            </ns0:m>
           </a:p>
           <a:p>
             <a:pPr>
               <a:spcAft>
                 <a:spcPts val="800"/>
               </a:spcAft>
-              <a:defRPr sz="2000"/>
-            </a:pPr>
-            <a:r>
-              <a:t>Почему они лучше Misclassification — объясним позже</a:t>
-            </a:r>
-          </a:p>
-        </p:txBody>
-      </p:sp>
-      <p:sp>
-        <p:nvSpPr>
-          <p:cNvPr id="4" name="TextBox 3"/>
-          <p:cNvSpPr txBox="1"/>
-          <p:nvPr/>
-        </p:nvSpPr>
-        <p:spPr>
-          <a:xfrm>
-            <a:off x="7772400" y="1371600"/>
-            <a:ext cx="4114800" cy="2286000"/>
-          </a:xfrm>
-          <a:prstGeom prst="rect">
-            <a:avLst/>
-          </a:prstGeom>
-          <a:noFill/>
-        </p:spPr>
-        <p:txBody>
-          <a:bodyPr wrap="square">
-            <a:spAutoFit/>
-          </a:bodyPr>
-          <a:lstStyle/>
-          <a:p>
-            <a:pPr>
-              <a:spcAft>
-                <a:spcPts val="600"/>
-              </a:spcAft>
-              <a:defRPr sz="1600">
-                <a:solidFill>
-                  <a:srgbClr val="555555"/>
-                </a:solidFill>
-              </a:defRPr>
-            </a:pPr>
-            <a:r>
-              <a:t>Энтропия и индекс Джини</a:t>
-            </a:r>
-          </a:p>
-          <a:p>
-            <a:pPr>
-              <a:spcAft>
-                <a:spcPts val="1000"/>
-              </a:spcAft>
-            </a:pPr>
-            <ns0:m xmlns:ns0="http://schemas.microsoft.com/office/drawing/2010/main">
-              <ns1:oMath xmlns:ns1="http://schemas.openxmlformats.org/officeDocument/2006/math">
-                <ns1:r>
-                  <ns1:t>H=−</ns1:t>
-                </ns1:r>
-              </ns1:oMath>
-            </ns0:m>
-          </a:p>
-          <a:p>
-            <a:pPr>
-              <a:spcAft>
-                <a:spcPts val="1000"/>
-              </a:spcAft>
-            </a:pPr>
-            <ns0:m xmlns:ns0="http://schemas.microsoft.com/office/drawing/2010/main">
-              <ns1:oMath xmlns:ns1="http://schemas.openxmlformats.org/officeDocument/2006/math">
-                <ns1:r>
-                  <ns1:t>G=</ns1:t>
-                </ns1:r>
-              </ns1:oMath>
-            </ns0:m>
-          </a:p>
-        </p:txBody>
-      </p:sp>
-    </p:spTree>
-  </p:cSld>
-  <p:clrMapOvr>
-    <a:masterClrMapping/>
-  </p:clrMapOvr>
-</p:sld>
-</file>
-
-<file path=ppt/slides/slide8.xml><?xml version="1.0" encoding="utf-8"?>
-<p:sld xmlns:a="http://schemas.openxmlformats.org/drawingml/2006/main" xmlns:p="http://schemas.openxmlformats.org/presentationml/2006/main" xmlns:r="http://schemas.openxmlformats.org/officeDocument/2006/relationships">
-  <p:cSld>
-    <p:spTree>
-      <p:nvGrpSpPr>
-        <p:cNvPr id="1" name=""/>
-        <p:cNvGrpSpPr/>
-        <p:nvPr/>
-      </p:nvGrpSpPr>
-      <p:grpSpPr/>
-      <p:sp>
-        <p:nvSpPr>
-          <p:cNvPr id="2" name="TextBox 1"/>
-          <p:cNvSpPr txBox="1"/>
-          <p:nvPr/>
-        </p:nvSpPr>
-        <p:spPr>
-          <a:xfrm>
-            <a:off x="457200" y="274320"/>
-            <a:ext cx="11247120" cy="914400"/>
-          </a:xfrm>
-          <a:prstGeom prst="rect">
-            <a:avLst/>
-          </a:prstGeom>
-          <a:noFill/>
-        </p:spPr>
-        <p:txBody>
-          <a:bodyPr wrap="square">
-            <a:spAutoFit/>
-          </a:bodyPr>
-          <a:lstStyle/>
-          <a:p>
-            <a:pPr>
-              <a:defRPr sz="3200" b="1">
-                <a:solidFill>
-                  <a:srgbClr val="1A1A2E"/>
-                </a:solidFill>
-              </a:defRPr>
-            </a:pPr>
-            <a:r>
-              <a:t>Энтропия и индекс Джини</a:t>
-            </a:r>
-          </a:p>
-        </p:txBody>
-      </p:sp>
-      <p:sp>
-        <p:nvSpPr>
-          <p:cNvPr id="3" name="TextBox 2"/>
-          <p:cNvSpPr txBox="1"/>
-          <p:nvPr/>
-        </p:nvSpPr>
-        <p:spPr>
-          <a:xfrm>
-            <a:off x="640080" y="1371600"/>
-            <a:ext cx="6858000" cy="5029200"/>
-          </a:xfrm>
-          <a:prstGeom prst="rect">
-            <a:avLst/>
-          </a:prstGeom>
-          <a:noFill/>
-        </p:spPr>
-        <p:txBody>
-          <a:bodyPr wrap="square">
-            <a:spAutoFit/>
-          </a:bodyPr>
-          <a:lstStyle/>
+            </a:pPr>
+            <a:r>
+              <a:rPr lang="ru-RU" dirty="0" sz="2000">
+                <a:solidFill>
+                  <a:srgbClr val="000000"/>
+                </a:solidFill>
+              </a:rPr>
+              <a:t>Обе функции строго вогнуты — учитывают распределение всех классов</a:t>
+            </a:r>
+          </a:p>
           <a:p>
             <a:pPr>
               <a:spcAft>
                 <a:spcPts val="800"/>
               </a:spcAft>
-              <a:defRPr sz="2000"/>
-            </a:pPr>
-            <a:r>
-              <a:t>Энтропия: H = -∑ p_k · log₂(p_k)</a:t>
+            </a:pPr>
+            <a:r>
+              <a:rPr lang="ru-RU" dirty="0" sz="2000">
+                <a:solidFill>
+                  <a:srgbClr val="000000"/>
+                </a:solidFill>
+              </a:rPr>
+              <a:t>Именно их используют на практике (sklearn: criterion='gini' или 'entropy')</a:t>
             </a:r>
           </a:p>
           <a:p>
@@ -8161,43 +8748,14 @@
               <a:spcAft>
                 <a:spcPts val="800"/>
               </a:spcAft>
-              <a:defRPr sz="2000"/>
-            </a:pPr>
-            <a:r>
-              <a:t>Индекс Джини: G = ∑ p_k · (1-p_k) = 1 - ∑ p_k²</a:t>
-            </a:r>
-          </a:p>
-          <a:p>
-            <a:pPr>
-              <a:spcAft>
-                <a:spcPts val="800"/>
-              </a:spcAft>
-              <a:defRPr sz="2000"/>
-            </a:pPr>
-            <a:r>
-              <a:t>Обе функции строго вогнуты — учитывают распределение всех классов</a:t>
-            </a:r>
-          </a:p>
-          <a:p>
-            <a:pPr>
-              <a:spcAft>
-                <a:spcPts val="800"/>
-              </a:spcAft>
-              <a:defRPr sz="2000"/>
-            </a:pPr>
-            <a:r>
-              <a:t>Именно их используют на практике (sklearn criterion=gini или entropy)</a:t>
-            </a:r>
-          </a:p>
-          <a:p>
-            <a:pPr>
-              <a:spcAft>
-                <a:spcPts val="800"/>
-              </a:spcAft>
-              <a:defRPr sz="2000"/>
-            </a:pPr>
-            <a:r>
-              <a:t>Почему они лучше Misclassification — объясним позже</a:t>
+            </a:pPr>
+            <a:r>
+              <a:rPr lang="ru-RU" dirty="0" sz="2000">
+                <a:solidFill>
+                  <a:srgbClr val="000000"/>
+                </a:solidFill>
+              </a:rPr>
+              <a:t>Почему misclassification слабее — разберём в теоретическом блоке</a:t>
             </a:r>
           </a:p>
         </p:txBody>
@@ -8234,6 +8792,140 @@
 </p:sld>
 </file>
 
+<file path=ppt/slides/slide8.xml><?xml version="1.0" encoding="utf-8"?>
+<p:sld xmlns:a="http://schemas.openxmlformats.org/drawingml/2006/main" xmlns:p="http://schemas.openxmlformats.org/presentationml/2006/main" xmlns:r="http://schemas.openxmlformats.org/officeDocument/2006/relationships">
+  <p:cSld>
+    <p:spTree>
+      <p:nvGrpSpPr>
+        <p:cNvPr id="1" name=""/>
+        <p:cNvGrpSpPr/>
+        <p:nvPr/>
+      </p:nvGrpSpPr>
+      <p:grpSpPr/>
+      <p:sp>
+        <p:nvSpPr>
+          <p:cNvPr id="2" name="TextBox 1"/>
+          <p:cNvSpPr txBox="1"/>
+          <p:nvPr/>
+        </p:nvSpPr>
+        <p:spPr>
+          <a:xfrm>
+            <a:off x="457200" y="274320"/>
+            <a:ext cx="11247120" cy="914400"/>
+          </a:xfrm>
+          <a:prstGeom prst="rect">
+            <a:avLst/>
+          </a:prstGeom>
+          <a:noFill/>
+        </p:spPr>
+        <p:txBody>
+          <a:bodyPr wrap="square">
+            <a:spAutoFit/>
+          </a:bodyPr>
+          <a:lstStyle/>
+          <a:p>
+            <a:r>
+              <a:rPr lang="ru-RU" dirty="0" sz="3200" b="1">
+                <a:solidFill>
+                  <a:srgbClr val="1A1A2E"/>
+                </a:solidFill>
+              </a:rPr>
+              <a:t>Классические алгоритмы деревьев решений</a:t>
+            </a:r>
+          </a:p>
+        </p:txBody>
+      </p:sp>
+      <p:sp>
+        <p:nvSpPr>
+          <p:cNvPr id="3" name="TextBox 2"/>
+          <p:cNvSpPr txBox="1"/>
+          <p:nvPr/>
+        </p:nvSpPr>
+        <p:spPr>
+          <a:xfrm>
+            <a:off x="640080" y="1371600"/>
+            <a:ext cx="11247120" cy="5029200"/>
+          </a:xfrm>
+          <a:prstGeom prst="rect">
+            <a:avLst/>
+          </a:prstGeom>
+          <a:noFill/>
+        </p:spPr>
+        <p:txBody>
+          <a:bodyPr wrap="square">
+            <a:spAutoFit/>
+          </a:bodyPr>
+          <a:lstStyle/>
+          <a:p>
+            <a:pPr>
+              <a:spcAft>
+                <a:spcPts val="800"/>
+              </a:spcAft>
+            </a:pPr>
+            <a:r>
+              <a:rPr lang="ru-RU" dirty="0" sz="2000">
+                <a:solidFill>
+                  <a:srgbClr val="000000"/>
+                </a:solidFill>
+              </a:rPr>
+              <a:t>ID3 (Iterative Dichotomiser 3, Quinlan, 1986) — энтропия, категориальные признаки, без прунинга</a:t>
+            </a:r>
+          </a:p>
+          <a:p>
+            <a:pPr>
+              <a:spcAft>
+                <a:spcPts val="800"/>
+              </a:spcAft>
+            </a:pPr>
+            <a:r>
+              <a:rPr lang="ru-RU" dirty="0" sz="2000">
+                <a:solidFill>
+                  <a:srgbClr val="000000"/>
+                </a:solidFill>
+              </a:rPr>
+              <a:t>C4.5 — наследник ID3: непрерывные признаки (пороги), Gain Ratio против high-cardinality, прунинг</a:t>
+            </a:r>
+          </a:p>
+          <a:p>
+            <a:pPr>
+              <a:spcAft>
+                <a:spcPts val="800"/>
+              </a:spcAft>
+            </a:pPr>
+            <a:r>
+              <a:rPr lang="ru-RU" dirty="0" sz="2000">
+                <a:solidFill>
+                  <a:srgbClr val="000000"/>
+                </a:solidFill>
+              </a:rPr>
+              <a:t>CART (Classification and Regression Trees, Breiman, 1984) — Gini/MSE, только бинарные разбиения</a:t>
+            </a:r>
+          </a:p>
+          <a:p>
+            <a:pPr>
+              <a:spcAft>
+                <a:spcPts val="800"/>
+              </a:spcAft>
+            </a:pPr>
+            <a:r>
+              <a:rPr lang="ru-RU" dirty="0" sz="2000">
+                <a:solidFill>
+                  <a:srgbClr val="000000"/>
+                </a:solidFill>
+              </a:rPr>
+              <a:t>sklearn DecisionTreeClassifier/Regressor — реализация в духе CART</a:t>
+            </a:r>
+          </a:p>
+        </p:txBody>
+      </p:sp>
+    </p:spTree>
+  </p:cSld>
+  <p:clrMapOvr>
+    <a:masterClrMapping/>
+  </p:clrMapOvr>
+</p:sld>
+</file>
+
 <file path=ppt/slides/slide9.xml><?xml version="1.0" encoding="utf-8"?>
 <p:sld xmlns:a="http://schemas.openxmlformats.org/drawingml/2006/main" xmlns:p="http://schemas.openxmlformats.org/presentationml/2006/main" xmlns:r="http://schemas.openxmlformats.org/officeDocument/2006/relationships">
   <p:cSld>
@@ -8266,14 +8958,12 @@
           </a:bodyPr>
           <a:lstStyle/>
           <a:p>
-            <a:pPr>
-              <a:defRPr sz="3200" b="1">
+            <a:r>
+              <a:rPr lang="ru-RU" dirty="0" sz="3200" b="1">
                 <a:solidFill>
                   <a:srgbClr val="1A1A2E"/>
                 </a:solidFill>
-              </a:defRPr>
-            </a:pPr>
-            <a:r>
+              </a:rPr>
               <a:t>Многоклассовая классификация без усилий</a:t>
             </a:r>
           </a:p>
@@ -8288,7 +8978,7 @@
         <p:spPr>
           <a:xfrm>
             <a:off x="640080" y="1371600"/>
-            <a:ext cx="6858000" cy="5029200"/>
+            <a:ext cx="11247120" cy="5029200"/>
           </a:xfrm>
           <a:prstGeom prst="rect">
             <a:avLst/>
@@ -8305,10 +8995,14 @@
               <a:spcAft>
                 <a:spcPts val="800"/>
               </a:spcAft>
-              <a:defRPr sz="2000"/>
-            </a:pPr>
-            <a:r>
-              <a:t>Линейным моделям нужно K бинарных классификаторов (one-vs-rest)</a:t>
+            </a:pPr>
+            <a:r>
+              <a:rPr lang="ru-RU" dirty="0" sz="2000">
+                <a:solidFill>
+                  <a:srgbClr val="000000"/>
+                </a:solidFill>
+              </a:rPr>
+              <a:t>Для K классов линейные модели часто используют one-vs-rest или одну модель с softmax</a:t>
             </a:r>
           </a:p>
           <a:p>
@@ -8316,10 +9010,14 @@
               <a:spcAft>
                 <a:spcPts val="800"/>
               </a:spcAft>
-              <a:defRPr sz="2000"/>
-            </a:pPr>
-            <a:r>
-              <a:t>Дерево решений обобщается на K классов естественно</a:t>
+            </a:pPr>
+            <a:r>
+              <a:rPr lang="ru-RU" dirty="0" sz="2000">
+                <a:solidFill>
+                  <a:srgbClr val="000000"/>
+                </a:solidFill>
+              </a:rPr>
+              <a:t>Дерево решений обобщается на K классов естественно — одна модель на все классы</a:t>
             </a:r>
           </a:p>
           <a:p>
@@ -8327,10 +9025,14 @@
               <a:spcAft>
                 <a:spcPts val="800"/>
               </a:spcAft>
-              <a:defRPr sz="2000"/>
-            </a:pPr>
-            <a:r>
-              <a:t>Просто подставляем K классов в формулы энтропии/Джини — алгоритм не меняется</a:t>
+            </a:pPr>
+            <a:r>
+              <a:rPr lang="ru-RU" dirty="0" sz="2000">
+                <a:solidFill>
+                  <a:srgbClr val="000000"/>
+                </a:solidFill>
+              </a:rPr>
+              <a:t>Подставляем K классов в формулы энтропии/Джини — алгоритм построения не меняется</a:t>
             </a:r>
           </a:p>
           <a:p>
@@ -8338,10 +9040,14 @@
               <a:spcAft>
                 <a:spcPts val="800"/>
               </a:spcAft>
-              <a:defRPr sz="2000"/>
-            </a:pPr>
-            <a:r>
-              <a:t>Никаких one-vs-rest, никаких дополнительных моделей</a:t>
+            </a:pPr>
+            <a:r>
+              <a:rPr lang="ru-RU" dirty="0" sz="2000">
+                <a:solidFill>
+                  <a:srgbClr val="000000"/>
+                </a:solidFill>
+              </a:rPr>
+              <a:t>Никаких дополнительных моделей и схем one-vs-rest</a:t>
             </a:r>
           </a:p>
         </p:txBody>

</xml_diff>

<commit_message>
Add references slides and Colab links for all complete lessons.
Create references.json per lesson, apply references agent (papers + Colab QR), and add apply_all_references.py helper. Logisticheskaya pptx rebuild pending (file locked).

Co-authored-by: Cursor <cursoragent@cursor.com>
</commit_message>
<xml_diff>
--- a/lessons/derevo_resheniy/presentation.pptx
+++ b/lessons/derevo_resheniy/presentation.pptx
@@ -29,6 +29,7 @@
     <p:sldId id="277" r:id="rId29"/>
     <p:sldId id="278" r:id="rId30"/>
     <p:sldId id="279" r:id="rId31"/>
+    <p:sldId id="280" r:id="rId32"/>
   </p:sldIdLst>
   <p:sldSz cx="12191695" cy="6858000" type="screen4x3"/>
   <p:notesSz cx="6858000" cy="9144000"/>
@@ -1576,6 +1577,76 @@
           <a:p>
             <a:r>
               <a:t>Краткое резюме. Можно пропустить при нехватке времени — суть уже на предыдущем слайде.</a:t>
+            </a:r>
+          </a:p>
+        </p:txBody>
+      </p:sp>
+      <p:sp>
+        <p:nvSpPr>
+          <p:cNvPr id="4" name="Slide Number Placeholder 3"/>
+          <p:cNvSpPr>
+            <a:spLocks noGrp="1"/>
+          </p:cNvSpPr>
+          <p:nvPr>
+            <p:ph type="sldNum" idx="5" sz="quarter"/>
+          </p:nvPr>
+        </p:nvSpPr>
+        <p:spPr/>
+      </p:sp>
+    </p:spTree>
+  </p:cSld>
+  <p:clrMapOvr>
+    <a:masterClrMapping/>
+  </p:clrMapOvr>
+</p:notes>
+</file>
+
+<file path=ppt/notesSlides/notesSlide24.xml><?xml version="1.0" encoding="utf-8"?>
+<p:notes xmlns:a="http://schemas.openxmlformats.org/drawingml/2006/main" xmlns:p="http://schemas.openxmlformats.org/presentationml/2006/main" xmlns:r="http://schemas.openxmlformats.org/officeDocument/2006/relationships">
+  <p:cSld>
+    <p:spTree>
+      <p:nvGrpSpPr>
+        <p:cNvPr id="1" name=""/>
+        <p:cNvGrpSpPr/>
+        <p:nvPr/>
+      </p:nvGrpSpPr>
+      <p:grpSpPr>
+        <a:xfrm>
+          <a:off x="0" y="0"/>
+          <a:ext cx="0" cy="0"/>
+          <a:chOff x="0" y="0"/>
+          <a:chExt cx="0" cy="0"/>
+        </a:xfrm>
+      </p:grpSpPr>
+      <p:sp>
+        <p:nvSpPr>
+          <p:cNvPr id="2" name="Slide Image Placeholder 1"/>
+          <p:cNvSpPr>
+            <a:spLocks noGrp="1"/>
+          </p:cNvSpPr>
+          <p:nvPr>
+            <p:ph type="sldImg" idx="2"/>
+          </p:nvPr>
+        </p:nvSpPr>
+        <p:spPr/>
+      </p:sp>
+      <p:sp>
+        <p:nvSpPr>
+          <p:cNvPr id="3" name="Notes Placeholder 2"/>
+          <p:cNvSpPr>
+            <a:spLocks noGrp="1"/>
+          </p:cNvSpPr>
+          <p:nvPr>
+            <p:ph type="body" idx="3" sz="quarter"/>
+          </p:nvPr>
+        </p:nvSpPr>
+        <p:spPr/>
+        <p:txBody>
+          <a:bodyPr/>
+          <a:lstStyle/>
+          <a:p>
+            <a:r>
+              <a:t>Colab-ссылки обновляются агентом при --apply.</a:t>
             </a:r>
           </a:p>
         </p:txBody>
@@ -5644,8 +5715,8 @@
         </p:blipFill>
         <p:spPr>
           <a:xfrm>
-            <a:off x="7772400" y="1371600"/>
-            <a:ext cx="4114800" cy="2571750"/>
+            <a:off x="7635240" y="2208847"/>
+            <a:ext cx="4343400" cy="2714625"/>
           </a:xfrm>
           <a:prstGeom prst="rect">
             <a:avLst/>
@@ -5921,8 +5992,8 @@
         </p:blipFill>
         <p:spPr>
           <a:xfrm>
-            <a:off x="7772400" y="1371600"/>
-            <a:ext cx="4114800" cy="2571750"/>
+            <a:off x="7635240" y="2208847"/>
+            <a:ext cx="4343400" cy="2714625"/>
           </a:xfrm>
           <a:prstGeom prst="rect">
             <a:avLst/>
@@ -6466,8 +6537,8 @@
         </p:blipFill>
         <p:spPr>
           <a:xfrm>
-            <a:off x="7772400" y="1371600"/>
-            <a:ext cx="4114800" cy="3086100"/>
+            <a:off x="7635240" y="1937384"/>
+            <a:ext cx="4343400" cy="3257550"/>
           </a:xfrm>
           <a:prstGeom prst="rect">
             <a:avLst/>
@@ -6758,8 +6829,8 @@
         </p:blipFill>
         <p:spPr>
           <a:xfrm>
-            <a:off x="7772400" y="1371600"/>
-            <a:ext cx="4114800" cy="2185477"/>
+            <a:off x="7635240" y="2412714"/>
+            <a:ext cx="4343400" cy="2306892"/>
           </a:xfrm>
           <a:prstGeom prst="rect">
             <a:avLst/>
@@ -7775,6 +7846,470 @@
 </p:sld>
 </file>
 
+<file path=ppt/slides/slide25.xml><?xml version="1.0" encoding="utf-8"?>
+<p:sld xmlns:a="http://schemas.openxmlformats.org/drawingml/2006/main" xmlns:p="http://schemas.openxmlformats.org/presentationml/2006/main" xmlns:r="http://schemas.openxmlformats.org/officeDocument/2006/relationships">
+  <p:cSld>
+    <p:spTree>
+      <p:nvGrpSpPr>
+        <p:cNvPr id="1" name=""/>
+        <p:cNvGrpSpPr/>
+        <p:nvPr/>
+      </p:nvGrpSpPr>
+      <p:grpSpPr/>
+      <p:sp>
+        <p:nvSpPr>
+          <p:cNvPr id="2" name="TextBox 1"/>
+          <p:cNvSpPr txBox="1"/>
+          <p:nvPr/>
+        </p:nvSpPr>
+        <p:spPr>
+          <a:xfrm>
+            <a:off x="457200" y="274320"/>
+            <a:ext cx="11247120" cy="914400"/>
+          </a:xfrm>
+          <a:prstGeom prst="rect">
+            <a:avLst/>
+          </a:prstGeom>
+          <a:noFill/>
+        </p:spPr>
+        <p:txBody>
+          <a:bodyPr wrap="square">
+            <a:spAutoFit/>
+          </a:bodyPr>
+          <a:lstStyle/>
+          <a:p>
+            <a:r>
+              <a:rPr lang="ru-RU" dirty="0" sz="3200" b="1">
+                <a:solidFill>
+                  <a:srgbClr val="1A1A2E"/>
+                </a:solidFill>
+              </a:rPr>
+              <a:t>Источники и практика</a:t>
+            </a:r>
+          </a:p>
+        </p:txBody>
+      </p:sp>
+      <p:sp>
+        <p:nvSpPr>
+          <p:cNvPr id="3" name="TextBox 2"/>
+          <p:cNvSpPr txBox="1"/>
+          <p:nvPr/>
+        </p:nvSpPr>
+        <p:spPr>
+          <a:xfrm>
+            <a:off x="640080" y="1325880"/>
+            <a:ext cx="6583680" cy="320040"/>
+          </a:xfrm>
+          <a:prstGeom prst="rect">
+            <a:avLst/>
+          </a:prstGeom>
+          <a:noFill/>
+        </p:spPr>
+        <p:txBody>
+          <a:bodyPr wrap="none">
+            <a:spAutoFit/>
+          </a:bodyPr>
+          <a:lstStyle/>
+          <a:p>
+            <a:pPr>
+              <a:defRPr sz="1800" b="1">
+                <a:solidFill>
+                  <a:srgbClr val="000000"/>
+                </a:solidFill>
+              </a:defRPr>
+            </a:pPr>
+            <a:r>
+              <a:t>Литература</a:t>
+            </a:r>
+          </a:p>
+        </p:txBody>
+      </p:sp>
+      <p:sp>
+        <p:nvSpPr>
+          <p:cNvPr id="4" name="TextBox 3"/>
+          <p:cNvSpPr txBox="1"/>
+          <p:nvPr/>
+        </p:nvSpPr>
+        <p:spPr>
+          <a:xfrm>
+            <a:off x="640080" y="1673352"/>
+            <a:ext cx="6583680" cy="566928"/>
+          </a:xfrm>
+          <a:prstGeom prst="rect">
+            <a:avLst/>
+          </a:prstGeom>
+          <a:noFill/>
+        </p:spPr>
+        <p:txBody>
+          <a:bodyPr wrap="square">
+            <a:spAutoFit/>
+          </a:bodyPr>
+          <a:lstStyle/>
+          <a:p>
+            <a:pPr>
+              <a:spcAft>
+                <a:spcPts val="400"/>
+              </a:spcAft>
+            </a:pPr>
+            <a:r>
+              <a:rPr lang="ru-RU" dirty="0" sz="1600">
+                <a:solidFill>
+                  <a:srgbClr val="000000"/>
+                </a:solidFill>
+              </a:rPr>
+              <a:t xml:space="preserve">• </a:t>
+            </a:r>
+            <a:r>
+              <a:rPr sz="1600">
+                <a:solidFill>
+                  <a:srgbClr val="3366CC"/>
+                </a:solidFill>
+                <a:hlinkClick r:id="rId2"/>
+              </a:rPr>
+              <a:t>Breiman L., Friedman J., Olshen R., Stone C. (1984). Classification and Regression Trees</a:t>
+            </a:r>
+          </a:p>
+        </p:txBody>
+      </p:sp>
+      <p:sp>
+        <p:nvSpPr>
+          <p:cNvPr id="5" name="TextBox 4"/>
+          <p:cNvSpPr txBox="1"/>
+          <p:nvPr/>
+        </p:nvSpPr>
+        <p:spPr>
+          <a:xfrm>
+            <a:off x="640080" y="2240280"/>
+            <a:ext cx="6583680" cy="566928"/>
+          </a:xfrm>
+          <a:prstGeom prst="rect">
+            <a:avLst/>
+          </a:prstGeom>
+          <a:noFill/>
+        </p:spPr>
+        <p:txBody>
+          <a:bodyPr wrap="square">
+            <a:spAutoFit/>
+          </a:bodyPr>
+          <a:lstStyle/>
+          <a:p>
+            <a:pPr>
+              <a:spcAft>
+                <a:spcPts val="400"/>
+              </a:spcAft>
+            </a:pPr>
+            <a:r>
+              <a:rPr lang="ru-RU" dirty="0" sz="1600">
+                <a:solidFill>
+                  <a:srgbClr val="000000"/>
+                </a:solidFill>
+              </a:rPr>
+              <a:t xml:space="preserve">• </a:t>
+            </a:r>
+            <a:r>
+              <a:rPr sz="1600">
+                <a:solidFill>
+                  <a:srgbClr val="3366CC"/>
+                </a:solidFill>
+                <a:hlinkClick r:id="rId3"/>
+              </a:rPr>
+              <a:t>Quinlan J.R. (1986). Induction of Decision Trees</a:t>
+            </a:r>
+          </a:p>
+        </p:txBody>
+      </p:sp>
+      <p:sp>
+        <p:nvSpPr>
+          <p:cNvPr id="6" name="TextBox 5"/>
+          <p:cNvSpPr txBox="1"/>
+          <p:nvPr/>
+        </p:nvSpPr>
+        <p:spPr>
+          <a:xfrm>
+            <a:off x="640080" y="2807208"/>
+            <a:ext cx="6583680" cy="566928"/>
+          </a:xfrm>
+          <a:prstGeom prst="rect">
+            <a:avLst/>
+          </a:prstGeom>
+          <a:noFill/>
+        </p:spPr>
+        <p:txBody>
+          <a:bodyPr wrap="square">
+            <a:spAutoFit/>
+          </a:bodyPr>
+          <a:lstStyle/>
+          <a:p>
+            <a:pPr>
+              <a:spcAft>
+                <a:spcPts val="400"/>
+              </a:spcAft>
+            </a:pPr>
+            <a:r>
+              <a:rPr lang="ru-RU" dirty="0" sz="1600">
+                <a:solidFill>
+                  <a:srgbClr val="000000"/>
+                </a:solidFill>
+              </a:rPr>
+              <a:t xml:space="preserve">• </a:t>
+            </a:r>
+            <a:r>
+              <a:rPr sz="1600">
+                <a:solidFill>
+                  <a:srgbClr val="3366CC"/>
+                </a:solidFill>
+                <a:hlinkClick r:id="rId4"/>
+              </a:rPr>
+              <a:t>Breiman L. (2001). Random Forests</a:t>
+            </a:r>
+          </a:p>
+        </p:txBody>
+      </p:sp>
+      <p:sp>
+        <p:nvSpPr>
+          <p:cNvPr id="7" name="TextBox 6"/>
+          <p:cNvSpPr txBox="1"/>
+          <p:nvPr/>
+        </p:nvSpPr>
+        <p:spPr>
+          <a:xfrm>
+            <a:off x="640080" y="3374136"/>
+            <a:ext cx="6583680" cy="320040"/>
+          </a:xfrm>
+          <a:prstGeom prst="rect">
+            <a:avLst/>
+          </a:prstGeom>
+          <a:noFill/>
+        </p:spPr>
+        <p:txBody>
+          <a:bodyPr wrap="none">
+            <a:spAutoFit/>
+          </a:bodyPr>
+          <a:lstStyle/>
+          <a:p>
+            <a:pPr>
+              <a:defRPr sz="1800" b="1">
+                <a:solidFill>
+                  <a:srgbClr val="000000"/>
+                </a:solidFill>
+              </a:defRPr>
+            </a:pPr>
+            <a:r>
+              <a:t>Практика в Colab</a:t>
+            </a:r>
+          </a:p>
+        </p:txBody>
+      </p:sp>
+      <p:sp>
+        <p:nvSpPr>
+          <p:cNvPr id="8" name="TextBox 7"/>
+          <p:cNvSpPr txBox="1"/>
+          <p:nvPr/>
+        </p:nvSpPr>
+        <p:spPr>
+          <a:xfrm>
+            <a:off x="640080" y="3721608"/>
+            <a:ext cx="6583680" cy="457200"/>
+          </a:xfrm>
+          <a:prstGeom prst="rect">
+            <a:avLst/>
+          </a:prstGeom>
+          <a:noFill/>
+        </p:spPr>
+        <p:txBody>
+          <a:bodyPr wrap="square">
+            <a:spAutoFit/>
+          </a:bodyPr>
+          <a:lstStyle/>
+          <a:p>
+            <a:r>
+              <a:rPr lang="ru-RU" dirty="0" sz="1500">
+                <a:solidFill>
+                  <a:srgbClr val="000000"/>
+                </a:solidFill>
+              </a:rPr>
+              <a:t xml:space="preserve">• Примеры по слайдам: </a:t>
+            </a:r>
+            <a:r>
+              <a:rPr sz="1400">
+                <a:solidFill>
+                  <a:srgbClr val="3366CC"/>
+                </a:solidFill>
+                <a:hlinkClick r:id="rId5"/>
+              </a:rPr>
+              <a:t>https://colab.research.google.com/github/gurovic/ml-lessons/blob/feature/references-and-slide-code/lessons/derevo_resheniy/code.ipynb</a:t>
+            </a:r>
+          </a:p>
+        </p:txBody>
+      </p:sp>
+      <p:sp>
+        <p:nvSpPr>
+          <p:cNvPr id="9" name="TextBox 8"/>
+          <p:cNvSpPr txBox="1"/>
+          <p:nvPr/>
+        </p:nvSpPr>
+        <p:spPr>
+          <a:xfrm>
+            <a:off x="640080" y="4178808"/>
+            <a:ext cx="6583680" cy="457200"/>
+          </a:xfrm>
+          <a:prstGeom prst="rect">
+            <a:avLst/>
+          </a:prstGeom>
+          <a:noFill/>
+        </p:spPr>
+        <p:txBody>
+          <a:bodyPr wrap="square">
+            <a:spAutoFit/>
+          </a:bodyPr>
+          <a:lstStyle/>
+          <a:p>
+            <a:r>
+              <a:rPr lang="ru-RU" dirty="0" sz="1500">
+                <a:solidFill>
+                  <a:srgbClr val="000000"/>
+                </a:solidFill>
+              </a:rPr>
+              <a:t xml:space="preserve">• Мини-проект: </a:t>
+            </a:r>
+            <a:r>
+              <a:rPr sz="1400">
+                <a:solidFill>
+                  <a:srgbClr val="3366CC"/>
+                </a:solidFill>
+                <a:hlinkClick r:id="rId6"/>
+              </a:rPr>
+              <a:t>https://colab.research.google.com/github/gurovic/ml-lessons/blob/feature/references-and-slide-code/lessons/derevo_resheniy/project.ipynb</a:t>
+            </a:r>
+          </a:p>
+        </p:txBody>
+      </p:sp>
+      <p:pic>
+        <p:nvPicPr>
+          <p:cNvPr id="10" name="Picture 9" descr="_qr_ref_24_0.png"/>
+          <p:cNvPicPr>
+            <a:picLocks noChangeAspect="1"/>
+          </p:cNvPicPr>
+          <p:nvPr/>
+        </p:nvPicPr>
+        <p:blipFill>
+          <a:blip r:embed="rId7"/>
+          <a:stretch>
+            <a:fillRect/>
+          </a:stretch>
+        </p:blipFill>
+        <p:spPr>
+          <a:xfrm>
+            <a:off x="8229600" y="1463040"/>
+            <a:ext cx="1051560" cy="1051560"/>
+          </a:xfrm>
+          <a:prstGeom prst="rect">
+            <a:avLst/>
+          </a:prstGeom>
+        </p:spPr>
+      </p:pic>
+      <p:sp>
+        <p:nvSpPr>
+          <p:cNvPr id="11" name="TextBox 10"/>
+          <p:cNvSpPr txBox="1"/>
+          <p:nvPr/>
+        </p:nvSpPr>
+        <p:spPr>
+          <a:xfrm>
+            <a:off x="8138160" y="2532888"/>
+            <a:ext cx="1417319" cy="274320"/>
+          </a:xfrm>
+          <a:prstGeom prst="rect">
+            <a:avLst/>
+          </a:prstGeom>
+          <a:noFill/>
+        </p:spPr>
+        <p:txBody>
+          <a:bodyPr wrap="none">
+            <a:spAutoFit/>
+          </a:bodyPr>
+          <a:lstStyle/>
+          <a:p>
+            <a:pPr algn="ctr">
+              <a:defRPr sz="1000">
+                <a:solidFill>
+                  <a:srgbClr val="555555"/>
+                </a:solidFill>
+              </a:defRPr>
+            </a:pPr>
+            <a:r>
+              <a:t>Примеры по слайдам</a:t>
+            </a:r>
+          </a:p>
+        </p:txBody>
+      </p:sp>
+      <p:pic>
+        <p:nvPicPr>
+          <p:cNvPr id="12" name="Picture 11" descr="_qr_ref_24_1.png"/>
+          <p:cNvPicPr>
+            <a:picLocks noChangeAspect="1"/>
+          </p:cNvPicPr>
+          <p:nvPr/>
+        </p:nvPicPr>
+        <p:blipFill>
+          <a:blip r:embed="rId8"/>
+          <a:stretch>
+            <a:fillRect/>
+          </a:stretch>
+        </p:blipFill>
+        <p:spPr>
+          <a:xfrm>
+            <a:off x="8229600" y="3063240"/>
+            <a:ext cx="1051560" cy="1051560"/>
+          </a:xfrm>
+          <a:prstGeom prst="rect">
+            <a:avLst/>
+          </a:prstGeom>
+        </p:spPr>
+      </p:pic>
+      <p:sp>
+        <p:nvSpPr>
+          <p:cNvPr id="13" name="TextBox 12"/>
+          <p:cNvSpPr txBox="1"/>
+          <p:nvPr/>
+        </p:nvSpPr>
+        <p:spPr>
+          <a:xfrm>
+            <a:off x="8138160" y="4133087"/>
+            <a:ext cx="1417319" cy="274320"/>
+          </a:xfrm>
+          <a:prstGeom prst="rect">
+            <a:avLst/>
+          </a:prstGeom>
+          <a:noFill/>
+        </p:spPr>
+        <p:txBody>
+          <a:bodyPr wrap="none">
+            <a:spAutoFit/>
+          </a:bodyPr>
+          <a:lstStyle/>
+          <a:p>
+            <a:pPr algn="ctr">
+              <a:defRPr sz="1000">
+                <a:solidFill>
+                  <a:srgbClr val="555555"/>
+                </a:solidFill>
+              </a:defRPr>
+            </a:pPr>
+            <a:r>
+              <a:t>Мини-проект</a:t>
+            </a:r>
+          </a:p>
+        </p:txBody>
+      </p:sp>
+    </p:spTree>
+  </p:cSld>
+  <p:clrMapOvr>
+    <a:masterClrMapping/>
+  </p:clrMapOvr>
+</p:sld>
+</file>
+
 <file path=ppt/slides/slide3.xml><?xml version="1.0" encoding="utf-8"?>
 <p:sld xmlns:a="http://schemas.openxmlformats.org/drawingml/2006/main" xmlns:p="http://schemas.openxmlformats.org/presentationml/2006/main" xmlns:r="http://schemas.openxmlformats.org/officeDocument/2006/relationships">
   <p:cSld>
@@ -7917,8 +8452,8 @@
         </p:blipFill>
         <p:spPr>
           <a:xfrm>
-            <a:off x="7772400" y="1371600"/>
-            <a:ext cx="4114800" cy="2375472"/>
+            <a:off x="7635240" y="2312438"/>
+            <a:ext cx="4343400" cy="2507442"/>
           </a:xfrm>
           <a:prstGeom prst="rect">
             <a:avLst/>
@@ -8156,8 +8691,8 @@
         </p:blipFill>
         <p:spPr>
           <a:xfrm>
-            <a:off x="7772400" y="1371600"/>
-            <a:ext cx="4114800" cy="3086100"/>
+            <a:off x="7635240" y="1937384"/>
+            <a:ext cx="4343400" cy="3257550"/>
           </a:xfrm>
           <a:prstGeom prst="rect">
             <a:avLst/>
@@ -8776,8 +9311,8 @@
         </p:blipFill>
         <p:spPr>
           <a:xfrm>
-            <a:off x="7772400" y="1371600"/>
-            <a:ext cx="4114800" cy="2571750"/>
+            <a:off x="7635240" y="2208847"/>
+            <a:ext cx="4343400" cy="2714625"/>
           </a:xfrm>
           <a:prstGeom prst="rect">
             <a:avLst/>

</xml_diff>

<commit_message>
Add slide code agent with bootstrap snippets and pptx rendering.
Enrich 59 slides across 5 lessons with code_examples, render monospace code blocks in pptx_builder, and document the pipeline step in RULES.md.

Co-authored-by: Cursor <cursoragent@cursor.com>
</commit_message>
<xml_diff>
--- a/lessons/derevo_resheniy/presentation.pptx
+++ b/lessons/derevo_resheniy/presentation.pptx
@@ -5342,7 +5342,7 @@
         <p:spPr>
           <a:xfrm>
             <a:off x="640080" y="1371600"/>
-            <a:ext cx="11247120" cy="5029200"/>
+            <a:ext cx="11247120" cy="1810512"/>
           </a:xfrm>
           <a:prstGeom prst="rect">
             <a:avLst/>
@@ -5476,7 +5476,7 @@
         <p:spPr>
           <a:xfrm>
             <a:off x="640080" y="1371600"/>
-            <a:ext cx="11247120" cy="5029200"/>
+            <a:ext cx="11247120" cy="1810512"/>
           </a:xfrm>
           <a:prstGeom prst="rect">
             <a:avLst/>
@@ -5546,6 +5546,173 @@
                 </a:solidFill>
               </a:rPr>
               <a:t>Это частично решает проблему дисбаланса</a:t>
+            </a:r>
+          </a:p>
+        </p:txBody>
+      </p:sp>
+      <p:sp>
+        <p:nvSpPr>
+          <p:cNvPr id="4" name="Rectangle 3"/>
+          <p:cNvSpPr/>
+          <p:nvPr/>
+        </p:nvSpPr>
+        <p:spPr>
+          <a:xfrm>
+            <a:off x="640080" y="3291840"/>
+            <a:ext cx="11155680" cy="804672"/>
+          </a:xfrm>
+          <a:prstGeom prst="rect">
+            <a:avLst/>
+          </a:prstGeom>
+          <a:solidFill>
+            <a:srgbClr val="F5F5F5"/>
+          </a:solidFill>
+          <a:ln>
+            <a:solidFill>
+              <a:srgbClr val="DDDDDD"/>
+            </a:solidFill>
+          </a:ln>
+        </p:spPr>
+        <p:style>
+          <a:lnRef idx="1">
+            <a:schemeClr val="accent1"/>
+          </a:lnRef>
+          <a:fillRef idx="3">
+            <a:schemeClr val="accent1"/>
+          </a:fillRef>
+          <a:effectRef idx="2">
+            <a:schemeClr val="accent1"/>
+          </a:effectRef>
+          <a:fontRef idx="minor">
+            <a:schemeClr val="lt1"/>
+          </a:fontRef>
+        </p:style>
+        <p:txBody>
+          <a:bodyPr rtlCol="0" anchor="ctr"/>
+          <a:lstStyle/>
+          <a:p>
+            <a:pPr algn="ctr"/>
+          </a:p>
+        </p:txBody>
+      </p:sp>
+      <p:sp>
+        <p:nvSpPr>
+          <p:cNvPr id="5" name="TextBox 4"/>
+          <p:cNvSpPr txBox="1"/>
+          <p:nvPr/>
+        </p:nvSpPr>
+        <p:spPr>
+          <a:xfrm>
+            <a:off x="713231" y="3328416"/>
+            <a:ext cx="11009376" cy="731520"/>
+          </a:xfrm>
+          <a:prstGeom prst="rect">
+            <a:avLst/>
+          </a:prstGeom>
+          <a:noFill/>
+        </p:spPr>
+        <p:txBody>
+          <a:bodyPr wrap="square">
+            <a:noAutofit/>
+          </a:bodyPr>
+          <a:lstStyle/>
+          <a:p>
+            <a:pPr>
+              <a:spcAft>
+                <a:spcPts val="0"/>
+              </a:spcAft>
+              <a:defRPr sz="1100">
+                <a:solidFill>
+                  <a:srgbClr val="000000"/>
+                </a:solidFill>
+                <a:latin typeface="Consolas"/>
+              </a:defRPr>
+            </a:pPr>
+            <a:r>
+              <a:t>from sklearn.metrics import accuracy_score, f1_score</a:t>
+            </a:r>
+          </a:p>
+          <a:p>
+            <a:pPr>
+              <a:spcAft>
+                <a:spcPts val="0"/>
+              </a:spcAft>
+              <a:defRPr sz="1100">
+                <a:solidFill>
+                  <a:srgbClr val="000000"/>
+                </a:solidFill>
+                <a:latin typeface="Consolas"/>
+              </a:defRPr>
+            </a:pPr>
+            <a:r>
+              <a:t>y_pred = clf.predict(X_test)</a:t>
+            </a:r>
+          </a:p>
+          <a:p>
+            <a:pPr>
+              <a:spcAft>
+                <a:spcPts val="0"/>
+              </a:spcAft>
+              <a:defRPr sz="1100">
+                <a:solidFill>
+                  <a:srgbClr val="000000"/>
+                </a:solidFill>
+                <a:latin typeface="Consolas"/>
+              </a:defRPr>
+            </a:pPr>
+            <a:r>
+              <a:t>print(accuracy_score(y_test, y_pred))</a:t>
+            </a:r>
+          </a:p>
+          <a:p>
+            <a:pPr>
+              <a:spcAft>
+                <a:spcPts val="0"/>
+              </a:spcAft>
+              <a:defRPr sz="1100">
+                <a:solidFill>
+                  <a:srgbClr val="000000"/>
+                </a:solidFill>
+                <a:latin typeface="Consolas"/>
+              </a:defRPr>
+            </a:pPr>
+            <a:r>
+              <a:t>print(f1_score(y_test, y_pred, average='macro'))</a:t>
+            </a:r>
+          </a:p>
+        </p:txBody>
+      </p:sp>
+      <p:sp>
+        <p:nvSpPr>
+          <p:cNvPr id="6" name="TextBox 5"/>
+          <p:cNvSpPr txBox="1"/>
+          <p:nvPr/>
+        </p:nvSpPr>
+        <p:spPr>
+          <a:xfrm>
+            <a:off x="640080" y="4151376"/>
+            <a:ext cx="11155680" cy="201168"/>
+          </a:xfrm>
+          <a:prstGeom prst="rect">
+            <a:avLst/>
+          </a:prstGeom>
+          <a:noFill/>
+        </p:spPr>
+        <p:txBody>
+          <a:bodyPr wrap="none">
+            <a:spAutoFit/>
+          </a:bodyPr>
+          <a:lstStyle/>
+          <a:p>
+            <a:pPr algn="l">
+              <a:defRPr sz="1000" i="1">
+                <a:solidFill>
+                  <a:srgbClr val="555555"/>
+                </a:solidFill>
+              </a:defRPr>
+            </a:pPr>
+            <a:r>
+              <a:t>Accuracy и F1</a:t>
             </a:r>
           </a:p>
         </p:txBody>
@@ -5610,7 +5777,7 @@
         <p:spPr>
           <a:xfrm>
             <a:off x="640080" y="1371600"/>
-            <a:ext cx="6858000" cy="5029200"/>
+            <a:ext cx="6858000" cy="2194560"/>
           </a:xfrm>
           <a:prstGeom prst="rect">
             <a:avLst/>
@@ -5699,9 +5866,160 @@
           </a:p>
         </p:txBody>
       </p:sp>
+      <p:sp>
+        <p:nvSpPr>
+          <p:cNvPr id="4" name="Rectangle 3"/>
+          <p:cNvSpPr/>
+          <p:nvPr/>
+        </p:nvSpPr>
+        <p:spPr>
+          <a:xfrm>
+            <a:off x="640080" y="3675887"/>
+            <a:ext cx="6766560" cy="630936"/>
+          </a:xfrm>
+          <a:prstGeom prst="rect">
+            <a:avLst/>
+          </a:prstGeom>
+          <a:solidFill>
+            <a:srgbClr val="F5F5F5"/>
+          </a:solidFill>
+          <a:ln>
+            <a:solidFill>
+              <a:srgbClr val="DDDDDD"/>
+            </a:solidFill>
+          </a:ln>
+        </p:spPr>
+        <p:style>
+          <a:lnRef idx="1">
+            <a:schemeClr val="accent1"/>
+          </a:lnRef>
+          <a:fillRef idx="3">
+            <a:schemeClr val="accent1"/>
+          </a:fillRef>
+          <a:effectRef idx="2">
+            <a:schemeClr val="accent1"/>
+          </a:effectRef>
+          <a:fontRef idx="minor">
+            <a:schemeClr val="lt1"/>
+          </a:fontRef>
+        </p:style>
+        <p:txBody>
+          <a:bodyPr rtlCol="0" anchor="ctr"/>
+          <a:lstStyle/>
+          <a:p>
+            <a:pPr algn="ctr"/>
+          </a:p>
+        </p:txBody>
+      </p:sp>
+      <p:sp>
+        <p:nvSpPr>
+          <p:cNvPr id="5" name="TextBox 4"/>
+          <p:cNvSpPr txBox="1"/>
+          <p:nvPr/>
+        </p:nvSpPr>
+        <p:spPr>
+          <a:xfrm>
+            <a:off x="713231" y="3712463"/>
+            <a:ext cx="6620256" cy="557784"/>
+          </a:xfrm>
+          <a:prstGeom prst="rect">
+            <a:avLst/>
+          </a:prstGeom>
+          <a:noFill/>
+        </p:spPr>
+        <p:txBody>
+          <a:bodyPr wrap="square">
+            <a:noAutofit/>
+          </a:bodyPr>
+          <a:lstStyle/>
+          <a:p>
+            <a:pPr>
+              <a:spcAft>
+                <a:spcPts val="0"/>
+              </a:spcAft>
+              <a:defRPr sz="1100">
+                <a:solidFill>
+                  <a:srgbClr val="000000"/>
+                </a:solidFill>
+                <a:latin typeface="Consolas"/>
+              </a:defRPr>
+            </a:pPr>
+            <a:r>
+              <a:t>clf_deep = DecisionTreeClassifier(max_depth=None)</a:t>
+            </a:r>
+          </a:p>
+          <a:p>
+            <a:pPr>
+              <a:spcAft>
+                <a:spcPts val="0"/>
+              </a:spcAft>
+              <a:defRPr sz="1100">
+                <a:solidFill>
+                  <a:srgbClr val="000000"/>
+                </a:solidFill>
+                <a:latin typeface="Consolas"/>
+              </a:defRPr>
+            </a:pPr>
+            <a:r>
+              <a:t>clf_reg = DecisionTreeClassifier(max_depth=3)</a:t>
+            </a:r>
+          </a:p>
+          <a:p>
+            <a:pPr>
+              <a:spcAft>
+                <a:spcPts val="0"/>
+              </a:spcAft>
+              <a:defRPr sz="1100">
+                <a:solidFill>
+                  <a:srgbClr val="000000"/>
+                </a:solidFill>
+                <a:latin typeface="Consolas"/>
+              </a:defRPr>
+            </a:pPr>
+            <a:r>
+              <a:t># глубокое дерево: высокий train, низкий test</a:t>
+            </a:r>
+          </a:p>
+        </p:txBody>
+      </p:sp>
+      <p:sp>
+        <p:nvSpPr>
+          <p:cNvPr id="6" name="TextBox 5"/>
+          <p:cNvSpPr txBox="1"/>
+          <p:nvPr/>
+        </p:nvSpPr>
+        <p:spPr>
+          <a:xfrm>
+            <a:off x="640080" y="4361688"/>
+            <a:ext cx="6766560" cy="201168"/>
+          </a:xfrm>
+          <a:prstGeom prst="rect">
+            <a:avLst/>
+          </a:prstGeom>
+          <a:noFill/>
+        </p:spPr>
+        <p:txBody>
+          <a:bodyPr wrap="none">
+            <a:spAutoFit/>
+          </a:bodyPr>
+          <a:lstStyle/>
+          <a:p>
+            <a:pPr algn="l">
+              <a:defRPr sz="1000" i="1">
+                <a:solidFill>
+                  <a:srgbClr val="555555"/>
+                </a:solidFill>
+              </a:defRPr>
+            </a:pPr>
+            <a:r>
+              <a:t>Ограничение max_depth</a:t>
+            </a:r>
+          </a:p>
+        </p:txBody>
+      </p:sp>
       <p:pic>
         <p:nvPicPr>
-          <p:cNvPr id="4" name="Picture 3" descr="overfitting_curve.png"/>
+          <p:cNvPr id="7" name="Picture 6" descr="overfitting_curve.png"/>
           <p:cNvPicPr>
             <a:picLocks noChangeAspect="1"/>
           </p:cNvPicPr>
@@ -5783,7 +6101,7 @@
         <p:spPr>
           <a:xfrm>
             <a:off x="640080" y="1371600"/>
-            <a:ext cx="11247120" cy="5029200"/>
+            <a:ext cx="11247120" cy="1810512"/>
           </a:xfrm>
           <a:prstGeom prst="rect">
             <a:avLst/>
@@ -5853,6 +6171,173 @@
                 </a:solidFill>
               </a:rPr>
               <a:t>Для воспроизводимости: random_state фиксирует случайность при равной информативности разбиений</a:t>
+            </a:r>
+          </a:p>
+        </p:txBody>
+      </p:sp>
+      <p:sp>
+        <p:nvSpPr>
+          <p:cNvPr id="4" name="Rectangle 3"/>
+          <p:cNvSpPr/>
+          <p:nvPr/>
+        </p:nvSpPr>
+        <p:spPr>
+          <a:xfrm>
+            <a:off x="640080" y="3291840"/>
+            <a:ext cx="11155680" cy="804672"/>
+          </a:xfrm>
+          <a:prstGeom prst="rect">
+            <a:avLst/>
+          </a:prstGeom>
+          <a:solidFill>
+            <a:srgbClr val="F5F5F5"/>
+          </a:solidFill>
+          <a:ln>
+            <a:solidFill>
+              <a:srgbClr val="DDDDDD"/>
+            </a:solidFill>
+          </a:ln>
+        </p:spPr>
+        <p:style>
+          <a:lnRef idx="1">
+            <a:schemeClr val="accent1"/>
+          </a:lnRef>
+          <a:fillRef idx="3">
+            <a:schemeClr val="accent1"/>
+          </a:fillRef>
+          <a:effectRef idx="2">
+            <a:schemeClr val="accent1"/>
+          </a:effectRef>
+          <a:fontRef idx="minor">
+            <a:schemeClr val="lt1"/>
+          </a:fontRef>
+        </p:style>
+        <p:txBody>
+          <a:bodyPr rtlCol="0" anchor="ctr"/>
+          <a:lstStyle/>
+          <a:p>
+            <a:pPr algn="ctr"/>
+          </a:p>
+        </p:txBody>
+      </p:sp>
+      <p:sp>
+        <p:nvSpPr>
+          <p:cNvPr id="5" name="TextBox 4"/>
+          <p:cNvSpPr txBox="1"/>
+          <p:nvPr/>
+        </p:nvSpPr>
+        <p:spPr>
+          <a:xfrm>
+            <a:off x="713231" y="3328416"/>
+            <a:ext cx="11009376" cy="731520"/>
+          </a:xfrm>
+          <a:prstGeom prst="rect">
+            <a:avLst/>
+          </a:prstGeom>
+          <a:noFill/>
+        </p:spPr>
+        <p:txBody>
+          <a:bodyPr wrap="square">
+            <a:noAutofit/>
+          </a:bodyPr>
+          <a:lstStyle/>
+          <a:p>
+            <a:pPr>
+              <a:spcAft>
+                <a:spcPts val="0"/>
+              </a:spcAft>
+              <a:defRPr sz="1100">
+                <a:solidFill>
+                  <a:srgbClr val="000000"/>
+                </a:solidFill>
+                <a:latin typeface="Consolas"/>
+              </a:defRPr>
+            </a:pPr>
+            <a:r>
+              <a:t>from sklearn.tree import DecisionTreeClassifier</a:t>
+            </a:r>
+          </a:p>
+          <a:p>
+            <a:pPr>
+              <a:spcAft>
+                <a:spcPts val="0"/>
+              </a:spcAft>
+              <a:defRPr sz="1100">
+                <a:solidFill>
+                  <a:srgbClr val="000000"/>
+                </a:solidFill>
+                <a:latin typeface="Consolas"/>
+              </a:defRPr>
+            </a:pPr>
+            <a:r>
+              <a:t>clf = DecisionTreeClassifier(max_depth=3, random_state=42)</a:t>
+            </a:r>
+          </a:p>
+          <a:p>
+            <a:pPr>
+              <a:spcAft>
+                <a:spcPts val="0"/>
+              </a:spcAft>
+              <a:defRPr sz="1100">
+                <a:solidFill>
+                  <a:srgbClr val="000000"/>
+                </a:solidFill>
+                <a:latin typeface="Consolas"/>
+              </a:defRPr>
+            </a:pPr>
+            <a:r>
+              <a:t>clf.fit(X_train, y_train)</a:t>
+            </a:r>
+          </a:p>
+          <a:p>
+            <a:pPr>
+              <a:spcAft>
+                <a:spcPts val="0"/>
+              </a:spcAft>
+              <a:defRPr sz="1100">
+                <a:solidFill>
+                  <a:srgbClr val="000000"/>
+                </a:solidFill>
+                <a:latin typeface="Consolas"/>
+              </a:defRPr>
+            </a:pPr>
+            <a:r>
+              <a:t>clf.predict(X_test)</a:t>
+            </a:r>
+          </a:p>
+        </p:txBody>
+      </p:sp>
+      <p:sp>
+        <p:nvSpPr>
+          <p:cNvPr id="6" name="TextBox 5"/>
+          <p:cNvSpPr txBox="1"/>
+          <p:nvPr/>
+        </p:nvSpPr>
+        <p:spPr>
+          <a:xfrm>
+            <a:off x="640080" y="4151376"/>
+            <a:ext cx="11155680" cy="201168"/>
+          </a:xfrm>
+          <a:prstGeom prst="rect">
+            <a:avLst/>
+          </a:prstGeom>
+          <a:noFill/>
+        </p:spPr>
+        <p:txBody>
+          <a:bodyPr wrap="none">
+            <a:spAutoFit/>
+          </a:bodyPr>
+          <a:lstStyle/>
+          <a:p>
+            <a:pPr algn="l">
+              <a:defRPr sz="1000" i="1">
+                <a:solidFill>
+                  <a:srgbClr val="555555"/>
+                </a:solidFill>
+              </a:defRPr>
+            </a:pPr>
+            <a:r>
+              <a:t>DecisionTreeClassifier</a:t>
             </a:r>
           </a:p>
         </p:txBody>
@@ -5917,7 +6402,7 @@
         <p:spPr>
           <a:xfrm>
             <a:off x="640080" y="1371600"/>
-            <a:ext cx="6858000" cy="5029200"/>
+            <a:ext cx="6858000" cy="1645920"/>
           </a:xfrm>
           <a:prstGeom prst="rect">
             <a:avLst/>
@@ -5976,9 +6461,160 @@
           </a:p>
         </p:txBody>
       </p:sp>
+      <p:sp>
+        <p:nvSpPr>
+          <p:cNvPr id="4" name="Rectangle 3"/>
+          <p:cNvSpPr/>
+          <p:nvPr/>
+        </p:nvSpPr>
+        <p:spPr>
+          <a:xfrm>
+            <a:off x="640080" y="3127248"/>
+            <a:ext cx="6766560" cy="630936"/>
+          </a:xfrm>
+          <a:prstGeom prst="rect">
+            <a:avLst/>
+          </a:prstGeom>
+          <a:solidFill>
+            <a:srgbClr val="F5F5F5"/>
+          </a:solidFill>
+          <a:ln>
+            <a:solidFill>
+              <a:srgbClr val="DDDDDD"/>
+            </a:solidFill>
+          </a:ln>
+        </p:spPr>
+        <p:style>
+          <a:lnRef idx="1">
+            <a:schemeClr val="accent1"/>
+          </a:lnRef>
+          <a:fillRef idx="3">
+            <a:schemeClr val="accent1"/>
+          </a:fillRef>
+          <a:effectRef idx="2">
+            <a:schemeClr val="accent1"/>
+          </a:effectRef>
+          <a:fontRef idx="minor">
+            <a:schemeClr val="lt1"/>
+          </a:fontRef>
+        </p:style>
+        <p:txBody>
+          <a:bodyPr rtlCol="0" anchor="ctr"/>
+          <a:lstStyle/>
+          <a:p>
+            <a:pPr algn="ctr"/>
+          </a:p>
+        </p:txBody>
+      </p:sp>
+      <p:sp>
+        <p:nvSpPr>
+          <p:cNvPr id="5" name="TextBox 4"/>
+          <p:cNvSpPr txBox="1"/>
+          <p:nvPr/>
+        </p:nvSpPr>
+        <p:spPr>
+          <a:xfrm>
+            <a:off x="713231" y="3163824"/>
+            <a:ext cx="6620256" cy="557784"/>
+          </a:xfrm>
+          <a:prstGeom prst="rect">
+            <a:avLst/>
+          </a:prstGeom>
+          <a:noFill/>
+        </p:spPr>
+        <p:txBody>
+          <a:bodyPr wrap="square">
+            <a:noAutofit/>
+          </a:bodyPr>
+          <a:lstStyle/>
+          <a:p>
+            <a:pPr>
+              <a:spcAft>
+                <a:spcPts val="0"/>
+              </a:spcAft>
+              <a:defRPr sz="1100">
+                <a:solidFill>
+                  <a:srgbClr val="000000"/>
+                </a:solidFill>
+                <a:latin typeface="Consolas"/>
+              </a:defRPr>
+            </a:pPr>
+            <a:r>
+              <a:t>import pandas as pd</a:t>
+            </a:r>
+          </a:p>
+          <a:p>
+            <a:pPr>
+              <a:spcAft>
+                <a:spcPts val="0"/>
+              </a:spcAft>
+              <a:defRPr sz="1100">
+                <a:solidFill>
+                  <a:srgbClr val="000000"/>
+                </a:solidFill>
+                <a:latin typeface="Consolas"/>
+              </a:defRPr>
+            </a:pPr>
+            <a:r>
+              <a:t>imp = pd.Series(clf.feature_importances_, index=feature_names)</a:t>
+            </a:r>
+          </a:p>
+          <a:p>
+            <a:pPr>
+              <a:spcAft>
+                <a:spcPts val="0"/>
+              </a:spcAft>
+              <a:defRPr sz="1100">
+                <a:solidFill>
+                  <a:srgbClr val="000000"/>
+                </a:solidFill>
+                <a:latin typeface="Consolas"/>
+              </a:defRPr>
+            </a:pPr>
+            <a:r>
+              <a:t>imp.sort_values(ascending=False).head()</a:t>
+            </a:r>
+          </a:p>
+        </p:txBody>
+      </p:sp>
+      <p:sp>
+        <p:nvSpPr>
+          <p:cNvPr id="6" name="TextBox 5"/>
+          <p:cNvSpPr txBox="1"/>
+          <p:nvPr/>
+        </p:nvSpPr>
+        <p:spPr>
+          <a:xfrm>
+            <a:off x="640080" y="3813048"/>
+            <a:ext cx="6766560" cy="201168"/>
+          </a:xfrm>
+          <a:prstGeom prst="rect">
+            <a:avLst/>
+          </a:prstGeom>
+          <a:noFill/>
+        </p:spPr>
+        <p:txBody>
+          <a:bodyPr wrap="none">
+            <a:spAutoFit/>
+          </a:bodyPr>
+          <a:lstStyle/>
+          <a:p>
+            <a:pPr algn="l">
+              <a:defRPr sz="1000" i="1">
+                <a:solidFill>
+                  <a:srgbClr val="555555"/>
+                </a:solidFill>
+              </a:defRPr>
+            </a:pPr>
+            <a:r>
+              <a:t>feature_importances_</a:t>
+            </a:r>
+          </a:p>
+        </p:txBody>
+      </p:sp>
       <p:pic>
         <p:nvPicPr>
-          <p:cNvPr id="4" name="Picture 3" descr="feature_importance.png"/>
+          <p:cNvPr id="7" name="Picture 6" descr="feature_importance.png"/>
           <p:cNvPicPr>
             <a:picLocks noChangeAspect="1"/>
           </p:cNvPicPr>
@@ -6060,7 +6696,7 @@
         <p:spPr>
           <a:xfrm>
             <a:off x="640080" y="1371600"/>
-            <a:ext cx="11247120" cy="5029200"/>
+            <a:ext cx="11247120" cy="1810512"/>
           </a:xfrm>
           <a:prstGeom prst="rect">
             <a:avLst/>
@@ -6130,6 +6766,173 @@
                 </a:solidFill>
               </a:rPr>
               <a:t>Выбросы в y: чувствительны при MSE; в sklearn — DecisionTreeRegressor(criterion='absolute_error') или чистка данных</a:t>
+            </a:r>
+          </a:p>
+        </p:txBody>
+      </p:sp>
+      <p:sp>
+        <p:nvSpPr>
+          <p:cNvPr id="4" name="Rectangle 3"/>
+          <p:cNvSpPr/>
+          <p:nvPr/>
+        </p:nvSpPr>
+        <p:spPr>
+          <a:xfrm>
+            <a:off x="640080" y="3291840"/>
+            <a:ext cx="11155680" cy="804672"/>
+          </a:xfrm>
+          <a:prstGeom prst="rect">
+            <a:avLst/>
+          </a:prstGeom>
+          <a:solidFill>
+            <a:srgbClr val="F5F5F5"/>
+          </a:solidFill>
+          <a:ln>
+            <a:solidFill>
+              <a:srgbClr val="DDDDDD"/>
+            </a:solidFill>
+          </a:ln>
+        </p:spPr>
+        <p:style>
+          <a:lnRef idx="1">
+            <a:schemeClr val="accent1"/>
+          </a:lnRef>
+          <a:fillRef idx="3">
+            <a:schemeClr val="accent1"/>
+          </a:fillRef>
+          <a:effectRef idx="2">
+            <a:schemeClr val="accent1"/>
+          </a:effectRef>
+          <a:fontRef idx="minor">
+            <a:schemeClr val="lt1"/>
+          </a:fontRef>
+        </p:style>
+        <p:txBody>
+          <a:bodyPr rtlCol="0" anchor="ctr"/>
+          <a:lstStyle/>
+          <a:p>
+            <a:pPr algn="ctr"/>
+          </a:p>
+        </p:txBody>
+      </p:sp>
+      <p:sp>
+        <p:nvSpPr>
+          <p:cNvPr id="5" name="TextBox 4"/>
+          <p:cNvSpPr txBox="1"/>
+          <p:nvPr/>
+        </p:nvSpPr>
+        <p:spPr>
+          <a:xfrm>
+            <a:off x="713231" y="3328416"/>
+            <a:ext cx="11009376" cy="731520"/>
+          </a:xfrm>
+          <a:prstGeom prst="rect">
+            <a:avLst/>
+          </a:prstGeom>
+          <a:noFill/>
+        </p:spPr>
+        <p:txBody>
+          <a:bodyPr wrap="square">
+            <a:noAutofit/>
+          </a:bodyPr>
+          <a:lstStyle/>
+          <a:p>
+            <a:pPr>
+              <a:spcAft>
+                <a:spcPts val="0"/>
+              </a:spcAft>
+              <a:defRPr sz="1100">
+                <a:solidFill>
+                  <a:srgbClr val="000000"/>
+                </a:solidFill>
+                <a:latin typeface="Consolas"/>
+              </a:defRPr>
+            </a:pPr>
+            <a:r>
+              <a:t>from sklearn.tree import DecisionTreeRegressor</a:t>
+            </a:r>
+          </a:p>
+          <a:p>
+            <a:pPr>
+              <a:spcAft>
+                <a:spcPts val="0"/>
+              </a:spcAft>
+              <a:defRPr sz="1100">
+                <a:solidFill>
+                  <a:srgbClr val="000000"/>
+                </a:solidFill>
+                <a:latin typeface="Consolas"/>
+              </a:defRPr>
+            </a:pPr>
+            <a:r>
+              <a:t>reg = DecisionTreeRegressor(max_depth=4, random_state=42)</a:t>
+            </a:r>
+          </a:p>
+          <a:p>
+            <a:pPr>
+              <a:spcAft>
+                <a:spcPts val="0"/>
+              </a:spcAft>
+              <a:defRPr sz="1100">
+                <a:solidFill>
+                  <a:srgbClr val="000000"/>
+                </a:solidFill>
+                <a:latin typeface="Consolas"/>
+              </a:defRPr>
+            </a:pPr>
+            <a:r>
+              <a:t>reg.fit(X_train, y_train)</a:t>
+            </a:r>
+          </a:p>
+          <a:p>
+            <a:pPr>
+              <a:spcAft>
+                <a:spcPts val="0"/>
+              </a:spcAft>
+              <a:defRPr sz="1100">
+                <a:solidFill>
+                  <a:srgbClr val="000000"/>
+                </a:solidFill>
+                <a:latin typeface="Consolas"/>
+              </a:defRPr>
+            </a:pPr>
+            <a:r>
+              <a:t>reg.predict(X_test)</a:t>
+            </a:r>
+          </a:p>
+        </p:txBody>
+      </p:sp>
+      <p:sp>
+        <p:nvSpPr>
+          <p:cNvPr id="6" name="TextBox 5"/>
+          <p:cNvSpPr txBox="1"/>
+          <p:nvPr/>
+        </p:nvSpPr>
+        <p:spPr>
+          <a:xfrm>
+            <a:off x="640080" y="4151376"/>
+            <a:ext cx="11155680" cy="201168"/>
+          </a:xfrm>
+          <a:prstGeom prst="rect">
+            <a:avLst/>
+          </a:prstGeom>
+          <a:noFill/>
+        </p:spPr>
+        <p:txBody>
+          <a:bodyPr wrap="none">
+            <a:spAutoFit/>
+          </a:bodyPr>
+          <a:lstStyle/>
+          <a:p>
+            <a:pPr algn="l">
+              <a:defRPr sz="1000" i="1">
+                <a:solidFill>
+                  <a:srgbClr val="555555"/>
+                </a:solidFill>
+              </a:defRPr>
+            </a:pPr>
+            <a:r>
+              <a:t>DecisionTreeRegressor</a:t>
             </a:r>
           </a:p>
         </p:txBody>
@@ -6194,7 +6997,7 @@
         <p:spPr>
           <a:xfrm>
             <a:off x="640080" y="1371600"/>
-            <a:ext cx="11247120" cy="5029200"/>
+            <a:ext cx="11247120" cy="2194560"/>
           </a:xfrm>
           <a:prstGeom prst="rect">
             <a:avLst/>
@@ -6343,7 +7146,7 @@
         <p:spPr>
           <a:xfrm>
             <a:off x="640080" y="1371600"/>
-            <a:ext cx="11247120" cy="5029200"/>
+            <a:ext cx="11247120" cy="1645920"/>
           </a:xfrm>
           <a:prstGeom prst="rect">
             <a:avLst/>
@@ -6398,6 +7201,173 @@
                 </a:solidFill>
               </a:rPr>
               <a:t>export_text — текстовое представление: правила вида X[0] &lt;= 2.5 → class=1</a:t>
+            </a:r>
+          </a:p>
+        </p:txBody>
+      </p:sp>
+      <p:sp>
+        <p:nvSpPr>
+          <p:cNvPr id="4" name="Rectangle 3"/>
+          <p:cNvSpPr/>
+          <p:nvPr/>
+        </p:nvSpPr>
+        <p:spPr>
+          <a:xfrm>
+            <a:off x="640080" y="3127248"/>
+            <a:ext cx="11155680" cy="804672"/>
+          </a:xfrm>
+          <a:prstGeom prst="rect">
+            <a:avLst/>
+          </a:prstGeom>
+          <a:solidFill>
+            <a:srgbClr val="F5F5F5"/>
+          </a:solidFill>
+          <a:ln>
+            <a:solidFill>
+              <a:srgbClr val="DDDDDD"/>
+            </a:solidFill>
+          </a:ln>
+        </p:spPr>
+        <p:style>
+          <a:lnRef idx="1">
+            <a:schemeClr val="accent1"/>
+          </a:lnRef>
+          <a:fillRef idx="3">
+            <a:schemeClr val="accent1"/>
+          </a:fillRef>
+          <a:effectRef idx="2">
+            <a:schemeClr val="accent1"/>
+          </a:effectRef>
+          <a:fontRef idx="minor">
+            <a:schemeClr val="lt1"/>
+          </a:fontRef>
+        </p:style>
+        <p:txBody>
+          <a:bodyPr rtlCol="0" anchor="ctr"/>
+          <a:lstStyle/>
+          <a:p>
+            <a:pPr algn="ctr"/>
+          </a:p>
+        </p:txBody>
+      </p:sp>
+      <p:sp>
+        <p:nvSpPr>
+          <p:cNvPr id="5" name="TextBox 4"/>
+          <p:cNvSpPr txBox="1"/>
+          <p:nvPr/>
+        </p:nvSpPr>
+        <p:spPr>
+          <a:xfrm>
+            <a:off x="713231" y="3163824"/>
+            <a:ext cx="11009376" cy="731520"/>
+          </a:xfrm>
+          <a:prstGeom prst="rect">
+            <a:avLst/>
+          </a:prstGeom>
+          <a:noFill/>
+        </p:spPr>
+        <p:txBody>
+          <a:bodyPr wrap="square">
+            <a:noAutofit/>
+          </a:bodyPr>
+          <a:lstStyle/>
+          <a:p>
+            <a:pPr>
+              <a:spcAft>
+                <a:spcPts val="0"/>
+              </a:spcAft>
+              <a:defRPr sz="1100">
+                <a:solidFill>
+                  <a:srgbClr val="000000"/>
+                </a:solidFill>
+                <a:latin typeface="Consolas"/>
+              </a:defRPr>
+            </a:pPr>
+            <a:r>
+              <a:t>from sklearn.tree import plot_tree</a:t>
+            </a:r>
+          </a:p>
+          <a:p>
+            <a:pPr>
+              <a:spcAft>
+                <a:spcPts val="0"/>
+              </a:spcAft>
+              <a:defRPr sz="1100">
+                <a:solidFill>
+                  <a:srgbClr val="000000"/>
+                </a:solidFill>
+                <a:latin typeface="Consolas"/>
+              </a:defRPr>
+            </a:pPr>
+            <a:r>
+              <a:t>import matplotlib.pyplot as plt</a:t>
+            </a:r>
+          </a:p>
+          <a:p>
+            <a:pPr>
+              <a:spcAft>
+                <a:spcPts val="0"/>
+              </a:spcAft>
+              <a:defRPr sz="1100">
+                <a:solidFill>
+                  <a:srgbClr val="000000"/>
+                </a:solidFill>
+                <a:latin typeface="Consolas"/>
+              </a:defRPr>
+            </a:pPr>
+            <a:r>
+              <a:t>plot_tree(clf, feature_names=names, filled=True)</a:t>
+            </a:r>
+          </a:p>
+          <a:p>
+            <a:pPr>
+              <a:spcAft>
+                <a:spcPts val="0"/>
+              </a:spcAft>
+              <a:defRPr sz="1100">
+                <a:solidFill>
+                  <a:srgbClr val="000000"/>
+                </a:solidFill>
+                <a:latin typeface="Consolas"/>
+              </a:defRPr>
+            </a:pPr>
+            <a:r>
+              <a:t>plt.show()</a:t>
+            </a:r>
+          </a:p>
+        </p:txBody>
+      </p:sp>
+      <p:sp>
+        <p:nvSpPr>
+          <p:cNvPr id="6" name="TextBox 5"/>
+          <p:cNvSpPr txBox="1"/>
+          <p:nvPr/>
+        </p:nvSpPr>
+        <p:spPr>
+          <a:xfrm>
+            <a:off x="640080" y="3986783"/>
+            <a:ext cx="11155680" cy="201168"/>
+          </a:xfrm>
+          <a:prstGeom prst="rect">
+            <a:avLst/>
+          </a:prstGeom>
+          <a:noFill/>
+        </p:spPr>
+        <p:txBody>
+          <a:bodyPr wrap="none">
+            <a:spAutoFit/>
+          </a:bodyPr>
+          <a:lstStyle/>
+          <a:p>
+            <a:pPr algn="l">
+              <a:defRPr sz="1000" i="1">
+                <a:solidFill>
+                  <a:srgbClr val="555555"/>
+                </a:solidFill>
+              </a:defRPr>
+            </a:pPr>
+            <a:r>
+              <a:t>plot_tree</a:t>
             </a:r>
           </a:p>
         </p:txBody>
@@ -6462,7 +7432,7 @@
         <p:spPr>
           <a:xfrm>
             <a:off x="640080" y="1371600"/>
-            <a:ext cx="6858000" cy="5029200"/>
+            <a:ext cx="6858000" cy="1645920"/>
           </a:xfrm>
           <a:prstGeom prst="rect">
             <a:avLst/>
@@ -6521,9 +7491,208 @@
           </a:p>
         </p:txBody>
       </p:sp>
+      <p:sp>
+        <p:nvSpPr>
+          <p:cNvPr id="4" name="Rectangle 3"/>
+          <p:cNvSpPr/>
+          <p:nvPr/>
+        </p:nvSpPr>
+        <p:spPr>
+          <a:xfrm>
+            <a:off x="640080" y="3127248"/>
+            <a:ext cx="6766560" cy="1152144"/>
+          </a:xfrm>
+          <a:prstGeom prst="rect">
+            <a:avLst/>
+          </a:prstGeom>
+          <a:solidFill>
+            <a:srgbClr val="F5F5F5"/>
+          </a:solidFill>
+          <a:ln>
+            <a:solidFill>
+              <a:srgbClr val="DDDDDD"/>
+            </a:solidFill>
+          </a:ln>
+        </p:spPr>
+        <p:style>
+          <a:lnRef idx="1">
+            <a:schemeClr val="accent1"/>
+          </a:lnRef>
+          <a:fillRef idx="3">
+            <a:schemeClr val="accent1"/>
+          </a:fillRef>
+          <a:effectRef idx="2">
+            <a:schemeClr val="accent1"/>
+          </a:effectRef>
+          <a:fontRef idx="minor">
+            <a:schemeClr val="lt1"/>
+          </a:fontRef>
+        </p:style>
+        <p:txBody>
+          <a:bodyPr rtlCol="0" anchor="ctr"/>
+          <a:lstStyle/>
+          <a:p>
+            <a:pPr algn="ctr"/>
+          </a:p>
+        </p:txBody>
+      </p:sp>
+      <p:sp>
+        <p:nvSpPr>
+          <p:cNvPr id="5" name="TextBox 4"/>
+          <p:cNvSpPr txBox="1"/>
+          <p:nvPr/>
+        </p:nvSpPr>
+        <p:spPr>
+          <a:xfrm>
+            <a:off x="713231" y="3163824"/>
+            <a:ext cx="6620256" cy="1078992"/>
+          </a:xfrm>
+          <a:prstGeom prst="rect">
+            <a:avLst/>
+          </a:prstGeom>
+          <a:noFill/>
+        </p:spPr>
+        <p:txBody>
+          <a:bodyPr wrap="square">
+            <a:noAutofit/>
+          </a:bodyPr>
+          <a:lstStyle/>
+          <a:p>
+            <a:pPr>
+              <a:spcAft>
+                <a:spcPts val="0"/>
+              </a:spcAft>
+              <a:defRPr sz="1100">
+                <a:solidFill>
+                  <a:srgbClr val="000000"/>
+                </a:solidFill>
+                <a:latin typeface="Consolas"/>
+              </a:defRPr>
+            </a:pPr>
+            <a:r>
+              <a:t>import numpy as np</a:t>
+            </a:r>
+          </a:p>
+          <a:p>
+            <a:pPr>
+              <a:spcAft>
+                <a:spcPts val="0"/>
+              </a:spcAft>
+              <a:defRPr sz="1100">
+                <a:solidFill>
+                  <a:srgbClr val="000000"/>
+                </a:solidFill>
+                <a:latin typeface="Consolas"/>
+              </a:defRPr>
+            </a:pPr>
+            <a:r>
+              <a:t>xx, yy = np.meshgrid(</a:t>
+            </a:r>
+          </a:p>
+          <a:p>
+            <a:pPr>
+              <a:spcAft>
+                <a:spcPts val="0"/>
+              </a:spcAft>
+              <a:defRPr sz="1100">
+                <a:solidFill>
+                  <a:srgbClr val="000000"/>
+                </a:solidFill>
+                <a:latin typeface="Consolas"/>
+              </a:defRPr>
+            </a:pPr>
+            <a:r>
+              <a:t>    np.linspace(x.min(), x.max(), 200),</a:t>
+            </a:r>
+          </a:p>
+          <a:p>
+            <a:pPr>
+              <a:spcAft>
+                <a:spcPts val="0"/>
+              </a:spcAft>
+              <a:defRPr sz="1100">
+                <a:solidFill>
+                  <a:srgbClr val="000000"/>
+                </a:solidFill>
+                <a:latin typeface="Consolas"/>
+              </a:defRPr>
+            </a:pPr>
+            <a:r>
+              <a:t>    np.linspace(y.min(), y.max(), 200),</a:t>
+            </a:r>
+          </a:p>
+          <a:p>
+            <a:pPr>
+              <a:spcAft>
+                <a:spcPts val="0"/>
+              </a:spcAft>
+              <a:defRPr sz="1100">
+                <a:solidFill>
+                  <a:srgbClr val="000000"/>
+                </a:solidFill>
+                <a:latin typeface="Consolas"/>
+              </a:defRPr>
+            </a:pPr>
+            <a:r>
+              <a:t>)</a:t>
+            </a:r>
+          </a:p>
+          <a:p>
+            <a:pPr>
+              <a:spcAft>
+                <a:spcPts val="0"/>
+              </a:spcAft>
+              <a:defRPr sz="1100">
+                <a:solidFill>
+                  <a:srgbClr val="000000"/>
+                </a:solidFill>
+                <a:latin typeface="Consolas"/>
+              </a:defRPr>
+            </a:pPr>
+            <a:r>
+              <a:t>Z = clf.predict(np.c_[xx.ravel(), yy.ravel()]).reshape(xx.shape)</a:t>
+            </a:r>
+          </a:p>
+        </p:txBody>
+      </p:sp>
+      <p:sp>
+        <p:nvSpPr>
+          <p:cNvPr id="6" name="TextBox 5"/>
+          <p:cNvSpPr txBox="1"/>
+          <p:nvPr/>
+        </p:nvSpPr>
+        <p:spPr>
+          <a:xfrm>
+            <a:off x="640080" y="4334256"/>
+            <a:ext cx="6766560" cy="201168"/>
+          </a:xfrm>
+          <a:prstGeom prst="rect">
+            <a:avLst/>
+          </a:prstGeom>
+          <a:noFill/>
+        </p:spPr>
+        <p:txBody>
+          <a:bodyPr wrap="none">
+            <a:spAutoFit/>
+          </a:bodyPr>
+          <a:lstStyle/>
+          <a:p>
+            <a:pPr algn="l">
+              <a:defRPr sz="1000" i="1">
+                <a:solidFill>
+                  <a:srgbClr val="555555"/>
+                </a:solidFill>
+              </a:defRPr>
+            </a:pPr>
+            <a:r>
+              <a:t>Сетка для границы</a:t>
+            </a:r>
+          </a:p>
+        </p:txBody>
+      </p:sp>
       <p:pic>
         <p:nvPicPr>
-          <p:cNvPr id="4" name="Picture 3" descr="decision_boundary.png"/>
+          <p:cNvPr id="7" name="Picture 6" descr="decision_boundary.png"/>
           <p:cNvPicPr>
             <a:picLocks noChangeAspect="1"/>
           </p:cNvPicPr>
@@ -6605,7 +7774,7 @@
         <p:spPr>
           <a:xfrm>
             <a:off x="640080" y="1371600"/>
-            <a:ext cx="11247120" cy="5029200"/>
+            <a:ext cx="11247120" cy="1810512"/>
           </a:xfrm>
           <a:prstGeom prst="rect">
             <a:avLst/>
@@ -6739,7 +7908,7 @@
         <p:spPr>
           <a:xfrm>
             <a:off x="640080" y="1371600"/>
-            <a:ext cx="6858000" cy="5029200"/>
+            <a:ext cx="6858000" cy="1810512"/>
           </a:xfrm>
           <a:prstGeom prst="rect">
             <a:avLst/>
@@ -6897,7 +8066,7 @@
         <p:spPr>
           <a:xfrm>
             <a:off x="640080" y="1371600"/>
-            <a:ext cx="11247120" cy="5029200"/>
+            <a:ext cx="11247120" cy="2578608"/>
           </a:xfrm>
           <a:prstGeom prst="rect">
             <a:avLst/>
@@ -6997,6 +8166,173 @@
                 </a:solidFill>
               </a:rPr>
               <a:t>One-Hot при 100+ категориях — разреженность и замедление; альтернатива — целевое кодирование</a:t>
+            </a:r>
+          </a:p>
+        </p:txBody>
+      </p:sp>
+      <p:sp>
+        <p:nvSpPr>
+          <p:cNvPr id="4" name="Rectangle 3"/>
+          <p:cNvSpPr/>
+          <p:nvPr/>
+        </p:nvSpPr>
+        <p:spPr>
+          <a:xfrm>
+            <a:off x="640080" y="4059936"/>
+            <a:ext cx="11155680" cy="804672"/>
+          </a:xfrm>
+          <a:prstGeom prst="rect">
+            <a:avLst/>
+          </a:prstGeom>
+          <a:solidFill>
+            <a:srgbClr val="F5F5F5"/>
+          </a:solidFill>
+          <a:ln>
+            <a:solidFill>
+              <a:srgbClr val="DDDDDD"/>
+            </a:solidFill>
+          </a:ln>
+        </p:spPr>
+        <p:style>
+          <a:lnRef idx="1">
+            <a:schemeClr val="accent1"/>
+          </a:lnRef>
+          <a:fillRef idx="3">
+            <a:schemeClr val="accent1"/>
+          </a:fillRef>
+          <a:effectRef idx="2">
+            <a:schemeClr val="accent1"/>
+          </a:effectRef>
+          <a:fontRef idx="minor">
+            <a:schemeClr val="lt1"/>
+          </a:fontRef>
+        </p:style>
+        <p:txBody>
+          <a:bodyPr rtlCol="0" anchor="ctr"/>
+          <a:lstStyle/>
+          <a:p>
+            <a:pPr algn="ctr"/>
+          </a:p>
+        </p:txBody>
+      </p:sp>
+      <p:sp>
+        <p:nvSpPr>
+          <p:cNvPr id="5" name="TextBox 4"/>
+          <p:cNvSpPr txBox="1"/>
+          <p:nvPr/>
+        </p:nvSpPr>
+        <p:spPr>
+          <a:xfrm>
+            <a:off x="713231" y="4096512"/>
+            <a:ext cx="11009376" cy="731520"/>
+          </a:xfrm>
+          <a:prstGeom prst="rect">
+            <a:avLst/>
+          </a:prstGeom>
+          <a:noFill/>
+        </p:spPr>
+        <p:txBody>
+          <a:bodyPr wrap="square">
+            <a:noAutofit/>
+          </a:bodyPr>
+          <a:lstStyle/>
+          <a:p>
+            <a:pPr>
+              <a:spcAft>
+                <a:spcPts val="0"/>
+              </a:spcAft>
+              <a:defRPr sz="1100">
+                <a:solidFill>
+                  <a:srgbClr val="000000"/>
+                </a:solidFill>
+                <a:latin typeface="Consolas"/>
+              </a:defRPr>
+            </a:pPr>
+            <a:r>
+              <a:t>from sklearn.tree import DecisionTreeClassifier</a:t>
+            </a:r>
+          </a:p>
+          <a:p>
+            <a:pPr>
+              <a:spcAft>
+                <a:spcPts val="0"/>
+              </a:spcAft>
+              <a:defRPr sz="1100">
+                <a:solidFill>
+                  <a:srgbClr val="000000"/>
+                </a:solidFill>
+                <a:latin typeface="Consolas"/>
+              </a:defRPr>
+            </a:pPr>
+            <a:r>
+              <a:t># масштабирование не обязательно</a:t>
+            </a:r>
+          </a:p>
+          <a:p>
+            <a:pPr>
+              <a:spcAft>
+                <a:spcPts val="0"/>
+              </a:spcAft>
+              <a:defRPr sz="1100">
+                <a:solidFill>
+                  <a:srgbClr val="000000"/>
+                </a:solidFill>
+                <a:latin typeface="Consolas"/>
+              </a:defRPr>
+            </a:pPr>
+            <a:r>
+              <a:t>clf = DecisionTreeClassifier(random_state=42)</a:t>
+            </a:r>
+          </a:p>
+          <a:p>
+            <a:pPr>
+              <a:spcAft>
+                <a:spcPts val="0"/>
+              </a:spcAft>
+              <a:defRPr sz="1100">
+                <a:solidFill>
+                  <a:srgbClr val="000000"/>
+                </a:solidFill>
+                <a:latin typeface="Consolas"/>
+              </a:defRPr>
+            </a:pPr>
+            <a:r>
+              <a:t>clf.fit(X_raw, y)  # можно на исходных признаках</a:t>
+            </a:r>
+          </a:p>
+        </p:txBody>
+      </p:sp>
+      <p:sp>
+        <p:nvSpPr>
+          <p:cNvPr id="6" name="TextBox 5"/>
+          <p:cNvSpPr txBox="1"/>
+          <p:nvPr/>
+        </p:nvSpPr>
+        <p:spPr>
+          <a:xfrm>
+            <a:off x="640080" y="4919472"/>
+            <a:ext cx="11155680" cy="201168"/>
+          </a:xfrm>
+          <a:prstGeom prst="rect">
+            <a:avLst/>
+          </a:prstGeom>
+          <a:noFill/>
+        </p:spPr>
+        <p:txBody>
+          <a:bodyPr wrap="none">
+            <a:spAutoFit/>
+          </a:bodyPr>
+          <a:lstStyle/>
+          <a:p>
+            <a:pPr algn="l">
+              <a:defRPr sz="1000" i="1">
+                <a:solidFill>
+                  <a:srgbClr val="555555"/>
+                </a:solidFill>
+              </a:defRPr>
+            </a:pPr>
+            <a:r>
+              <a:t>Без StandardScaler</a:t>
             </a:r>
           </a:p>
         </p:txBody>
@@ -7061,7 +8397,7 @@
         <p:spPr>
           <a:xfrm>
             <a:off x="640080" y="1371600"/>
-            <a:ext cx="11247120" cy="5029200"/>
+            <a:ext cx="11247120" cy="2194560"/>
           </a:xfrm>
           <a:prstGeom prst="rect">
             <a:avLst/>
@@ -7210,7 +8546,7 @@
         <p:spPr>
           <a:xfrm>
             <a:off x="640080" y="1371600"/>
-            <a:ext cx="11247120" cy="5029200"/>
+            <a:ext cx="11247120" cy="2194560"/>
           </a:xfrm>
           <a:prstGeom prst="rect">
             <a:avLst/>
@@ -7425,7 +8761,7 @@
         <p:spPr>
           <a:xfrm>
             <a:off x="640080" y="1371600"/>
-            <a:ext cx="11247120" cy="5029200"/>
+            <a:ext cx="11247120" cy="2962656"/>
           </a:xfrm>
           <a:prstGeom prst="rect">
             <a:avLst/>
@@ -7710,7 +9046,7 @@
         <p:spPr>
           <a:xfrm>
             <a:off x="640080" y="1371600"/>
-            <a:ext cx="11247120" cy="5029200"/>
+            <a:ext cx="11247120" cy="1810512"/>
           </a:xfrm>
           <a:prstGeom prst="rect">
             <a:avLst/>
@@ -8362,7 +9698,7 @@
         <p:spPr>
           <a:xfrm>
             <a:off x="640080" y="1371600"/>
-            <a:ext cx="6858000" cy="5029200"/>
+            <a:ext cx="6858000" cy="1810512"/>
           </a:xfrm>
           <a:prstGeom prst="rect">
             <a:avLst/>
@@ -8586,7 +9922,7 @@
         <p:spPr>
           <a:xfrm>
             <a:off x="640080" y="1371600"/>
-            <a:ext cx="6858000" cy="5029200"/>
+            <a:ext cx="6858000" cy="2194560"/>
           </a:xfrm>
           <a:prstGeom prst="rect">
             <a:avLst/>
@@ -8675,9 +10011,176 @@
           </a:p>
         </p:txBody>
       </p:sp>
+      <p:sp>
+        <p:nvSpPr>
+          <p:cNvPr id="4" name="Rectangle 3"/>
+          <p:cNvSpPr/>
+          <p:nvPr/>
+        </p:nvSpPr>
+        <p:spPr>
+          <a:xfrm>
+            <a:off x="640080" y="3675887"/>
+            <a:ext cx="6766560" cy="804672"/>
+          </a:xfrm>
+          <a:prstGeom prst="rect">
+            <a:avLst/>
+          </a:prstGeom>
+          <a:solidFill>
+            <a:srgbClr val="F5F5F5"/>
+          </a:solidFill>
+          <a:ln>
+            <a:solidFill>
+              <a:srgbClr val="DDDDDD"/>
+            </a:solidFill>
+          </a:ln>
+        </p:spPr>
+        <p:style>
+          <a:lnRef idx="1">
+            <a:schemeClr val="accent1"/>
+          </a:lnRef>
+          <a:fillRef idx="3">
+            <a:schemeClr val="accent1"/>
+          </a:fillRef>
+          <a:effectRef idx="2">
+            <a:schemeClr val="accent1"/>
+          </a:effectRef>
+          <a:fontRef idx="minor">
+            <a:schemeClr val="lt1"/>
+          </a:fontRef>
+        </p:style>
+        <p:txBody>
+          <a:bodyPr rtlCol="0" anchor="ctr"/>
+          <a:lstStyle/>
+          <a:p>
+            <a:pPr algn="ctr"/>
+          </a:p>
+        </p:txBody>
+      </p:sp>
+      <p:sp>
+        <p:nvSpPr>
+          <p:cNvPr id="5" name="TextBox 4"/>
+          <p:cNvSpPr txBox="1"/>
+          <p:nvPr/>
+        </p:nvSpPr>
+        <p:spPr>
+          <a:xfrm>
+            <a:off x="713231" y="3712463"/>
+            <a:ext cx="6620256" cy="731520"/>
+          </a:xfrm>
+          <a:prstGeom prst="rect">
+            <a:avLst/>
+          </a:prstGeom>
+          <a:noFill/>
+        </p:spPr>
+        <p:txBody>
+          <a:bodyPr wrap="square">
+            <a:noAutofit/>
+          </a:bodyPr>
+          <a:lstStyle/>
+          <a:p>
+            <a:pPr>
+              <a:spcAft>
+                <a:spcPts val="0"/>
+              </a:spcAft>
+              <a:defRPr sz="1100">
+                <a:solidFill>
+                  <a:srgbClr val="000000"/>
+                </a:solidFill>
+                <a:latin typeface="Consolas"/>
+              </a:defRPr>
+            </a:pPr>
+            <a:r>
+              <a:t>from sklearn.datasets import load_iris</a:t>
+            </a:r>
+          </a:p>
+          <a:p>
+            <a:pPr>
+              <a:spcAft>
+                <a:spcPts val="0"/>
+              </a:spcAft>
+              <a:defRPr sz="1100">
+                <a:solidFill>
+                  <a:srgbClr val="000000"/>
+                </a:solidFill>
+                <a:latin typeface="Consolas"/>
+              </a:defRPr>
+            </a:pPr>
+            <a:r>
+              <a:t>X, y = load_iris(return_X_y=True)</a:t>
+            </a:r>
+          </a:p>
+          <a:p>
+            <a:pPr>
+              <a:spcAft>
+                <a:spcPts val="0"/>
+              </a:spcAft>
+              <a:defRPr sz="1100">
+                <a:solidFill>
+                  <a:srgbClr val="000000"/>
+                </a:solidFill>
+                <a:latin typeface="Consolas"/>
+              </a:defRPr>
+            </a:pPr>
+            <a:r>
+              <a:t>X, y = X[y != 2], (y[y != 2] == 0).astype(int)</a:t>
+            </a:r>
+          </a:p>
+          <a:p>
+            <a:pPr>
+              <a:spcAft>
+                <a:spcPts val="0"/>
+              </a:spcAft>
+              <a:defRPr sz="1100">
+                <a:solidFill>
+                  <a:srgbClr val="000000"/>
+                </a:solidFill>
+                <a:latin typeface="Consolas"/>
+              </a:defRPr>
+            </a:pPr>
+            <a:r>
+              <a:t># бинарная задача: setosa vs остальные</a:t>
+            </a:r>
+          </a:p>
+        </p:txBody>
+      </p:sp>
+      <p:sp>
+        <p:nvSpPr>
+          <p:cNvPr id="6" name="TextBox 5"/>
+          <p:cNvSpPr txBox="1"/>
+          <p:nvPr/>
+        </p:nvSpPr>
+        <p:spPr>
+          <a:xfrm>
+            <a:off x="640080" y="4535423"/>
+            <a:ext cx="6766560" cy="201168"/>
+          </a:xfrm>
+          <a:prstGeom prst="rect">
+            <a:avLst/>
+          </a:prstGeom>
+          <a:noFill/>
+        </p:spPr>
+        <p:txBody>
+          <a:bodyPr wrap="none">
+            <a:spAutoFit/>
+          </a:bodyPr>
+          <a:lstStyle/>
+          <a:p>
+            <a:pPr algn="l">
+              <a:defRPr sz="1000" i="1">
+                <a:solidFill>
+                  <a:srgbClr val="555555"/>
+                </a:solidFill>
+              </a:defRPr>
+            </a:pPr>
+            <a:r>
+              <a:t>Два класса из iris</a:t>
+            </a:r>
+          </a:p>
+        </p:txBody>
+      </p:sp>
       <p:pic>
         <p:nvPicPr>
-          <p:cNvPr id="4" name="Picture 3" descr="binary_classification_rectangles.png"/>
+          <p:cNvPr id="7" name="Picture 6" descr="binary_classification_rectangles.png"/>
           <p:cNvPicPr>
             <a:picLocks noChangeAspect="1"/>
           </p:cNvPicPr>
@@ -8759,7 +10262,7 @@
         <p:spPr>
           <a:xfrm>
             <a:off x="640080" y="1371600"/>
-            <a:ext cx="11247120" cy="5029200"/>
+            <a:ext cx="11247120" cy="1810512"/>
           </a:xfrm>
           <a:prstGeom prst="rect">
             <a:avLst/>
@@ -8893,7 +10396,7 @@
         <p:spPr>
           <a:xfrm>
             <a:off x="640080" y="1371600"/>
-            <a:ext cx="11247120" cy="5029200"/>
+            <a:ext cx="11247120" cy="1645920"/>
           </a:xfrm>
           <a:prstGeom prst="rect">
             <a:avLst/>
@@ -9055,7 +10558,7 @@
         <p:spPr>
           <a:xfrm>
             <a:off x="640080" y="1371600"/>
-            <a:ext cx="6858000" cy="5029200"/>
+            <a:ext cx="6858000" cy="2194560"/>
           </a:xfrm>
           <a:prstGeom prst="rect">
             <a:avLst/>
@@ -9295,9 +10798,176 @@
           </a:p>
         </p:txBody>
       </p:sp>
+      <p:sp>
+        <p:nvSpPr>
+          <p:cNvPr id="4" name="Rectangle 3"/>
+          <p:cNvSpPr/>
+          <p:nvPr/>
+        </p:nvSpPr>
+        <p:spPr>
+          <a:xfrm>
+            <a:off x="640080" y="3675887"/>
+            <a:ext cx="6766560" cy="804672"/>
+          </a:xfrm>
+          <a:prstGeom prst="rect">
+            <a:avLst/>
+          </a:prstGeom>
+          <a:solidFill>
+            <a:srgbClr val="F5F5F5"/>
+          </a:solidFill>
+          <a:ln>
+            <a:solidFill>
+              <a:srgbClr val="DDDDDD"/>
+            </a:solidFill>
+          </a:ln>
+        </p:spPr>
+        <p:style>
+          <a:lnRef idx="1">
+            <a:schemeClr val="accent1"/>
+          </a:lnRef>
+          <a:fillRef idx="3">
+            <a:schemeClr val="accent1"/>
+          </a:fillRef>
+          <a:effectRef idx="2">
+            <a:schemeClr val="accent1"/>
+          </a:effectRef>
+          <a:fontRef idx="minor">
+            <a:schemeClr val="lt1"/>
+          </a:fontRef>
+        </p:style>
+        <p:txBody>
+          <a:bodyPr rtlCol="0" anchor="ctr"/>
+          <a:lstStyle/>
+          <a:p>
+            <a:pPr algn="ctr"/>
+          </a:p>
+        </p:txBody>
+      </p:sp>
+      <p:sp>
+        <p:nvSpPr>
+          <p:cNvPr id="5" name="TextBox 4"/>
+          <p:cNvSpPr txBox="1"/>
+          <p:nvPr/>
+        </p:nvSpPr>
+        <p:spPr>
+          <a:xfrm>
+            <a:off x="713231" y="3712463"/>
+            <a:ext cx="6620256" cy="731520"/>
+          </a:xfrm>
+          <a:prstGeom prst="rect">
+            <a:avLst/>
+          </a:prstGeom>
+          <a:noFill/>
+        </p:spPr>
+        <p:txBody>
+          <a:bodyPr wrap="square">
+            <a:noAutofit/>
+          </a:bodyPr>
+          <a:lstStyle/>
+          <a:p>
+            <a:pPr>
+              <a:spcAft>
+                <a:spcPts val="0"/>
+              </a:spcAft>
+              <a:defRPr sz="1100">
+                <a:solidFill>
+                  <a:srgbClr val="000000"/>
+                </a:solidFill>
+                <a:latin typeface="Consolas"/>
+              </a:defRPr>
+            </a:pPr>
+            <a:r>
+              <a:t>from sklearn.tree import DecisionTreeClassifier</a:t>
+            </a:r>
+          </a:p>
+          <a:p>
+            <a:pPr>
+              <a:spcAft>
+                <a:spcPts val="0"/>
+              </a:spcAft>
+              <a:defRPr sz="1100">
+                <a:solidFill>
+                  <a:srgbClr val="000000"/>
+                </a:solidFill>
+                <a:latin typeface="Consolas"/>
+              </a:defRPr>
+            </a:pPr>
+            <a:r>
+              <a:t>clf = DecisionTreeClassifier(criterion='gini')</a:t>
+            </a:r>
+          </a:p>
+          <a:p>
+            <a:pPr>
+              <a:spcAft>
+                <a:spcPts val="0"/>
+              </a:spcAft>
+              <a:defRPr sz="1100">
+                <a:solidFill>
+                  <a:srgbClr val="000000"/>
+                </a:solidFill>
+                <a:latin typeface="Consolas"/>
+              </a:defRPr>
+            </a:pPr>
+            <a:r>
+              <a:t>clf_ent = DecisionTreeClassifier(criterion='entropy')</a:t>
+            </a:r>
+          </a:p>
+          <a:p>
+            <a:pPr>
+              <a:spcAft>
+                <a:spcPts val="0"/>
+              </a:spcAft>
+              <a:defRPr sz="1100">
+                <a:solidFill>
+                  <a:srgbClr val="000000"/>
+                </a:solidFill>
+                <a:latin typeface="Consolas"/>
+              </a:defRPr>
+            </a:pPr>
+            <a:r>
+              <a:t># сравните деревья на одних данных</a:t>
+            </a:r>
+          </a:p>
+        </p:txBody>
+      </p:sp>
+      <p:sp>
+        <p:nvSpPr>
+          <p:cNvPr id="6" name="TextBox 5"/>
+          <p:cNvSpPr txBox="1"/>
+          <p:nvPr/>
+        </p:nvSpPr>
+        <p:spPr>
+          <a:xfrm>
+            <a:off x="640080" y="4535423"/>
+            <a:ext cx="6766560" cy="201168"/>
+          </a:xfrm>
+          <a:prstGeom prst="rect">
+            <a:avLst/>
+          </a:prstGeom>
+          <a:noFill/>
+        </p:spPr>
+        <p:txBody>
+          <a:bodyPr wrap="none">
+            <a:spAutoFit/>
+          </a:bodyPr>
+          <a:lstStyle/>
+          <a:p>
+            <a:pPr algn="l">
+              <a:defRPr sz="1000" i="1">
+                <a:solidFill>
+                  <a:srgbClr val="555555"/>
+                </a:solidFill>
+              </a:defRPr>
+            </a:pPr>
+            <a:r>
+              <a:t>Gini vs entropy</a:t>
+            </a:r>
+          </a:p>
+        </p:txBody>
+      </p:sp>
       <p:pic>
         <p:nvPicPr>
-          <p:cNvPr id="4" name="Picture 3" descr="impurity_functions.png"/>
+          <p:cNvPr id="7" name="Picture 6" descr="impurity_functions.png"/>
           <p:cNvPicPr>
             <a:picLocks noChangeAspect="1"/>
           </p:cNvPicPr>
@@ -9379,7 +11049,7 @@
         <p:spPr>
           <a:xfrm>
             <a:off x="640080" y="1371600"/>
-            <a:ext cx="11247120" cy="5029200"/>
+            <a:ext cx="11247120" cy="1810512"/>
           </a:xfrm>
           <a:prstGeom prst="rect">
             <a:avLst/>
@@ -9513,7 +11183,7 @@
         <p:spPr>
           <a:xfrm>
             <a:off x="640080" y="1371600"/>
-            <a:ext cx="11247120" cy="5029200"/>
+            <a:ext cx="11247120" cy="1810512"/>
           </a:xfrm>
           <a:prstGeom prst="rect">
             <a:avLst/>

</xml_diff>

<commit_message>
Regenerate all lesson presentations (references, code examples).
Co-authored-by: Cursor <cursoragent@cursor.com>
</commit_message>
<xml_diff>
--- a/lessons/derevo_resheniy/presentation.pptx
+++ b/lessons/derevo_resheniy/presentation.pptx
@@ -9473,7 +9473,7 @@
                 </a:solidFill>
                 <a:hlinkClick r:id="rId5"/>
               </a:rPr>
-              <a:t>https://colab.research.google.com/github/gurovic/ml-lessons/blob/feature/references-and-slide-code/lessons/derevo_resheniy/code.ipynb</a:t>
+              <a:t>https://colab.research.google.com/github/gurovic/ml-lessons/blob/main/lessons/derevo_resheniy/code.ipynb</a:t>
             </a:r>
           </a:p>
         </p:txBody>
@@ -9515,7 +9515,7 @@
                 </a:solidFill>
                 <a:hlinkClick r:id="rId6"/>
               </a:rPr>
-              <a:t>https://colab.research.google.com/github/gurovic/ml-lessons/blob/feature/references-and-slide-code/lessons/derevo_resheniy/project.ipynb</a:t>
+              <a:t>https://colab.research.google.com/github/gurovic/ml-lessons/blob/main/lessons/derevo_resheniy/project.ipynb</a:t>
             </a:r>
           </a:p>
         </p:txBody>

</xml_diff>

<commit_message>
Improve code slide rendering with Pygments; full-text reference URLs; regenerate pptx.
Co-authored-by: Cursor <cursoragent@cursor.com>
</commit_message>
<xml_diff>
--- a/lessons/derevo_resheniy/presentation.pptx
+++ b/lessons/derevo_resheniy/presentation.pptx
@@ -5476,7 +5476,7 @@
         <p:spPr>
           <a:xfrm>
             <a:off x="640080" y="1371600"/>
-            <a:ext cx="11247120" cy="1810512"/>
+            <a:ext cx="11247120" cy="3209544"/>
           </a:xfrm>
           <a:prstGeom prst="rect">
             <a:avLst/>
@@ -5485,7 +5485,7 @@
         </p:spPr>
         <p:txBody>
           <a:bodyPr wrap="square">
-            <a:spAutoFit/>
+            <a:normAutofit/>
           </a:bodyPr>
           <a:lstStyle/>
           <a:p>
@@ -5558,7 +5558,7 @@
         </p:nvSpPr>
         <p:spPr>
           <a:xfrm>
-            <a:off x="640080" y="3291840"/>
+            <a:off x="640080" y="4690872"/>
             <a:ext cx="11155680" cy="804672"/>
           </a:xfrm>
           <a:prstGeom prst="rect">
@@ -5603,7 +5603,7 @@
         </p:nvSpPr>
         <p:spPr>
           <a:xfrm>
-            <a:off x="713231" y="3328416"/>
+            <a:off x="713231" y="4727448"/>
             <a:ext cx="11009376" cy="731520"/>
           </a:xfrm>
           <a:prstGeom prst="rect">
@@ -5612,7 +5612,7 @@
           <a:noFill/>
         </p:spPr>
         <p:txBody>
-          <a:bodyPr wrap="square">
+          <a:bodyPr wrap="none">
             <a:noAutofit/>
           </a:bodyPr>
           <a:lstStyle/>
@@ -5621,14 +5621,14 @@
               <a:spcAft>
                 <a:spcPts val="0"/>
               </a:spcAft>
-              <a:defRPr sz="1100">
+            </a:pPr>
+            <a:r>
+              <a:rPr sz="1100">
                 <a:solidFill>
                   <a:srgbClr val="000000"/>
                 </a:solidFill>
                 <a:latin typeface="Consolas"/>
-              </a:defRPr>
-            </a:pPr>
-            <a:r>
+              </a:rPr>
               <a:t>from sklearn.metrics import accuracy_score, f1_score</a:t>
             </a:r>
           </a:p>
@@ -5637,14 +5637,14 @@
               <a:spcAft>
                 <a:spcPts val="0"/>
               </a:spcAft>
-              <a:defRPr sz="1100">
+            </a:pPr>
+            <a:r>
+              <a:rPr sz="1100">
                 <a:solidFill>
                   <a:srgbClr val="000000"/>
                 </a:solidFill>
                 <a:latin typeface="Consolas"/>
-              </a:defRPr>
-            </a:pPr>
-            <a:r>
+              </a:rPr>
               <a:t>y_pred = clf.predict(X_test)</a:t>
             </a:r>
           </a:p>
@@ -5653,14 +5653,14 @@
               <a:spcAft>
                 <a:spcPts val="0"/>
               </a:spcAft>
-              <a:defRPr sz="1100">
+            </a:pPr>
+            <a:r>
+              <a:rPr sz="1100">
                 <a:solidFill>
                   <a:srgbClr val="000000"/>
                 </a:solidFill>
                 <a:latin typeface="Consolas"/>
-              </a:defRPr>
-            </a:pPr>
-            <a:r>
+              </a:rPr>
               <a:t>print(accuracy_score(y_test, y_pred))</a:t>
             </a:r>
           </a:p>
@@ -5669,14 +5669,14 @@
               <a:spcAft>
                 <a:spcPts val="0"/>
               </a:spcAft>
-              <a:defRPr sz="1100">
+            </a:pPr>
+            <a:r>
+              <a:rPr sz="1100">
                 <a:solidFill>
                   <a:srgbClr val="000000"/>
                 </a:solidFill>
                 <a:latin typeface="Consolas"/>
-              </a:defRPr>
-            </a:pPr>
-            <a:r>
+              </a:rPr>
               <a:t>print(f1_score(y_test, y_pred, average='macro'))</a:t>
             </a:r>
           </a:p>
@@ -5690,7 +5690,7 @@
         </p:nvSpPr>
         <p:spPr>
           <a:xfrm>
-            <a:off x="640080" y="4151376"/>
+            <a:off x="640080" y="5550408"/>
             <a:ext cx="11155680" cy="201168"/>
           </a:xfrm>
           <a:prstGeom prst="rect">
@@ -5777,7 +5777,7 @@
         <p:spPr>
           <a:xfrm>
             <a:off x="640080" y="1371600"/>
-            <a:ext cx="6858000" cy="2194560"/>
+            <a:ext cx="6858000" cy="3383279"/>
           </a:xfrm>
           <a:prstGeom prst="rect">
             <a:avLst/>
@@ -5786,7 +5786,7 @@
         </p:spPr>
         <p:txBody>
           <a:bodyPr wrap="square">
-            <a:spAutoFit/>
+            <a:normAutofit/>
           </a:bodyPr>
           <a:lstStyle/>
           <a:p>
@@ -5874,7 +5874,7 @@
         </p:nvSpPr>
         <p:spPr>
           <a:xfrm>
-            <a:off x="640080" y="3675887"/>
+            <a:off x="640080" y="4864607"/>
             <a:ext cx="6766560" cy="630936"/>
           </a:xfrm>
           <a:prstGeom prst="rect">
@@ -5919,7 +5919,7 @@
         </p:nvSpPr>
         <p:spPr>
           <a:xfrm>
-            <a:off x="713231" y="3712463"/>
+            <a:off x="713231" y="4901183"/>
             <a:ext cx="6620256" cy="557784"/>
           </a:xfrm>
           <a:prstGeom prst="rect">
@@ -5928,7 +5928,7 @@
           <a:noFill/>
         </p:spPr>
         <p:txBody>
-          <a:bodyPr wrap="square">
+          <a:bodyPr wrap="none">
             <a:noAutofit/>
           </a:bodyPr>
           <a:lstStyle/>
@@ -5937,14 +5937,14 @@
               <a:spcAft>
                 <a:spcPts val="0"/>
               </a:spcAft>
-              <a:defRPr sz="1100">
+            </a:pPr>
+            <a:r>
+              <a:rPr sz="1100">
                 <a:solidFill>
                   <a:srgbClr val="000000"/>
                 </a:solidFill>
                 <a:latin typeface="Consolas"/>
-              </a:defRPr>
-            </a:pPr>
-            <a:r>
+              </a:rPr>
               <a:t>clf_deep = DecisionTreeClassifier(max_depth=None)</a:t>
             </a:r>
           </a:p>
@@ -5953,14 +5953,14 @@
               <a:spcAft>
                 <a:spcPts val="0"/>
               </a:spcAft>
-              <a:defRPr sz="1100">
+            </a:pPr>
+            <a:r>
+              <a:rPr sz="1100">
                 <a:solidFill>
                   <a:srgbClr val="000000"/>
                 </a:solidFill>
                 <a:latin typeface="Consolas"/>
-              </a:defRPr>
-            </a:pPr>
-            <a:r>
+              </a:rPr>
               <a:t>clf_reg = DecisionTreeClassifier(max_depth=3)</a:t>
             </a:r>
           </a:p>
@@ -5969,14 +5969,14 @@
               <a:spcAft>
                 <a:spcPts val="0"/>
               </a:spcAft>
-              <a:defRPr sz="1100">
+            </a:pPr>
+            <a:r>
+              <a:rPr sz="1100">
                 <a:solidFill>
                   <a:srgbClr val="000000"/>
                 </a:solidFill>
                 <a:latin typeface="Consolas"/>
-              </a:defRPr>
-            </a:pPr>
-            <a:r>
+              </a:rPr>
               <a:t># глубокое дерево: высокий train, низкий test</a:t>
             </a:r>
           </a:p>
@@ -5990,7 +5990,7 @@
         </p:nvSpPr>
         <p:spPr>
           <a:xfrm>
-            <a:off x="640080" y="4361688"/>
+            <a:off x="640080" y="5550407"/>
             <a:ext cx="6766560" cy="201168"/>
           </a:xfrm>
           <a:prstGeom prst="rect">
@@ -6101,7 +6101,7 @@
         <p:spPr>
           <a:xfrm>
             <a:off x="640080" y="1371600"/>
-            <a:ext cx="11247120" cy="1810512"/>
+            <a:ext cx="11247120" cy="3209544"/>
           </a:xfrm>
           <a:prstGeom prst="rect">
             <a:avLst/>
@@ -6110,7 +6110,7 @@
         </p:spPr>
         <p:txBody>
           <a:bodyPr wrap="square">
-            <a:spAutoFit/>
+            <a:normAutofit/>
           </a:bodyPr>
           <a:lstStyle/>
           <a:p>
@@ -6183,7 +6183,7 @@
         </p:nvSpPr>
         <p:spPr>
           <a:xfrm>
-            <a:off x="640080" y="3291840"/>
+            <a:off x="640080" y="4690872"/>
             <a:ext cx="11155680" cy="804672"/>
           </a:xfrm>
           <a:prstGeom prst="rect">
@@ -6228,7 +6228,7 @@
         </p:nvSpPr>
         <p:spPr>
           <a:xfrm>
-            <a:off x="713231" y="3328416"/>
+            <a:off x="713231" y="4727448"/>
             <a:ext cx="11009376" cy="731520"/>
           </a:xfrm>
           <a:prstGeom prst="rect">
@@ -6237,7 +6237,7 @@
           <a:noFill/>
         </p:spPr>
         <p:txBody>
-          <a:bodyPr wrap="square">
+          <a:bodyPr wrap="none">
             <a:noAutofit/>
           </a:bodyPr>
           <a:lstStyle/>
@@ -6246,14 +6246,14 @@
               <a:spcAft>
                 <a:spcPts val="0"/>
               </a:spcAft>
-              <a:defRPr sz="1100">
+            </a:pPr>
+            <a:r>
+              <a:rPr sz="1100">
                 <a:solidFill>
                   <a:srgbClr val="000000"/>
                 </a:solidFill>
                 <a:latin typeface="Consolas"/>
-              </a:defRPr>
-            </a:pPr>
-            <a:r>
+              </a:rPr>
               <a:t>from sklearn.tree import DecisionTreeClassifier</a:t>
             </a:r>
           </a:p>
@@ -6262,14 +6262,14 @@
               <a:spcAft>
                 <a:spcPts val="0"/>
               </a:spcAft>
-              <a:defRPr sz="1100">
+            </a:pPr>
+            <a:r>
+              <a:rPr sz="1100">
                 <a:solidFill>
                   <a:srgbClr val="000000"/>
                 </a:solidFill>
                 <a:latin typeface="Consolas"/>
-              </a:defRPr>
-            </a:pPr>
-            <a:r>
+              </a:rPr>
               <a:t>clf = DecisionTreeClassifier(max_depth=3, random_state=42)</a:t>
             </a:r>
           </a:p>
@@ -6278,14 +6278,14 @@
               <a:spcAft>
                 <a:spcPts val="0"/>
               </a:spcAft>
-              <a:defRPr sz="1100">
+            </a:pPr>
+            <a:r>
+              <a:rPr sz="1100">
                 <a:solidFill>
                   <a:srgbClr val="000000"/>
                 </a:solidFill>
                 <a:latin typeface="Consolas"/>
-              </a:defRPr>
-            </a:pPr>
-            <a:r>
+              </a:rPr>
               <a:t>clf.fit(X_train, y_train)</a:t>
             </a:r>
           </a:p>
@@ -6294,14 +6294,14 @@
               <a:spcAft>
                 <a:spcPts val="0"/>
               </a:spcAft>
-              <a:defRPr sz="1100">
+            </a:pPr>
+            <a:r>
+              <a:rPr sz="1100">
                 <a:solidFill>
                   <a:srgbClr val="000000"/>
                 </a:solidFill>
                 <a:latin typeface="Consolas"/>
-              </a:defRPr>
-            </a:pPr>
-            <a:r>
+              </a:rPr>
               <a:t>clf.predict(X_test)</a:t>
             </a:r>
           </a:p>
@@ -6315,7 +6315,7 @@
         </p:nvSpPr>
         <p:spPr>
           <a:xfrm>
-            <a:off x="640080" y="4151376"/>
+            <a:off x="640080" y="5550408"/>
             <a:ext cx="11155680" cy="201168"/>
           </a:xfrm>
           <a:prstGeom prst="rect">
@@ -6402,7 +6402,7 @@
         <p:spPr>
           <a:xfrm>
             <a:off x="640080" y="1371600"/>
-            <a:ext cx="6858000" cy="1645920"/>
+            <a:ext cx="6858000" cy="3383279"/>
           </a:xfrm>
           <a:prstGeom prst="rect">
             <a:avLst/>
@@ -6411,7 +6411,7 @@
         </p:spPr>
         <p:txBody>
           <a:bodyPr wrap="square">
-            <a:spAutoFit/>
+            <a:normAutofit/>
           </a:bodyPr>
           <a:lstStyle/>
           <a:p>
@@ -6469,7 +6469,7 @@
         </p:nvSpPr>
         <p:spPr>
           <a:xfrm>
-            <a:off x="640080" y="3127248"/>
+            <a:off x="640080" y="4864607"/>
             <a:ext cx="6766560" cy="630936"/>
           </a:xfrm>
           <a:prstGeom prst="rect">
@@ -6514,7 +6514,7 @@
         </p:nvSpPr>
         <p:spPr>
           <a:xfrm>
-            <a:off x="713231" y="3163824"/>
+            <a:off x="713231" y="4901183"/>
             <a:ext cx="6620256" cy="557784"/>
           </a:xfrm>
           <a:prstGeom prst="rect">
@@ -6523,7 +6523,7 @@
           <a:noFill/>
         </p:spPr>
         <p:txBody>
-          <a:bodyPr wrap="square">
+          <a:bodyPr wrap="none">
             <a:noAutofit/>
           </a:bodyPr>
           <a:lstStyle/>
@@ -6532,14 +6532,14 @@
               <a:spcAft>
                 <a:spcPts val="0"/>
               </a:spcAft>
-              <a:defRPr sz="1100">
+            </a:pPr>
+            <a:r>
+              <a:rPr sz="1100">
                 <a:solidFill>
                   <a:srgbClr val="000000"/>
                 </a:solidFill>
                 <a:latin typeface="Consolas"/>
-              </a:defRPr>
-            </a:pPr>
-            <a:r>
+              </a:rPr>
               <a:t>import pandas as pd</a:t>
             </a:r>
           </a:p>
@@ -6548,14 +6548,14 @@
               <a:spcAft>
                 <a:spcPts val="0"/>
               </a:spcAft>
-              <a:defRPr sz="1100">
+            </a:pPr>
+            <a:r>
+              <a:rPr sz="1100">
                 <a:solidFill>
                   <a:srgbClr val="000000"/>
                 </a:solidFill>
                 <a:latin typeface="Consolas"/>
-              </a:defRPr>
-            </a:pPr>
-            <a:r>
+              </a:rPr>
               <a:t>imp = pd.Series(clf.feature_importances_, index=feature_names)</a:t>
             </a:r>
           </a:p>
@@ -6564,14 +6564,14 @@
               <a:spcAft>
                 <a:spcPts val="0"/>
               </a:spcAft>
-              <a:defRPr sz="1100">
+            </a:pPr>
+            <a:r>
+              <a:rPr sz="1100">
                 <a:solidFill>
                   <a:srgbClr val="000000"/>
                 </a:solidFill>
                 <a:latin typeface="Consolas"/>
-              </a:defRPr>
-            </a:pPr>
-            <a:r>
+              </a:rPr>
               <a:t>imp.sort_values(ascending=False).head()</a:t>
             </a:r>
           </a:p>
@@ -6585,7 +6585,7 @@
         </p:nvSpPr>
         <p:spPr>
           <a:xfrm>
-            <a:off x="640080" y="3813048"/>
+            <a:off x="640080" y="5550407"/>
             <a:ext cx="6766560" cy="201168"/>
           </a:xfrm>
           <a:prstGeom prst="rect">
@@ -6696,7 +6696,7 @@
         <p:spPr>
           <a:xfrm>
             <a:off x="640080" y="1371600"/>
-            <a:ext cx="11247120" cy="1810512"/>
+            <a:ext cx="11247120" cy="3209544"/>
           </a:xfrm>
           <a:prstGeom prst="rect">
             <a:avLst/>
@@ -6705,7 +6705,7 @@
         </p:spPr>
         <p:txBody>
           <a:bodyPr wrap="square">
-            <a:spAutoFit/>
+            <a:normAutofit/>
           </a:bodyPr>
           <a:lstStyle/>
           <a:p>
@@ -6778,7 +6778,7 @@
         </p:nvSpPr>
         <p:spPr>
           <a:xfrm>
-            <a:off x="640080" y="3291840"/>
+            <a:off x="640080" y="4690872"/>
             <a:ext cx="11155680" cy="804672"/>
           </a:xfrm>
           <a:prstGeom prst="rect">
@@ -6823,7 +6823,7 @@
         </p:nvSpPr>
         <p:spPr>
           <a:xfrm>
-            <a:off x="713231" y="3328416"/>
+            <a:off x="713231" y="4727448"/>
             <a:ext cx="11009376" cy="731520"/>
           </a:xfrm>
           <a:prstGeom prst="rect">
@@ -6832,7 +6832,7 @@
           <a:noFill/>
         </p:spPr>
         <p:txBody>
-          <a:bodyPr wrap="square">
+          <a:bodyPr wrap="none">
             <a:noAutofit/>
           </a:bodyPr>
           <a:lstStyle/>
@@ -6841,14 +6841,14 @@
               <a:spcAft>
                 <a:spcPts val="0"/>
               </a:spcAft>
-              <a:defRPr sz="1100">
+            </a:pPr>
+            <a:r>
+              <a:rPr sz="1100">
                 <a:solidFill>
                   <a:srgbClr val="000000"/>
                 </a:solidFill>
                 <a:latin typeface="Consolas"/>
-              </a:defRPr>
-            </a:pPr>
-            <a:r>
+              </a:rPr>
               <a:t>from sklearn.tree import DecisionTreeRegressor</a:t>
             </a:r>
           </a:p>
@@ -6857,14 +6857,14 @@
               <a:spcAft>
                 <a:spcPts val="0"/>
               </a:spcAft>
-              <a:defRPr sz="1100">
+            </a:pPr>
+            <a:r>
+              <a:rPr sz="1100">
                 <a:solidFill>
                   <a:srgbClr val="000000"/>
                 </a:solidFill>
                 <a:latin typeface="Consolas"/>
-              </a:defRPr>
-            </a:pPr>
-            <a:r>
+              </a:rPr>
               <a:t>reg = DecisionTreeRegressor(max_depth=4, random_state=42)</a:t>
             </a:r>
           </a:p>
@@ -6873,14 +6873,14 @@
               <a:spcAft>
                 <a:spcPts val="0"/>
               </a:spcAft>
-              <a:defRPr sz="1100">
+            </a:pPr>
+            <a:r>
+              <a:rPr sz="1100">
                 <a:solidFill>
                   <a:srgbClr val="000000"/>
                 </a:solidFill>
                 <a:latin typeface="Consolas"/>
-              </a:defRPr>
-            </a:pPr>
-            <a:r>
+              </a:rPr>
               <a:t>reg.fit(X_train, y_train)</a:t>
             </a:r>
           </a:p>
@@ -6889,14 +6889,14 @@
               <a:spcAft>
                 <a:spcPts val="0"/>
               </a:spcAft>
-              <a:defRPr sz="1100">
+            </a:pPr>
+            <a:r>
+              <a:rPr sz="1100">
                 <a:solidFill>
                   <a:srgbClr val="000000"/>
                 </a:solidFill>
                 <a:latin typeface="Consolas"/>
-              </a:defRPr>
-            </a:pPr>
-            <a:r>
+              </a:rPr>
               <a:t>reg.predict(X_test)</a:t>
             </a:r>
           </a:p>
@@ -6910,7 +6910,7 @@
         </p:nvSpPr>
         <p:spPr>
           <a:xfrm>
-            <a:off x="640080" y="4151376"/>
+            <a:off x="640080" y="5550408"/>
             <a:ext cx="11155680" cy="201168"/>
           </a:xfrm>
           <a:prstGeom prst="rect">
@@ -7146,7 +7146,7 @@
         <p:spPr>
           <a:xfrm>
             <a:off x="640080" y="1371600"/>
-            <a:ext cx="11247120" cy="1645920"/>
+            <a:ext cx="11247120" cy="3209544"/>
           </a:xfrm>
           <a:prstGeom prst="rect">
             <a:avLst/>
@@ -7155,7 +7155,7 @@
         </p:spPr>
         <p:txBody>
           <a:bodyPr wrap="square">
-            <a:spAutoFit/>
+            <a:normAutofit/>
           </a:bodyPr>
           <a:lstStyle/>
           <a:p>
@@ -7213,7 +7213,7 @@
         </p:nvSpPr>
         <p:spPr>
           <a:xfrm>
-            <a:off x="640080" y="3127248"/>
+            <a:off x="640080" y="4690872"/>
             <a:ext cx="11155680" cy="804672"/>
           </a:xfrm>
           <a:prstGeom prst="rect">
@@ -7258,7 +7258,7 @@
         </p:nvSpPr>
         <p:spPr>
           <a:xfrm>
-            <a:off x="713231" y="3163824"/>
+            <a:off x="713231" y="4727448"/>
             <a:ext cx="11009376" cy="731520"/>
           </a:xfrm>
           <a:prstGeom prst="rect">
@@ -7267,7 +7267,7 @@
           <a:noFill/>
         </p:spPr>
         <p:txBody>
-          <a:bodyPr wrap="square">
+          <a:bodyPr wrap="none">
             <a:noAutofit/>
           </a:bodyPr>
           <a:lstStyle/>
@@ -7276,14 +7276,14 @@
               <a:spcAft>
                 <a:spcPts val="0"/>
               </a:spcAft>
-              <a:defRPr sz="1100">
+            </a:pPr>
+            <a:r>
+              <a:rPr sz="1100">
                 <a:solidFill>
                   <a:srgbClr val="000000"/>
                 </a:solidFill>
                 <a:latin typeface="Consolas"/>
-              </a:defRPr>
-            </a:pPr>
-            <a:r>
+              </a:rPr>
               <a:t>from sklearn.tree import plot_tree</a:t>
             </a:r>
           </a:p>
@@ -7292,14 +7292,14 @@
               <a:spcAft>
                 <a:spcPts val="0"/>
               </a:spcAft>
-              <a:defRPr sz="1100">
+            </a:pPr>
+            <a:r>
+              <a:rPr sz="1100">
                 <a:solidFill>
                   <a:srgbClr val="000000"/>
                 </a:solidFill>
                 <a:latin typeface="Consolas"/>
-              </a:defRPr>
-            </a:pPr>
-            <a:r>
+              </a:rPr>
               <a:t>import matplotlib.pyplot as plt</a:t>
             </a:r>
           </a:p>
@@ -7308,14 +7308,14 @@
               <a:spcAft>
                 <a:spcPts val="0"/>
               </a:spcAft>
-              <a:defRPr sz="1100">
+            </a:pPr>
+            <a:r>
+              <a:rPr sz="1100">
                 <a:solidFill>
                   <a:srgbClr val="000000"/>
                 </a:solidFill>
                 <a:latin typeface="Consolas"/>
-              </a:defRPr>
-            </a:pPr>
-            <a:r>
+              </a:rPr>
               <a:t>plot_tree(clf, feature_names=names, filled=True)</a:t>
             </a:r>
           </a:p>
@@ -7324,14 +7324,14 @@
               <a:spcAft>
                 <a:spcPts val="0"/>
               </a:spcAft>
-              <a:defRPr sz="1100">
+            </a:pPr>
+            <a:r>
+              <a:rPr sz="1100">
                 <a:solidFill>
                   <a:srgbClr val="000000"/>
                 </a:solidFill>
                 <a:latin typeface="Consolas"/>
-              </a:defRPr>
-            </a:pPr>
-            <a:r>
+              </a:rPr>
               <a:t>plt.show()</a:t>
             </a:r>
           </a:p>
@@ -7345,7 +7345,7 @@
         </p:nvSpPr>
         <p:spPr>
           <a:xfrm>
-            <a:off x="640080" y="3986783"/>
+            <a:off x="640080" y="5550408"/>
             <a:ext cx="11155680" cy="201168"/>
           </a:xfrm>
           <a:prstGeom prst="rect">
@@ -7432,7 +7432,7 @@
         <p:spPr>
           <a:xfrm>
             <a:off x="640080" y="1371600"/>
-            <a:ext cx="6858000" cy="1645920"/>
+            <a:ext cx="6858000" cy="2862071"/>
           </a:xfrm>
           <a:prstGeom prst="rect">
             <a:avLst/>
@@ -7441,7 +7441,7 @@
         </p:spPr>
         <p:txBody>
           <a:bodyPr wrap="square">
-            <a:spAutoFit/>
+            <a:normAutofit/>
           </a:bodyPr>
           <a:lstStyle/>
           <a:p>
@@ -7499,7 +7499,7 @@
         </p:nvSpPr>
         <p:spPr>
           <a:xfrm>
-            <a:off x="640080" y="3127248"/>
+            <a:off x="640080" y="4343399"/>
             <a:ext cx="6766560" cy="1152144"/>
           </a:xfrm>
           <a:prstGeom prst="rect">
@@ -7544,7 +7544,7 @@
         </p:nvSpPr>
         <p:spPr>
           <a:xfrm>
-            <a:off x="713231" y="3163824"/>
+            <a:off x="713231" y="4379975"/>
             <a:ext cx="6620256" cy="1078992"/>
           </a:xfrm>
           <a:prstGeom prst="rect">
@@ -7553,7 +7553,7 @@
           <a:noFill/>
         </p:spPr>
         <p:txBody>
-          <a:bodyPr wrap="square">
+          <a:bodyPr wrap="none">
             <a:noAutofit/>
           </a:bodyPr>
           <a:lstStyle/>
@@ -7562,14 +7562,14 @@
               <a:spcAft>
                 <a:spcPts val="0"/>
               </a:spcAft>
-              <a:defRPr sz="1100">
+            </a:pPr>
+            <a:r>
+              <a:rPr sz="1100">
                 <a:solidFill>
                   <a:srgbClr val="000000"/>
                 </a:solidFill>
                 <a:latin typeface="Consolas"/>
-              </a:defRPr>
-            </a:pPr>
-            <a:r>
+              </a:rPr>
               <a:t>import numpy as np</a:t>
             </a:r>
           </a:p>
@@ -7578,14 +7578,14 @@
               <a:spcAft>
                 <a:spcPts val="0"/>
               </a:spcAft>
-              <a:defRPr sz="1100">
+            </a:pPr>
+            <a:r>
+              <a:rPr sz="1100">
                 <a:solidFill>
                   <a:srgbClr val="000000"/>
                 </a:solidFill>
                 <a:latin typeface="Consolas"/>
-              </a:defRPr>
-            </a:pPr>
-            <a:r>
+              </a:rPr>
               <a:t>xx, yy = np.meshgrid(</a:t>
             </a:r>
           </a:p>
@@ -7594,14 +7594,14 @@
               <a:spcAft>
                 <a:spcPts val="0"/>
               </a:spcAft>
-              <a:defRPr sz="1100">
+            </a:pPr>
+            <a:r>
+              <a:rPr sz="1100">
                 <a:solidFill>
                   <a:srgbClr val="000000"/>
                 </a:solidFill>
                 <a:latin typeface="Consolas"/>
-              </a:defRPr>
-            </a:pPr>
-            <a:r>
+              </a:rPr>
               <a:t>    np.linspace(x.min(), x.max(), 200),</a:t>
             </a:r>
           </a:p>
@@ -7610,14 +7610,14 @@
               <a:spcAft>
                 <a:spcPts val="0"/>
               </a:spcAft>
-              <a:defRPr sz="1100">
+            </a:pPr>
+            <a:r>
+              <a:rPr sz="1100">
                 <a:solidFill>
                   <a:srgbClr val="000000"/>
                 </a:solidFill>
                 <a:latin typeface="Consolas"/>
-              </a:defRPr>
-            </a:pPr>
-            <a:r>
+              </a:rPr>
               <a:t>    np.linspace(y.min(), y.max(), 200),</a:t>
             </a:r>
           </a:p>
@@ -7626,14 +7626,14 @@
               <a:spcAft>
                 <a:spcPts val="0"/>
               </a:spcAft>
-              <a:defRPr sz="1100">
+            </a:pPr>
+            <a:r>
+              <a:rPr sz="1100">
                 <a:solidFill>
                   <a:srgbClr val="000000"/>
                 </a:solidFill>
                 <a:latin typeface="Consolas"/>
-              </a:defRPr>
-            </a:pPr>
-            <a:r>
+              </a:rPr>
               <a:t>)</a:t>
             </a:r>
           </a:p>
@@ -7642,14 +7642,14 @@
               <a:spcAft>
                 <a:spcPts val="0"/>
               </a:spcAft>
-              <a:defRPr sz="1100">
+            </a:pPr>
+            <a:r>
+              <a:rPr sz="1100">
                 <a:solidFill>
                   <a:srgbClr val="000000"/>
                 </a:solidFill>
                 <a:latin typeface="Consolas"/>
-              </a:defRPr>
-            </a:pPr>
-            <a:r>
+              </a:rPr>
               <a:t>Z = clf.predict(np.c_[xx.ravel(), yy.ravel()]).reshape(xx.shape)</a:t>
             </a:r>
           </a:p>
@@ -7663,7 +7663,7 @@
         </p:nvSpPr>
         <p:spPr>
           <a:xfrm>
-            <a:off x="640080" y="4334256"/>
+            <a:off x="640080" y="5550407"/>
             <a:ext cx="6766560" cy="201168"/>
           </a:xfrm>
           <a:prstGeom prst="rect">
@@ -8066,7 +8066,7 @@
         <p:spPr>
           <a:xfrm>
             <a:off x="640080" y="1371600"/>
-            <a:ext cx="11247120" cy="2578608"/>
+            <a:ext cx="11247120" cy="3209544"/>
           </a:xfrm>
           <a:prstGeom prst="rect">
             <a:avLst/>
@@ -8075,7 +8075,7 @@
         </p:spPr>
         <p:txBody>
           <a:bodyPr wrap="square">
-            <a:spAutoFit/>
+            <a:normAutofit/>
           </a:bodyPr>
           <a:lstStyle/>
           <a:p>
@@ -8178,7 +8178,7 @@
         </p:nvSpPr>
         <p:spPr>
           <a:xfrm>
-            <a:off x="640080" y="4059936"/>
+            <a:off x="640080" y="4690872"/>
             <a:ext cx="11155680" cy="804672"/>
           </a:xfrm>
           <a:prstGeom prst="rect">
@@ -8223,7 +8223,7 @@
         </p:nvSpPr>
         <p:spPr>
           <a:xfrm>
-            <a:off x="713231" y="4096512"/>
+            <a:off x="713231" y="4727448"/>
             <a:ext cx="11009376" cy="731520"/>
           </a:xfrm>
           <a:prstGeom prst="rect">
@@ -8232,7 +8232,7 @@
           <a:noFill/>
         </p:spPr>
         <p:txBody>
-          <a:bodyPr wrap="square">
+          <a:bodyPr wrap="none">
             <a:noAutofit/>
           </a:bodyPr>
           <a:lstStyle/>
@@ -8241,14 +8241,14 @@
               <a:spcAft>
                 <a:spcPts val="0"/>
               </a:spcAft>
-              <a:defRPr sz="1100">
+            </a:pPr>
+            <a:r>
+              <a:rPr sz="1100">
                 <a:solidFill>
                   <a:srgbClr val="000000"/>
                 </a:solidFill>
                 <a:latin typeface="Consolas"/>
-              </a:defRPr>
-            </a:pPr>
-            <a:r>
+              </a:rPr>
               <a:t>from sklearn.tree import DecisionTreeClassifier</a:t>
             </a:r>
           </a:p>
@@ -8257,14 +8257,14 @@
               <a:spcAft>
                 <a:spcPts val="0"/>
               </a:spcAft>
-              <a:defRPr sz="1100">
+            </a:pPr>
+            <a:r>
+              <a:rPr sz="1100">
                 <a:solidFill>
                   <a:srgbClr val="000000"/>
                 </a:solidFill>
                 <a:latin typeface="Consolas"/>
-              </a:defRPr>
-            </a:pPr>
-            <a:r>
+              </a:rPr>
               <a:t># масштабирование не обязательно</a:t>
             </a:r>
           </a:p>
@@ -8273,14 +8273,14 @@
               <a:spcAft>
                 <a:spcPts val="0"/>
               </a:spcAft>
-              <a:defRPr sz="1100">
+            </a:pPr>
+            <a:r>
+              <a:rPr sz="1100">
                 <a:solidFill>
                   <a:srgbClr val="000000"/>
                 </a:solidFill>
                 <a:latin typeface="Consolas"/>
-              </a:defRPr>
-            </a:pPr>
-            <a:r>
+              </a:rPr>
               <a:t>clf = DecisionTreeClassifier(random_state=42)</a:t>
             </a:r>
           </a:p>
@@ -8289,14 +8289,14 @@
               <a:spcAft>
                 <a:spcPts val="0"/>
               </a:spcAft>
-              <a:defRPr sz="1100">
+            </a:pPr>
+            <a:r>
+              <a:rPr sz="1100">
                 <a:solidFill>
                   <a:srgbClr val="000000"/>
                 </a:solidFill>
                 <a:latin typeface="Consolas"/>
-              </a:defRPr>
-            </a:pPr>
-            <a:r>
+              </a:rPr>
               <a:t>clf.fit(X_raw, y)  # можно на исходных признаках</a:t>
             </a:r>
           </a:p>
@@ -8310,7 +8310,7 @@
         </p:nvSpPr>
         <p:spPr>
           <a:xfrm>
-            <a:off x="640080" y="4919472"/>
+            <a:off x="640080" y="5550408"/>
             <a:ext cx="11155680" cy="201168"/>
           </a:xfrm>
           <a:prstGeom prst="rect">
@@ -9293,16 +9293,7 @@
                   <a:srgbClr val="000000"/>
                 </a:solidFill>
               </a:rPr>
-              <a:t xml:space="preserve">• </a:t>
-            </a:r>
-            <a:r>
-              <a:rPr sz="1600">
-                <a:solidFill>
-                  <a:srgbClr val="3366CC"/>
-                </a:solidFill>
-                <a:hlinkClick r:id="rId2"/>
-              </a:rPr>
-              <a:t>Breiman L., Friedman J., Olshen R., Stone C. (1984). Classification and Regression Trees</a:t>
+              <a:t>• Breiman L., Friedman J., Olshen R., Stone C. (1984). Classification and Regression Trees</a:t>
             </a:r>
           </a:p>
         </p:txBody>
@@ -9347,7 +9338,7 @@
                 <a:solidFill>
                   <a:srgbClr val="3366CC"/>
                 </a:solidFill>
-                <a:hlinkClick r:id="rId3"/>
+                <a:hlinkClick r:id="rId2"/>
               </a:rPr>
               <a:t>Quinlan J.R. (1986). Induction of Decision Trees</a:t>
             </a:r>
@@ -9394,7 +9385,7 @@
                 <a:solidFill>
                   <a:srgbClr val="3366CC"/>
                 </a:solidFill>
-                <a:hlinkClick r:id="rId4"/>
+                <a:hlinkClick r:id="rId3"/>
               </a:rPr>
               <a:t>Breiman L. (2001). Random Forests</a:t>
             </a:r>
@@ -9471,7 +9462,7 @@
                 <a:solidFill>
                   <a:srgbClr val="3366CC"/>
                 </a:solidFill>
-                <a:hlinkClick r:id="rId5"/>
+                <a:hlinkClick r:id="rId4"/>
               </a:rPr>
               <a:t>https://colab.research.google.com/github/gurovic/ml-lessons/blob/main/lessons/derevo_resheniy/code.ipynb</a:t>
             </a:r>
@@ -9513,7 +9504,7 @@
                 <a:solidFill>
                   <a:srgbClr val="3366CC"/>
                 </a:solidFill>
-                <a:hlinkClick r:id="rId6"/>
+                <a:hlinkClick r:id="rId5"/>
               </a:rPr>
               <a:t>https://colab.research.google.com/github/gurovic/ml-lessons/blob/main/lessons/derevo_resheniy/project.ipynb</a:t>
             </a:r>
@@ -9529,7 +9520,7 @@
           <p:nvPr/>
         </p:nvPicPr>
         <p:blipFill>
-          <a:blip r:embed="rId7"/>
+          <a:blip r:embed="rId6"/>
           <a:stretch>
             <a:fillRect/>
           </a:stretch>
@@ -9588,7 +9579,7 @@
           <p:nvPr/>
         </p:nvPicPr>
         <p:blipFill>
-          <a:blip r:embed="rId8"/>
+          <a:blip r:embed="rId7"/>
           <a:stretch>
             <a:fillRect/>
           </a:stretch>
@@ -9922,7 +9913,7 @@
         <p:spPr>
           <a:xfrm>
             <a:off x="640080" y="1371600"/>
-            <a:ext cx="6858000" cy="2194560"/>
+            <a:ext cx="6858000" cy="3209544"/>
           </a:xfrm>
           <a:prstGeom prst="rect">
             <a:avLst/>
@@ -9931,7 +9922,7 @@
         </p:spPr>
         <p:txBody>
           <a:bodyPr wrap="square">
-            <a:spAutoFit/>
+            <a:normAutofit/>
           </a:bodyPr>
           <a:lstStyle/>
           <a:p>
@@ -10019,7 +10010,7 @@
         </p:nvSpPr>
         <p:spPr>
           <a:xfrm>
-            <a:off x="640080" y="3675887"/>
+            <a:off x="640080" y="4690872"/>
             <a:ext cx="6766560" cy="804672"/>
           </a:xfrm>
           <a:prstGeom prst="rect">
@@ -10064,7 +10055,7 @@
         </p:nvSpPr>
         <p:spPr>
           <a:xfrm>
-            <a:off x="713231" y="3712463"/>
+            <a:off x="713231" y="4727448"/>
             <a:ext cx="6620256" cy="731520"/>
           </a:xfrm>
           <a:prstGeom prst="rect">
@@ -10073,7 +10064,7 @@
           <a:noFill/>
         </p:spPr>
         <p:txBody>
-          <a:bodyPr wrap="square">
+          <a:bodyPr wrap="none">
             <a:noAutofit/>
           </a:bodyPr>
           <a:lstStyle/>
@@ -10082,14 +10073,14 @@
               <a:spcAft>
                 <a:spcPts val="0"/>
               </a:spcAft>
-              <a:defRPr sz="1100">
+            </a:pPr>
+            <a:r>
+              <a:rPr sz="1100">
                 <a:solidFill>
                   <a:srgbClr val="000000"/>
                 </a:solidFill>
                 <a:latin typeface="Consolas"/>
-              </a:defRPr>
-            </a:pPr>
-            <a:r>
+              </a:rPr>
               <a:t>from sklearn.datasets import load_iris</a:t>
             </a:r>
           </a:p>
@@ -10098,14 +10089,14 @@
               <a:spcAft>
                 <a:spcPts val="0"/>
               </a:spcAft>
-              <a:defRPr sz="1100">
+            </a:pPr>
+            <a:r>
+              <a:rPr sz="1100">
                 <a:solidFill>
                   <a:srgbClr val="000000"/>
                 </a:solidFill>
                 <a:latin typeface="Consolas"/>
-              </a:defRPr>
-            </a:pPr>
-            <a:r>
+              </a:rPr>
               <a:t>X, y = load_iris(return_X_y=True)</a:t>
             </a:r>
           </a:p>
@@ -10114,14 +10105,14 @@
               <a:spcAft>
                 <a:spcPts val="0"/>
               </a:spcAft>
-              <a:defRPr sz="1100">
+            </a:pPr>
+            <a:r>
+              <a:rPr sz="1100">
                 <a:solidFill>
                   <a:srgbClr val="000000"/>
                 </a:solidFill>
                 <a:latin typeface="Consolas"/>
-              </a:defRPr>
-            </a:pPr>
-            <a:r>
+              </a:rPr>
               <a:t>X, y = X[y != 2], (y[y != 2] == 0).astype(int)</a:t>
             </a:r>
           </a:p>
@@ -10130,14 +10121,14 @@
               <a:spcAft>
                 <a:spcPts val="0"/>
               </a:spcAft>
-              <a:defRPr sz="1100">
+            </a:pPr>
+            <a:r>
+              <a:rPr sz="1100">
                 <a:solidFill>
                   <a:srgbClr val="000000"/>
                 </a:solidFill>
                 <a:latin typeface="Consolas"/>
-              </a:defRPr>
-            </a:pPr>
-            <a:r>
+              </a:rPr>
               <a:t># бинарная задача: setosa vs остальные</a:t>
             </a:r>
           </a:p>
@@ -10151,7 +10142,7 @@
         </p:nvSpPr>
         <p:spPr>
           <a:xfrm>
-            <a:off x="640080" y="4535423"/>
+            <a:off x="640080" y="5550408"/>
             <a:ext cx="6766560" cy="201168"/>
           </a:xfrm>
           <a:prstGeom prst="rect">
@@ -10558,7 +10549,7 @@
         <p:spPr>
           <a:xfrm>
             <a:off x="640080" y="1371600"/>
-            <a:ext cx="6858000" cy="2194560"/>
+            <a:ext cx="6858000" cy="3209544"/>
           </a:xfrm>
           <a:prstGeom prst="rect">
             <a:avLst/>
@@ -10567,7 +10558,7 @@
         </p:spPr>
         <p:txBody>
           <a:bodyPr wrap="square">
-            <a:spAutoFit/>
+            <a:normAutofit/>
           </a:bodyPr>
           <a:lstStyle/>
           <a:p>
@@ -10806,7 +10797,7 @@
         </p:nvSpPr>
         <p:spPr>
           <a:xfrm>
-            <a:off x="640080" y="3675887"/>
+            <a:off x="640080" y="4690872"/>
             <a:ext cx="6766560" cy="804672"/>
           </a:xfrm>
           <a:prstGeom prst="rect">
@@ -10851,7 +10842,7 @@
         </p:nvSpPr>
         <p:spPr>
           <a:xfrm>
-            <a:off x="713231" y="3712463"/>
+            <a:off x="713231" y="4727448"/>
             <a:ext cx="6620256" cy="731520"/>
           </a:xfrm>
           <a:prstGeom prst="rect">
@@ -10860,7 +10851,7 @@
           <a:noFill/>
         </p:spPr>
         <p:txBody>
-          <a:bodyPr wrap="square">
+          <a:bodyPr wrap="none">
             <a:noAutofit/>
           </a:bodyPr>
           <a:lstStyle/>
@@ -10869,14 +10860,14 @@
               <a:spcAft>
                 <a:spcPts val="0"/>
               </a:spcAft>
-              <a:defRPr sz="1100">
+            </a:pPr>
+            <a:r>
+              <a:rPr sz="1100">
                 <a:solidFill>
                   <a:srgbClr val="000000"/>
                 </a:solidFill>
                 <a:latin typeface="Consolas"/>
-              </a:defRPr>
-            </a:pPr>
-            <a:r>
+              </a:rPr>
               <a:t>from sklearn.tree import DecisionTreeClassifier</a:t>
             </a:r>
           </a:p>
@@ -10885,14 +10876,14 @@
               <a:spcAft>
                 <a:spcPts val="0"/>
               </a:spcAft>
-              <a:defRPr sz="1100">
+            </a:pPr>
+            <a:r>
+              <a:rPr sz="1100">
                 <a:solidFill>
                   <a:srgbClr val="000000"/>
                 </a:solidFill>
                 <a:latin typeface="Consolas"/>
-              </a:defRPr>
-            </a:pPr>
-            <a:r>
+              </a:rPr>
               <a:t>clf = DecisionTreeClassifier(criterion='gini')</a:t>
             </a:r>
           </a:p>
@@ -10901,14 +10892,14 @@
               <a:spcAft>
                 <a:spcPts val="0"/>
               </a:spcAft>
-              <a:defRPr sz="1100">
+            </a:pPr>
+            <a:r>
+              <a:rPr sz="1100">
                 <a:solidFill>
                   <a:srgbClr val="000000"/>
                 </a:solidFill>
                 <a:latin typeface="Consolas"/>
-              </a:defRPr>
-            </a:pPr>
-            <a:r>
+              </a:rPr>
               <a:t>clf_ent = DecisionTreeClassifier(criterion='entropy')</a:t>
             </a:r>
           </a:p>
@@ -10917,14 +10908,14 @@
               <a:spcAft>
                 <a:spcPts val="0"/>
               </a:spcAft>
-              <a:defRPr sz="1100">
+            </a:pPr>
+            <a:r>
+              <a:rPr sz="1100">
                 <a:solidFill>
                   <a:srgbClr val="000000"/>
                 </a:solidFill>
                 <a:latin typeface="Consolas"/>
-              </a:defRPr>
-            </a:pPr>
-            <a:r>
+              </a:rPr>
               <a:t># сравните деревья на одних данных</a:t>
             </a:r>
           </a:p>
@@ -10938,7 +10929,7 @@
         </p:nvSpPr>
         <p:spPr>
           <a:xfrm>
-            <a:off x="640080" y="4535423"/>
+            <a:off x="640080" y="5550408"/>
             <a:ext cx="6766560" cy="201168"/>
           </a:xfrm>
           <a:prstGeom prst="rect">

</xml_diff>

<commit_message>
Improve slide visuals pipeline and regenerate lesson illustrations (#34)
* Document concise code style and trim lesson examples.

Closes #25

Co-authored-by: Cursor <cursoragent@cursor.com>

* Refactor author feedback handling in AI review process

Separate author feedback into a dedicated author_feedback.md file and update documentation in RULES and pipeline docs to reflect these changes. Ensure that lesson_reviewer does not modify author files.

* Update RULES.md to clarify code style guidelines

Reorganize and renumber rules for concise code style, ensuring clarity on syntax and import practices. Emphasize the use of basic pandas/numpy constructs and maintain consistency across notebooks.

* Refactor slide_generator.md: Update visuals guidelines and remove outdated illustration policies. Clarify requirements for the visuals field and streamline the checklist for including illustrations in slides.

---------

Co-authored-by: Cursor <cursoragent@cursor.com>
</commit_message>
<xml_diff>
--- a/lessons/derevo_resheniy/presentation.pptx
+++ b/lessons/derevo_resheniy/presentation.pptx
@@ -5277,7 +5277,7 @@
               </a:defRPr>
             </a:pPr>
             <a:r>
-              <a:t>28.06.2026</a:t>
+              <a:t>29.06.2026</a:t>
             </a:r>
           </a:p>
         </p:txBody>
@@ -5342,7 +5342,7 @@
         <p:spPr>
           <a:xfrm>
             <a:off x="640080" y="1371600"/>
-            <a:ext cx="11247120" cy="1810512"/>
+            <a:ext cx="11247120" cy="2423160"/>
           </a:xfrm>
           <a:prstGeom prst="rect">
             <a:avLst/>
@@ -5366,7 +5366,7 @@
                   <a:srgbClr val="000000"/>
                 </a:solidFill>
               </a:rPr>
-              <a:t>Дерево склонно выбирать признаки с большим числом уникальных значений (ID, дата рождения, имя)</a:t>
+              <a:t>• Дерево склонно выбирать признаки с большим числом уникальных значений (ID, дата рождения, имя)</a:t>
             </a:r>
           </a:p>
           <a:p>
@@ -5381,7 +5381,7 @@
                   <a:srgbClr val="000000"/>
                 </a:solidFill>
               </a:rPr>
-              <a:t>Такой признак может идеально разделить выборку — каждому объекту свой лист → переобучение</a:t>
+              <a:t>• Такой признак может идеально разделить выборку — каждому объекту свой лист → переобучение</a:t>
             </a:r>
           </a:p>
           <a:p>
@@ -5396,7 +5396,7 @@
                   <a:srgbClr val="000000"/>
                 </a:solidFill>
               </a:rPr>
-              <a:t>Решение: Gain Ratio в C4.5 (нормирует gain на split information), ограничение глубины, min_samples_leaf</a:t>
+              <a:t>• Решение: Gain Ratio в C4.5 (нормирует gain на split information), ограничение глубины, min_samples_leaf</a:t>
             </a:r>
           </a:p>
           <a:p>
@@ -5411,7 +5411,7 @@
                   <a:srgbClr val="000000"/>
                 </a:solidFill>
               </a:rPr>
-              <a:t>Если есть ID или строка-идентификатор — УДАЛИТЕ перед обучением!</a:t>
+              <a:t>• Если есть ID или строка-идентификатор — УДАЛИТЕ перед обучением!</a:t>
             </a:r>
           </a:p>
         </p:txBody>
@@ -5476,7 +5476,7 @@
         <p:spPr>
           <a:xfrm>
             <a:off x="640080" y="1371600"/>
-            <a:ext cx="11247120" cy="3209544"/>
+            <a:ext cx="11247120" cy="2148839"/>
           </a:xfrm>
           <a:prstGeom prst="rect">
             <a:avLst/>
@@ -5485,7 +5485,7 @@
         </p:spPr>
         <p:txBody>
           <a:bodyPr wrap="square">
-            <a:normAutofit/>
+            <a:spAutoFit/>
           </a:bodyPr>
           <a:lstStyle/>
           <a:p>
@@ -5500,7 +5500,7 @@
                   <a:srgbClr val="000000"/>
                 </a:solidFill>
               </a:rPr>
-              <a:t>Accuracy недостаточна для несбалансированных данных — смотрите precision, recall, F1 по классам</a:t>
+              <a:t>• Accuracy недостаточна для несбалансированных данных — смотрите precision, recall, F1 по классам</a:t>
             </a:r>
           </a:p>
           <a:p>
@@ -5515,7 +5515,7 @@
                   <a:srgbClr val="000000"/>
                 </a:solidFill>
               </a:rPr>
-              <a:t>Для многоклассовой классификации — микро/макро-усреднение метрик</a:t>
+              <a:t>• Для многоклассовой классификации — микро/макро-усреднение метрик</a:t>
             </a:r>
           </a:p>
           <a:p>
@@ -5530,7 +5530,7 @@
                   <a:srgbClr val="000000"/>
                 </a:solidFill>
               </a:rPr>
-              <a:t>DecisionTreeClassifier: class_weight='balanced' — увеличивает вес минорных классов при подсчёте impurity при построении дерева (не при predict)</a:t>
+              <a:t>• DecisionTreeClassifier: class_weight='balanced' — увеличивает вес минорных классов при подсчёте impurity при построении дерева (не при predict)</a:t>
             </a:r>
           </a:p>
           <a:p>
@@ -5545,7 +5545,7 @@
                   <a:srgbClr val="000000"/>
                 </a:solidFill>
               </a:rPr>
-              <a:t>Это частично решает проблему дисбаланса</a:t>
+              <a:t>• Это частично решает проблему дисбаланса</a:t>
             </a:r>
           </a:p>
         </p:txBody>
@@ -5559,7 +5559,7 @@
         <p:spPr>
           <a:xfrm>
             <a:off x="640080" y="4690872"/>
-            <a:ext cx="11155680" cy="804672"/>
+            <a:ext cx="11155680" cy="630936"/>
           </a:xfrm>
           <a:prstGeom prst="rect">
             <a:avLst/>
@@ -5604,7 +5604,7 @@
         <p:spPr>
           <a:xfrm>
             <a:off x="713231" y="4727448"/>
-            <a:ext cx="11009376" cy="731520"/>
+            <a:ext cx="11009376" cy="557784"/>
           </a:xfrm>
           <a:prstGeom prst="rect">
             <a:avLst/>
@@ -5629,22 +5629,6 @@
                 </a:solidFill>
                 <a:latin typeface="Consolas"/>
               </a:rPr>
-              <a:t>from sklearn.metrics import accuracy_score, f1_score</a:t>
-            </a:r>
-          </a:p>
-          <a:p>
-            <a:pPr>
-              <a:spcAft>
-                <a:spcPts val="0"/>
-              </a:spcAft>
-            </a:pPr>
-            <a:r>
-              <a:rPr sz="1100">
-                <a:solidFill>
-                  <a:srgbClr val="000000"/>
-                </a:solidFill>
-                <a:latin typeface="Consolas"/>
-              </a:rPr>
               <a:t>y_pred = clf.predict(X_test)</a:t>
             </a:r>
           </a:p>
@@ -5690,7 +5674,7 @@
         </p:nvSpPr>
         <p:spPr>
           <a:xfrm>
-            <a:off x="640080" y="5550408"/>
+            <a:off x="640080" y="5376672"/>
             <a:ext cx="11155680" cy="201168"/>
           </a:xfrm>
           <a:prstGeom prst="rect">
@@ -5777,7 +5761,7 @@
         <p:spPr>
           <a:xfrm>
             <a:off x="640080" y="1371600"/>
-            <a:ext cx="6858000" cy="3383279"/>
+            <a:ext cx="6263640" cy="2971800"/>
           </a:xfrm>
           <a:prstGeom prst="rect">
             <a:avLst/>
@@ -5786,7 +5770,7 @@
         </p:spPr>
         <p:txBody>
           <a:bodyPr wrap="square">
-            <a:normAutofit/>
+            <a:spAutoFit/>
           </a:bodyPr>
           <a:lstStyle/>
           <a:p>
@@ -5801,7 +5785,7 @@
                   <a:srgbClr val="000000"/>
                 </a:solidFill>
               </a:rPr>
-              <a:t>Переобучение: дерево идеально запоминает шум — accuracy 100% на train, низкая на test</a:t>
+              <a:t>• Переобучение: дерево идеально запоминает шум — accuracy 100% на train, низкая на test</a:t>
             </a:r>
           </a:p>
           <a:p>
@@ -5816,7 +5800,7 @@
                   <a:srgbClr val="000000"/>
                 </a:solidFill>
               </a:rPr>
-              <a:t>Нестабильность (высокая дисперсия): малое изменение данных → полностью другое дерево</a:t>
+              <a:t>• Нестабильность (высокая дисперсия): малое изменение данных → полностью другое дерево</a:t>
             </a:r>
           </a:p>
           <a:p>
@@ -5831,7 +5815,7 @@
                   <a:srgbClr val="000000"/>
                 </a:solidFill>
               </a:rPr>
-              <a:t>Одно дерево — плохая идея в продакшене из-за этой нестабильности</a:t>
+              <a:t>• Одно дерево — плохая идея в продакшене из-за этой нестабильности</a:t>
             </a:r>
           </a:p>
           <a:p>
@@ -5846,7 +5830,7 @@
                   <a:srgbClr val="000000"/>
                 </a:solidFill>
               </a:rPr>
-              <a:t>Оценка: обязательно train/test split! Ошибка на тех же данных — грубейшая ошибка!</a:t>
+              <a:t>• Оценка: обязательно train/test split! Ошибка на тех же данных — грубейшая ошибка!</a:t>
             </a:r>
           </a:p>
           <a:p>
@@ -5861,7 +5845,7 @@
                   <a:srgbClr val="000000"/>
                 </a:solidFill>
               </a:rPr>
-              <a:t>Прунинг (ccp_alpha): вырастить глубокое дерево, затем обрезать ветки с малым приростом качества — эффективнее жёсткого max_depth</a:t>
+              <a:t>• Прунинг (ccp_alpha): вырастить глубокое дерево, затем обрезать ветки с малым приростом качества — эффективнее жёсткого max_depth</a:t>
             </a:r>
           </a:p>
         </p:txBody>
@@ -5874,8 +5858,8 @@
         </p:nvSpPr>
         <p:spPr>
           <a:xfrm>
-            <a:off x="640080" y="4864607"/>
-            <a:ext cx="6766560" cy="630936"/>
+            <a:off x="640080" y="4690872"/>
+            <a:ext cx="6172200" cy="630936"/>
           </a:xfrm>
           <a:prstGeom prst="rect">
             <a:avLst/>
@@ -5919,8 +5903,8 @@
         </p:nvSpPr>
         <p:spPr>
           <a:xfrm>
-            <a:off x="713231" y="4901183"/>
-            <a:ext cx="6620256" cy="557784"/>
+            <a:off x="713231" y="4727448"/>
+            <a:ext cx="6025896" cy="557784"/>
           </a:xfrm>
           <a:prstGeom prst="rect">
             <a:avLst/>
@@ -5990,8 +5974,8 @@
         </p:nvSpPr>
         <p:spPr>
           <a:xfrm>
-            <a:off x="640080" y="5550407"/>
-            <a:ext cx="6766560" cy="201168"/>
+            <a:off x="640080" y="5376672"/>
+            <a:ext cx="6172200" cy="201168"/>
           </a:xfrm>
           <a:prstGeom prst="rect">
             <a:avLst/>
@@ -6033,8 +6017,8 @@
         </p:blipFill>
         <p:spPr>
           <a:xfrm>
-            <a:off x="7635240" y="2208847"/>
-            <a:ext cx="4343400" cy="2714625"/>
+            <a:off x="7269480" y="1325880"/>
+            <a:ext cx="4465015" cy="2878076"/>
           </a:xfrm>
           <a:prstGeom prst="rect">
             <a:avLst/>
@@ -6101,7 +6085,7 @@
         <p:spPr>
           <a:xfrm>
             <a:off x="640080" y="1371600"/>
-            <a:ext cx="11247120" cy="3209544"/>
+            <a:ext cx="11247120" cy="1874519"/>
           </a:xfrm>
           <a:prstGeom prst="rect">
             <a:avLst/>
@@ -6110,7 +6094,7 @@
         </p:spPr>
         <p:txBody>
           <a:bodyPr wrap="square">
-            <a:normAutofit/>
+            <a:spAutoFit/>
           </a:bodyPr>
           <a:lstStyle/>
           <a:p>
@@ -6125,7 +6109,7 @@
                   <a:srgbClr val="000000"/>
                 </a:solidFill>
               </a:rPr>
-              <a:t>clf = DecisionTreeClassifier(max_depth=3, ccp_alpha=0.01, random_state=42)</a:t>
+              <a:t>• clf = DecisionTreeClassifier(max_depth=3, ccp_alpha=0.01, random_state=42)</a:t>
             </a:r>
           </a:p>
           <a:p>
@@ -6140,7 +6124,7 @@
                   <a:srgbClr val="000000"/>
                 </a:solidFill>
               </a:rPr>
-              <a:t>clf.fit(X, y)</a:t>
+              <a:t>• clf.fit(X, y)</a:t>
             </a:r>
           </a:p>
           <a:p>
@@ -6155,7 +6139,7 @@
                   <a:srgbClr val="000000"/>
                 </a:solidFill>
               </a:rPr>
-              <a:t>Важные параметры: max_depth, min_samples_leaf, ccp_alpha, criterion (gini/entropy)</a:t>
+              <a:t>• Важные параметры: max_depth, min_samples_leaf, ccp_alpha, criterion (gini/entropy)</a:t>
             </a:r>
           </a:p>
           <a:p>
@@ -6170,7 +6154,7 @@
                   <a:srgbClr val="000000"/>
                 </a:solidFill>
               </a:rPr>
-              <a:t>Для воспроизводимости: random_state фиксирует случайность при равной информативности разбиений</a:t>
+              <a:t>• Для воспроизводимости: random_state фиксирует случайность при равной информативности разбиений</a:t>
             </a:r>
           </a:p>
         </p:txBody>
@@ -6184,7 +6168,7 @@
         <p:spPr>
           <a:xfrm>
             <a:off x="640080" y="4690872"/>
-            <a:ext cx="11155680" cy="804672"/>
+            <a:ext cx="11155680" cy="630936"/>
           </a:xfrm>
           <a:prstGeom prst="rect">
             <a:avLst/>
@@ -6229,7 +6213,7 @@
         <p:spPr>
           <a:xfrm>
             <a:off x="713231" y="4727448"/>
-            <a:ext cx="11009376" cy="731520"/>
+            <a:ext cx="11009376" cy="557784"/>
           </a:xfrm>
           <a:prstGeom prst="rect">
             <a:avLst/>
@@ -6254,22 +6238,6 @@
                 </a:solidFill>
                 <a:latin typeface="Consolas"/>
               </a:rPr>
-              <a:t>from sklearn.tree import DecisionTreeClassifier</a:t>
-            </a:r>
-          </a:p>
-          <a:p>
-            <a:pPr>
-              <a:spcAft>
-                <a:spcPts val="0"/>
-              </a:spcAft>
-            </a:pPr>
-            <a:r>
-              <a:rPr sz="1100">
-                <a:solidFill>
-                  <a:srgbClr val="000000"/>
-                </a:solidFill>
-                <a:latin typeface="Consolas"/>
-              </a:rPr>
               <a:t>clf = DecisionTreeClassifier(max_depth=3, random_state=42)</a:t>
             </a:r>
           </a:p>
@@ -6315,7 +6283,7 @@
         </p:nvSpPr>
         <p:spPr>
           <a:xfrm>
-            <a:off x="640080" y="5550408"/>
+            <a:off x="640080" y="5376672"/>
             <a:ext cx="11155680" cy="201168"/>
           </a:xfrm>
           <a:prstGeom prst="rect">
@@ -6402,7 +6370,7 @@
         <p:spPr>
           <a:xfrm>
             <a:off x="640080" y="1371600"/>
-            <a:ext cx="6858000" cy="3383279"/>
+            <a:ext cx="6263640" cy="2697480"/>
           </a:xfrm>
           <a:prstGeom prst="rect">
             <a:avLst/>
@@ -6411,7 +6379,7 @@
         </p:spPr>
         <p:txBody>
           <a:bodyPr wrap="square">
-            <a:normAutofit/>
+            <a:spAutoFit/>
           </a:bodyPr>
           <a:lstStyle/>
           <a:p>
@@ -6426,7 +6394,7 @@
                   <a:srgbClr val="000000"/>
                 </a:solidFill>
               </a:rPr>
-              <a:t>Важность признака: суммарное уменьшение impurity во всех узлах, где он используется, взвешенное на число объектов</a:t>
+              <a:t>• Важность признака: суммарное уменьшение impurity во всех узлах, где он используется, взвешенное на число объектов</a:t>
             </a:r>
           </a:p>
           <a:p>
@@ -6441,7 +6409,7 @@
                   <a:srgbClr val="000000"/>
                 </a:solidFill>
               </a:rPr>
-              <a:t>Можно отсортировать признаки по важности — понять, что реально влияет</a:t>
+              <a:t>• Можно отсортировать признаки по важности — понять, что реально влияет</a:t>
             </a:r>
           </a:p>
           <a:p>
@@ -6456,7 +6424,7 @@
                   <a:srgbClr val="000000"/>
                 </a:solidFill>
               </a:rPr>
-              <a:t>Важно помнить о bias: модель может выучить несправедливые закономерности (пол, национальность) — дерево их воспроизведёт</a:t>
+              <a:t>• Важно помнить о bias: модель может выучить несправедливые закономерности (пол, национальность) — дерево их воспроизведёт</a:t>
             </a:r>
           </a:p>
         </p:txBody>
@@ -6469,8 +6437,8 @@
         </p:nvSpPr>
         <p:spPr>
           <a:xfrm>
-            <a:off x="640080" y="4864607"/>
-            <a:ext cx="6766560" cy="630936"/>
+            <a:off x="640080" y="4892040"/>
+            <a:ext cx="6172200" cy="457200"/>
           </a:xfrm>
           <a:prstGeom prst="rect">
             <a:avLst/>
@@ -6514,8 +6482,8 @@
         </p:nvSpPr>
         <p:spPr>
           <a:xfrm>
-            <a:off x="713231" y="4901183"/>
-            <a:ext cx="6620256" cy="557784"/>
+            <a:off x="713231" y="4928616"/>
+            <a:ext cx="6025896" cy="384048"/>
           </a:xfrm>
           <a:prstGeom prst="rect">
             <a:avLst/>
@@ -6540,22 +6508,6 @@
                 </a:solidFill>
                 <a:latin typeface="Consolas"/>
               </a:rPr>
-              <a:t>import pandas as pd</a:t>
-            </a:r>
-          </a:p>
-          <a:p>
-            <a:pPr>
-              <a:spcAft>
-                <a:spcPts val="0"/>
-              </a:spcAft>
-            </a:pPr>
-            <a:r>
-              <a:rPr sz="1100">
-                <a:solidFill>
-                  <a:srgbClr val="000000"/>
-                </a:solidFill>
-                <a:latin typeface="Consolas"/>
-              </a:rPr>
               <a:t>imp = pd.Series(clf.feature_importances_, index=feature_names)</a:t>
             </a:r>
           </a:p>
@@ -6585,8 +6537,8 @@
         </p:nvSpPr>
         <p:spPr>
           <a:xfrm>
-            <a:off x="640080" y="5550407"/>
-            <a:ext cx="6766560" cy="201168"/>
+            <a:off x="640080" y="5404104"/>
+            <a:ext cx="6172200" cy="201168"/>
           </a:xfrm>
           <a:prstGeom prst="rect">
             <a:avLst/>
@@ -6628,8 +6580,8 @@
         </p:blipFill>
         <p:spPr>
           <a:xfrm>
-            <a:off x="7635240" y="2208847"/>
-            <a:ext cx="4343400" cy="2714625"/>
+            <a:off x="7269480" y="1325880"/>
+            <a:ext cx="4465015" cy="2227866"/>
           </a:xfrm>
           <a:prstGeom prst="rect">
             <a:avLst/>
@@ -6696,7 +6648,7 @@
         <p:spPr>
           <a:xfrm>
             <a:off x="640080" y="1371600"/>
-            <a:ext cx="11247120" cy="3209544"/>
+            <a:ext cx="11247120" cy="1874519"/>
           </a:xfrm>
           <a:prstGeom prst="rect">
             <a:avLst/>
@@ -6705,7 +6657,7 @@
         </p:spPr>
         <p:txBody>
           <a:bodyPr wrap="square">
-            <a:normAutofit/>
+            <a:spAutoFit/>
           </a:bodyPr>
           <a:lstStyle/>
           <a:p>
@@ -6720,7 +6672,7 @@
                   <a:srgbClr val="000000"/>
                 </a:solidFill>
               </a:rPr>
-              <a:t>Критерий разбиения — MSE (средний квадрат ошибки)</a:t>
+              <a:t>• Критерий разбиения — MSE (средний квадрат ошибки)</a:t>
             </a:r>
           </a:p>
           <a:p>
@@ -6735,7 +6687,7 @@
                   <a:srgbClr val="000000"/>
                 </a:solidFill>
               </a:rPr>
-              <a:t>Значение в листе — среднее арифметическое целевой переменной</a:t>
+              <a:t>• Значение в листе — среднее арифметическое целевой переменной</a:t>
             </a:r>
           </a:p>
           <a:p>
@@ -6750,7 +6702,7 @@
                   <a:srgbClr val="000000"/>
                 </a:solidFill>
               </a:rPr>
-              <a:t>Отличие от классификации: не голосование, а среднее</a:t>
+              <a:t>• Отличие от классификации: не голосование, а среднее</a:t>
             </a:r>
           </a:p>
           <a:p>
@@ -6765,7 +6717,7 @@
                   <a:srgbClr val="000000"/>
                 </a:solidFill>
               </a:rPr>
-              <a:t>Выбросы в y: чувствительны при MSE; в sklearn — DecisionTreeRegressor(criterion='absolute_error') или чистка данных</a:t>
+              <a:t>• Выбросы в y: чувствительны при MSE; в sklearn — DecisionTreeRegressor(criterion='absolute_error') или чистка данных</a:t>
             </a:r>
           </a:p>
         </p:txBody>
@@ -6779,7 +6731,7 @@
         <p:spPr>
           <a:xfrm>
             <a:off x="640080" y="4690872"/>
-            <a:ext cx="11155680" cy="804672"/>
+            <a:ext cx="11155680" cy="630936"/>
           </a:xfrm>
           <a:prstGeom prst="rect">
             <a:avLst/>
@@ -6824,7 +6776,7 @@
         <p:spPr>
           <a:xfrm>
             <a:off x="713231" y="4727448"/>
-            <a:ext cx="11009376" cy="731520"/>
+            <a:ext cx="11009376" cy="557784"/>
           </a:xfrm>
           <a:prstGeom prst="rect">
             <a:avLst/>
@@ -6849,22 +6801,6 @@
                 </a:solidFill>
                 <a:latin typeface="Consolas"/>
               </a:rPr>
-              <a:t>from sklearn.tree import DecisionTreeRegressor</a:t>
-            </a:r>
-          </a:p>
-          <a:p>
-            <a:pPr>
-              <a:spcAft>
-                <a:spcPts val="0"/>
-              </a:spcAft>
-            </a:pPr>
-            <a:r>
-              <a:rPr sz="1100">
-                <a:solidFill>
-                  <a:srgbClr val="000000"/>
-                </a:solidFill>
-                <a:latin typeface="Consolas"/>
-              </a:rPr>
               <a:t>reg = DecisionTreeRegressor(max_depth=4, random_state=42)</a:t>
             </a:r>
           </a:p>
@@ -6910,7 +6846,7 @@
         </p:nvSpPr>
         <p:spPr>
           <a:xfrm>
-            <a:off x="640080" y="5550408"/>
+            <a:off x="640080" y="5376672"/>
             <a:ext cx="11155680" cy="201168"/>
           </a:xfrm>
           <a:prstGeom prst="rect">
@@ -6997,7 +6933,7 @@
         <p:spPr>
           <a:xfrm>
             <a:off x="640080" y="1371600"/>
-            <a:ext cx="11247120" cy="2194560"/>
+            <a:ext cx="5532120" cy="2148839"/>
           </a:xfrm>
           <a:prstGeom prst="rect">
             <a:avLst/>
@@ -7021,7 +6957,7 @@
                   <a:srgbClr val="000000"/>
                 </a:solidFill>
               </a:rPr>
-              <a:t>Одно дерево — нестабильно и склонно к переобучению</a:t>
+              <a:t>• Одно дерево — нестабильно и склонно к переобучению</a:t>
             </a:r>
           </a:p>
           <a:p>
@@ -7036,7 +6972,7 @@
                   <a:srgbClr val="000000"/>
                 </a:solidFill>
               </a:rPr>
-              <a:t>Решение: строить много деревьев и усреднять их ответы</a:t>
+              <a:t>• Решение: строить много деревьев и усреднять их ответы</a:t>
             </a:r>
           </a:p>
           <a:p>
@@ -7051,9 +6987,32 @@
                   <a:srgbClr val="000000"/>
                 </a:solidFill>
               </a:rPr>
-              <a:t>Random Forest: случайные подвыборки данных и признаков → независимые деревья → среднее</a:t>
-            </a:r>
-          </a:p>
+              <a:t>• Random Forest: случайные подвыборки данных и признаков → независимые деревья → среднее</a:t>
+            </a:r>
+          </a:p>
+        </p:txBody>
+      </p:sp>
+      <p:sp>
+        <p:nvSpPr>
+          <p:cNvPr id="4" name="TextBox 3"/>
+          <p:cNvSpPr txBox="1"/>
+          <p:nvPr/>
+        </p:nvSpPr>
+        <p:spPr>
+          <a:xfrm>
+            <a:off x="6355080" y="1371600"/>
+            <a:ext cx="5532120" cy="2148839"/>
+          </a:xfrm>
+          <a:prstGeom prst="rect">
+            <a:avLst/>
+          </a:prstGeom>
+          <a:noFill/>
+        </p:spPr>
+        <p:txBody>
+          <a:bodyPr wrap="square">
+            <a:spAutoFit/>
+          </a:bodyPr>
+          <a:lstStyle/>
           <a:p>
             <a:pPr>
               <a:spcAft>
@@ -7066,7 +7025,7 @@
                   <a:srgbClr val="000000"/>
                 </a:solidFill>
               </a:rPr>
-              <a:t>Gradient Boosting: деревья строятся последовательно, каждое исправляет ошибки предыдущего</a:t>
+              <a:t>• Gradient Boosting: деревья строятся последовательно, каждое исправляет ошибки предыдущего</a:t>
             </a:r>
           </a:p>
           <a:p>
@@ -7081,7 +7040,7 @@
                   <a:srgbClr val="000000"/>
                 </a:solidFill>
               </a:rPr>
-              <a:t>Оба подхода используют жадные деревья как слабых учеников</a:t>
+              <a:t>• Оба подхода используют жадные деревья как слабых учеников</a:t>
             </a:r>
           </a:p>
         </p:txBody>
@@ -7146,7 +7105,7 @@
         <p:spPr>
           <a:xfrm>
             <a:off x="640080" y="1371600"/>
-            <a:ext cx="11247120" cy="3209544"/>
+            <a:ext cx="11247120" cy="1325880"/>
           </a:xfrm>
           <a:prstGeom prst="rect">
             <a:avLst/>
@@ -7155,7 +7114,7 @@
         </p:spPr>
         <p:txBody>
           <a:bodyPr wrap="square">
-            <a:normAutofit/>
+            <a:spAutoFit/>
           </a:bodyPr>
           <a:lstStyle/>
           <a:p>
@@ -7170,7 +7129,7 @@
                   <a:srgbClr val="000000"/>
                 </a:solidFill>
               </a:rPr>
-              <a:t>sklearn.tree.plot_tree(clf, filled=True) — графическое дерево с цветом классов</a:t>
+              <a:t>• sklearn.tree.plot_tree(clf, filled=True) — графическое дерево с цветом классов</a:t>
             </a:r>
           </a:p>
           <a:p>
@@ -7185,7 +7144,7 @@
                   <a:srgbClr val="000000"/>
                 </a:solidFill>
               </a:rPr>
-              <a:t>export_graphviz — экспорт для Graphviz (dot-формат)</a:t>
+              <a:t>• export_graphviz — экспорт для Graphviz (dot-формат)</a:t>
             </a:r>
           </a:p>
           <a:p>
@@ -7200,7 +7159,7 @@
                   <a:srgbClr val="000000"/>
                 </a:solidFill>
               </a:rPr>
-              <a:t>export_text — текстовое представление: правила вида X[0] &lt;= 2.5 → class=1</a:t>
+              <a:t>• export_text — текстовое представление: правила вида X[0] &lt;= 2.5 → class=1</a:t>
             </a:r>
           </a:p>
         </p:txBody>
@@ -7213,8 +7172,8 @@
         </p:nvSpPr>
         <p:spPr>
           <a:xfrm>
-            <a:off x="640080" y="4690872"/>
-            <a:ext cx="11155680" cy="804672"/>
+            <a:off x="640080" y="4892040"/>
+            <a:ext cx="11155680" cy="457200"/>
           </a:xfrm>
           <a:prstGeom prst="rect">
             <a:avLst/>
@@ -7258,8 +7217,8 @@
         </p:nvSpPr>
         <p:spPr>
           <a:xfrm>
-            <a:off x="713231" y="4727448"/>
-            <a:ext cx="11009376" cy="731520"/>
+            <a:off x="713231" y="4928616"/>
+            <a:ext cx="11009376" cy="384048"/>
           </a:xfrm>
           <a:prstGeom prst="rect">
             <a:avLst/>
@@ -7284,38 +7243,6 @@
                 </a:solidFill>
                 <a:latin typeface="Consolas"/>
               </a:rPr>
-              <a:t>from sklearn.tree import plot_tree</a:t>
-            </a:r>
-          </a:p>
-          <a:p>
-            <a:pPr>
-              <a:spcAft>
-                <a:spcPts val="0"/>
-              </a:spcAft>
-            </a:pPr>
-            <a:r>
-              <a:rPr sz="1100">
-                <a:solidFill>
-                  <a:srgbClr val="000000"/>
-                </a:solidFill>
-                <a:latin typeface="Consolas"/>
-              </a:rPr>
-              <a:t>import matplotlib.pyplot as plt</a:t>
-            </a:r>
-          </a:p>
-          <a:p>
-            <a:pPr>
-              <a:spcAft>
-                <a:spcPts val="0"/>
-              </a:spcAft>
-            </a:pPr>
-            <a:r>
-              <a:rPr sz="1100">
-                <a:solidFill>
-                  <a:srgbClr val="000000"/>
-                </a:solidFill>
-                <a:latin typeface="Consolas"/>
-              </a:rPr>
               <a:t>plot_tree(clf, feature_names=names, filled=True)</a:t>
             </a:r>
           </a:p>
@@ -7345,7 +7272,7 @@
         </p:nvSpPr>
         <p:spPr>
           <a:xfrm>
-            <a:off x="640080" y="5550408"/>
+            <a:off x="640080" y="5404104"/>
             <a:ext cx="11155680" cy="201168"/>
           </a:xfrm>
           <a:prstGeom prst="rect">
@@ -7432,7 +7359,7 @@
         <p:spPr>
           <a:xfrm>
             <a:off x="640080" y="1371600"/>
-            <a:ext cx="6858000" cy="2862071"/>
+            <a:ext cx="6263640" cy="2148839"/>
           </a:xfrm>
           <a:prstGeom prst="rect">
             <a:avLst/>
@@ -7441,7 +7368,7 @@
         </p:spPr>
         <p:txBody>
           <a:bodyPr wrap="square">
-            <a:normAutofit/>
+            <a:spAutoFit/>
           </a:bodyPr>
           <a:lstStyle/>
           <a:p>
@@ -7456,7 +7383,7 @@
                   <a:srgbClr val="000000"/>
                 </a:solidFill>
               </a:rPr>
-              <a:t>Дерево делит пространство признаков на прямоугольники (оси-параллельные)</a:t>
+              <a:t>• Дерево делит пространство признаков на прямоугольники (оси-параллельные)</a:t>
             </a:r>
           </a:p>
           <a:p>
@@ -7471,7 +7398,7 @@
                   <a:srgbClr val="000000"/>
                 </a:solidFill>
               </a:rPr>
-              <a:t>Проблема лестницы: дерево не может провести диагональные или круговые границы</a:t>
+              <a:t>• Проблема лестницы: дерево не может провести диагональные или круговые границы</a:t>
             </a:r>
           </a:p>
           <a:p>
@@ -7486,7 +7413,7 @@
                   <a:srgbClr val="000000"/>
                 </a:solidFill>
               </a:rPr>
-              <a:t>Для регрессии — кусочно-постоянная аппроксимация (в каждом прямоугольнике — своя константа)</a:t>
+              <a:t>• Для регрессии — кусочно-постоянная аппроксимация (в каждом прямоугольнике — своя константа)</a:t>
             </a:r>
           </a:p>
         </p:txBody>
@@ -7499,8 +7426,8 @@
         </p:nvSpPr>
         <p:spPr>
           <a:xfrm>
-            <a:off x="640080" y="4343399"/>
-            <a:ext cx="6766560" cy="1152144"/>
+            <a:off x="640080" y="4288536"/>
+            <a:ext cx="6172200" cy="978407"/>
           </a:xfrm>
           <a:prstGeom prst="rect">
             <a:avLst/>
@@ -7544,8 +7471,8 @@
         </p:nvSpPr>
         <p:spPr>
           <a:xfrm>
-            <a:off x="713231" y="4379975"/>
-            <a:ext cx="6620256" cy="1078992"/>
+            <a:off x="713231" y="4325112"/>
+            <a:ext cx="6025896" cy="905255"/>
           </a:xfrm>
           <a:prstGeom prst="rect">
             <a:avLst/>
@@ -7570,22 +7497,6 @@
                 </a:solidFill>
                 <a:latin typeface="Consolas"/>
               </a:rPr>
-              <a:t>import numpy as np</a:t>
-            </a:r>
-          </a:p>
-          <a:p>
-            <a:pPr>
-              <a:spcAft>
-                <a:spcPts val="0"/>
-              </a:spcAft>
-            </a:pPr>
-            <a:r>
-              <a:rPr sz="1100">
-                <a:solidFill>
-                  <a:srgbClr val="000000"/>
-                </a:solidFill>
-                <a:latin typeface="Consolas"/>
-              </a:rPr>
               <a:t>xx, yy = np.meshgrid(</a:t>
             </a:r>
           </a:p>
@@ -7663,8 +7574,8 @@
         </p:nvSpPr>
         <p:spPr>
           <a:xfrm>
-            <a:off x="640080" y="5550407"/>
-            <a:ext cx="6766560" cy="201168"/>
+            <a:off x="640080" y="5321807"/>
+            <a:ext cx="6172200" cy="201168"/>
           </a:xfrm>
           <a:prstGeom prst="rect">
             <a:avLst/>
@@ -7706,8 +7617,8 @@
         </p:blipFill>
         <p:spPr>
           <a:xfrm>
-            <a:off x="7635240" y="1937384"/>
-            <a:ext cx="4343400" cy="3257550"/>
+            <a:off x="7269480" y="1325880"/>
+            <a:ext cx="4465015" cy="2578036"/>
           </a:xfrm>
           <a:prstGeom prst="rect">
             <a:avLst/>
@@ -7774,7 +7685,7 @@
         <p:spPr>
           <a:xfrm>
             <a:off x="640080" y="1371600"/>
-            <a:ext cx="11247120" cy="1810512"/>
+            <a:ext cx="11247120" cy="1828800"/>
           </a:xfrm>
           <a:prstGeom prst="rect">
             <a:avLst/>
@@ -7798,7 +7709,7 @@
                   <a:srgbClr val="000000"/>
                 </a:solidFill>
               </a:rPr>
-              <a:t>Скорость и память: работает на слабых устройствах (микроконтроллеры, старые ноутбуки)</a:t>
+              <a:t>• Скорость и память: работает на слабых устройствах (микроконтроллеры, старые ноутбуки)</a:t>
             </a:r>
           </a:p>
           <a:p>
@@ -7813,7 +7724,7 @@
                   <a:srgbClr val="000000"/>
                 </a:solidFill>
               </a:rPr>
-              <a:t>Интерпретируемость: решение можно объяснить пошагово (в отличие от нейросети)</a:t>
+              <a:t>• Интерпретируемость: решение можно объяснить пошагово (в отличие от нейросети)</a:t>
             </a:r>
           </a:p>
           <a:p>
@@ -7828,7 +7739,7 @@
                   <a:srgbClr val="000000"/>
                 </a:solidFill>
               </a:rPr>
-              <a:t>Чем лучше логистической регрессии? — ловит нелинейности без ручного создания признаков</a:t>
+              <a:t>• Чем лучше логистической регрессии? — ловит нелинейности без ручного создания признаков</a:t>
             </a:r>
           </a:p>
           <a:p>
@@ -7843,7 +7754,7 @@
                   <a:srgbClr val="000000"/>
                 </a:solidFill>
               </a:rPr>
-              <a:t>Чем лучше KNN? — не хранит обучающую выборку; предсказание за O(глубина дерева)</a:t>
+              <a:t>• Чем лучше KNN? — не хранит обучающую выборку; предсказание за O(глубина дерева)</a:t>
             </a:r>
           </a:p>
         </p:txBody>
@@ -7908,7 +7819,7 @@
         <p:spPr>
           <a:xfrm>
             <a:off x="640080" y="1371600"/>
-            <a:ext cx="6858000" cy="1810512"/>
+            <a:ext cx="6263640" cy="2697480"/>
           </a:xfrm>
           <a:prstGeom prst="rect">
             <a:avLst/>
@@ -7932,7 +7843,7 @@
                   <a:srgbClr val="000000"/>
                 </a:solidFill>
               </a:rPr>
-              <a:t>Игра 'Угадай число': последовательность вопросов → структура дерева</a:t>
+              <a:t>• Игра 'Угадай число': последовательность вопросов → структура дерева</a:t>
             </a:r>
           </a:p>
           <a:p>
@@ -7947,7 +7858,7 @@
                   <a:srgbClr val="000000"/>
                 </a:solidFill>
               </a:rPr>
-              <a:t>Каждый вопрос разделяет множество вариантов на подмножества</a:t>
+              <a:t>• Каждый вопрос разделяет множество вариантов на подмножества</a:t>
             </a:r>
           </a:p>
           <a:p>
@@ -7962,7 +7873,7 @@
                   <a:srgbClr val="000000"/>
                 </a:solidFill>
               </a:rPr>
-              <a:t>Дерево: связный ациклический граф с корнем, внутренними узлами (вопросы) и листьями (ответы)</a:t>
+              <a:t>• Дерево: связный ациклический граф с корнем, внутренними узлами (вопросы) и листьями (ответы)</a:t>
             </a:r>
           </a:p>
           <a:p>
@@ -7977,7 +7888,7 @@
                   <a:srgbClr val="000000"/>
                 </a:solidFill>
               </a:rPr>
-              <a:t>Глубина дерева — максимальное число вопросов до ответа</a:t>
+              <a:t>• Глубина дерева — максимальное число вопросов до ответа</a:t>
             </a:r>
           </a:p>
         </p:txBody>
@@ -7998,8 +7909,8 @@
         </p:blipFill>
         <p:spPr>
           <a:xfrm>
-            <a:off x="7635240" y="2412714"/>
-            <a:ext cx="4343400" cy="2306892"/>
+            <a:off x="7269480" y="1325880"/>
+            <a:ext cx="4465015" cy="2495677"/>
           </a:xfrm>
           <a:prstGeom prst="rect">
             <a:avLst/>
@@ -8066,7 +7977,7 @@
         <p:spPr>
           <a:xfrm>
             <a:off x="640080" y="1371600"/>
-            <a:ext cx="11247120" cy="3209544"/>
+            <a:ext cx="5532120" cy="2697480"/>
           </a:xfrm>
           <a:prstGeom prst="rect">
             <a:avLst/>
@@ -8075,7 +7986,7 @@
         </p:spPr>
         <p:txBody>
           <a:bodyPr wrap="square">
-            <a:normAutofit/>
+            <a:spAutoFit/>
           </a:bodyPr>
           <a:lstStyle/>
           <a:p>
@@ -8090,7 +8001,7 @@
                   <a:srgbClr val="000000"/>
                 </a:solidFill>
               </a:rPr>
-              <a:t>Нормализация не нужна — масштабирование не меняет порядок значений, структура дерева не изменится</a:t>
+              <a:t>• Нормализация не нужна — масштабирование не меняет порядок значений, структура дерева не изменится</a:t>
             </a:r>
           </a:p>
           <a:p>
@@ -8105,7 +8016,7 @@
                   <a:srgbClr val="000000"/>
                 </a:solidFill>
               </a:rPr>
-              <a:t>Пропуски нужно заполнять (impute); sklearn DecisionTree не работает с NaN (в отличие от XGBoost)</a:t>
+              <a:t>• Пропуски нужно заполнять (impute); sklearn DecisionTree не работает с NaN (в отличие от XGBoost)</a:t>
             </a:r>
           </a:p>
           <a:p>
@@ -8120,9 +8031,32 @@
                   <a:srgbClr val="000000"/>
                 </a:solidFill>
               </a:rPr>
-              <a:t>Категориальные признаки: sklearn не принимает строки — нужно кодирование</a:t>
-            </a:r>
-          </a:p>
+              <a:t>• Категориальные признаки: sklearn не принимает строки — нужно кодирование</a:t>
+            </a:r>
+          </a:p>
+        </p:txBody>
+      </p:sp>
+      <p:sp>
+        <p:nvSpPr>
+          <p:cNvPr id="4" name="TextBox 3"/>
+          <p:cNvSpPr txBox="1"/>
+          <p:nvPr/>
+        </p:nvSpPr>
+        <p:spPr>
+          <a:xfrm>
+            <a:off x="6355080" y="1371600"/>
+            <a:ext cx="5532120" cy="2697480"/>
+          </a:xfrm>
+          <a:prstGeom prst="rect">
+            <a:avLst/>
+          </a:prstGeom>
+          <a:noFill/>
+        </p:spPr>
+        <p:txBody>
+          <a:bodyPr wrap="square">
+            <a:spAutoFit/>
+          </a:bodyPr>
+          <a:lstStyle/>
           <a:p>
             <a:pPr>
               <a:spcAft>
@@ -8135,7 +8069,7 @@
                   <a:srgbClr val="000000"/>
                 </a:solidFill>
               </a:rPr>
-              <a:t>Порядковые категории (младший, средний, старший): Label Encoding (0, 1, 2)</a:t>
+              <a:t>• Порядковые категории (младший, средний, старший): Label Encoding (0, 1, 2)</a:t>
             </a:r>
           </a:p>
           <a:p>
@@ -8150,7 +8084,7 @@
                   <a:srgbClr val="000000"/>
                 </a:solidFill>
               </a:rPr>
-              <a:t>Номинативные (цвет, город, пол): только One-Hot Encoding — иначе вопросы вида «цвет &lt; 2.5» бессмысленны</a:t>
+              <a:t>• Номинативные (цвет, город, пол): только One-Hot Encoding — иначе вопросы вида «цвет &lt; 2.5» бессмысленны</a:t>
             </a:r>
           </a:p>
           <a:p>
@@ -8165,21 +8099,21 @@
                   <a:srgbClr val="000000"/>
                 </a:solidFill>
               </a:rPr>
-              <a:t>One-Hot при 100+ категориях — разреженность и замедление; альтернатива — целевое кодирование</a:t>
-            </a:r>
-          </a:p>
-        </p:txBody>
-      </p:sp>
-      <p:sp>
-        <p:nvSpPr>
-          <p:cNvPr id="4" name="Rectangle 3"/>
+              <a:t>• One-Hot при 100+ категориях — разреженность и замедление; альтернатива — целевое кодирование</a:t>
+            </a:r>
+          </a:p>
+        </p:txBody>
+      </p:sp>
+      <p:sp>
+        <p:nvSpPr>
+          <p:cNvPr id="5" name="Rectangle 4"/>
           <p:cNvSpPr/>
           <p:nvPr/>
         </p:nvSpPr>
         <p:spPr>
           <a:xfrm>
             <a:off x="640080" y="4690872"/>
-            <a:ext cx="11155680" cy="804672"/>
+            <a:ext cx="11155680" cy="630936"/>
           </a:xfrm>
           <a:prstGeom prst="rect">
             <a:avLst/>
@@ -8217,14 +8151,14 @@
       </p:sp>
       <p:sp>
         <p:nvSpPr>
-          <p:cNvPr id="5" name="TextBox 4"/>
+          <p:cNvPr id="6" name="TextBox 5"/>
           <p:cNvSpPr txBox="1"/>
           <p:nvPr/>
         </p:nvSpPr>
         <p:spPr>
           <a:xfrm>
             <a:off x="713231" y="4727448"/>
-            <a:ext cx="11009376" cy="731520"/>
+            <a:ext cx="11009376" cy="557784"/>
           </a:xfrm>
           <a:prstGeom prst="rect">
             <a:avLst/>
@@ -8249,7 +8183,7 @@
                 </a:solidFill>
                 <a:latin typeface="Consolas"/>
               </a:rPr>
-              <a:t>from sklearn.tree import DecisionTreeClassifier</a:t>
+              <a:t># масштабирование не обязательно</a:t>
             </a:r>
           </a:p>
           <a:p>
@@ -8265,7 +8199,7 @@
                 </a:solidFill>
                 <a:latin typeface="Consolas"/>
               </a:rPr>
-              <a:t># масштабирование не обязательно</a:t>
+              <a:t>clf = DecisionTreeClassifier(random_state=42)</a:t>
             </a:r>
           </a:p>
           <a:p>
@@ -8281,22 +8215,6 @@
                 </a:solidFill>
                 <a:latin typeface="Consolas"/>
               </a:rPr>
-              <a:t>clf = DecisionTreeClassifier(random_state=42)</a:t>
-            </a:r>
-          </a:p>
-          <a:p>
-            <a:pPr>
-              <a:spcAft>
-                <a:spcPts val="0"/>
-              </a:spcAft>
-            </a:pPr>
-            <a:r>
-              <a:rPr sz="1100">
-                <a:solidFill>
-                  <a:srgbClr val="000000"/>
-                </a:solidFill>
-                <a:latin typeface="Consolas"/>
-              </a:rPr>
               <a:t>clf.fit(X_raw, y)  # можно на исходных признаках</a:t>
             </a:r>
           </a:p>
@@ -8304,13 +8222,13 @@
       </p:sp>
       <p:sp>
         <p:nvSpPr>
-          <p:cNvPr id="6" name="TextBox 5"/>
+          <p:cNvPr id="7" name="TextBox 6"/>
           <p:cNvSpPr txBox="1"/>
           <p:nvPr/>
         </p:nvSpPr>
         <p:spPr>
           <a:xfrm>
-            <a:off x="640080" y="5550408"/>
+            <a:off x="640080" y="5376672"/>
             <a:ext cx="11155680" cy="201168"/>
           </a:xfrm>
           <a:prstGeom prst="rect">
@@ -8397,7 +8315,7 @@
         <p:spPr>
           <a:xfrm>
             <a:off x="640080" y="1371600"/>
-            <a:ext cx="11247120" cy="2194560"/>
+            <a:ext cx="5532120" cy="2423160"/>
           </a:xfrm>
           <a:prstGeom prst="rect">
             <a:avLst/>
@@ -8421,7 +8339,7 @@
                   <a:srgbClr val="000000"/>
                 </a:solidFill>
               </a:rPr>
-              <a:t>Перебор комбинаций признаков в каждом узле вырос бы экспоненциально</a:t>
+              <a:t>• Перебор комбинаций признаков в каждом узле вырос бы экспоненциально</a:t>
             </a:r>
           </a:p>
           <a:p>
@@ -8436,7 +8354,7 @@
                   <a:srgbClr val="000000"/>
                 </a:solidFill>
               </a:rPr>
-              <a:t>Интерпретируемость: простые, понятные правила (если x &lt; a, то …)</a:t>
+              <a:t>• Интерпретируемость: простые, понятные правила (если x &lt; a, то …)</a:t>
             </a:r>
           </a:p>
           <a:p>
@@ -8451,9 +8369,32 @@
                   <a:srgbClr val="000000"/>
                 </a:solidFill>
               </a:rPr>
-              <a:t>Один признак → оси-параллельные прямоугольные области; при достаточной глубине ими можно аппроксимировать сложные границы</a:t>
-            </a:r>
-          </a:p>
+              <a:t>• Один признак → оси-параллельные прямоугольные области; при достаточной глубине ими можно аппроксимировать сложные границы</a:t>
+            </a:r>
+          </a:p>
+        </p:txBody>
+      </p:sp>
+      <p:sp>
+        <p:nvSpPr>
+          <p:cNvPr id="4" name="TextBox 3"/>
+          <p:cNvSpPr txBox="1"/>
+          <p:nvPr/>
+        </p:nvSpPr>
+        <p:spPr>
+          <a:xfrm>
+            <a:off x="6355080" y="1371600"/>
+            <a:ext cx="5532120" cy="2423160"/>
+          </a:xfrm>
+          <a:prstGeom prst="rect">
+            <a:avLst/>
+          </a:prstGeom>
+          <a:noFill/>
+        </p:spPr>
+        <p:txBody>
+          <a:bodyPr wrap="square">
+            <a:spAutoFit/>
+          </a:bodyPr>
+          <a:lstStyle/>
           <a:p>
             <a:pPr>
               <a:spcAft>
@@ -8466,7 +8407,7 @@
                   <a:srgbClr val="000000"/>
                 </a:solidFill>
               </a:rPr>
-              <a:t>Сложные комбинации в одном узле резко повышают риск переобучения</a:t>
+              <a:t>• Сложные комбинации в одном узле резко повышают риск переобучения</a:t>
             </a:r>
           </a:p>
           <a:p>
@@ -8481,7 +8422,7 @@
                   <a:srgbClr val="000000"/>
                 </a:solidFill>
               </a:rPr>
-              <a:t>Исключение: ID3/C4.5 для категориальных признаков допускают небинарные узлы, но каждый узел всё равно соответствует одному признаку</a:t>
+              <a:t>• Исключение: ID3/C4.5 для категориальных признаков допускают небинарные узлы, но каждый узел всё равно соответствует одному признаку</a:t>
             </a:r>
           </a:p>
         </p:txBody>
@@ -8546,7 +8487,7 @@
         <p:spPr>
           <a:xfrm>
             <a:off x="640080" y="1371600"/>
-            <a:ext cx="11247120" cy="2194560"/>
+            <a:ext cx="5532120" cy="2423160"/>
           </a:xfrm>
           <a:prstGeom prst="rect">
             <a:avLst/>
@@ -8570,7 +8511,7 @@
                   <a:srgbClr val="000000"/>
                 </a:solidFill>
               </a:rPr>
-              <a:t>Краткий ответ: компромисс между качеством, временем и переобучением</a:t>
+              <a:t>• Краткий ответ: компромисс между качеством, временем и переобучением</a:t>
             </a:r>
           </a:p>
           <a:p>
@@ -8585,7 +8526,7 @@
                   <a:srgbClr val="000000"/>
                 </a:solidFill>
               </a:rPr>
-              <a:t>Полный перебор оптимального дерева — NP-трудная задача (доказано)</a:t>
+              <a:t>• Полный перебор оптимального дерева — NP-трудная задача (доказано)</a:t>
             </a:r>
           </a:p>
           <a:p>
@@ -8600,7 +8541,7 @@
                   <a:srgbClr val="000000"/>
                 </a:solidFill>
               </a:rPr>
-              <a:t xml:space="preserve">Жадный алгоритм: </a:t>
+              <a:t xml:space="preserve">• Жадный алгоритм: </a:t>
             </a:r>
             <ns0:m xmlns:ns0="http://schemas.microsoft.com/office/drawing/2010/main">
               <m:oMath xmlns:m="http://schemas.openxmlformats.org/officeDocument/2006/math">
@@ -8669,6 +8610,29 @@
               <a:t xml:space="preserve"> на узел (в sklearn — сортировка по признаку)</a:t>
             </a:r>
           </a:p>
+        </p:txBody>
+      </p:sp>
+      <p:sp>
+        <p:nvSpPr>
+          <p:cNvPr id="4" name="TextBox 3"/>
+          <p:cNvSpPr txBox="1"/>
+          <p:nvPr/>
+        </p:nvSpPr>
+        <p:spPr>
+          <a:xfrm>
+            <a:off x="6355080" y="1371600"/>
+            <a:ext cx="5532120" cy="2423160"/>
+          </a:xfrm>
+          <a:prstGeom prst="rect">
+            <a:avLst/>
+          </a:prstGeom>
+          <a:noFill/>
+        </p:spPr>
+        <p:txBody>
+          <a:bodyPr wrap="square">
+            <a:spAutoFit/>
+          </a:bodyPr>
+          <a:lstStyle/>
           <a:p>
             <a:pPr>
               <a:spcAft>
@@ -8681,7 +8645,7 @@
                   <a:srgbClr val="000000"/>
                 </a:solidFill>
               </a:rPr>
-              <a:t>Жадность даёт интерпретируемые результаты и контроль сложности (остановка, прунинг)</a:t>
+              <a:t>• Жадность даёт интерпретируемые результаты и контроль сложности (остановка, прунинг)</a:t>
             </a:r>
           </a:p>
           <a:p>
@@ -8696,7 +8660,7 @@
                   <a:srgbClr val="000000"/>
                 </a:solidFill>
               </a:rPr>
-              <a:t>Недостатки жадности — плюс в ансамблях: много слабых деревьев лучше одного сильного</a:t>
+              <a:t>• Недостатки жадности — плюс в ансамблях: много слабых деревьев лучше одного сильного</a:t>
             </a:r>
           </a:p>
         </p:txBody>
@@ -8761,7 +8725,7 @@
         <p:spPr>
           <a:xfrm>
             <a:off x="640080" y="1371600"/>
-            <a:ext cx="11247120" cy="2962656"/>
+            <a:ext cx="5532120" cy="3246120"/>
           </a:xfrm>
           <a:prstGeom prst="rect">
             <a:avLst/>
@@ -8785,7 +8749,7 @@
                   <a:srgbClr val="000000"/>
                 </a:solidFill>
               </a:rPr>
-              <a:t>Гладкость не является причиной (она не обязательна для выбора разбиения)</a:t>
+              <a:t>• Гладкость не является причиной (она не обязательна для выбора разбиения)</a:t>
             </a:r>
           </a:p>
           <a:p>
@@ -8800,7 +8764,7 @@
                   <a:srgbClr val="000000"/>
                 </a:solidFill>
               </a:rPr>
-              <a:t>Misclassification impurity кусочно-линейна и не является строго вогнутой — в этом суть проблемы</a:t>
+              <a:t>• Misclassification impurity кусочно-линейна и не является строго вогнутой — в этом суть проблемы</a:t>
             </a:r>
           </a:p>
           <a:p>
@@ -8815,7 +8779,7 @@
                   <a:srgbClr val="000000"/>
                 </a:solidFill>
               </a:rPr>
-              <a:t xml:space="preserve">При </a:t>
+              <a:t xml:space="preserve">• При </a:t>
             </a:r>
             <ns0:m xmlns:ns0="http://schemas.microsoft.com/office/drawing/2010/main">
               <m:oMath xmlns:m="http://schemas.openxmlformats.org/officeDocument/2006/math">
@@ -8845,7 +8809,7 @@
                   <a:srgbClr val="000000"/>
                 </a:solidFill>
               </a:rPr>
-              <a:t xml:space="preserve">Пример: </a:t>
+              <a:t xml:space="preserve">• Пример: </a:t>
             </a:r>
             <ns0:m xmlns:ns0="http://schemas.microsoft.com/office/drawing/2010/main">
               <m:oMath xmlns:m="http://schemas.openxmlformats.org/officeDocument/2006/math">
@@ -8939,6 +8903,29 @@
               <a:t>, но разную энтропию и Джини</a:t>
             </a:r>
           </a:p>
+        </p:txBody>
+      </p:sp>
+      <p:sp>
+        <p:nvSpPr>
+          <p:cNvPr id="4" name="TextBox 3"/>
+          <p:cNvSpPr txBox="1"/>
+          <p:nvPr/>
+        </p:nvSpPr>
+        <p:spPr>
+          <a:xfrm>
+            <a:off x="6355080" y="1371600"/>
+            <a:ext cx="5532120" cy="3246120"/>
+          </a:xfrm>
+          <a:prstGeom prst="rect">
+            <a:avLst/>
+          </a:prstGeom>
+          <a:noFill/>
+        </p:spPr>
+        <p:txBody>
+          <a:bodyPr wrap="square">
+            <a:spAutoFit/>
+          </a:bodyPr>
+          <a:lstStyle/>
           <a:p>
             <a:pPr>
               <a:spcAft>
@@ -8951,7 +8938,7 @@
                   <a:srgbClr val="000000"/>
                 </a:solidFill>
               </a:rPr>
-              <a:t>Misclassification смотрит только на самый большой класс, игнорируя остальные</a:t>
+              <a:t>• Misclassification смотрит только на самый большой класс, игнорируя остальные</a:t>
             </a:r>
           </a:p>
           <a:p>
@@ -8966,7 +8953,7 @@
                   <a:srgbClr val="000000"/>
                 </a:solidFill>
               </a:rPr>
-              <a:t>Энтропия и Джини строго вогнуты — прирост разбиения однозначен, меньше случайности в выборе порога</a:t>
+              <a:t>• Энтропия и Джини строго вогнуты — прирост разбиения однозначен, меньше случайности в выборе порога</a:t>
             </a:r>
           </a:p>
           <a:p>
@@ -8981,7 +8968,7 @@
                   <a:srgbClr val="000000"/>
                 </a:solidFill>
               </a:rPr>
-              <a:t>Вывод: misclassification на практике почти не используют; деревья с Gini и entropy обычно близки по качеству</a:t>
+              <a:t>• Вывод: misclassification на практике почти не используют; деревья с Gini и entropy обычно близки по качеству</a:t>
             </a:r>
           </a:p>
         </p:txBody>
@@ -9046,7 +9033,7 @@
         <p:spPr>
           <a:xfrm>
             <a:off x="640080" y="1371600"/>
-            <a:ext cx="11247120" cy="1810512"/>
+            <a:ext cx="11247120" cy="2423160"/>
           </a:xfrm>
           <a:prstGeom prst="rect">
             <a:avLst/>
@@ -9070,7 +9057,7 @@
                   <a:srgbClr val="000000"/>
                 </a:solidFill>
               </a:rPr>
-              <a:t xml:space="preserve">Джини быстрее (только квадраты), энтропия требует </a:t>
+              <a:t xml:space="preserve">• Джини быстрее (только квадраты), энтропия требует </a:t>
             </a:r>
             <ns0:m xmlns:ns0="http://schemas.microsoft.com/office/drawing/2010/main">
               <m:oMath xmlns:m="http://schemas.openxmlformats.org/officeDocument/2006/math">
@@ -9112,7 +9099,7 @@
                   <a:srgbClr val="000000"/>
                 </a:solidFill>
               </a:rPr>
-              <a:t>Энтропия: интерпретация в битах; Джини — квадратичное приближение энтропии вблизи равномерного распределения</a:t>
+              <a:t>• Энтропия: интерпретация в битах; Джини — квадратичное приближение энтропии вблизи равномерного распределения</a:t>
             </a:r>
           </a:p>
           <a:p>
@@ -9127,7 +9114,7 @@
                   <a:srgbClr val="000000"/>
                 </a:solidFill>
               </a:rPr>
-              <a:t>Вблизи чистых узлов (</a:t>
+              <a:t>• Вблизи чистых узлов (</a:t>
             </a:r>
             <ns0:m xmlns:ns0="http://schemas.microsoft.com/office/drawing/2010/main">
               <m:oMath xmlns:m="http://schemas.openxmlformats.org/officeDocument/2006/math">
@@ -9169,7 +9156,7 @@
                   <a:srgbClr val="000000"/>
                 </a:solidFill>
               </a:rPr>
-              <a:t>На практике деревья почти одинаковы — начинайте с Gini (default в sklearn), не тратьте время на тонкую настройку</a:t>
+              <a:t>• На практике деревья почти одинаковы — начинайте с Gini (default в sklearn), не тратьте время на тонкую настройку</a:t>
             </a:r>
           </a:p>
         </p:txBody>
@@ -9689,7 +9676,7 @@
         <p:spPr>
           <a:xfrm>
             <a:off x="640080" y="1371600"/>
-            <a:ext cx="6858000" cy="1810512"/>
+            <a:ext cx="6263640" cy="2423160"/>
           </a:xfrm>
           <a:prstGeom prst="rect">
             <a:avLst/>
@@ -9713,7 +9700,7 @@
                   <a:srgbClr val="000000"/>
                 </a:solidFill>
               </a:rPr>
-              <a:t>Акинатор угадывает персонажа/объект по серии вопросов ('да/нет')</a:t>
+              <a:t>• Акинатор угадывает персонажа/объект по серии вопросов ('да/нет')</a:t>
             </a:r>
           </a:p>
           <a:p>
@@ -9728,7 +9715,7 @@
                   <a:srgbClr val="000000"/>
                 </a:solidFill>
               </a:rPr>
-              <a:t>Каждый ответ ведёт к следующему вопросу — структура дерева</a:t>
+              <a:t>• Каждый ответ ведёт к следующему вопросу — структура дерева</a:t>
             </a:r>
           </a:p>
           <a:p>
@@ -9743,7 +9730,7 @@
                   <a:srgbClr val="000000"/>
                 </a:solidFill>
               </a:rPr>
-              <a:t>Листья — конкретные персонажи/объекты</a:t>
+              <a:t>• Листья — конкретные персонажи/объекты</a:t>
             </a:r>
           </a:p>
           <a:p>
@@ -9758,7 +9745,7 @@
                   <a:srgbClr val="000000"/>
                 </a:solidFill>
               </a:rPr>
-              <a:t>Демонстрация: дерево решений уже используется в повседневных приложениях</a:t>
+              <a:t>• Демонстрация: дерево решений уже используется в повседневных приложениях</a:t>
             </a:r>
           </a:p>
         </p:txBody>
@@ -9779,8 +9766,8 @@
         </p:blipFill>
         <p:spPr>
           <a:xfrm>
-            <a:off x="7635240" y="2312438"/>
-            <a:ext cx="4343400" cy="2507442"/>
+            <a:off x="7269480" y="1325880"/>
+            <a:ext cx="4465015" cy="2907852"/>
           </a:xfrm>
           <a:prstGeom prst="rect">
             <a:avLst/>
@@ -9913,7 +9900,7 @@
         <p:spPr>
           <a:xfrm>
             <a:off x="640080" y="1371600"/>
-            <a:ext cx="6858000" cy="3209544"/>
+            <a:ext cx="6263640" cy="2697480"/>
           </a:xfrm>
           <a:prstGeom prst="rect">
             <a:avLst/>
@@ -9922,7 +9909,7 @@
         </p:spPr>
         <p:txBody>
           <a:bodyPr wrap="square">
-            <a:normAutofit/>
+            <a:spAutoFit/>
           </a:bodyPr>
           <a:lstStyle/>
           <a:p>
@@ -9937,7 +9924,7 @@
                   <a:srgbClr val="000000"/>
                 </a:solidFill>
               </a:rPr>
-              <a:t>Дано: объекты с признаками (x₁, x₂, ..., xₙ) и меткой класса (0 или 1)</a:t>
+              <a:t>• Дано: объекты с признаками (x₁, x₂, ..., xₙ) и меткой класса (0 или 1)</a:t>
             </a:r>
           </a:p>
           <a:p>
@@ -9952,7 +9939,7 @@
                   <a:srgbClr val="000000"/>
                 </a:solidFill>
               </a:rPr>
-              <a:t>Дерево задаёт вопросы вида xᵢ &lt; a — ровно один признак в узле</a:t>
+              <a:t>• Дерево задаёт вопросы вида xᵢ &lt; a — ровно один признак в узле</a:t>
             </a:r>
           </a:p>
           <a:p>
@@ -9967,7 +9954,7 @@
                   <a:srgbClr val="000000"/>
                 </a:solidFill>
               </a:rPr>
-              <a:t>Да → левый потомок, Нет → правый потомок</a:t>
+              <a:t>• Да → левый потомок, Нет → правый потомок</a:t>
             </a:r>
           </a:p>
           <a:p>
@@ -9982,7 +9969,7 @@
                   <a:srgbClr val="000000"/>
                 </a:solidFill>
               </a:rPr>
-              <a:t>В листе: ответ — мажоритарный класс среди попавших туда объектов</a:t>
+              <a:t>• В листе: ответ — мажоритарный класс среди попавших туда объектов</a:t>
             </a:r>
           </a:p>
           <a:p>
@@ -9997,7 +9984,7 @@
                   <a:srgbClr val="000000"/>
                 </a:solidFill>
               </a:rPr>
-              <a:t>Граница решения: оси-параллельные прямоугольники</a:t>
+              <a:t>• Граница решения: оси-параллельные прямоугольники</a:t>
             </a:r>
           </a:p>
         </p:txBody>
@@ -10010,8 +9997,8 @@
         </p:nvSpPr>
         <p:spPr>
           <a:xfrm>
-            <a:off x="640080" y="4690872"/>
-            <a:ext cx="6766560" cy="804672"/>
+            <a:off x="640080" y="4489703"/>
+            <a:ext cx="6172200" cy="804672"/>
           </a:xfrm>
           <a:prstGeom prst="rect">
             <a:avLst/>
@@ -10055,8 +10042,8 @@
         </p:nvSpPr>
         <p:spPr>
           <a:xfrm>
-            <a:off x="713231" y="4727448"/>
-            <a:ext cx="6620256" cy="731520"/>
+            <a:off x="713231" y="4526279"/>
+            <a:ext cx="6025896" cy="731520"/>
           </a:xfrm>
           <a:prstGeom prst="rect">
             <a:avLst/>
@@ -10142,8 +10129,8 @@
         </p:nvSpPr>
         <p:spPr>
           <a:xfrm>
-            <a:off x="640080" y="5550408"/>
-            <a:ext cx="6766560" cy="201168"/>
+            <a:off x="640080" y="5349240"/>
+            <a:ext cx="6172200" cy="201168"/>
           </a:xfrm>
           <a:prstGeom prst="rect">
             <a:avLst/>
@@ -10185,8 +10172,8 @@
         </p:blipFill>
         <p:spPr>
           <a:xfrm>
-            <a:off x="7635240" y="1937384"/>
-            <a:ext cx="4343400" cy="3257550"/>
+            <a:off x="7269480" y="1325880"/>
+            <a:ext cx="4465015" cy="2578036"/>
           </a:xfrm>
           <a:prstGeom prst="rect">
             <a:avLst/>
@@ -10253,7 +10240,7 @@
         <p:spPr>
           <a:xfrm>
             <a:off x="640080" y="1371600"/>
-            <a:ext cx="11247120" cy="1810512"/>
+            <a:ext cx="11247120" cy="2148839"/>
           </a:xfrm>
           <a:prstGeom prst="rect">
             <a:avLst/>
@@ -10277,7 +10264,7 @@
                   <a:srgbClr val="000000"/>
                 </a:solidFill>
               </a:rPr>
-              <a:t>Перебираем все признаки, для каждого — все возможные пороги (их конечное число, т.к. между соседними объектами impurity не меняется)</a:t>
+              <a:t>• Перебираем все признаки, для каждого — все возможные пороги (их конечное число, т.к. между соседними объектами impurity не меняется)</a:t>
             </a:r>
           </a:p>
           <a:p>
@@ -10292,7 +10279,7 @@
                   <a:srgbClr val="000000"/>
                 </a:solidFill>
               </a:rPr>
-              <a:t>Выбираем разбиение с максимальным уменьшением неоднородности узла — критерии misclassification, энтропия и Джини на следующих слайдах</a:t>
+              <a:t>• Выбираем разбиение с максимальным уменьшением неоднородности узла — критерии misclassification, энтропия и Джини на следующих слайдах</a:t>
             </a:r>
           </a:p>
           <a:p>
@@ -10307,7 +10294,7 @@
                   <a:srgbClr val="000000"/>
                 </a:solidFill>
               </a:rPr>
-              <a:t>Критерии остановки: max_depth, min_samples_leaf — чтобы не переобучаться</a:t>
+              <a:t>• Критерии остановки: max_depth, min_samples_leaf — чтобы не переобучаться</a:t>
             </a:r>
           </a:p>
           <a:p>
@@ -10322,7 +10309,7 @@
                   <a:srgbClr val="000000"/>
                 </a:solidFill>
               </a:rPr>
-              <a:t>В листе: ответ — мажоритарный класс попавших туда объектов</a:t>
+              <a:t>• В листе: ответ — мажоритарный класс попавших туда объектов</a:t>
             </a:r>
           </a:p>
         </p:txBody>
@@ -10387,7 +10374,7 @@
         <p:spPr>
           <a:xfrm>
             <a:off x="640080" y="1371600"/>
-            <a:ext cx="11247120" cy="1645920"/>
+            <a:ext cx="11247120" cy="1828800"/>
           </a:xfrm>
           <a:prstGeom prst="rect">
             <a:avLst/>
@@ -10405,6 +10392,14 @@
                 <a:spcPts val="800"/>
               </a:spcAft>
             </a:pPr>
+            <a:r>
+              <a:rPr lang="ru-RU" dirty="0" sz="2000">
+                <a:solidFill>
+                  <a:srgbClr val="000000"/>
+                </a:solidFill>
+              </a:rPr>
+              <a:t xml:space="preserve">• </a:t>
+            </a:r>
             <ns0:m xmlns:ns0="http://schemas.microsoft.com/office/drawing/2010/main">
               <m:oMath xmlns:m="http://schemas.openxmlformats.org/officeDocument/2006/math">
                 <m:sSub>
@@ -10469,22 +10464,7 @@
                   <a:srgbClr val="000000"/>
                 </a:solidFill>
               </a:rPr>
-              <a:t xml:space="preserve">Простой и интуитивный, но есть недостатки при </a:t>
-            </a:r>
-            <ns0:m xmlns:ns0="http://schemas.microsoft.com/office/drawing/2010/main">
-              <m:oMath xmlns:m="http://schemas.openxmlformats.org/officeDocument/2006/math">
-                <m:r>
-                  <m:t>K≥3</m:t>
-                </m:r>
-              </m:oMath>
-            </ns0:m>
-            <a:r>
-              <a:rPr lang="ru-RU" dirty="0" sz="2000">
-                <a:solidFill>
-                  <a:srgbClr val="000000"/>
-                </a:solidFill>
-              </a:rPr>
-              <a:t xml:space="preserve"> — разберём в теоретическом блоке</a:t>
+              <a:t>• Простой и интуитивный, но есть недостатки (обсудим на слайде 21)</a:t>
             </a:r>
           </a:p>
         </p:txBody>
@@ -10549,7 +10529,7 @@
         <p:spPr>
           <a:xfrm>
             <a:off x="640080" y="1371600"/>
-            <a:ext cx="6858000" cy="3209544"/>
+            <a:ext cx="6263640" cy="2971800"/>
           </a:xfrm>
           <a:prstGeom prst="rect">
             <a:avLst/>
@@ -10558,7 +10538,7 @@
         </p:spPr>
         <p:txBody>
           <a:bodyPr wrap="square">
-            <a:normAutofit/>
+            <a:spAutoFit/>
           </a:bodyPr>
           <a:lstStyle/>
           <a:p>
@@ -10573,7 +10553,7 @@
                   <a:srgbClr val="000000"/>
                 </a:solidFill>
               </a:rPr>
-              <a:t xml:space="preserve">Энтропия: </a:t>
+              <a:t xml:space="preserve">• Энтропия: </a:t>
             </a:r>
             <ns0:m xmlns:ns0="http://schemas.microsoft.com/office/drawing/2010/main">
               <m:oMath xmlns:m="http://schemas.openxmlformats.org/officeDocument/2006/math">
@@ -10651,7 +10631,7 @@
                   <a:srgbClr val="000000"/>
                 </a:solidFill>
               </a:rPr>
-              <a:t xml:space="preserve">Индекс Джини: </a:t>
+              <a:t xml:space="preserve">• Индекс Джини: </a:t>
             </a:r>
             <ns0:m xmlns:ns0="http://schemas.microsoft.com/office/drawing/2010/main">
               <m:oMath xmlns:m="http://schemas.openxmlformats.org/officeDocument/2006/math">
@@ -10754,7 +10734,7 @@
                   <a:srgbClr val="000000"/>
                 </a:solidFill>
               </a:rPr>
-              <a:t>Обе функции строго вогнуты — учитывают распределение всех классов</a:t>
+              <a:t>• Обе функции строго вогнуты — учитывают распределение всех классов</a:t>
             </a:r>
           </a:p>
           <a:p>
@@ -10769,7 +10749,7 @@
                   <a:srgbClr val="000000"/>
                 </a:solidFill>
               </a:rPr>
-              <a:t>Именно их используют на практике (sklearn: criterion='gini' или 'entropy')</a:t>
+              <a:t>• Именно их используют на практике (sklearn: criterion='gini' или 'entropy')</a:t>
             </a:r>
           </a:p>
           <a:p>
@@ -10784,7 +10764,7 @@
                   <a:srgbClr val="000000"/>
                 </a:solidFill>
               </a:rPr>
-              <a:t>Почему misclassification слабее — разберём в теоретическом блоке</a:t>
+              <a:t>• Почему misclassification слабее — разберём в теоретическом блоке</a:t>
             </a:r>
           </a:p>
         </p:txBody>
@@ -10798,7 +10778,7 @@
         <p:spPr>
           <a:xfrm>
             <a:off x="640080" y="4690872"/>
-            <a:ext cx="6766560" cy="804672"/>
+            <a:ext cx="6172200" cy="630936"/>
           </a:xfrm>
           <a:prstGeom prst="rect">
             <a:avLst/>
@@ -10843,7 +10823,7 @@
         <p:spPr>
           <a:xfrm>
             <a:off x="713231" y="4727448"/>
-            <a:ext cx="6620256" cy="731520"/>
+            <a:ext cx="6025896" cy="557784"/>
           </a:xfrm>
           <a:prstGeom prst="rect">
             <a:avLst/>
@@ -10868,22 +10848,6 @@
                 </a:solidFill>
                 <a:latin typeface="Consolas"/>
               </a:rPr>
-              <a:t>from sklearn.tree import DecisionTreeClassifier</a:t>
-            </a:r>
-          </a:p>
-          <a:p>
-            <a:pPr>
-              <a:spcAft>
-                <a:spcPts val="0"/>
-              </a:spcAft>
-            </a:pPr>
-            <a:r>
-              <a:rPr sz="1100">
-                <a:solidFill>
-                  <a:srgbClr val="000000"/>
-                </a:solidFill>
-                <a:latin typeface="Consolas"/>
-              </a:rPr>
               <a:t>clf = DecisionTreeClassifier(criterion='gini')</a:t>
             </a:r>
           </a:p>
@@ -10929,8 +10893,8 @@
         </p:nvSpPr>
         <p:spPr>
           <a:xfrm>
-            <a:off x="640080" y="5550408"/>
-            <a:ext cx="6766560" cy="201168"/>
+            <a:off x="640080" y="5376672"/>
+            <a:ext cx="6172200" cy="201168"/>
           </a:xfrm>
           <a:prstGeom prst="rect">
             <a:avLst/>
@@ -10972,8 +10936,8 @@
         </p:blipFill>
         <p:spPr>
           <a:xfrm>
-            <a:off x="7635240" y="2208847"/>
-            <a:ext cx="4343400" cy="2714625"/>
+            <a:off x="7269480" y="1325880"/>
+            <a:ext cx="4465015" cy="2404496"/>
           </a:xfrm>
           <a:prstGeom prst="rect">
             <a:avLst/>
@@ -11040,7 +11004,7 @@
         <p:spPr>
           <a:xfrm>
             <a:off x="640080" y="1371600"/>
-            <a:ext cx="11247120" cy="1810512"/>
+            <a:ext cx="11247120" cy="2423160"/>
           </a:xfrm>
           <a:prstGeom prst="rect">
             <a:avLst/>
@@ -11064,7 +11028,7 @@
                   <a:srgbClr val="000000"/>
                 </a:solidFill>
               </a:rPr>
-              <a:t>ID3 (Iterative Dichotomiser 3, Quinlan, 1986) — энтропия, категориальные признаки, без прунинга</a:t>
+              <a:t>• ID3 (Iterative Dichotomiser 3, Quinlan, 1986) — энтропия, категориальные признаки, без прунинга</a:t>
             </a:r>
           </a:p>
           <a:p>
@@ -11079,7 +11043,7 @@
                   <a:srgbClr val="000000"/>
                 </a:solidFill>
               </a:rPr>
-              <a:t>C4.5 — наследник ID3: непрерывные признаки (пороги), Gain Ratio против high-cardinality, прунинг</a:t>
+              <a:t>• C4.5 — наследник ID3: непрерывные признаки (пороги), Gain Ratio против high-cardinality, прунинг</a:t>
             </a:r>
           </a:p>
           <a:p>
@@ -11094,7 +11058,7 @@
                   <a:srgbClr val="000000"/>
                 </a:solidFill>
               </a:rPr>
-              <a:t>CART (Classification and Regression Trees, Breiman, 1984) — Gini/MSE, только бинарные разбиения</a:t>
+              <a:t>• CART (Classification and Regression Trees, Breiman, 1984) — Gini/MSE, только бинарные разбиения</a:t>
             </a:r>
           </a:p>
           <a:p>
@@ -11109,7 +11073,7 @@
                   <a:srgbClr val="000000"/>
                 </a:solidFill>
               </a:rPr>
-              <a:t>sklearn DecisionTreeClassifier/Regressor — реализация в духе CART</a:t>
+              <a:t>• sklearn DecisionTreeClassifier/Regressor — реализация в духе CART</a:t>
             </a:r>
           </a:p>
         </p:txBody>
@@ -11174,7 +11138,7 @@
         <p:spPr>
           <a:xfrm>
             <a:off x="640080" y="1371600"/>
-            <a:ext cx="11247120" cy="1810512"/>
+            <a:ext cx="11247120" cy="1828800"/>
           </a:xfrm>
           <a:prstGeom prst="rect">
             <a:avLst/>
@@ -11198,7 +11162,7 @@
                   <a:srgbClr val="000000"/>
                 </a:solidFill>
               </a:rPr>
-              <a:t>Для K классов линейные модели часто используют one-vs-rest или одну модель с softmax</a:t>
+              <a:t>• Для K классов линейные модели часто используют one-vs-rest или одну модель с softmax</a:t>
             </a:r>
           </a:p>
           <a:p>
@@ -11213,7 +11177,7 @@
                   <a:srgbClr val="000000"/>
                 </a:solidFill>
               </a:rPr>
-              <a:t>Дерево решений обобщается на K классов естественно — одна модель на все классы</a:t>
+              <a:t>• Дерево решений обобщается на K классов естественно — одна модель на все классы</a:t>
             </a:r>
           </a:p>
           <a:p>
@@ -11228,7 +11192,7 @@
                   <a:srgbClr val="000000"/>
                 </a:solidFill>
               </a:rPr>
-              <a:t>Подставляем K классов в формулы энтропии/Джини — алгоритм построения не меняется</a:t>
+              <a:t>• Подставляем K классов в формулы энтропии/Джини — алгоритм построения не меняется</a:t>
             </a:r>
           </a:p>
           <a:p>
@@ -11243,7 +11207,7 @@
                   <a:srgbClr val="000000"/>
                 </a:solidFill>
               </a:rPr>
-              <a:t>Никаких дополнительных моделей и схем one-vs-rest</a:t>
+              <a:t>• Никаких дополнительных моделей и схем one-vs-rest</a:t>
             </a:r>
           </a:p>
         </p:txBody>

</xml_diff>